<commit_message>
Fill slide 8 of the science-fair deck with results from the software
Slide 8 was a title with no body. It now shows the software's results
screen for the bo_sach dataset, four headline figures (140/140 placed,
39% first choice, 16 via reserved places, 0.02 s), and a native chart of
placements by preference rank, all measured by running the software.
The title's seat count is corrected from 120 to 150, and the data is
labelled as simulated.

Co-Authored-By: Claude Opus 5.5 <noreply@anthropic.com>
Claude-Session: https://claude.ai/code/session_01W1TN5sV8nD2mQymMCwHHSg
</commit_message>
<xml_diff>
--- a/THUYET_TRINH_KHKT_DA_SUA_FONT.pptx
+++ b/THUYET_TRINH_KHKT_DA_SUA_FONT.pptx
@@ -114,6 +114,642 @@
     </a:lvl9pPr>
   </p:defaultTextStyle>
 </p:presentation>
+</file>
+
+<file path=ppt/charts/chart1.xml><?xml version="1.0" encoding="utf-8"?>
+<c:chartSpace xmlns:c="http://schemas.openxmlformats.org/drawingml/2006/chart" xmlns:a="http://schemas.openxmlformats.org/drawingml/2006/main" xmlns:r="http://schemas.openxmlformats.org/officeDocument/2006/relationships">
+  <c:date1904 val="0"/>
+  <c:chart>
+    <c:title>
+      <c:tx>
+        <c:rich>
+          <a:bodyPr/>
+          <a:lstStyle/>
+          <a:p>
+            <a:r>
+              <a:rPr sz="1200" b="1">
+                <a:solidFill>
+                  <a:srgbClr val="1F1F1F"/>
+                </a:solidFill>
+                <a:latin typeface="Arial"/>
+              </a:rPr>
+              <a:t>Số học sinh theo nguyện vọng được xếp</a:t>
+            </a:r>
+          </a:p>
+        </c:rich>
+      </c:tx>
+      <c:layout/>
+      <c:overlay val="0"/>
+    </c:title>
+    <c:autoTitleDeleted val="0"/>
+    <c:plotArea>
+      <c:barChart>
+        <c:barDir val="col"/>
+        <c:grouping val="clustered"/>
+        <c:ser>
+          <c:idx val="0"/>
+          <c:order val="0"/>
+          <c:tx>
+            <c:strRef>
+              <c:f>Sheet1!$B$1</c:f>
+              <c:strCache>
+                <c:ptCount val="1"/>
+                <c:pt idx="0">
+                  <c:v>Số học sinh</c:v>
+                </c:pt>
+              </c:strCache>
+            </c:strRef>
+          </c:tx>
+          <c:spPr>
+            <a:solidFill>
+              <a:srgbClr val="3F6B52"/>
+            </a:solidFill>
+          </c:spPr>
+          <c:cat>
+            <c:strRef>
+              <c:f>Sheet1!$A$2:$A$7</c:f>
+              <c:strCache>
+                <c:ptCount val="6"/>
+                <c:pt idx="0">
+                  <c:v>NV 1</c:v>
+                </c:pt>
+                <c:pt idx="1">
+                  <c:v>NV 2</c:v>
+                </c:pt>
+                <c:pt idx="2">
+                  <c:v>NV 3</c:v>
+                </c:pt>
+                <c:pt idx="3">
+                  <c:v>NV 4</c:v>
+                </c:pt>
+                <c:pt idx="4">
+                  <c:v>NV 5</c:v>
+                </c:pt>
+                <c:pt idx="5">
+                  <c:v>NV 6</c:v>
+                </c:pt>
+              </c:strCache>
+            </c:strRef>
+          </c:cat>
+          <c:val>
+            <c:numRef>
+              <c:f>Sheet1!$B$2:$B$7</c:f>
+              <c:numCache>
+                <c:formatCode>General</c:formatCode>
+                <c:ptCount val="6"/>
+                <c:pt idx="0">
+                  <c:v>54</c:v>
+                </c:pt>
+                <c:pt idx="1">
+                  <c:v>46</c:v>
+                </c:pt>
+                <c:pt idx="2">
+                  <c:v>21</c:v>
+                </c:pt>
+                <c:pt idx="3">
+                  <c:v>11</c:v>
+                </c:pt>
+                <c:pt idx="4">
+                  <c:v>7</c:v>
+                </c:pt>
+                <c:pt idx="5">
+                  <c:v>1</c:v>
+                </c:pt>
+              </c:numCache>
+            </c:numRef>
+          </c:val>
+        </c:ser>
+        <c:dLbls>
+          <c:numFmt formatCode="0" sourceLinked="0"/>
+          <c:txPr>
+            <a:bodyPr/>
+            <a:lstStyle/>
+            <a:p>
+              <a:pPr>
+                <a:defRPr sz="1100">
+                  <a:latin typeface="Arial"/>
+                </a:defRPr>
+              </a:pPr>
+            </a:p>
+          </c:txPr>
+          <c:dLblPos val="outEnd"/>
+          <c:showLegendKey val="0"/>
+          <c:showVal val="1"/>
+          <c:showCatName val="0"/>
+          <c:showSerName val="0"/>
+          <c:showPercent val="0"/>
+          <c:showBubbleSize val="0"/>
+          <c:showLeaderLines val="1"/>
+        </c:dLbls>
+        <c:gapWidth val="60"/>
+        <c:axId val="-2068027336"/>
+        <c:axId val="-2113994440"/>
+      </c:barChart>
+      <c:catAx>
+        <c:axId val="-2068027336"/>
+        <c:scaling>
+          <c:orientation val="minMax"/>
+        </c:scaling>
+        <c:delete val="0"/>
+        <c:axPos val="b"/>
+        <c:majorTickMark val="out"/>
+        <c:minorTickMark val="none"/>
+        <c:tickLblPos val="nextTo"/>
+        <c:txPr>
+          <a:bodyPr/>
+          <a:lstStyle/>
+          <a:p>
+            <a:pPr>
+              <a:defRPr sz="1100">
+                <a:solidFill>
+                  <a:srgbClr val="595959"/>
+                </a:solidFill>
+              </a:defRPr>
+            </a:pPr>
+          </a:p>
+        </c:txPr>
+        <c:crossAx val="-2113994440"/>
+        <c:crosses val="autoZero"/>
+        <c:auto val="1"/>
+        <c:lblAlgn val="ctr"/>
+        <c:lblOffset val="100"/>
+        <c:noMultiLvlLbl val="0"/>
+      </c:catAx>
+      <c:valAx>
+        <c:axId val="-2113994440"/>
+        <c:scaling/>
+        <c:delete val="0"/>
+        <c:axPos val="l"/>
+        <c:majorGridlines>
+          <c:spPr>
+            <a:ln>
+              <a:solidFill>
+                <a:srgbClr val="E3E3E3"/>
+              </a:solidFill>
+            </a:ln>
+          </c:spPr>
+        </c:majorGridlines>
+        <c:majorTickMark val="out"/>
+        <c:minorTickMark val="none"/>
+        <c:tickLblPos val="nextTo"/>
+        <c:spPr>
+          <a:ln>
+            <a:noFill/>
+          </a:ln>
+        </c:spPr>
+        <c:txPr>
+          <a:bodyPr/>
+          <a:lstStyle/>
+          <a:p>
+            <a:pPr>
+              <a:defRPr sz="1000">
+                <a:solidFill>
+                  <a:srgbClr val="595959"/>
+                </a:solidFill>
+              </a:defRPr>
+            </a:pPr>
+          </a:p>
+        </c:txPr>
+        <c:crossAx val="-2068027336"/>
+        <c:crosses val="autoZero"/>
+      </c:valAx>
+    </c:plotArea>
+    <c:dispBlanksAs val="gap"/>
+  </c:chart>
+  <c:txPr>
+    <a:bodyPr/>
+    <a:lstStyle/>
+    <a:p>
+      <a:pPr>
+        <a:defRPr sz="1800"/>
+      </a:pPr>
+      <a:endParaRPr lang="en-US"/>
+    </a:p>
+  </c:txPr>
+  <c:externalData r:id="rId1">
+    <c:autoUpdate val="0"/>
+  </c:externalData>
+</c:chartSpace>
+</file>
+
+<file path=ppt/notesMasters/notesMaster1.xml><?xml version="1.0" encoding="utf-8"?>
+<p:notesMaster xmlns:a="http://schemas.openxmlformats.org/drawingml/2006/main" xmlns:p="http://schemas.openxmlformats.org/presentationml/2006/main" xmlns:r="http://schemas.openxmlformats.org/officeDocument/2006/relationships">
+  <p:cSld>
+    <p:bg>
+      <p:bgRef idx="1001">
+        <a:schemeClr val="bg1"/>
+      </p:bgRef>
+    </p:bg>
+    <p:spTree>
+      <p:nvGrpSpPr>
+        <p:cNvPr id="1" name=""/>
+        <p:cNvGrpSpPr/>
+        <p:nvPr/>
+      </p:nvGrpSpPr>
+      <p:grpSpPr>
+        <a:xfrm>
+          <a:off x="0" y="0"/>
+          <a:ext cx="0" cy="0"/>
+          <a:chOff x="0" y="0"/>
+          <a:chExt cx="0" cy="0"/>
+        </a:xfrm>
+      </p:grpSpPr>
+      <p:sp>
+        <p:nvSpPr>
+          <p:cNvPr id="2" name="Header Placeholder 1"/>
+          <p:cNvSpPr>
+            <a:spLocks noGrp="1"/>
+          </p:cNvSpPr>
+          <p:nvPr>
+            <p:ph type="hdr" sz="quarter"/>
+          </p:nvPr>
+        </p:nvSpPr>
+        <p:spPr>
+          <a:xfrm>
+            <a:off x="0" y="0"/>
+            <a:ext cx="2971800" cy="457200"/>
+          </a:xfrm>
+          <a:prstGeom prst="rect">
+            <a:avLst/>
+          </a:prstGeom>
+        </p:spPr>
+        <p:txBody>
+          <a:bodyPr vert="horz" lIns="91440" tIns="45720" rIns="91440" bIns="45720" rtlCol="0"/>
+          <a:lstStyle>
+            <a:lvl1pPr algn="l">
+              <a:defRPr sz="1200"/>
+            </a:lvl1pPr>
+          </a:lstStyle>
+          <a:p>
+            <a:endParaRPr lang="en-US"/>
+          </a:p>
+        </p:txBody>
+      </p:sp>
+      <p:sp>
+        <p:nvSpPr>
+          <p:cNvPr id="3" name="Date Placeholder 2"/>
+          <p:cNvSpPr>
+            <a:spLocks noGrp="1"/>
+          </p:cNvSpPr>
+          <p:nvPr>
+            <p:ph type="dt" idx="1"/>
+          </p:nvPr>
+        </p:nvSpPr>
+        <p:spPr>
+          <a:xfrm>
+            <a:off x="3884613" y="0"/>
+            <a:ext cx="2971800" cy="457200"/>
+          </a:xfrm>
+          <a:prstGeom prst="rect">
+            <a:avLst/>
+          </a:prstGeom>
+        </p:spPr>
+        <p:txBody>
+          <a:bodyPr vert="horz" lIns="91440" tIns="45720" rIns="91440" bIns="45720" rtlCol="0"/>
+          <a:lstStyle>
+            <a:lvl1pPr algn="r">
+              <a:defRPr sz="1200"/>
+            </a:lvl1pPr>
+          </a:lstStyle>
+          <a:p>
+            <a:fld id="{0F89C1C7-3DCD-1040-A9CF-14679D8B5DDD}" type="datetimeFigureOut">
+              <a:rPr lang="en-US" smtClean="0"/>
+              <a:t>10/17/16</a:t>
+            </a:fld>
+            <a:endParaRPr lang="en-US"/>
+          </a:p>
+        </p:txBody>
+      </p:sp>
+      <p:sp>
+        <p:nvSpPr>
+          <p:cNvPr id="4" name="Slide Image Placeholder 3"/>
+          <p:cNvSpPr>
+            <a:spLocks noGrp="1" noRot="1" noChangeAspect="1"/>
+          </p:cNvSpPr>
+          <p:nvPr>
+            <p:ph type="sldImg" idx="2"/>
+          </p:nvPr>
+        </p:nvSpPr>
+        <p:spPr>
+          <a:xfrm>
+            <a:off x="1143000" y="685800"/>
+            <a:ext cx="4572000" cy="3429000"/>
+          </a:xfrm>
+          <a:prstGeom prst="rect">
+            <a:avLst/>
+          </a:prstGeom>
+          <a:noFill/>
+          <a:ln w="12700">
+            <a:solidFill>
+              <a:prstClr val="black"/>
+            </a:solidFill>
+          </a:ln>
+        </p:spPr>
+        <p:txBody>
+          <a:bodyPr vert="horz" lIns="91440" tIns="45720" rIns="91440" bIns="45720" rtlCol="0" anchor="ctr"/>
+          <a:lstStyle/>
+          <a:p>
+            <a:endParaRPr lang="en-US"/>
+          </a:p>
+        </p:txBody>
+      </p:sp>
+      <p:sp>
+        <p:nvSpPr>
+          <p:cNvPr id="5" name="Notes Placeholder 4"/>
+          <p:cNvSpPr>
+            <a:spLocks noGrp="1"/>
+          </p:cNvSpPr>
+          <p:nvPr>
+            <p:ph type="body" sz="quarter" idx="3"/>
+          </p:nvPr>
+        </p:nvSpPr>
+        <p:spPr>
+          <a:xfrm>
+            <a:off x="685800" y="4343400"/>
+            <a:ext cx="5486400" cy="4114800"/>
+          </a:xfrm>
+          <a:prstGeom prst="rect">
+            <a:avLst/>
+          </a:prstGeom>
+        </p:spPr>
+        <p:txBody>
+          <a:bodyPr vert="horz" lIns="91440" tIns="45720" rIns="91440" bIns="45720" rtlCol="0"/>
+          <a:lstStyle/>
+          <a:p>
+            <a:pPr lvl="0"/>
+            <a:r>
+              <a:rPr lang="en-US" smtClean="0"/>
+              <a:t>Click to edit Master text styles</a:t>
+            </a:r>
+          </a:p>
+          <a:p>
+            <a:pPr lvl="1"/>
+            <a:r>
+              <a:rPr lang="en-US" smtClean="0"/>
+              <a:t>Second level</a:t>
+            </a:r>
+          </a:p>
+          <a:p>
+            <a:pPr lvl="2"/>
+            <a:r>
+              <a:rPr lang="en-US" smtClean="0"/>
+              <a:t>Third level</a:t>
+            </a:r>
+          </a:p>
+          <a:p>
+            <a:pPr lvl="3"/>
+            <a:r>
+              <a:rPr lang="en-US" smtClean="0"/>
+              <a:t>Fourth level</a:t>
+            </a:r>
+          </a:p>
+          <a:p>
+            <a:pPr lvl="4"/>
+            <a:r>
+              <a:rPr lang="en-US" smtClean="0"/>
+              <a:t>Fifth level</a:t>
+            </a:r>
+            <a:endParaRPr lang="en-US"/>
+          </a:p>
+        </p:txBody>
+      </p:sp>
+      <p:sp>
+        <p:nvSpPr>
+          <p:cNvPr id="6" name="Footer Placeholder 5"/>
+          <p:cNvSpPr>
+            <a:spLocks noGrp="1"/>
+          </p:cNvSpPr>
+          <p:nvPr>
+            <p:ph type="ftr" sz="quarter" idx="4"/>
+          </p:nvPr>
+        </p:nvSpPr>
+        <p:spPr>
+          <a:xfrm>
+            <a:off x="0" y="8685213"/>
+            <a:ext cx="2971800" cy="457200"/>
+          </a:xfrm>
+          <a:prstGeom prst="rect">
+            <a:avLst/>
+          </a:prstGeom>
+        </p:spPr>
+        <p:txBody>
+          <a:bodyPr vert="horz" lIns="91440" tIns="45720" rIns="91440" bIns="45720" rtlCol="0" anchor="b"/>
+          <a:lstStyle>
+            <a:lvl1pPr algn="l">
+              <a:defRPr sz="1200"/>
+            </a:lvl1pPr>
+          </a:lstStyle>
+          <a:p>
+            <a:endParaRPr lang="en-US"/>
+          </a:p>
+        </p:txBody>
+      </p:sp>
+      <p:sp>
+        <p:nvSpPr>
+          <p:cNvPr id="7" name="Slide Number Placeholder 6"/>
+          <p:cNvSpPr>
+            <a:spLocks noGrp="1"/>
+          </p:cNvSpPr>
+          <p:nvPr>
+            <p:ph type="sldNum" sz="quarter" idx="5"/>
+          </p:nvPr>
+        </p:nvSpPr>
+        <p:spPr>
+          <a:xfrm>
+            <a:off x="3884613" y="8685213"/>
+            <a:ext cx="2971800" cy="457200"/>
+          </a:xfrm>
+          <a:prstGeom prst="rect">
+            <a:avLst/>
+          </a:prstGeom>
+        </p:spPr>
+        <p:txBody>
+          <a:bodyPr vert="horz" lIns="91440" tIns="45720" rIns="91440" bIns="45720" rtlCol="0" anchor="b"/>
+          <a:lstStyle>
+            <a:lvl1pPr algn="r">
+              <a:defRPr sz="1200"/>
+            </a:lvl1pPr>
+          </a:lstStyle>
+          <a:p>
+            <a:fld id="{BB5E49A5-4136-284D-997B-48E1D791AD67}" type="slidenum">
+              <a:rPr lang="en-US" smtClean="0"/>
+              <a:t>‹#›</a:t>
+            </a:fld>
+            <a:endParaRPr lang="en-US"/>
+          </a:p>
+        </p:txBody>
+      </p:sp>
+    </p:spTree>
+    <p:extLst>
+      <p:ext uri="{BB962C8B-B14F-4D97-AF65-F5344CB8AC3E}">
+        <p14:creationId xmlns:p14="http://schemas.microsoft.com/office/powerpoint/2010/main" val="2623252185"/>
+      </p:ext>
+    </p:extLst>
+  </p:cSld>
+  <p:clrMap bg1="lt1" tx1="dk1" bg2="lt2" tx2="dk2" accent1="accent1" accent2="accent2" accent3="accent3" accent4="accent4" accent5="accent5" accent6="accent6" hlink="hlink" folHlink="folHlink"/>
+  <p:notesStyle>
+    <a:lvl1pPr marL="0" algn="l" defTabSz="457200" rtl="0" eaLnBrk="1" latinLnBrk="0" hangingPunct="1">
+      <a:defRPr sz="1200" kern="1200">
+        <a:solidFill>
+          <a:schemeClr val="tx1"/>
+        </a:solidFill>
+        <a:latin typeface="+mn-lt"/>
+        <a:ea typeface="+mn-ea"/>
+        <a:cs typeface="+mn-cs"/>
+      </a:defRPr>
+    </a:lvl1pPr>
+    <a:lvl2pPr marL="457200" algn="l" defTabSz="457200" rtl="0" eaLnBrk="1" latinLnBrk="0" hangingPunct="1">
+      <a:defRPr sz="1200" kern="1200">
+        <a:solidFill>
+          <a:schemeClr val="tx1"/>
+        </a:solidFill>
+        <a:latin typeface="+mn-lt"/>
+        <a:ea typeface="+mn-ea"/>
+        <a:cs typeface="+mn-cs"/>
+      </a:defRPr>
+    </a:lvl2pPr>
+    <a:lvl3pPr marL="914400" algn="l" defTabSz="457200" rtl="0" eaLnBrk="1" latinLnBrk="0" hangingPunct="1">
+      <a:defRPr sz="1200" kern="1200">
+        <a:solidFill>
+          <a:schemeClr val="tx1"/>
+        </a:solidFill>
+        <a:latin typeface="+mn-lt"/>
+        <a:ea typeface="+mn-ea"/>
+        <a:cs typeface="+mn-cs"/>
+      </a:defRPr>
+    </a:lvl3pPr>
+    <a:lvl4pPr marL="1371600" algn="l" defTabSz="457200" rtl="0" eaLnBrk="1" latinLnBrk="0" hangingPunct="1">
+      <a:defRPr sz="1200" kern="1200">
+        <a:solidFill>
+          <a:schemeClr val="tx1"/>
+        </a:solidFill>
+        <a:latin typeface="+mn-lt"/>
+        <a:ea typeface="+mn-ea"/>
+        <a:cs typeface="+mn-cs"/>
+      </a:defRPr>
+    </a:lvl4pPr>
+    <a:lvl5pPr marL="1828800" algn="l" defTabSz="457200" rtl="0" eaLnBrk="1" latinLnBrk="0" hangingPunct="1">
+      <a:defRPr sz="1200" kern="1200">
+        <a:solidFill>
+          <a:schemeClr val="tx1"/>
+        </a:solidFill>
+        <a:latin typeface="+mn-lt"/>
+        <a:ea typeface="+mn-ea"/>
+        <a:cs typeface="+mn-cs"/>
+      </a:defRPr>
+    </a:lvl5pPr>
+    <a:lvl6pPr marL="2286000" algn="l" defTabSz="457200" rtl="0" eaLnBrk="1" latinLnBrk="0" hangingPunct="1">
+      <a:defRPr sz="1200" kern="1200">
+        <a:solidFill>
+          <a:schemeClr val="tx1"/>
+        </a:solidFill>
+        <a:latin typeface="+mn-lt"/>
+        <a:ea typeface="+mn-ea"/>
+        <a:cs typeface="+mn-cs"/>
+      </a:defRPr>
+    </a:lvl6pPr>
+    <a:lvl7pPr marL="2743200" algn="l" defTabSz="457200" rtl="0" eaLnBrk="1" latinLnBrk="0" hangingPunct="1">
+      <a:defRPr sz="1200" kern="1200">
+        <a:solidFill>
+          <a:schemeClr val="tx1"/>
+        </a:solidFill>
+        <a:latin typeface="+mn-lt"/>
+        <a:ea typeface="+mn-ea"/>
+        <a:cs typeface="+mn-cs"/>
+      </a:defRPr>
+    </a:lvl7pPr>
+    <a:lvl8pPr marL="3200400" algn="l" defTabSz="457200" rtl="0" eaLnBrk="1" latinLnBrk="0" hangingPunct="1">
+      <a:defRPr sz="1200" kern="1200">
+        <a:solidFill>
+          <a:schemeClr val="tx1"/>
+        </a:solidFill>
+        <a:latin typeface="+mn-lt"/>
+        <a:ea typeface="+mn-ea"/>
+        <a:cs typeface="+mn-cs"/>
+      </a:defRPr>
+    </a:lvl8pPr>
+    <a:lvl9pPr marL="3657600" algn="l" defTabSz="457200" rtl="0" eaLnBrk="1" latinLnBrk="0" hangingPunct="1">
+      <a:defRPr sz="1200" kern="1200">
+        <a:solidFill>
+          <a:schemeClr val="tx1"/>
+        </a:solidFill>
+        <a:latin typeface="+mn-lt"/>
+        <a:ea typeface="+mn-ea"/>
+        <a:cs typeface="+mn-cs"/>
+      </a:defRPr>
+    </a:lvl9pPr>
+  </p:notesStyle>
+</p:notesMaster>
+</file>
+
+<file path=ppt/notesSlides/notesSlide1.xml><?xml version="1.0" encoding="utf-8"?>
+<p:notes xmlns:a="http://schemas.openxmlformats.org/drawingml/2006/main" xmlns:p="http://schemas.openxmlformats.org/presentationml/2006/main" xmlns:r="http://schemas.openxmlformats.org/officeDocument/2006/relationships">
+  <p:cSld>
+    <p:spTree>
+      <p:nvGrpSpPr>
+        <p:cNvPr id="1" name=""/>
+        <p:cNvGrpSpPr/>
+        <p:nvPr/>
+      </p:nvGrpSpPr>
+      <p:grpSpPr>
+        <a:xfrm>
+          <a:off x="0" y="0"/>
+          <a:ext cx="0" cy="0"/>
+          <a:chOff x="0" y="0"/>
+          <a:chExt cx="0" cy="0"/>
+        </a:xfrm>
+      </p:grpSpPr>
+      <p:sp>
+        <p:nvSpPr>
+          <p:cNvPr id="2" name="Slide Image Placeholder 1"/>
+          <p:cNvSpPr>
+            <a:spLocks noGrp="1"/>
+          </p:cNvSpPr>
+          <p:nvPr>
+            <p:ph type="sldImg" idx="2"/>
+          </p:nvPr>
+        </p:nvSpPr>
+        <p:spPr/>
+      </p:sp>
+      <p:sp>
+        <p:nvSpPr>
+          <p:cNvPr id="3" name="Notes Placeholder 2"/>
+          <p:cNvSpPr>
+            <a:spLocks noGrp="1"/>
+          </p:cNvSpPr>
+          <p:nvPr>
+            <p:ph type="body" idx="3" sz="quarter"/>
+          </p:nvPr>
+        </p:nvSpPr>
+        <p:spPr/>
+        <p:txBody>
+          <a:bodyPr/>
+          <a:lstStyle/>
+          <a:p>
+            <a:r>
+              <a:t>Số liệu lấy từ phần mềm, chạy bộ du_lieu_test/bo_sach với hạt giống bốc thăm 42: 140 học sinh, 12 CLB, 150 chỗ, trong đó 16 suất dự trữ. Cả 140 học sinh đều có CLB; 9 trên 12 CLB kín chỗ, còn 10 chỗ trống. 54 học sinh (39%) được nguyện vọng 1. Tỉ lệ nguyện vọng 1 không cao vì bộ này cố ý cho mọi học sinh thi 4 CLB và ghi 6 nguyện vọng, nên nguyện vọng đầu cạnh tranh gắt. Đây là dữ liệu mô phỏng.</a:t>
+            </a:r>
+          </a:p>
+        </p:txBody>
+      </p:sp>
+      <p:sp>
+        <p:nvSpPr>
+          <p:cNvPr id="4" name="Slide Number Placeholder 3"/>
+          <p:cNvSpPr>
+            <a:spLocks noGrp="1"/>
+          </p:cNvSpPr>
+          <p:nvPr>
+            <p:ph type="sldNum" idx="5" sz="quarter"/>
+          </p:nvPr>
+        </p:nvSpPr>
+        <p:spPr/>
+      </p:sp>
+    </p:spTree>
+  </p:cSld>
+  <p:clrMapOvr>
+    <a:masterClrMapping/>
+  </p:clrMapOvr>
+</p:notes>
 </file>
 
 <file path=ppt/slideLayouts/slideLayout1.xml><?xml version="1.0" encoding="utf-8"?>
@@ -5522,35 +6158,397 @@
           <a:lstStyle/>
           <a:p>
             <a:r>
-              <a:rPr lang="vi-VN"/>
-              <a:t>Thử nghiệm với 140 HS, 12 CLB, 120 suất</a:t>
+              <a:rPr lang="vi-VN" sz="3800"/>
+              <a:t>Thử nghiệm với 140 HS, 12 CLB, 150 suất</a:t>
             </a:r>
             <a:endParaRPr lang="vi-VN" dirty="0"/>
           </a:p>
         </p:txBody>
       </p:sp>
-      <p:sp>
-        <p:nvSpPr>
-          <p:cNvPr id="3" name="Content Placeholder 2">
-            <a:extLst>
-              <a:ext uri="{FF2B5EF4-FFF2-40B4-BE49-F238E27FC236}">
-                <a16:creationId xmlns:a16="http://schemas.microsoft.com/office/drawing/2014/main" id="{C05F248B-CB00-2361-7C5C-1E9E80AFDE61}"/>
-              </a:ext>
-            </a:extLst>
-          </p:cNvPr>
-          <p:cNvSpPr>
-            <a:spLocks noGrp="1"/>
-          </p:cNvSpPr>
-          <p:nvPr>
-            <p:ph idx="1"/>
-          </p:nvPr>
-        </p:nvSpPr>
-        <p:spPr/>
-        <p:txBody>
-          <a:bodyPr/>
+      <p:pic>
+        <p:nvPicPr>
+          <p:cNvPr id="3" name="Picture 2" descr="c_sach_results.png"/>
+          <p:cNvPicPr>
+            <a:picLocks noChangeAspect="1"/>
+          </p:cNvPicPr>
+          <p:nvPr/>
+        </p:nvPicPr>
+        <p:blipFill>
+          <a:blip r:embed="rId2"/>
+          <a:stretch>
+            <a:fillRect/>
+          </a:stretch>
+        </p:blipFill>
+        <p:spPr>
+          <a:xfrm>
+            <a:off x="841248" y="1783080"/>
+            <a:ext cx="5120640" cy="3778679"/>
+          </a:xfrm>
+          <a:prstGeom prst="rect">
+            <a:avLst/>
+          </a:prstGeom>
+          <a:ln w="9525">
+            <a:solidFill>
+              <a:srgbClr val="D0D0D0"/>
+            </a:solidFill>
+          </a:ln>
+        </p:spPr>
+      </p:pic>
+      <p:sp>
+        <p:nvSpPr>
+          <p:cNvPr id="4" name="TextBox 3"/>
+          <p:cNvSpPr txBox="1"/>
+          <p:nvPr/>
+        </p:nvSpPr>
+        <p:spPr>
+          <a:xfrm>
+            <a:off x="841248" y="5634911"/>
+            <a:ext cx="5120640" cy="274320"/>
+          </a:xfrm>
+          <a:prstGeom prst="rect">
+            <a:avLst/>
+          </a:prstGeom>
+          <a:noFill/>
+        </p:spPr>
+        <p:txBody>
+          <a:bodyPr wrap="square" lIns="0" rIns="0" tIns="0" bIns="0">
+            <a:spAutoFit/>
+          </a:bodyPr>
           <a:lstStyle/>
           <a:p>
-            <a:endParaRPr lang="vi-VN" dirty="0"/>
+            <a:r>
+              <a:rPr sz="1100" b="0" i="1" lang="vi-VN">
+                <a:solidFill>
+                  <a:srgbClr val="595959"/>
+                </a:solidFill>
+                <a:latin typeface="Arial"/>
+              </a:rPr>
+              <a:t>Màn hình Kết quả của phần mềm. Xanh: xét chung. Vàng: vào bằng suất dự trữ.</a:t>
+            </a:r>
+          </a:p>
+        </p:txBody>
+      </p:sp>
+      <p:sp>
+        <p:nvSpPr>
+          <p:cNvPr id="5" name="TextBox 4"/>
+          <p:cNvSpPr txBox="1"/>
+          <p:nvPr/>
+        </p:nvSpPr>
+        <p:spPr>
+          <a:xfrm>
+            <a:off x="6355080" y="1783080"/>
+            <a:ext cx="2377440" cy="457200"/>
+          </a:xfrm>
+          <a:prstGeom prst="rect">
+            <a:avLst/>
+          </a:prstGeom>
+          <a:noFill/>
+        </p:spPr>
+        <p:txBody>
+          <a:bodyPr wrap="square" lIns="0" rIns="0" tIns="0" bIns="0">
+            <a:spAutoFit/>
+          </a:bodyPr>
+          <a:lstStyle/>
+          <a:p>
+            <a:r>
+              <a:rPr sz="2600" b="1" i="0" lang="vi-VN">
+                <a:solidFill>
+                  <a:srgbClr val="3F6B52"/>
+                </a:solidFill>
+                <a:latin typeface="Arial"/>
+              </a:rPr>
+              <a:t>140/140</a:t>
+            </a:r>
+          </a:p>
+        </p:txBody>
+      </p:sp>
+      <p:sp>
+        <p:nvSpPr>
+          <p:cNvPr id="6" name="TextBox 5"/>
+          <p:cNvSpPr txBox="1"/>
+          <p:nvPr/>
+        </p:nvSpPr>
+        <p:spPr>
+          <a:xfrm>
+            <a:off x="6355080" y="2240280"/>
+            <a:ext cx="2377440" cy="320040"/>
+          </a:xfrm>
+          <a:prstGeom prst="rect">
+            <a:avLst/>
+          </a:prstGeom>
+          <a:noFill/>
+        </p:spPr>
+        <p:txBody>
+          <a:bodyPr wrap="square" lIns="0" rIns="0" tIns="0" bIns="0">
+            <a:spAutoFit/>
+          </a:bodyPr>
+          <a:lstStyle/>
+          <a:p>
+            <a:r>
+              <a:rPr sz="1200" b="0" i="0" lang="vi-VN">
+                <a:solidFill>
+                  <a:srgbClr val="595959"/>
+                </a:solidFill>
+                <a:latin typeface="Arial"/>
+              </a:rPr>
+              <a:t>học sinh có CLB</a:t>
+            </a:r>
+          </a:p>
+        </p:txBody>
+      </p:sp>
+      <p:sp>
+        <p:nvSpPr>
+          <p:cNvPr id="7" name="TextBox 6"/>
+          <p:cNvSpPr txBox="1"/>
+          <p:nvPr/>
+        </p:nvSpPr>
+        <p:spPr>
+          <a:xfrm>
+            <a:off x="8869680" y="1783080"/>
+            <a:ext cx="2377440" cy="457200"/>
+          </a:xfrm>
+          <a:prstGeom prst="rect">
+            <a:avLst/>
+          </a:prstGeom>
+          <a:noFill/>
+        </p:spPr>
+        <p:txBody>
+          <a:bodyPr wrap="square" lIns="0" rIns="0" tIns="0" bIns="0">
+            <a:spAutoFit/>
+          </a:bodyPr>
+          <a:lstStyle/>
+          <a:p>
+            <a:r>
+              <a:rPr sz="2600" b="1" i="0" lang="vi-VN">
+                <a:solidFill>
+                  <a:srgbClr val="3F6B52"/>
+                </a:solidFill>
+                <a:latin typeface="Arial"/>
+              </a:rPr>
+              <a:t>39%</a:t>
+            </a:r>
+          </a:p>
+        </p:txBody>
+      </p:sp>
+      <p:sp>
+        <p:nvSpPr>
+          <p:cNvPr id="8" name="TextBox 7"/>
+          <p:cNvSpPr txBox="1"/>
+          <p:nvPr/>
+        </p:nvSpPr>
+        <p:spPr>
+          <a:xfrm>
+            <a:off x="8869680" y="2240280"/>
+            <a:ext cx="2377440" cy="320040"/>
+          </a:xfrm>
+          <a:prstGeom prst="rect">
+            <a:avLst/>
+          </a:prstGeom>
+          <a:noFill/>
+        </p:spPr>
+        <p:txBody>
+          <a:bodyPr wrap="square" lIns="0" rIns="0" tIns="0" bIns="0">
+            <a:spAutoFit/>
+          </a:bodyPr>
+          <a:lstStyle/>
+          <a:p>
+            <a:r>
+              <a:rPr sz="1200" b="0" i="0" lang="vi-VN">
+                <a:solidFill>
+                  <a:srgbClr val="595959"/>
+                </a:solidFill>
+                <a:latin typeface="Arial"/>
+              </a:rPr>
+              <a:t>được nguyện vọng 1</a:t>
+            </a:r>
+          </a:p>
+        </p:txBody>
+      </p:sp>
+      <p:sp>
+        <p:nvSpPr>
+          <p:cNvPr id="9" name="TextBox 8"/>
+          <p:cNvSpPr txBox="1"/>
+          <p:nvPr/>
+        </p:nvSpPr>
+        <p:spPr>
+          <a:xfrm>
+            <a:off x="6355080" y="2651760"/>
+            <a:ext cx="2377440" cy="457200"/>
+          </a:xfrm>
+          <a:prstGeom prst="rect">
+            <a:avLst/>
+          </a:prstGeom>
+          <a:noFill/>
+        </p:spPr>
+        <p:txBody>
+          <a:bodyPr wrap="square" lIns="0" rIns="0" tIns="0" bIns="0">
+            <a:spAutoFit/>
+          </a:bodyPr>
+          <a:lstStyle/>
+          <a:p>
+            <a:r>
+              <a:rPr sz="2600" b="1" i="0" lang="vi-VN">
+                <a:solidFill>
+                  <a:srgbClr val="3F6B52"/>
+                </a:solidFill>
+                <a:latin typeface="Arial"/>
+              </a:rPr>
+              <a:t>16</a:t>
+            </a:r>
+          </a:p>
+        </p:txBody>
+      </p:sp>
+      <p:sp>
+        <p:nvSpPr>
+          <p:cNvPr id="10" name="TextBox 9"/>
+          <p:cNvSpPr txBox="1"/>
+          <p:nvPr/>
+        </p:nvSpPr>
+        <p:spPr>
+          <a:xfrm>
+            <a:off x="6355080" y="3108960"/>
+            <a:ext cx="2377440" cy="320040"/>
+          </a:xfrm>
+          <a:prstGeom prst="rect">
+            <a:avLst/>
+          </a:prstGeom>
+          <a:noFill/>
+        </p:spPr>
+        <p:txBody>
+          <a:bodyPr wrap="square" lIns="0" rIns="0" tIns="0" bIns="0">
+            <a:spAutoFit/>
+          </a:bodyPr>
+          <a:lstStyle/>
+          <a:p>
+            <a:r>
+              <a:rPr sz="1200" b="0" i="0" lang="vi-VN">
+                <a:solidFill>
+                  <a:srgbClr val="595959"/>
+                </a:solidFill>
+                <a:latin typeface="Arial"/>
+              </a:rPr>
+              <a:t>học sinh vào bằng suất dự trữ</a:t>
+            </a:r>
+          </a:p>
+        </p:txBody>
+      </p:sp>
+      <p:sp>
+        <p:nvSpPr>
+          <p:cNvPr id="11" name="TextBox 10"/>
+          <p:cNvSpPr txBox="1"/>
+          <p:nvPr/>
+        </p:nvSpPr>
+        <p:spPr>
+          <a:xfrm>
+            <a:off x="8869680" y="2651760"/>
+            <a:ext cx="2377440" cy="457200"/>
+          </a:xfrm>
+          <a:prstGeom prst="rect">
+            <a:avLst/>
+          </a:prstGeom>
+          <a:noFill/>
+        </p:spPr>
+        <p:txBody>
+          <a:bodyPr wrap="square" lIns="0" rIns="0" tIns="0" bIns="0">
+            <a:spAutoFit/>
+          </a:bodyPr>
+          <a:lstStyle/>
+          <a:p>
+            <a:r>
+              <a:rPr sz="2600" b="1" i="0" lang="vi-VN">
+                <a:solidFill>
+                  <a:srgbClr val="3F6B52"/>
+                </a:solidFill>
+                <a:latin typeface="Arial"/>
+              </a:rPr>
+              <a:t>0,02 giây</a:t>
+            </a:r>
+          </a:p>
+        </p:txBody>
+      </p:sp>
+      <p:sp>
+        <p:nvSpPr>
+          <p:cNvPr id="12" name="TextBox 11"/>
+          <p:cNvSpPr txBox="1"/>
+          <p:nvPr/>
+        </p:nvSpPr>
+        <p:spPr>
+          <a:xfrm>
+            <a:off x="8869680" y="3108960"/>
+            <a:ext cx="2377440" cy="320040"/>
+          </a:xfrm>
+          <a:prstGeom prst="rect">
+            <a:avLst/>
+          </a:prstGeom>
+          <a:noFill/>
+        </p:spPr>
+        <p:txBody>
+          <a:bodyPr wrap="square" lIns="0" rIns="0" tIns="0" bIns="0">
+            <a:spAutoFit/>
+          </a:bodyPr>
+          <a:lstStyle/>
+          <a:p>
+            <a:r>
+              <a:rPr sz="1200" b="0" i="0" lang="vi-VN">
+                <a:solidFill>
+                  <a:srgbClr val="595959"/>
+                </a:solidFill>
+                <a:latin typeface="Arial"/>
+              </a:rPr>
+              <a:t>thời gian chạy sắp xếp</a:t>
+            </a:r>
+          </a:p>
+        </p:txBody>
+      </p:sp>
+      <p:graphicFrame>
+        <p:nvGraphicFramePr>
+          <p:cNvPr id="13" name="Chart 12"/>
+          <p:cNvGraphicFramePr>
+            <a:graphicFrameLocks noGrp="1"/>
+          </p:cNvGraphicFramePr>
+          <p:nvPr/>
+        </p:nvGraphicFramePr>
+        <p:xfrm>
+          <a:off x="6355080" y="3611880"/>
+          <a:ext cx="5001768" cy="2331720"/>
+        </p:xfrm>
+        <a:graphic>
+          <a:graphicData uri="http://schemas.openxmlformats.org/drawingml/2006/chart">
+            <c:chart xmlns:c="http://schemas.openxmlformats.org/drawingml/2006/chart" r:id="rId3"/>
+          </a:graphicData>
+        </a:graphic>
+      </p:graphicFrame>
+      <p:sp>
+        <p:nvSpPr>
+          <p:cNvPr id="14" name="TextBox 13"/>
+          <p:cNvSpPr txBox="1"/>
+          <p:nvPr/>
+        </p:nvSpPr>
+        <p:spPr>
+          <a:xfrm>
+            <a:off x="841248" y="6144768"/>
+            <a:ext cx="10515600" cy="274320"/>
+          </a:xfrm>
+          <a:prstGeom prst="rect">
+            <a:avLst/>
+          </a:prstGeom>
+          <a:noFill/>
+        </p:spPr>
+        <p:txBody>
+          <a:bodyPr wrap="square" lIns="0" rIns="0" tIns="0" bIns="0">
+            <a:spAutoFit/>
+          </a:bodyPr>
+          <a:lstStyle/>
+          <a:p>
+            <a:r>
+              <a:rPr sz="1100" b="0" i="1" lang="vi-VN">
+                <a:solidFill>
+                  <a:srgbClr val="B84A3E"/>
+                </a:solidFill>
+                <a:latin typeface="Arial"/>
+              </a:rPr>
+              <a:t>Dữ liệu mô phỏng do máy tạo ra (bộ bo_sach), không phải học sinh thật. Mỗi học sinh thi 4 CLB và ghi 6 nguyện vọng.</a:t>
+            </a:r>
           </a:p>
         </p:txBody>
       </p:sp>
@@ -5987,4 +6985,324 @@
     </a:ext>
   </a:extLst>
 </a:theme>
+</file>
+
+<file path=ppt/theme/theme2.xml><?xml version="1.0" encoding="utf-8"?>
+<a:theme xmlns:a="http://schemas.openxmlformats.org/drawingml/2006/main" name="Office Theme">
+  <a:themeElements>
+    <a:clrScheme name="Office">
+      <a:dk1>
+        <a:sysClr val="windowText" lastClr="000000"/>
+      </a:dk1>
+      <a:lt1>
+        <a:sysClr val="window" lastClr="FFFFFF"/>
+      </a:lt1>
+      <a:dk2>
+        <a:srgbClr val="1F497D"/>
+      </a:dk2>
+      <a:lt2>
+        <a:srgbClr val="EEECE1"/>
+      </a:lt2>
+      <a:accent1>
+        <a:srgbClr val="4F81BD"/>
+      </a:accent1>
+      <a:accent2>
+        <a:srgbClr val="C0504D"/>
+      </a:accent2>
+      <a:accent3>
+        <a:srgbClr val="9BBB59"/>
+      </a:accent3>
+      <a:accent4>
+        <a:srgbClr val="8064A2"/>
+      </a:accent4>
+      <a:accent5>
+        <a:srgbClr val="4BACC6"/>
+      </a:accent5>
+      <a:accent6>
+        <a:srgbClr val="F79646"/>
+      </a:accent6>
+      <a:hlink>
+        <a:srgbClr val="0000FF"/>
+      </a:hlink>
+      <a:folHlink>
+        <a:srgbClr val="800080"/>
+      </a:folHlink>
+    </a:clrScheme>
+    <a:fontScheme name="Office">
+      <a:majorFont>
+        <a:latin typeface="Calibri"/>
+        <a:ea typeface=""/>
+        <a:cs typeface=""/>
+        <a:font script="Jpan" typeface="ＭＳ Ｐゴシック"/>
+        <a:font script="Hang" typeface="맑은 고딕"/>
+        <a:font script="Hans" typeface="宋体"/>
+        <a:font script="Hant" typeface="新細明體"/>
+        <a:font script="Arab" typeface="Times New Roman"/>
+        <a:font script="Hebr" typeface="Times New Roman"/>
+        <a:font script="Thai" typeface="Angsana New"/>
+        <a:font script="Ethi" typeface="Nyala"/>
+        <a:font script="Beng" typeface="Vrinda"/>
+        <a:font script="Gujr" typeface="Shruti"/>
+        <a:font script="Khmr" typeface="MoolBoran"/>
+        <a:font script="Knda" typeface="Tunga"/>
+        <a:font script="Guru" typeface="Raavi"/>
+        <a:font script="Cans" typeface="Euphemia"/>
+        <a:font script="Cher" typeface="Plantagenet Cherokee"/>
+        <a:font script="Yiii" typeface="Microsoft Yi Baiti"/>
+        <a:font script="Tibt" typeface="Microsoft Himalaya"/>
+        <a:font script="Thaa" typeface="MV Boli"/>
+        <a:font script="Deva" typeface="Mangal"/>
+        <a:font script="Telu" typeface="Gautami"/>
+        <a:font script="Taml" typeface="Latha"/>
+        <a:font script="Syrc" typeface="Estrangelo Edessa"/>
+        <a:font script="Orya" typeface="Kalinga"/>
+        <a:font script="Mlym" typeface="Kartika"/>
+        <a:font script="Laoo" typeface="DokChampa"/>
+        <a:font script="Sinh" typeface="Iskoola Pota"/>
+        <a:font script="Mong" typeface="Mongolian Baiti"/>
+        <a:font script="Viet" typeface="Times New Roman"/>
+        <a:font script="Uigh" typeface="Microsoft Uighur"/>
+        <a:font script="Geor" typeface="Sylfaen"/>
+      </a:majorFont>
+      <a:minorFont>
+        <a:latin typeface="Calibri"/>
+        <a:ea typeface=""/>
+        <a:cs typeface=""/>
+        <a:font script="Jpan" typeface="ＭＳ Ｐゴシック"/>
+        <a:font script="Hang" typeface="맑은 고딕"/>
+        <a:font script="Hans" typeface="宋体"/>
+        <a:font script="Hant" typeface="新細明體"/>
+        <a:font script="Arab" typeface="Arial"/>
+        <a:font script="Hebr" typeface="Arial"/>
+        <a:font script="Thai" typeface="Cordia New"/>
+        <a:font script="Ethi" typeface="Nyala"/>
+        <a:font script="Beng" typeface="Vrinda"/>
+        <a:font script="Gujr" typeface="Shruti"/>
+        <a:font script="Khmr" typeface="DaunPenh"/>
+        <a:font script="Knda" typeface="Tunga"/>
+        <a:font script="Guru" typeface="Raavi"/>
+        <a:font script="Cans" typeface="Euphemia"/>
+        <a:font script="Cher" typeface="Plantagenet Cherokee"/>
+        <a:font script="Yiii" typeface="Microsoft Yi Baiti"/>
+        <a:font script="Tibt" typeface="Microsoft Himalaya"/>
+        <a:font script="Thaa" typeface="MV Boli"/>
+        <a:font script="Deva" typeface="Mangal"/>
+        <a:font script="Telu" typeface="Gautami"/>
+        <a:font script="Taml" typeface="Latha"/>
+        <a:font script="Syrc" typeface="Estrangelo Edessa"/>
+        <a:font script="Orya" typeface="Kalinga"/>
+        <a:font script="Mlym" typeface="Kartika"/>
+        <a:font script="Laoo" typeface="DokChampa"/>
+        <a:font script="Sinh" typeface="Iskoola Pota"/>
+        <a:font script="Mong" typeface="Mongolian Baiti"/>
+        <a:font script="Viet" typeface="Arial"/>
+        <a:font script="Uigh" typeface="Microsoft Uighur"/>
+        <a:font script="Geor" typeface="Sylfaen"/>
+      </a:minorFont>
+    </a:fontScheme>
+    <a:fmtScheme name="Office">
+      <a:fillStyleLst>
+        <a:solidFill>
+          <a:schemeClr val="phClr"/>
+        </a:solidFill>
+        <a:gradFill rotWithShape="1">
+          <a:gsLst>
+            <a:gs pos="0">
+              <a:schemeClr val="phClr">
+                <a:tint val="50000"/>
+                <a:satMod val="300000"/>
+              </a:schemeClr>
+            </a:gs>
+            <a:gs pos="35000">
+              <a:schemeClr val="phClr">
+                <a:tint val="37000"/>
+                <a:satMod val="300000"/>
+              </a:schemeClr>
+            </a:gs>
+            <a:gs pos="100000">
+              <a:schemeClr val="phClr">
+                <a:tint val="15000"/>
+                <a:satMod val="350000"/>
+              </a:schemeClr>
+            </a:gs>
+          </a:gsLst>
+          <a:lin ang="16200000" scaled="1"/>
+        </a:gradFill>
+        <a:gradFill rotWithShape="1">
+          <a:gsLst>
+            <a:gs pos="0">
+              <a:schemeClr val="phClr">
+                <a:tint val="100000"/>
+                <a:shade val="100000"/>
+                <a:satMod val="130000"/>
+              </a:schemeClr>
+            </a:gs>
+            <a:gs pos="100000">
+              <a:schemeClr val="phClr">
+                <a:tint val="50000"/>
+                <a:shade val="100000"/>
+                <a:satMod val="350000"/>
+              </a:schemeClr>
+            </a:gs>
+          </a:gsLst>
+          <a:lin ang="16200000" scaled="0"/>
+        </a:gradFill>
+      </a:fillStyleLst>
+      <a:lnStyleLst>
+        <a:ln w="9525" cap="flat" cmpd="sng" algn="ctr">
+          <a:solidFill>
+            <a:schemeClr val="phClr">
+              <a:shade val="95000"/>
+              <a:satMod val="105000"/>
+            </a:schemeClr>
+          </a:solidFill>
+          <a:prstDash val="solid"/>
+        </a:ln>
+        <a:ln w="25400" cap="flat" cmpd="sng" algn="ctr">
+          <a:solidFill>
+            <a:schemeClr val="phClr"/>
+          </a:solidFill>
+          <a:prstDash val="solid"/>
+        </a:ln>
+        <a:ln w="38100" cap="flat" cmpd="sng" algn="ctr">
+          <a:solidFill>
+            <a:schemeClr val="phClr"/>
+          </a:solidFill>
+          <a:prstDash val="solid"/>
+        </a:ln>
+      </a:lnStyleLst>
+      <a:effectStyleLst>
+        <a:effectStyle>
+          <a:effectLst>
+            <a:outerShdw blurRad="40000" dist="20000" dir="5400000" rotWithShape="0">
+              <a:srgbClr val="000000">
+                <a:alpha val="38000"/>
+              </a:srgbClr>
+            </a:outerShdw>
+          </a:effectLst>
+        </a:effectStyle>
+        <a:effectStyle>
+          <a:effectLst>
+            <a:outerShdw blurRad="40000" dist="23000" dir="5400000" rotWithShape="0">
+              <a:srgbClr val="000000">
+                <a:alpha val="35000"/>
+              </a:srgbClr>
+            </a:outerShdw>
+          </a:effectLst>
+        </a:effectStyle>
+        <a:effectStyle>
+          <a:effectLst>
+            <a:outerShdw blurRad="40000" dist="23000" dir="5400000" rotWithShape="0">
+              <a:srgbClr val="000000">
+                <a:alpha val="35000"/>
+              </a:srgbClr>
+            </a:outerShdw>
+          </a:effectLst>
+          <a:scene3d>
+            <a:camera prst="orthographicFront">
+              <a:rot lat="0" lon="0" rev="0"/>
+            </a:camera>
+            <a:lightRig rig="threePt" dir="t">
+              <a:rot lat="0" lon="0" rev="1200000"/>
+            </a:lightRig>
+          </a:scene3d>
+          <a:sp3d>
+            <a:bevelT w="63500" h="25400"/>
+          </a:sp3d>
+        </a:effectStyle>
+      </a:effectStyleLst>
+      <a:bgFillStyleLst>
+        <a:solidFill>
+          <a:schemeClr val="phClr"/>
+        </a:solidFill>
+        <a:gradFill rotWithShape="1">
+          <a:gsLst>
+            <a:gs pos="0">
+              <a:schemeClr val="phClr">
+                <a:tint val="40000"/>
+                <a:satMod val="350000"/>
+              </a:schemeClr>
+            </a:gs>
+            <a:gs pos="40000">
+              <a:schemeClr val="phClr">
+                <a:tint val="45000"/>
+                <a:shade val="99000"/>
+                <a:satMod val="350000"/>
+              </a:schemeClr>
+            </a:gs>
+            <a:gs pos="100000">
+              <a:schemeClr val="phClr">
+                <a:shade val="20000"/>
+                <a:satMod val="255000"/>
+              </a:schemeClr>
+            </a:gs>
+          </a:gsLst>
+          <a:path path="circle">
+            <a:fillToRect l="50000" t="-80000" r="50000" b="180000"/>
+          </a:path>
+        </a:gradFill>
+        <a:gradFill rotWithShape="1">
+          <a:gsLst>
+            <a:gs pos="0">
+              <a:schemeClr val="phClr">
+                <a:tint val="80000"/>
+                <a:satMod val="300000"/>
+              </a:schemeClr>
+            </a:gs>
+            <a:gs pos="100000">
+              <a:schemeClr val="phClr">
+                <a:shade val="30000"/>
+                <a:satMod val="200000"/>
+              </a:schemeClr>
+            </a:gs>
+          </a:gsLst>
+          <a:path path="circle">
+            <a:fillToRect l="50000" t="50000" r="50000" b="50000"/>
+          </a:path>
+        </a:gradFill>
+      </a:bgFillStyleLst>
+    </a:fmtScheme>
+  </a:themeElements>
+  <a:objectDefaults>
+    <a:spDef>
+      <a:spPr/>
+      <a:bodyPr/>
+      <a:lstStyle/>
+      <a:style>
+        <a:lnRef idx="1">
+          <a:schemeClr val="accent1"/>
+        </a:lnRef>
+        <a:fillRef idx="3">
+          <a:schemeClr val="accent1"/>
+        </a:fillRef>
+        <a:effectRef idx="2">
+          <a:schemeClr val="accent1"/>
+        </a:effectRef>
+        <a:fontRef idx="minor">
+          <a:schemeClr val="lt1"/>
+        </a:fontRef>
+      </a:style>
+    </a:spDef>
+    <a:lnDef>
+      <a:spPr/>
+      <a:bodyPr/>
+      <a:lstStyle/>
+      <a:style>
+        <a:lnRef idx="2">
+          <a:schemeClr val="accent1"/>
+        </a:lnRef>
+        <a:fillRef idx="0">
+          <a:schemeClr val="accent1"/>
+        </a:fillRef>
+        <a:effectRef idx="1">
+          <a:schemeClr val="accent1"/>
+        </a:effectRef>
+        <a:fontRef idx="minor">
+          <a:schemeClr val="tx1"/>
+        </a:fontRef>
+      </a:style>
+    </a:lnDef>
+  </a:objectDefaults>
+  <a:extraClrSchemeLst/>
+</a:theme>
 </file>
</xml_diff>

<commit_message>
Redesign slides 2 to 5 of the science-fair deck
The contents, problem, solution and steps slides were plain bullet
lists. They are now a numbered card grid, four problem cards with
icons, a three-stage input/software/output flow, and a numbered step
timeline. The wording is unchanged; only the layout and styling differ,
matching the green accent and Arial type already used on slide 8.

Co-Authored-By: Claude Opus 5.5 <noreply@anthropic.com>
Claude-Session: https://claude.ai/code/session_01W1TN5sV8nD2mQymMCwHHSg
</commit_message>
<xml_diff>
--- a/THUYET_TRINH_KHKT_DA_SUA_FONT.pptx
+++ b/THUYET_TRINH_KHKT_DA_SUA_FONT.pptx
@@ -4561,65 +4561,685 @@
       </p:sp>
       <p:sp>
         <p:nvSpPr>
-          <p:cNvPr id="3" name="Content Placeholder 2">
-            <a:extLst>
-              <a:ext uri="{FF2B5EF4-FFF2-40B4-BE49-F238E27FC236}">
-                <a16:creationId xmlns:a16="http://schemas.microsoft.com/office/drawing/2014/main" id="{AB83B065-AC36-A5CC-8F5A-A4D38A7F975E}"/>
-              </a:ext>
-            </a:extLst>
-          </p:cNvPr>
-          <p:cNvSpPr txBox="1">
-            <a:spLocks noGrp="1"/>
-          </p:cNvSpPr>
-          <p:nvPr>
-            <p:ph idx="1"/>
-          </p:nvPr>
-        </p:nvSpPr>
-        <p:spPr/>
-        <p:txBody>
-          <a:bodyPr/>
-          <a:lstStyle/>
-          <a:p>
-            <a:r>
-              <a:rPr lang="vi-VN"/>
-              <a:t>1. Bài toán</a:t>
-            </a:r>
-            <a:endParaRPr lang="vi-VN" dirty="0"/>
-          </a:p>
-          <a:p>
-            <a:r>
-              <a:rPr lang="vi-VN"/>
-              <a:t>2. Giải pháp</a:t>
-            </a:r>
-            <a:endParaRPr lang="vi-VN" dirty="0"/>
-          </a:p>
-          <a:p>
-            <a:r>
-              <a:rPr lang="vi-VN"/>
-              <a:t>3. Cách phần mềm hoạt động</a:t>
-            </a:r>
-            <a:endParaRPr lang="vi-VN" dirty="0"/>
-          </a:p>
-          <a:p>
-            <a:r>
-              <a:rPr lang="vi-VN"/>
-              <a:t>4. Vận hành phần mềm</a:t>
-            </a:r>
-            <a:endParaRPr lang="vi-VN" dirty="0"/>
-          </a:p>
-          <a:p>
-            <a:r>
-              <a:rPr lang="vi-VN"/>
-              <a:t>5. Các số liệu khác</a:t>
-            </a:r>
-            <a:endParaRPr lang="vi-VN" dirty="0"/>
-          </a:p>
-          <a:p>
-            <a:r>
-              <a:rPr lang="vi-VN"/>
-              <a:t>6. Tính năng khác</a:t>
-            </a:r>
-            <a:endParaRPr lang="vi-VN" dirty="0"/>
+          <p:cNvPr id="3" name="Rounded Rectangle 2"/>
+          <p:cNvSpPr/>
+          <p:nvPr/>
+        </p:nvSpPr>
+        <p:spPr>
+          <a:xfrm>
+            <a:off x="841248" y="1828800"/>
+            <a:ext cx="3322320" cy="2057400"/>
+          </a:xfrm>
+          <a:prstGeom prst="roundRect">
+            <a:avLst>
+              <a:gd name="adj" fmla="val 6000"/>
+            </a:avLst>
+          </a:prstGeom>
+          <a:solidFill>
+            <a:srgbClr val="F3F4F1"/>
+          </a:solidFill>
+          <a:ln>
+            <a:noFill/>
+          </a:ln>
+          <a:effectLst/>
+        </p:spPr>
+        <p:style>
+          <a:lnRef idx="1">
+            <a:schemeClr val="accent1"/>
+          </a:lnRef>
+          <a:fillRef idx="3">
+            <a:schemeClr val="accent1"/>
+          </a:fillRef>
+          <a:effectRef idx="2">
+            <a:schemeClr val="accent1"/>
+          </a:effectRef>
+          <a:fontRef idx="minor">
+            <a:schemeClr val="lt1"/>
+          </a:fontRef>
+        </p:style>
+        <p:txBody>
+          <a:bodyPr rtlCol="0" anchor="ctr"/>
+          <a:lstStyle/>
+          <a:p/>
+        </p:txBody>
+      </p:sp>
+      <p:sp>
+        <p:nvSpPr>
+          <p:cNvPr id="4" name="TextBox 3"/>
+          <p:cNvSpPr txBox="1"/>
+          <p:nvPr/>
+        </p:nvSpPr>
+        <p:spPr>
+          <a:xfrm>
+            <a:off x="1161288" y="2148840"/>
+            <a:ext cx="1371600" cy="640080"/>
+          </a:xfrm>
+          <a:prstGeom prst="rect">
+            <a:avLst/>
+          </a:prstGeom>
+          <a:noFill/>
+        </p:spPr>
+        <p:txBody>
+          <a:bodyPr wrap="square" anchor="t" lIns="0" rIns="0" tIns="0" bIns="0">
+            <a:spAutoFit/>
+          </a:bodyPr>
+          <a:lstStyle/>
+          <a:p>
+            <a:pPr algn="l"/>
+            <a:r>
+              <a:rPr sz="4000" b="1" lang="vi-VN">
+                <a:solidFill>
+                  <a:srgbClr val="3F6B52"/>
+                </a:solidFill>
+                <a:latin typeface="Arial"/>
+              </a:rPr>
+              <a:t>01</a:t>
+            </a:r>
+          </a:p>
+        </p:txBody>
+      </p:sp>
+      <p:sp>
+        <p:nvSpPr>
+          <p:cNvPr id="5" name="TextBox 4"/>
+          <p:cNvSpPr txBox="1"/>
+          <p:nvPr/>
+        </p:nvSpPr>
+        <p:spPr>
+          <a:xfrm>
+            <a:off x="1161288" y="2971800"/>
+            <a:ext cx="2682240" cy="731520"/>
+          </a:xfrm>
+          <a:prstGeom prst="rect">
+            <a:avLst/>
+          </a:prstGeom>
+          <a:noFill/>
+        </p:spPr>
+        <p:txBody>
+          <a:bodyPr wrap="square" anchor="t" lIns="0" rIns="0" tIns="0" bIns="0">
+            <a:spAutoFit/>
+          </a:bodyPr>
+          <a:lstStyle/>
+          <a:p>
+            <a:pPr algn="l"/>
+            <a:r>
+              <a:rPr sz="2000" b="1" lang="vi-VN">
+                <a:solidFill>
+                  <a:srgbClr val="1F1F1F"/>
+                </a:solidFill>
+                <a:latin typeface="Arial"/>
+              </a:rPr>
+              <a:t>Bài toán</a:t>
+            </a:r>
+          </a:p>
+        </p:txBody>
+      </p:sp>
+      <p:sp>
+        <p:nvSpPr>
+          <p:cNvPr id="6" name="Rounded Rectangle 5"/>
+          <p:cNvSpPr/>
+          <p:nvPr/>
+        </p:nvSpPr>
+        <p:spPr>
+          <a:xfrm>
+            <a:off x="4437888" y="1828800"/>
+            <a:ext cx="3322320" cy="2057400"/>
+          </a:xfrm>
+          <a:prstGeom prst="roundRect">
+            <a:avLst>
+              <a:gd name="adj" fmla="val 6000"/>
+            </a:avLst>
+          </a:prstGeom>
+          <a:solidFill>
+            <a:srgbClr val="F3F4F1"/>
+          </a:solidFill>
+          <a:ln>
+            <a:noFill/>
+          </a:ln>
+          <a:effectLst/>
+        </p:spPr>
+        <p:style>
+          <a:lnRef idx="1">
+            <a:schemeClr val="accent1"/>
+          </a:lnRef>
+          <a:fillRef idx="3">
+            <a:schemeClr val="accent1"/>
+          </a:fillRef>
+          <a:effectRef idx="2">
+            <a:schemeClr val="accent1"/>
+          </a:effectRef>
+          <a:fontRef idx="minor">
+            <a:schemeClr val="lt1"/>
+          </a:fontRef>
+        </p:style>
+        <p:txBody>
+          <a:bodyPr rtlCol="0" anchor="ctr"/>
+          <a:lstStyle/>
+          <a:p/>
+        </p:txBody>
+      </p:sp>
+      <p:sp>
+        <p:nvSpPr>
+          <p:cNvPr id="7" name="TextBox 6"/>
+          <p:cNvSpPr txBox="1"/>
+          <p:nvPr/>
+        </p:nvSpPr>
+        <p:spPr>
+          <a:xfrm>
+            <a:off x="4757928" y="2148840"/>
+            <a:ext cx="1371600" cy="640080"/>
+          </a:xfrm>
+          <a:prstGeom prst="rect">
+            <a:avLst/>
+          </a:prstGeom>
+          <a:noFill/>
+        </p:spPr>
+        <p:txBody>
+          <a:bodyPr wrap="square" anchor="t" lIns="0" rIns="0" tIns="0" bIns="0">
+            <a:spAutoFit/>
+          </a:bodyPr>
+          <a:lstStyle/>
+          <a:p>
+            <a:pPr algn="l"/>
+            <a:r>
+              <a:rPr sz="4000" b="1" lang="vi-VN">
+                <a:solidFill>
+                  <a:srgbClr val="3F6B52"/>
+                </a:solidFill>
+                <a:latin typeface="Arial"/>
+              </a:rPr>
+              <a:t>02</a:t>
+            </a:r>
+          </a:p>
+        </p:txBody>
+      </p:sp>
+      <p:sp>
+        <p:nvSpPr>
+          <p:cNvPr id="8" name="TextBox 7"/>
+          <p:cNvSpPr txBox="1"/>
+          <p:nvPr/>
+        </p:nvSpPr>
+        <p:spPr>
+          <a:xfrm>
+            <a:off x="4757928" y="2971800"/>
+            <a:ext cx="2682240" cy="731520"/>
+          </a:xfrm>
+          <a:prstGeom prst="rect">
+            <a:avLst/>
+          </a:prstGeom>
+          <a:noFill/>
+        </p:spPr>
+        <p:txBody>
+          <a:bodyPr wrap="square" anchor="t" lIns="0" rIns="0" tIns="0" bIns="0">
+            <a:spAutoFit/>
+          </a:bodyPr>
+          <a:lstStyle/>
+          <a:p>
+            <a:pPr algn="l"/>
+            <a:r>
+              <a:rPr sz="2000" b="1" lang="vi-VN">
+                <a:solidFill>
+                  <a:srgbClr val="1F1F1F"/>
+                </a:solidFill>
+                <a:latin typeface="Arial"/>
+              </a:rPr>
+              <a:t>Giải pháp</a:t>
+            </a:r>
+          </a:p>
+        </p:txBody>
+      </p:sp>
+      <p:sp>
+        <p:nvSpPr>
+          <p:cNvPr id="9" name="Rounded Rectangle 8"/>
+          <p:cNvSpPr/>
+          <p:nvPr/>
+        </p:nvSpPr>
+        <p:spPr>
+          <a:xfrm>
+            <a:off x="8034528" y="1828800"/>
+            <a:ext cx="3322320" cy="2057400"/>
+          </a:xfrm>
+          <a:prstGeom prst="roundRect">
+            <a:avLst>
+              <a:gd name="adj" fmla="val 6000"/>
+            </a:avLst>
+          </a:prstGeom>
+          <a:solidFill>
+            <a:srgbClr val="F3F4F1"/>
+          </a:solidFill>
+          <a:ln>
+            <a:noFill/>
+          </a:ln>
+          <a:effectLst/>
+        </p:spPr>
+        <p:style>
+          <a:lnRef idx="1">
+            <a:schemeClr val="accent1"/>
+          </a:lnRef>
+          <a:fillRef idx="3">
+            <a:schemeClr val="accent1"/>
+          </a:fillRef>
+          <a:effectRef idx="2">
+            <a:schemeClr val="accent1"/>
+          </a:effectRef>
+          <a:fontRef idx="minor">
+            <a:schemeClr val="lt1"/>
+          </a:fontRef>
+        </p:style>
+        <p:txBody>
+          <a:bodyPr rtlCol="0" anchor="ctr"/>
+          <a:lstStyle/>
+          <a:p/>
+        </p:txBody>
+      </p:sp>
+      <p:sp>
+        <p:nvSpPr>
+          <p:cNvPr id="10" name="TextBox 9"/>
+          <p:cNvSpPr txBox="1"/>
+          <p:nvPr/>
+        </p:nvSpPr>
+        <p:spPr>
+          <a:xfrm>
+            <a:off x="8354568" y="2148840"/>
+            <a:ext cx="1371600" cy="640080"/>
+          </a:xfrm>
+          <a:prstGeom prst="rect">
+            <a:avLst/>
+          </a:prstGeom>
+          <a:noFill/>
+        </p:spPr>
+        <p:txBody>
+          <a:bodyPr wrap="square" anchor="t" lIns="0" rIns="0" tIns="0" bIns="0">
+            <a:spAutoFit/>
+          </a:bodyPr>
+          <a:lstStyle/>
+          <a:p>
+            <a:pPr algn="l"/>
+            <a:r>
+              <a:rPr sz="4000" b="1" lang="vi-VN">
+                <a:solidFill>
+                  <a:srgbClr val="3F6B52"/>
+                </a:solidFill>
+                <a:latin typeface="Arial"/>
+              </a:rPr>
+              <a:t>03</a:t>
+            </a:r>
+          </a:p>
+        </p:txBody>
+      </p:sp>
+      <p:sp>
+        <p:nvSpPr>
+          <p:cNvPr id="11" name="TextBox 10"/>
+          <p:cNvSpPr txBox="1"/>
+          <p:nvPr/>
+        </p:nvSpPr>
+        <p:spPr>
+          <a:xfrm>
+            <a:off x="8354568" y="2971800"/>
+            <a:ext cx="2682240" cy="731520"/>
+          </a:xfrm>
+          <a:prstGeom prst="rect">
+            <a:avLst/>
+          </a:prstGeom>
+          <a:noFill/>
+        </p:spPr>
+        <p:txBody>
+          <a:bodyPr wrap="square" anchor="t" lIns="0" rIns="0" tIns="0" bIns="0">
+            <a:spAutoFit/>
+          </a:bodyPr>
+          <a:lstStyle/>
+          <a:p>
+            <a:pPr algn="l"/>
+            <a:r>
+              <a:rPr sz="2000" b="1" lang="vi-VN">
+                <a:solidFill>
+                  <a:srgbClr val="1F1F1F"/>
+                </a:solidFill>
+                <a:latin typeface="Arial"/>
+              </a:rPr>
+              <a:t>Cách phần mềm hoạt động</a:t>
+            </a:r>
+          </a:p>
+        </p:txBody>
+      </p:sp>
+      <p:sp>
+        <p:nvSpPr>
+          <p:cNvPr id="12" name="Rounded Rectangle 11"/>
+          <p:cNvSpPr/>
+          <p:nvPr/>
+        </p:nvSpPr>
+        <p:spPr>
+          <a:xfrm>
+            <a:off x="841248" y="4160520"/>
+            <a:ext cx="3322320" cy="2057400"/>
+          </a:xfrm>
+          <a:prstGeom prst="roundRect">
+            <a:avLst>
+              <a:gd name="adj" fmla="val 6000"/>
+            </a:avLst>
+          </a:prstGeom>
+          <a:solidFill>
+            <a:srgbClr val="F3F4F1"/>
+          </a:solidFill>
+          <a:ln>
+            <a:noFill/>
+          </a:ln>
+          <a:effectLst/>
+        </p:spPr>
+        <p:style>
+          <a:lnRef idx="1">
+            <a:schemeClr val="accent1"/>
+          </a:lnRef>
+          <a:fillRef idx="3">
+            <a:schemeClr val="accent1"/>
+          </a:fillRef>
+          <a:effectRef idx="2">
+            <a:schemeClr val="accent1"/>
+          </a:effectRef>
+          <a:fontRef idx="minor">
+            <a:schemeClr val="lt1"/>
+          </a:fontRef>
+        </p:style>
+        <p:txBody>
+          <a:bodyPr rtlCol="0" anchor="ctr"/>
+          <a:lstStyle/>
+          <a:p/>
+        </p:txBody>
+      </p:sp>
+      <p:sp>
+        <p:nvSpPr>
+          <p:cNvPr id="13" name="TextBox 12"/>
+          <p:cNvSpPr txBox="1"/>
+          <p:nvPr/>
+        </p:nvSpPr>
+        <p:spPr>
+          <a:xfrm>
+            <a:off x="1161288" y="4480559"/>
+            <a:ext cx="1371600" cy="640080"/>
+          </a:xfrm>
+          <a:prstGeom prst="rect">
+            <a:avLst/>
+          </a:prstGeom>
+          <a:noFill/>
+        </p:spPr>
+        <p:txBody>
+          <a:bodyPr wrap="square" anchor="t" lIns="0" rIns="0" tIns="0" bIns="0">
+            <a:spAutoFit/>
+          </a:bodyPr>
+          <a:lstStyle/>
+          <a:p>
+            <a:pPr algn="l"/>
+            <a:r>
+              <a:rPr sz="4000" b="1" lang="vi-VN">
+                <a:solidFill>
+                  <a:srgbClr val="3F6B52"/>
+                </a:solidFill>
+                <a:latin typeface="Arial"/>
+              </a:rPr>
+              <a:t>04</a:t>
+            </a:r>
+          </a:p>
+        </p:txBody>
+      </p:sp>
+      <p:sp>
+        <p:nvSpPr>
+          <p:cNvPr id="14" name="TextBox 13"/>
+          <p:cNvSpPr txBox="1"/>
+          <p:nvPr/>
+        </p:nvSpPr>
+        <p:spPr>
+          <a:xfrm>
+            <a:off x="1161288" y="5303520"/>
+            <a:ext cx="2682240" cy="731520"/>
+          </a:xfrm>
+          <a:prstGeom prst="rect">
+            <a:avLst/>
+          </a:prstGeom>
+          <a:noFill/>
+        </p:spPr>
+        <p:txBody>
+          <a:bodyPr wrap="square" anchor="t" lIns="0" rIns="0" tIns="0" bIns="0">
+            <a:spAutoFit/>
+          </a:bodyPr>
+          <a:lstStyle/>
+          <a:p>
+            <a:pPr algn="l"/>
+            <a:r>
+              <a:rPr sz="2000" b="1" lang="vi-VN">
+                <a:solidFill>
+                  <a:srgbClr val="1F1F1F"/>
+                </a:solidFill>
+                <a:latin typeface="Arial"/>
+              </a:rPr>
+              <a:t>Vận hành phần mềm</a:t>
+            </a:r>
+          </a:p>
+        </p:txBody>
+      </p:sp>
+      <p:sp>
+        <p:nvSpPr>
+          <p:cNvPr id="15" name="Rounded Rectangle 14"/>
+          <p:cNvSpPr/>
+          <p:nvPr/>
+        </p:nvSpPr>
+        <p:spPr>
+          <a:xfrm>
+            <a:off x="4437888" y="4160520"/>
+            <a:ext cx="3322320" cy="2057400"/>
+          </a:xfrm>
+          <a:prstGeom prst="roundRect">
+            <a:avLst>
+              <a:gd name="adj" fmla="val 6000"/>
+            </a:avLst>
+          </a:prstGeom>
+          <a:solidFill>
+            <a:srgbClr val="F3F4F1"/>
+          </a:solidFill>
+          <a:ln>
+            <a:noFill/>
+          </a:ln>
+          <a:effectLst/>
+        </p:spPr>
+        <p:style>
+          <a:lnRef idx="1">
+            <a:schemeClr val="accent1"/>
+          </a:lnRef>
+          <a:fillRef idx="3">
+            <a:schemeClr val="accent1"/>
+          </a:fillRef>
+          <a:effectRef idx="2">
+            <a:schemeClr val="accent1"/>
+          </a:effectRef>
+          <a:fontRef idx="minor">
+            <a:schemeClr val="lt1"/>
+          </a:fontRef>
+        </p:style>
+        <p:txBody>
+          <a:bodyPr rtlCol="0" anchor="ctr"/>
+          <a:lstStyle/>
+          <a:p/>
+        </p:txBody>
+      </p:sp>
+      <p:sp>
+        <p:nvSpPr>
+          <p:cNvPr id="16" name="TextBox 15"/>
+          <p:cNvSpPr txBox="1"/>
+          <p:nvPr/>
+        </p:nvSpPr>
+        <p:spPr>
+          <a:xfrm>
+            <a:off x="4757928" y="4480559"/>
+            <a:ext cx="1371600" cy="640080"/>
+          </a:xfrm>
+          <a:prstGeom prst="rect">
+            <a:avLst/>
+          </a:prstGeom>
+          <a:noFill/>
+        </p:spPr>
+        <p:txBody>
+          <a:bodyPr wrap="square" anchor="t" lIns="0" rIns="0" tIns="0" bIns="0">
+            <a:spAutoFit/>
+          </a:bodyPr>
+          <a:lstStyle/>
+          <a:p>
+            <a:pPr algn="l"/>
+            <a:r>
+              <a:rPr sz="4000" b="1" lang="vi-VN">
+                <a:solidFill>
+                  <a:srgbClr val="3F6B52"/>
+                </a:solidFill>
+                <a:latin typeface="Arial"/>
+              </a:rPr>
+              <a:t>05</a:t>
+            </a:r>
+          </a:p>
+        </p:txBody>
+      </p:sp>
+      <p:sp>
+        <p:nvSpPr>
+          <p:cNvPr id="17" name="TextBox 16"/>
+          <p:cNvSpPr txBox="1"/>
+          <p:nvPr/>
+        </p:nvSpPr>
+        <p:spPr>
+          <a:xfrm>
+            <a:off x="4757928" y="5303520"/>
+            <a:ext cx="2682240" cy="731520"/>
+          </a:xfrm>
+          <a:prstGeom prst="rect">
+            <a:avLst/>
+          </a:prstGeom>
+          <a:noFill/>
+        </p:spPr>
+        <p:txBody>
+          <a:bodyPr wrap="square" anchor="t" lIns="0" rIns="0" tIns="0" bIns="0">
+            <a:spAutoFit/>
+          </a:bodyPr>
+          <a:lstStyle/>
+          <a:p>
+            <a:pPr algn="l"/>
+            <a:r>
+              <a:rPr sz="2000" b="1" lang="vi-VN">
+                <a:solidFill>
+                  <a:srgbClr val="1F1F1F"/>
+                </a:solidFill>
+                <a:latin typeface="Arial"/>
+              </a:rPr>
+              <a:t>Các số liệu khác</a:t>
+            </a:r>
+          </a:p>
+        </p:txBody>
+      </p:sp>
+      <p:sp>
+        <p:nvSpPr>
+          <p:cNvPr id="18" name="Rounded Rectangle 17"/>
+          <p:cNvSpPr/>
+          <p:nvPr/>
+        </p:nvSpPr>
+        <p:spPr>
+          <a:xfrm>
+            <a:off x="8034528" y="4160520"/>
+            <a:ext cx="3322320" cy="2057400"/>
+          </a:xfrm>
+          <a:prstGeom prst="roundRect">
+            <a:avLst>
+              <a:gd name="adj" fmla="val 6000"/>
+            </a:avLst>
+          </a:prstGeom>
+          <a:solidFill>
+            <a:srgbClr val="F3F4F1"/>
+          </a:solidFill>
+          <a:ln>
+            <a:noFill/>
+          </a:ln>
+          <a:effectLst/>
+        </p:spPr>
+        <p:style>
+          <a:lnRef idx="1">
+            <a:schemeClr val="accent1"/>
+          </a:lnRef>
+          <a:fillRef idx="3">
+            <a:schemeClr val="accent1"/>
+          </a:fillRef>
+          <a:effectRef idx="2">
+            <a:schemeClr val="accent1"/>
+          </a:effectRef>
+          <a:fontRef idx="minor">
+            <a:schemeClr val="lt1"/>
+          </a:fontRef>
+        </p:style>
+        <p:txBody>
+          <a:bodyPr rtlCol="0" anchor="ctr"/>
+          <a:lstStyle/>
+          <a:p/>
+        </p:txBody>
+      </p:sp>
+      <p:sp>
+        <p:nvSpPr>
+          <p:cNvPr id="19" name="TextBox 18"/>
+          <p:cNvSpPr txBox="1"/>
+          <p:nvPr/>
+        </p:nvSpPr>
+        <p:spPr>
+          <a:xfrm>
+            <a:off x="8354568" y="4480559"/>
+            <a:ext cx="1371600" cy="640080"/>
+          </a:xfrm>
+          <a:prstGeom prst="rect">
+            <a:avLst/>
+          </a:prstGeom>
+          <a:noFill/>
+        </p:spPr>
+        <p:txBody>
+          <a:bodyPr wrap="square" anchor="t" lIns="0" rIns="0" tIns="0" bIns="0">
+            <a:spAutoFit/>
+          </a:bodyPr>
+          <a:lstStyle/>
+          <a:p>
+            <a:pPr algn="l"/>
+            <a:r>
+              <a:rPr sz="4000" b="1" lang="vi-VN">
+                <a:solidFill>
+                  <a:srgbClr val="3F6B52"/>
+                </a:solidFill>
+                <a:latin typeface="Arial"/>
+              </a:rPr>
+              <a:t>06</a:t>
+            </a:r>
+          </a:p>
+        </p:txBody>
+      </p:sp>
+      <p:sp>
+        <p:nvSpPr>
+          <p:cNvPr id="20" name="TextBox 19"/>
+          <p:cNvSpPr txBox="1"/>
+          <p:nvPr/>
+        </p:nvSpPr>
+        <p:spPr>
+          <a:xfrm>
+            <a:off x="8354568" y="5303520"/>
+            <a:ext cx="2682240" cy="731520"/>
+          </a:xfrm>
+          <a:prstGeom prst="rect">
+            <a:avLst/>
+          </a:prstGeom>
+          <a:noFill/>
+        </p:spPr>
+        <p:txBody>
+          <a:bodyPr wrap="square" anchor="t" lIns="0" rIns="0" tIns="0" bIns="0">
+            <a:spAutoFit/>
+          </a:bodyPr>
+          <a:lstStyle/>
+          <a:p>
+            <a:pPr algn="l"/>
+            <a:r>
+              <a:rPr sz="2000" b="1" lang="vi-VN">
+                <a:solidFill>
+                  <a:srgbClr val="1F1F1F"/>
+                </a:solidFill>
+                <a:latin typeface="Arial"/>
+              </a:rPr>
+              <a:t>Tính năng khác</a:t>
+            </a:r>
           </a:p>
         </p:txBody>
       </p:sp>
@@ -4678,1022 +5298,653 @@
       </p:sp>
       <p:sp>
         <p:nvSpPr>
-          <p:cNvPr id="5" name="Text Placeholder 4">
-            <a:extLst>
-              <a:ext uri="{FF2B5EF4-FFF2-40B4-BE49-F238E27FC236}">
-                <a16:creationId xmlns:a16="http://schemas.microsoft.com/office/drawing/2014/main" id="{765E4B7B-4610-0CFA-2774-8678DCEB29A2}"/>
-              </a:ext>
-            </a:extLst>
-          </p:cNvPr>
-          <p:cNvSpPr>
-            <a:spLocks noGrp="1"/>
-          </p:cNvSpPr>
-          <p:nvPr>
-            <p:ph type="body" idx="1"/>
-          </p:nvPr>
-        </p:nvSpPr>
-        <p:spPr/>
-        <p:txBody>
-          <a:bodyPr/>
-          <a:lstStyle/>
-          <a:p>
-            <a:r>
-              <a:rPr lang="vi-VN"/>
-              <a:t>Xét theo thứ tự đăng kí</a:t>
-            </a:r>
-          </a:p>
-        </p:txBody>
-      </p:sp>
-      <p:sp>
-        <p:nvSpPr>
-          <p:cNvPr id="6" name="Content Placeholder 5">
-            <a:extLst>
-              <a:ext uri="{FF2B5EF4-FFF2-40B4-BE49-F238E27FC236}">
-                <a16:creationId xmlns:a16="http://schemas.microsoft.com/office/drawing/2014/main" id="{BB713268-BEA4-93AD-C866-D6AF99BCD14C}"/>
-              </a:ext>
-            </a:extLst>
-          </p:cNvPr>
-          <p:cNvSpPr>
-            <a:spLocks noGrp="1"/>
-          </p:cNvSpPr>
-          <p:nvPr>
-            <p:ph idx="2"/>
-          </p:nvPr>
-        </p:nvSpPr>
-        <p:spPr>
-          <a:xfrm>
-            <a:off x="839784" y="2505072"/>
-            <a:ext cx="5157782" cy="1316030"/>
-          </a:xfrm>
-        </p:spPr>
-        <p:txBody>
-          <a:bodyPr/>
-          <a:lstStyle/>
-          <a:p>
-            <a:r>
-              <a:rPr lang="vi-VN"/>
-              <a:t>Xét theo thứ tự đăng ký chỉ đánh giá tốc độ chứ không xét trình độ hay nguyện vọng</a:t>
-            </a:r>
-            <a:endParaRPr lang="vi-VN" dirty="0"/>
-          </a:p>
-        </p:txBody>
-      </p:sp>
-      <p:sp>
-        <p:nvSpPr>
-          <p:cNvPr id="7" name="Text Placeholder 6">
-            <a:extLst>
-              <a:ext uri="{FF2B5EF4-FFF2-40B4-BE49-F238E27FC236}">
-                <a16:creationId xmlns:a16="http://schemas.microsoft.com/office/drawing/2014/main" id="{20FD1AF1-1165-6FEA-88F7-4CFEF6CEF2EF}"/>
-              </a:ext>
-            </a:extLst>
-          </p:cNvPr>
-          <p:cNvSpPr>
-            <a:spLocks noGrp="1"/>
-          </p:cNvSpPr>
-          <p:nvPr>
-            <p:ph type="body" idx="3"/>
-          </p:nvPr>
-        </p:nvSpPr>
-        <p:spPr/>
-        <p:txBody>
-          <a:bodyPr/>
-          <a:lstStyle/>
-          <a:p>
-            <a:r>
-              <a:rPr lang="vi-VN"/>
-              <a:t>Đảm bảo chất lượng đầu vào</a:t>
-            </a:r>
-            <a:endParaRPr lang="vi-VN" dirty="0"/>
-          </a:p>
-        </p:txBody>
-      </p:sp>
-      <p:sp>
-        <p:nvSpPr>
-          <p:cNvPr id="8" name="Content Placeholder 7">
-            <a:extLst>
-              <a:ext uri="{FF2B5EF4-FFF2-40B4-BE49-F238E27FC236}">
-                <a16:creationId xmlns:a16="http://schemas.microsoft.com/office/drawing/2014/main" id="{66F34D05-2A76-3DA0-2593-91A85D06FFEA}"/>
-              </a:ext>
-            </a:extLst>
-          </p:cNvPr>
-          <p:cNvSpPr>
-            <a:spLocks noGrp="1"/>
-          </p:cNvSpPr>
-          <p:nvPr>
-            <p:ph idx="4"/>
-          </p:nvPr>
-        </p:nvSpPr>
-        <p:spPr>
-          <a:xfrm>
-            <a:off x="6172200" y="2505072"/>
-            <a:ext cx="5183184" cy="1316030"/>
-          </a:xfrm>
-        </p:spPr>
-        <p:txBody>
-          <a:bodyPr/>
-          <a:lstStyle/>
-          <a:p>
-            <a:r>
-              <a:rPr lang="vi-VN"/>
-              <a:t>Những CLB không thể đánh giá chất lượng đầu vào</a:t>
-            </a:r>
-            <a:endParaRPr lang="vi-VN" dirty="0"/>
-          </a:p>
-        </p:txBody>
-      </p:sp>
-      <p:sp>
-        <p:nvSpPr>
-          <p:cNvPr id="9" name="Text Placeholder 4">
-            <a:extLst>
-              <a:ext uri="{FF2B5EF4-FFF2-40B4-BE49-F238E27FC236}">
-                <a16:creationId xmlns:a16="http://schemas.microsoft.com/office/drawing/2014/main" id="{838191A4-2EAC-07B5-A1C8-8A25CFBB5A47}"/>
-              </a:ext>
-            </a:extLst>
-          </p:cNvPr>
-          <p:cNvSpPr txBox="1">
-            <a:spLocks/>
-          </p:cNvSpPr>
+          <p:cNvPr id="5" name="Rounded Rectangle 4"/>
+          <p:cNvSpPr/>
           <p:nvPr/>
         </p:nvSpPr>
         <p:spPr>
           <a:xfrm>
-            <a:off x="836616" y="3763200"/>
-            <a:ext cx="5157782" cy="823910"/>
-          </a:xfrm>
-          <a:prstGeom prst="rect">
-            <a:avLst/>
-          </a:prstGeom>
-          <a:noFill/>
+            <a:off x="841248" y="1828800"/>
+            <a:ext cx="5120640" cy="2103120"/>
+          </a:xfrm>
+          <a:prstGeom prst="roundRect">
+            <a:avLst>
+              <a:gd name="adj" fmla="val 6000"/>
+            </a:avLst>
+          </a:prstGeom>
+          <a:solidFill>
+            <a:srgbClr val="F3F4F1"/>
+          </a:solidFill>
           <a:ln>
             <a:noFill/>
           </a:ln>
-        </p:spPr>
-        <p:txBody>
-          <a:bodyPr vert="horz" wrap="square" lIns="91440" tIns="45720" rIns="91440" bIns="45720" anchor="b" anchorCtr="0" compatLnSpc="1">
-            <a:normAutofit/>
-          </a:bodyPr>
-          <a:lstStyle>
-            <a:lvl1pPr marL="0" marR="0" lvl="0" indent="0" algn="l" defTabSz="914400" rtl="0" fontAlgn="auto" hangingPunct="1">
-              <a:lnSpc>
-                <a:spcPct val="90000"/>
-              </a:lnSpc>
-              <a:spcBef>
-                <a:spcPts val="1000"/>
-              </a:spcBef>
-              <a:spcAft>
-                <a:spcPts val="0"/>
-              </a:spcAft>
-              <a:buSzPct val="100000"/>
-              <a:buFont typeface="Arial" pitchFamily="34"/>
-              <a:buNone/>
-              <a:tabLst/>
-              <a:defRPr lang="vi-VN" sz="2400" b="1" i="0" u="none" strike="noStrike" kern="1200" cap="none" spc="0" baseline="0">
-                <a:solidFill>
-                  <a:srgbClr val="000000"/>
-                </a:solidFill>
-                <a:uFillTx/>
-                <a:latin typeface="Arial"/>
-              </a:defRPr>
-            </a:lvl1pPr>
-            <a:lvl2pPr marL="685800" marR="0" lvl="1" indent="-228600" algn="l" defTabSz="914400" rtl="0" fontAlgn="auto" hangingPunct="1">
-              <a:lnSpc>
-                <a:spcPct val="90000"/>
-              </a:lnSpc>
-              <a:spcBef>
-                <a:spcPts val="500"/>
-              </a:spcBef>
-              <a:spcAft>
-                <a:spcPts val="0"/>
-              </a:spcAft>
-              <a:buSzPct val="100000"/>
-              <a:buFont typeface="Arial" pitchFamily="34"/>
-              <a:buChar char="•"/>
-              <a:tabLst/>
-              <a:defRPr lang="vi-VN" sz="2400" b="0" i="0" u="none" strike="noStrike" kern="1200" cap="none" spc="0" baseline="0">
-                <a:solidFill>
-                  <a:srgbClr val="000000"/>
-                </a:solidFill>
-                <a:uFillTx/>
-                <a:latin typeface="Arial"/>
-              </a:defRPr>
-            </a:lvl2pPr>
-            <a:lvl3pPr marL="1143000" marR="0" lvl="2" indent="-228600" algn="l" defTabSz="914400" rtl="0" fontAlgn="auto" hangingPunct="1">
-              <a:lnSpc>
-                <a:spcPct val="90000"/>
-              </a:lnSpc>
-              <a:spcBef>
-                <a:spcPts val="500"/>
-              </a:spcBef>
-              <a:spcAft>
-                <a:spcPts val="0"/>
-              </a:spcAft>
-              <a:buSzPct val="100000"/>
-              <a:buFont typeface="Arial" pitchFamily="34"/>
-              <a:buChar char="•"/>
-              <a:tabLst/>
-              <a:defRPr lang="vi-VN" sz="2000" b="0" i="0" u="none" strike="noStrike" kern="1200" cap="none" spc="0" baseline="0">
-                <a:solidFill>
-                  <a:srgbClr val="000000"/>
-                </a:solidFill>
-                <a:uFillTx/>
-                <a:latin typeface="Arial"/>
-              </a:defRPr>
-            </a:lvl3pPr>
-            <a:lvl4pPr marL="1600200" marR="0" lvl="3" indent="-228600" algn="l" defTabSz="914400" rtl="0" fontAlgn="auto" hangingPunct="1">
-              <a:lnSpc>
-                <a:spcPct val="90000"/>
-              </a:lnSpc>
-              <a:spcBef>
-                <a:spcPts val="500"/>
-              </a:spcBef>
-              <a:spcAft>
-                <a:spcPts val="0"/>
-              </a:spcAft>
-              <a:buSzPct val="100000"/>
-              <a:buFont typeface="Arial" pitchFamily="34"/>
-              <a:buChar char="•"/>
-              <a:tabLst/>
-              <a:defRPr lang="vi-VN" sz="1800" b="0" i="0" u="none" strike="noStrike" kern="1200" cap="none" spc="0" baseline="0">
-                <a:solidFill>
-                  <a:srgbClr val="000000"/>
-                </a:solidFill>
-                <a:uFillTx/>
-                <a:latin typeface="Arial"/>
-              </a:defRPr>
-            </a:lvl4pPr>
-            <a:lvl5pPr marL="2057400" marR="0" lvl="4" indent="-228600" algn="l" defTabSz="914400" rtl="0" fontAlgn="auto" hangingPunct="1">
-              <a:lnSpc>
-                <a:spcPct val="90000"/>
-              </a:lnSpc>
-              <a:spcBef>
-                <a:spcPts val="500"/>
-              </a:spcBef>
-              <a:spcAft>
-                <a:spcPts val="0"/>
-              </a:spcAft>
-              <a:buSzPct val="100000"/>
-              <a:buFont typeface="Arial" pitchFamily="34"/>
-              <a:buChar char="•"/>
-              <a:tabLst/>
-              <a:defRPr lang="vi-VN" sz="1800" b="0" i="0" u="none" strike="noStrike" kern="1200" cap="none" spc="0" baseline="0">
-                <a:solidFill>
-                  <a:srgbClr val="000000"/>
-                </a:solidFill>
-                <a:uFillTx/>
-                <a:latin typeface="Arial"/>
-              </a:defRPr>
-            </a:lvl5pPr>
-            <a:lvl6pPr marL="2514600" indent="-228600" algn="l" defTabSz="914400" rtl="0" eaLnBrk="1" latinLnBrk="0" hangingPunct="1">
-              <a:lnSpc>
-                <a:spcPct val="90000"/>
-              </a:lnSpc>
-              <a:spcBef>
-                <a:spcPts val="500"/>
-              </a:spcBef>
-              <a:buFont typeface="Arial" panose="020B0604020202020204" pitchFamily="34" charset="0"/>
-              <a:buChar char="•"/>
-              <a:defRPr sz="1800" kern="1200">
-                <a:solidFill>
-                  <a:schemeClr val="tx1"/>
-                </a:solidFill>
-                <a:latin typeface="+mn-lt"/>
-                <a:ea typeface="+mn-ea"/>
-                <a:cs typeface="+mn-cs"/>
-              </a:defRPr>
-            </a:lvl6pPr>
-            <a:lvl7pPr marL="2971800" indent="-228600" algn="l" defTabSz="914400" rtl="0" eaLnBrk="1" latinLnBrk="0" hangingPunct="1">
-              <a:lnSpc>
-                <a:spcPct val="90000"/>
-              </a:lnSpc>
-              <a:spcBef>
-                <a:spcPts val="500"/>
-              </a:spcBef>
-              <a:buFont typeface="Arial" panose="020B0604020202020204" pitchFamily="34" charset="0"/>
-              <a:buChar char="•"/>
-              <a:defRPr sz="1800" kern="1200">
-                <a:solidFill>
-                  <a:schemeClr val="tx1"/>
-                </a:solidFill>
-                <a:latin typeface="+mn-lt"/>
-                <a:ea typeface="+mn-ea"/>
-                <a:cs typeface="+mn-cs"/>
-              </a:defRPr>
-            </a:lvl7pPr>
-            <a:lvl8pPr marL="3429000" indent="-228600" algn="l" defTabSz="914400" rtl="0" eaLnBrk="1" latinLnBrk="0" hangingPunct="1">
-              <a:lnSpc>
-                <a:spcPct val="90000"/>
-              </a:lnSpc>
-              <a:spcBef>
-                <a:spcPts val="500"/>
-              </a:spcBef>
-              <a:buFont typeface="Arial" panose="020B0604020202020204" pitchFamily="34" charset="0"/>
-              <a:buChar char="•"/>
-              <a:defRPr sz="1800" kern="1200">
-                <a:solidFill>
-                  <a:schemeClr val="tx1"/>
-                </a:solidFill>
-                <a:latin typeface="+mn-lt"/>
-                <a:ea typeface="+mn-ea"/>
-                <a:cs typeface="+mn-cs"/>
-              </a:defRPr>
-            </a:lvl8pPr>
-            <a:lvl9pPr marL="3886200" indent="-228600" algn="l" defTabSz="914400" rtl="0" eaLnBrk="1" latinLnBrk="0" hangingPunct="1">
-              <a:lnSpc>
-                <a:spcPct val="90000"/>
-              </a:lnSpc>
-              <a:spcBef>
-                <a:spcPts val="500"/>
-              </a:spcBef>
-              <a:buFont typeface="Arial" panose="020B0604020202020204" pitchFamily="34" charset="0"/>
-              <a:buChar char="•"/>
-              <a:defRPr sz="1800" kern="1200">
-                <a:solidFill>
-                  <a:schemeClr val="tx1"/>
-                </a:solidFill>
-                <a:latin typeface="+mn-lt"/>
-                <a:ea typeface="+mn-ea"/>
-                <a:cs typeface="+mn-cs"/>
-              </a:defRPr>
-            </a:lvl9pPr>
-          </a:lstStyle>
-          <a:p>
-            <a:r>
-              <a:rPr lang="vi-VN"/>
-              <a:t>Cần phải hỗ trợ các HS có hoàn cảnh</a:t>
-            </a:r>
-            <a:endParaRPr lang="vi-VN" dirty="0"/>
-          </a:p>
-        </p:txBody>
-      </p:sp>
-      <p:sp>
-        <p:nvSpPr>
-          <p:cNvPr id="10" name="Text Placeholder 4">
-            <a:extLst>
-              <a:ext uri="{FF2B5EF4-FFF2-40B4-BE49-F238E27FC236}">
-                <a16:creationId xmlns:a16="http://schemas.microsoft.com/office/drawing/2014/main" id="{74E5CAC8-9174-D278-9CE7-B9882CC97772}"/>
-              </a:ext>
-            </a:extLst>
-          </p:cNvPr>
-          <p:cNvSpPr txBox="1">
-            <a:spLocks/>
-          </p:cNvSpPr>
+          <a:effectLst/>
+        </p:spPr>
+        <p:style>
+          <a:lnRef idx="1">
+            <a:schemeClr val="accent1"/>
+          </a:lnRef>
+          <a:fillRef idx="3">
+            <a:schemeClr val="accent1"/>
+          </a:fillRef>
+          <a:effectRef idx="2">
+            <a:schemeClr val="accent1"/>
+          </a:effectRef>
+          <a:fontRef idx="minor">
+            <a:schemeClr val="lt1"/>
+          </a:fontRef>
+        </p:style>
+        <p:txBody>
+          <a:bodyPr rtlCol="0" anchor="ctr"/>
+          <a:lstStyle/>
+          <a:p/>
+        </p:txBody>
+      </p:sp>
+      <p:sp>
+        <p:nvSpPr>
+          <p:cNvPr id="6" name="Oval 5"/>
+          <p:cNvSpPr/>
           <p:nvPr/>
         </p:nvSpPr>
         <p:spPr>
           <a:xfrm>
-            <a:off x="6194436" y="3502516"/>
-            <a:ext cx="5157782" cy="823910"/>
-          </a:xfrm>
-          <a:prstGeom prst="rect">
+            <a:off x="1161288" y="2148840"/>
+            <a:ext cx="777240" cy="777240"/>
+          </a:xfrm>
+          <a:prstGeom prst="ellipse">
             <a:avLst/>
           </a:prstGeom>
-          <a:noFill/>
+          <a:solidFill>
+            <a:srgbClr val="F3DCD9"/>
+          </a:solidFill>
           <a:ln>
             <a:noFill/>
           </a:ln>
-        </p:spPr>
-        <p:txBody>
-          <a:bodyPr vert="horz" wrap="square" lIns="91440" tIns="45720" rIns="91440" bIns="45720" anchor="b" anchorCtr="0" compatLnSpc="1">
-            <a:normAutofit/>
-          </a:bodyPr>
-          <a:lstStyle>
-            <a:lvl1pPr marL="0" marR="0" lvl="0" indent="0" algn="l" defTabSz="914400" rtl="0" fontAlgn="auto" hangingPunct="1">
-              <a:lnSpc>
-                <a:spcPct val="90000"/>
-              </a:lnSpc>
-              <a:spcBef>
-                <a:spcPts val="1000"/>
-              </a:spcBef>
-              <a:spcAft>
-                <a:spcPts val="0"/>
-              </a:spcAft>
-              <a:buSzPct val="100000"/>
-              <a:buFont typeface="Arial" pitchFamily="34"/>
-              <a:buNone/>
-              <a:tabLst/>
-              <a:defRPr lang="vi-VN" sz="2400" b="1" i="0" u="none" strike="noStrike" kern="1200" cap="none" spc="0" baseline="0">
-                <a:solidFill>
-                  <a:srgbClr val="000000"/>
-                </a:solidFill>
-                <a:uFillTx/>
-                <a:latin typeface="Arial"/>
-              </a:defRPr>
-            </a:lvl1pPr>
-            <a:lvl2pPr marL="685800" marR="0" lvl="1" indent="-228600" algn="l" defTabSz="914400" rtl="0" fontAlgn="auto" hangingPunct="1">
-              <a:lnSpc>
-                <a:spcPct val="90000"/>
-              </a:lnSpc>
-              <a:spcBef>
-                <a:spcPts val="500"/>
-              </a:spcBef>
-              <a:spcAft>
-                <a:spcPts val="0"/>
-              </a:spcAft>
-              <a:buSzPct val="100000"/>
-              <a:buFont typeface="Arial" pitchFamily="34"/>
-              <a:buChar char="•"/>
-              <a:tabLst/>
-              <a:defRPr lang="vi-VN" sz="2400" b="0" i="0" u="none" strike="noStrike" kern="1200" cap="none" spc="0" baseline="0">
-                <a:solidFill>
-                  <a:srgbClr val="000000"/>
-                </a:solidFill>
-                <a:uFillTx/>
-                <a:latin typeface="Arial"/>
-              </a:defRPr>
-            </a:lvl2pPr>
-            <a:lvl3pPr marL="1143000" marR="0" lvl="2" indent="-228600" algn="l" defTabSz="914400" rtl="0" fontAlgn="auto" hangingPunct="1">
-              <a:lnSpc>
-                <a:spcPct val="90000"/>
-              </a:lnSpc>
-              <a:spcBef>
-                <a:spcPts val="500"/>
-              </a:spcBef>
-              <a:spcAft>
-                <a:spcPts val="0"/>
-              </a:spcAft>
-              <a:buSzPct val="100000"/>
-              <a:buFont typeface="Arial" pitchFamily="34"/>
-              <a:buChar char="•"/>
-              <a:tabLst/>
-              <a:defRPr lang="vi-VN" sz="2000" b="0" i="0" u="none" strike="noStrike" kern="1200" cap="none" spc="0" baseline="0">
-                <a:solidFill>
-                  <a:srgbClr val="000000"/>
-                </a:solidFill>
-                <a:uFillTx/>
-                <a:latin typeface="Arial"/>
-              </a:defRPr>
-            </a:lvl3pPr>
-            <a:lvl4pPr marL="1600200" marR="0" lvl="3" indent="-228600" algn="l" defTabSz="914400" rtl="0" fontAlgn="auto" hangingPunct="1">
-              <a:lnSpc>
-                <a:spcPct val="90000"/>
-              </a:lnSpc>
-              <a:spcBef>
-                <a:spcPts val="500"/>
-              </a:spcBef>
-              <a:spcAft>
-                <a:spcPts val="0"/>
-              </a:spcAft>
-              <a:buSzPct val="100000"/>
-              <a:buFont typeface="Arial" pitchFamily="34"/>
-              <a:buChar char="•"/>
-              <a:tabLst/>
-              <a:defRPr lang="vi-VN" sz="1800" b="0" i="0" u="none" strike="noStrike" kern="1200" cap="none" spc="0" baseline="0">
-                <a:solidFill>
-                  <a:srgbClr val="000000"/>
-                </a:solidFill>
-                <a:uFillTx/>
-                <a:latin typeface="Arial"/>
-              </a:defRPr>
-            </a:lvl4pPr>
-            <a:lvl5pPr marL="2057400" marR="0" lvl="4" indent="-228600" algn="l" defTabSz="914400" rtl="0" fontAlgn="auto" hangingPunct="1">
-              <a:lnSpc>
-                <a:spcPct val="90000"/>
-              </a:lnSpc>
-              <a:spcBef>
-                <a:spcPts val="500"/>
-              </a:spcBef>
-              <a:spcAft>
-                <a:spcPts val="0"/>
-              </a:spcAft>
-              <a:buSzPct val="100000"/>
-              <a:buFont typeface="Arial" pitchFamily="34"/>
-              <a:buChar char="•"/>
-              <a:tabLst/>
-              <a:defRPr lang="vi-VN" sz="1800" b="0" i="0" u="none" strike="noStrike" kern="1200" cap="none" spc="0" baseline="0">
-                <a:solidFill>
-                  <a:srgbClr val="000000"/>
-                </a:solidFill>
-                <a:uFillTx/>
-                <a:latin typeface="Arial"/>
-              </a:defRPr>
-            </a:lvl5pPr>
-            <a:lvl6pPr marL="2514600" indent="-228600" algn="l" defTabSz="914400" rtl="0" eaLnBrk="1" latinLnBrk="0" hangingPunct="1">
-              <a:lnSpc>
-                <a:spcPct val="90000"/>
-              </a:lnSpc>
-              <a:spcBef>
-                <a:spcPts val="500"/>
-              </a:spcBef>
-              <a:buFont typeface="Arial" panose="020B0604020202020204" pitchFamily="34" charset="0"/>
-              <a:buChar char="•"/>
-              <a:defRPr sz="1800" kern="1200">
-                <a:solidFill>
-                  <a:schemeClr val="tx1"/>
-                </a:solidFill>
-                <a:latin typeface="+mn-lt"/>
-                <a:ea typeface="+mn-ea"/>
-                <a:cs typeface="+mn-cs"/>
-              </a:defRPr>
-            </a:lvl6pPr>
-            <a:lvl7pPr marL="2971800" indent="-228600" algn="l" defTabSz="914400" rtl="0" eaLnBrk="1" latinLnBrk="0" hangingPunct="1">
-              <a:lnSpc>
-                <a:spcPct val="90000"/>
-              </a:lnSpc>
-              <a:spcBef>
-                <a:spcPts val="500"/>
-              </a:spcBef>
-              <a:buFont typeface="Arial" panose="020B0604020202020204" pitchFamily="34" charset="0"/>
-              <a:buChar char="•"/>
-              <a:defRPr sz="1800" kern="1200">
-                <a:solidFill>
-                  <a:schemeClr val="tx1"/>
-                </a:solidFill>
-                <a:latin typeface="+mn-lt"/>
-                <a:ea typeface="+mn-ea"/>
-                <a:cs typeface="+mn-cs"/>
-              </a:defRPr>
-            </a:lvl7pPr>
-            <a:lvl8pPr marL="3429000" indent="-228600" algn="l" defTabSz="914400" rtl="0" eaLnBrk="1" latinLnBrk="0" hangingPunct="1">
-              <a:lnSpc>
-                <a:spcPct val="90000"/>
-              </a:lnSpc>
-              <a:spcBef>
-                <a:spcPts val="500"/>
-              </a:spcBef>
-              <a:buFont typeface="Arial" panose="020B0604020202020204" pitchFamily="34" charset="0"/>
-              <a:buChar char="•"/>
-              <a:defRPr sz="1800" kern="1200">
-                <a:solidFill>
-                  <a:schemeClr val="tx1"/>
-                </a:solidFill>
-                <a:latin typeface="+mn-lt"/>
-                <a:ea typeface="+mn-ea"/>
-                <a:cs typeface="+mn-cs"/>
-              </a:defRPr>
-            </a:lvl8pPr>
-            <a:lvl9pPr marL="3886200" indent="-228600" algn="l" defTabSz="914400" rtl="0" eaLnBrk="1" latinLnBrk="0" hangingPunct="1">
-              <a:lnSpc>
-                <a:spcPct val="90000"/>
-              </a:lnSpc>
-              <a:spcBef>
-                <a:spcPts val="500"/>
-              </a:spcBef>
-              <a:buFont typeface="Arial" panose="020B0604020202020204" pitchFamily="34" charset="0"/>
-              <a:buChar char="•"/>
-              <a:defRPr sz="1800" kern="1200">
-                <a:solidFill>
-                  <a:schemeClr val="tx1"/>
-                </a:solidFill>
-                <a:latin typeface="+mn-lt"/>
-                <a:ea typeface="+mn-ea"/>
-                <a:cs typeface="+mn-cs"/>
-              </a:defRPr>
-            </a:lvl9pPr>
-          </a:lstStyle>
-          <a:p>
-            <a:r>
-              <a:rPr lang="vi-VN"/>
-              <a:t>Số chỗ có thể ít hơn số lượng HS</a:t>
-            </a:r>
-            <a:endParaRPr lang="vi-VN" dirty="0"/>
-          </a:p>
-        </p:txBody>
-      </p:sp>
-      <p:sp>
-        <p:nvSpPr>
-          <p:cNvPr id="12" name="Content Placeholder 5">
-            <a:extLst>
-              <a:ext uri="{FF2B5EF4-FFF2-40B4-BE49-F238E27FC236}">
-                <a16:creationId xmlns:a16="http://schemas.microsoft.com/office/drawing/2014/main" id="{85E6BFB9-221D-4A04-0E7B-03106BE7AEDD}"/>
-              </a:ext>
-            </a:extLst>
-          </p:cNvPr>
-          <p:cNvSpPr txBox="1">
-            <a:spLocks/>
-          </p:cNvSpPr>
+          <a:effectLst/>
+        </p:spPr>
+        <p:style>
+          <a:lnRef idx="1">
+            <a:schemeClr val="accent1"/>
+          </a:lnRef>
+          <a:fillRef idx="3">
+            <a:schemeClr val="accent1"/>
+          </a:fillRef>
+          <a:effectRef idx="2">
+            <a:schemeClr val="accent1"/>
+          </a:effectRef>
+          <a:fontRef idx="minor">
+            <a:schemeClr val="lt1"/>
+          </a:fontRef>
+        </p:style>
+        <p:txBody>
+          <a:bodyPr rtlCol="0" anchor="ctr"/>
+          <a:lstStyle/>
+          <a:p>
+            <a:pPr algn="ctr"/>
+          </a:p>
+        </p:txBody>
+      </p:sp>
+      <p:pic>
+        <p:nvPicPr>
+          <p:cNvPr id="7" name="Picture 6" descr="clock_rust.png"/>
+          <p:cNvPicPr>
+            <a:picLocks noChangeAspect="1"/>
+          </p:cNvPicPr>
           <p:nvPr/>
-        </p:nvSpPr>
-        <p:spPr>
-          <a:xfrm>
-            <a:off x="833448" y="4587110"/>
-            <a:ext cx="5157782" cy="1316030"/>
+        </p:nvPicPr>
+        <p:blipFill>
+          <a:blip r:embed="rId2"/>
+          <a:stretch>
+            <a:fillRect/>
+          </a:stretch>
+        </p:blipFill>
+        <p:spPr>
+          <a:xfrm>
+            <a:off x="1363370" y="2350922"/>
+            <a:ext cx="373075" cy="373075"/>
           </a:xfrm>
           <a:prstGeom prst="rect">
             <a:avLst/>
           </a:prstGeom>
+        </p:spPr>
+      </p:pic>
+      <p:sp>
+        <p:nvSpPr>
+          <p:cNvPr id="8" name="TextBox 7"/>
+          <p:cNvSpPr txBox="1"/>
+          <p:nvPr/>
+        </p:nvSpPr>
+        <p:spPr>
+          <a:xfrm>
+            <a:off x="2167128" y="2176272"/>
+            <a:ext cx="3474720" cy="1554479"/>
+          </a:xfrm>
+          <a:prstGeom prst="rect">
+            <a:avLst/>
+          </a:prstGeom>
           <a:noFill/>
+        </p:spPr>
+        <p:txBody>
+          <a:bodyPr wrap="square" anchor="t" lIns="0" rIns="0" tIns="0" bIns="0">
+            <a:spAutoFit/>
+          </a:bodyPr>
+          <a:lstStyle/>
+          <a:p>
+            <a:pPr algn="l"/>
+            <a:r>
+              <a:rPr sz="1900" b="1" lang="vi-VN">
+                <a:solidFill>
+                  <a:srgbClr val="1F1F1F"/>
+                </a:solidFill>
+                <a:latin typeface="Arial"/>
+              </a:rPr>
+              <a:t>Xét theo thứ tự đăng kí</a:t>
+            </a:r>
+          </a:p>
+          <a:p>
+            <a:pPr>
+              <a:spcBef>
+                <a:spcPts val="800"/>
+              </a:spcBef>
+            </a:pPr>
+            <a:r>
+              <a:rPr sz="1500" lang="vi-VN">
+                <a:solidFill>
+                  <a:srgbClr val="555B58"/>
+                </a:solidFill>
+                <a:latin typeface="Arial"/>
+              </a:rPr>
+              <a:t>Xét theo thứ tự đăng ký chỉ đánh giá tốc độ chứ không xét trình độ hay nguyện vọng</a:t>
+            </a:r>
+          </a:p>
+        </p:txBody>
+      </p:sp>
+      <p:sp>
+        <p:nvSpPr>
+          <p:cNvPr id="9" name="Rounded Rectangle 8"/>
+          <p:cNvSpPr/>
+          <p:nvPr/>
+        </p:nvSpPr>
+        <p:spPr>
+          <a:xfrm>
+            <a:off x="6236207" y="1828800"/>
+            <a:ext cx="5120640" cy="2103120"/>
+          </a:xfrm>
+          <a:prstGeom prst="roundRect">
+            <a:avLst>
+              <a:gd name="adj" fmla="val 6000"/>
+            </a:avLst>
+          </a:prstGeom>
+          <a:solidFill>
+            <a:srgbClr val="F3F4F1"/>
+          </a:solidFill>
           <a:ln>
             <a:noFill/>
           </a:ln>
-        </p:spPr>
-        <p:txBody>
-          <a:bodyPr vert="horz" wrap="square" lIns="91440" tIns="45720" rIns="91440" bIns="45720" anchor="t" anchorCtr="0" compatLnSpc="1">
-            <a:normAutofit/>
-          </a:bodyPr>
-          <a:lstStyle>
-            <a:lvl1pPr marL="228600" marR="0" lvl="0" indent="-228600" algn="l" defTabSz="914400" rtl="0" fontAlgn="auto" hangingPunct="1">
-              <a:lnSpc>
-                <a:spcPct val="90000"/>
-              </a:lnSpc>
-              <a:spcBef>
-                <a:spcPts val="1000"/>
-              </a:spcBef>
-              <a:spcAft>
-                <a:spcPts val="0"/>
-              </a:spcAft>
-              <a:buSzPct val="100000"/>
-              <a:buFont typeface="Arial" pitchFamily="34"/>
-              <a:buChar char="•"/>
-              <a:tabLst/>
-              <a:defRPr lang="vi-VN" sz="2800" b="0" i="0" u="none" strike="noStrike" kern="1200" cap="none" spc="0" baseline="0">
-                <a:solidFill>
-                  <a:srgbClr val="000000"/>
-                </a:solidFill>
-                <a:uFillTx/>
-                <a:latin typeface="Arial"/>
-              </a:defRPr>
-            </a:lvl1pPr>
-            <a:lvl2pPr marL="685800" marR="0" lvl="1" indent="-228600" algn="l" defTabSz="914400" rtl="0" fontAlgn="auto" hangingPunct="1">
-              <a:lnSpc>
-                <a:spcPct val="90000"/>
-              </a:lnSpc>
-              <a:spcBef>
-                <a:spcPts val="500"/>
-              </a:spcBef>
-              <a:spcAft>
-                <a:spcPts val="0"/>
-              </a:spcAft>
-              <a:buSzPct val="100000"/>
-              <a:buFont typeface="Arial" pitchFamily="34"/>
-              <a:buChar char="•"/>
-              <a:tabLst/>
-              <a:defRPr lang="vi-VN" sz="2400" b="0" i="0" u="none" strike="noStrike" kern="1200" cap="none" spc="0" baseline="0">
-                <a:solidFill>
-                  <a:srgbClr val="000000"/>
-                </a:solidFill>
-                <a:uFillTx/>
-                <a:latin typeface="Arial"/>
-              </a:defRPr>
-            </a:lvl2pPr>
-            <a:lvl3pPr marL="1143000" marR="0" lvl="2" indent="-228600" algn="l" defTabSz="914400" rtl="0" fontAlgn="auto" hangingPunct="1">
-              <a:lnSpc>
-                <a:spcPct val="90000"/>
-              </a:lnSpc>
-              <a:spcBef>
-                <a:spcPts val="500"/>
-              </a:spcBef>
-              <a:spcAft>
-                <a:spcPts val="0"/>
-              </a:spcAft>
-              <a:buSzPct val="100000"/>
-              <a:buFont typeface="Arial" pitchFamily="34"/>
-              <a:buChar char="•"/>
-              <a:tabLst/>
-              <a:defRPr lang="vi-VN" sz="2000" b="0" i="0" u="none" strike="noStrike" kern="1200" cap="none" spc="0" baseline="0">
-                <a:solidFill>
-                  <a:srgbClr val="000000"/>
-                </a:solidFill>
-                <a:uFillTx/>
-                <a:latin typeface="Arial"/>
-              </a:defRPr>
-            </a:lvl3pPr>
-            <a:lvl4pPr marL="1600200" marR="0" lvl="3" indent="-228600" algn="l" defTabSz="914400" rtl="0" fontAlgn="auto" hangingPunct="1">
-              <a:lnSpc>
-                <a:spcPct val="90000"/>
-              </a:lnSpc>
-              <a:spcBef>
-                <a:spcPts val="500"/>
-              </a:spcBef>
-              <a:spcAft>
-                <a:spcPts val="0"/>
-              </a:spcAft>
-              <a:buSzPct val="100000"/>
-              <a:buFont typeface="Arial" pitchFamily="34"/>
-              <a:buChar char="•"/>
-              <a:tabLst/>
-              <a:defRPr lang="vi-VN" sz="1800" b="0" i="0" u="none" strike="noStrike" kern="1200" cap="none" spc="0" baseline="0">
-                <a:solidFill>
-                  <a:srgbClr val="000000"/>
-                </a:solidFill>
-                <a:uFillTx/>
-                <a:latin typeface="Arial"/>
-              </a:defRPr>
-            </a:lvl4pPr>
-            <a:lvl5pPr marL="2057400" marR="0" lvl="4" indent="-228600" algn="l" defTabSz="914400" rtl="0" fontAlgn="auto" hangingPunct="1">
-              <a:lnSpc>
-                <a:spcPct val="90000"/>
-              </a:lnSpc>
-              <a:spcBef>
-                <a:spcPts val="500"/>
-              </a:spcBef>
-              <a:spcAft>
-                <a:spcPts val="0"/>
-              </a:spcAft>
-              <a:buSzPct val="100000"/>
-              <a:buFont typeface="Arial" pitchFamily="34"/>
-              <a:buChar char="•"/>
-              <a:tabLst/>
-              <a:defRPr lang="vi-VN" sz="1800" b="0" i="0" u="none" strike="noStrike" kern="1200" cap="none" spc="0" baseline="0">
-                <a:solidFill>
-                  <a:srgbClr val="000000"/>
-                </a:solidFill>
-                <a:uFillTx/>
-                <a:latin typeface="Arial"/>
-              </a:defRPr>
-            </a:lvl5pPr>
-            <a:lvl6pPr marL="2514600" indent="-228600" algn="l" defTabSz="914400" rtl="0" eaLnBrk="1" latinLnBrk="0" hangingPunct="1">
-              <a:lnSpc>
-                <a:spcPct val="90000"/>
-              </a:lnSpc>
-              <a:spcBef>
-                <a:spcPts val="500"/>
-              </a:spcBef>
-              <a:buFont typeface="Arial" panose="020B0604020202020204" pitchFamily="34" charset="0"/>
-              <a:buChar char="•"/>
-              <a:defRPr sz="1800" kern="1200">
-                <a:solidFill>
-                  <a:schemeClr val="tx1"/>
-                </a:solidFill>
-                <a:latin typeface="+mn-lt"/>
-                <a:ea typeface="+mn-ea"/>
-                <a:cs typeface="+mn-cs"/>
-              </a:defRPr>
-            </a:lvl6pPr>
-            <a:lvl7pPr marL="2971800" indent="-228600" algn="l" defTabSz="914400" rtl="0" eaLnBrk="1" latinLnBrk="0" hangingPunct="1">
-              <a:lnSpc>
-                <a:spcPct val="90000"/>
-              </a:lnSpc>
-              <a:spcBef>
-                <a:spcPts val="500"/>
-              </a:spcBef>
-              <a:buFont typeface="Arial" panose="020B0604020202020204" pitchFamily="34" charset="0"/>
-              <a:buChar char="•"/>
-              <a:defRPr sz="1800" kern="1200">
-                <a:solidFill>
-                  <a:schemeClr val="tx1"/>
-                </a:solidFill>
-                <a:latin typeface="+mn-lt"/>
-                <a:ea typeface="+mn-ea"/>
-                <a:cs typeface="+mn-cs"/>
-              </a:defRPr>
-            </a:lvl7pPr>
-            <a:lvl8pPr marL="3429000" indent="-228600" algn="l" defTabSz="914400" rtl="0" eaLnBrk="1" latinLnBrk="0" hangingPunct="1">
-              <a:lnSpc>
-                <a:spcPct val="90000"/>
-              </a:lnSpc>
-              <a:spcBef>
-                <a:spcPts val="500"/>
-              </a:spcBef>
-              <a:buFont typeface="Arial" panose="020B0604020202020204" pitchFamily="34" charset="0"/>
-              <a:buChar char="•"/>
-              <a:defRPr sz="1800" kern="1200">
-                <a:solidFill>
-                  <a:schemeClr val="tx1"/>
-                </a:solidFill>
-                <a:latin typeface="+mn-lt"/>
-                <a:ea typeface="+mn-ea"/>
-                <a:cs typeface="+mn-cs"/>
-              </a:defRPr>
-            </a:lvl8pPr>
-            <a:lvl9pPr marL="3886200" indent="-228600" algn="l" defTabSz="914400" rtl="0" eaLnBrk="1" latinLnBrk="0" hangingPunct="1">
-              <a:lnSpc>
-                <a:spcPct val="90000"/>
-              </a:lnSpc>
-              <a:spcBef>
-                <a:spcPts val="500"/>
-              </a:spcBef>
-              <a:buFont typeface="Arial" panose="020B0604020202020204" pitchFamily="34" charset="0"/>
-              <a:buChar char="•"/>
-              <a:defRPr sz="1800" kern="1200">
-                <a:solidFill>
-                  <a:schemeClr val="tx1"/>
-                </a:solidFill>
-                <a:latin typeface="+mn-lt"/>
-                <a:ea typeface="+mn-ea"/>
-                <a:cs typeface="+mn-cs"/>
-              </a:defRPr>
-            </a:lvl9pPr>
-          </a:lstStyle>
-          <a:p>
-            <a:r>
-              <a:rPr lang="vi-VN"/>
-              <a:t>Lời giải cần tạo cách để ưu tiên các HS khó khăn vào CLB nếu cần thiết</a:t>
-            </a:r>
-            <a:endParaRPr lang="vi-VN" dirty="0"/>
-          </a:p>
-        </p:txBody>
-      </p:sp>
-      <p:sp>
-        <p:nvSpPr>
-          <p:cNvPr id="13" name="Content Placeholder 7">
-            <a:extLst>
-              <a:ext uri="{FF2B5EF4-FFF2-40B4-BE49-F238E27FC236}">
-                <a16:creationId xmlns:a16="http://schemas.microsoft.com/office/drawing/2014/main" id="{D9E1E72D-62E4-4C98-9685-7E418D7FD4D8}"/>
-              </a:ext>
-            </a:extLst>
-          </p:cNvPr>
-          <p:cNvSpPr txBox="1">
-            <a:spLocks/>
-          </p:cNvSpPr>
+          <a:effectLst/>
+        </p:spPr>
+        <p:style>
+          <a:lnRef idx="1">
+            <a:schemeClr val="accent1"/>
+          </a:lnRef>
+          <a:fillRef idx="3">
+            <a:schemeClr val="accent1"/>
+          </a:fillRef>
+          <a:effectRef idx="2">
+            <a:schemeClr val="accent1"/>
+          </a:effectRef>
+          <a:fontRef idx="minor">
+            <a:schemeClr val="lt1"/>
+          </a:fontRef>
+        </p:style>
+        <p:txBody>
+          <a:bodyPr rtlCol="0" anchor="ctr"/>
+          <a:lstStyle/>
+          <a:p/>
+        </p:txBody>
+      </p:sp>
+      <p:sp>
+        <p:nvSpPr>
+          <p:cNvPr id="10" name="Oval 9"/>
+          <p:cNvSpPr/>
           <p:nvPr/>
         </p:nvSpPr>
         <p:spPr>
           <a:xfrm>
-            <a:off x="6169034" y="4587110"/>
-            <a:ext cx="5183184" cy="1316030"/>
-          </a:xfrm>
-          <a:prstGeom prst="rect">
+            <a:off x="6556247" y="2148840"/>
+            <a:ext cx="777240" cy="777240"/>
+          </a:xfrm>
+          <a:prstGeom prst="ellipse">
             <a:avLst/>
           </a:prstGeom>
-          <a:noFill/>
+          <a:solidFill>
+            <a:srgbClr val="DCE9E0"/>
+          </a:solidFill>
           <a:ln>
             <a:noFill/>
           </a:ln>
-        </p:spPr>
-        <p:txBody>
-          <a:bodyPr vert="horz" wrap="square" lIns="91440" tIns="45720" rIns="91440" bIns="45720" anchor="t" anchorCtr="0" compatLnSpc="1">
-            <a:normAutofit/>
+          <a:effectLst/>
+        </p:spPr>
+        <p:style>
+          <a:lnRef idx="1">
+            <a:schemeClr val="accent1"/>
+          </a:lnRef>
+          <a:fillRef idx="3">
+            <a:schemeClr val="accent1"/>
+          </a:fillRef>
+          <a:effectRef idx="2">
+            <a:schemeClr val="accent1"/>
+          </a:effectRef>
+          <a:fontRef idx="minor">
+            <a:schemeClr val="lt1"/>
+          </a:fontRef>
+        </p:style>
+        <p:txBody>
+          <a:bodyPr rtlCol="0" anchor="ctr"/>
+          <a:lstStyle/>
+          <a:p>
+            <a:pPr algn="ctr"/>
+          </a:p>
+        </p:txBody>
+      </p:sp>
+      <p:pic>
+        <p:nvPicPr>
+          <p:cNvPr id="11" name="Picture 10" descr="clip_moss.png"/>
+          <p:cNvPicPr>
+            <a:picLocks noChangeAspect="1"/>
+          </p:cNvPicPr>
+          <p:nvPr/>
+        </p:nvPicPr>
+        <p:blipFill>
+          <a:blip r:embed="rId3"/>
+          <a:stretch>
+            <a:fillRect/>
+          </a:stretch>
+        </p:blipFill>
+        <p:spPr>
+          <a:xfrm>
+            <a:off x="6758330" y="2350922"/>
+            <a:ext cx="373075" cy="373075"/>
+          </a:xfrm>
+          <a:prstGeom prst="rect">
+            <a:avLst/>
+          </a:prstGeom>
+        </p:spPr>
+      </p:pic>
+      <p:sp>
+        <p:nvSpPr>
+          <p:cNvPr id="12" name="TextBox 11"/>
+          <p:cNvSpPr txBox="1"/>
+          <p:nvPr/>
+        </p:nvSpPr>
+        <p:spPr>
+          <a:xfrm>
+            <a:off x="7562088" y="2176272"/>
+            <a:ext cx="3474720" cy="1554479"/>
+          </a:xfrm>
+          <a:prstGeom prst="rect">
+            <a:avLst/>
+          </a:prstGeom>
+          <a:noFill/>
+        </p:spPr>
+        <p:txBody>
+          <a:bodyPr wrap="square" anchor="t" lIns="0" rIns="0" tIns="0" bIns="0">
+            <a:spAutoFit/>
           </a:bodyPr>
-          <a:lstStyle>
-            <a:lvl1pPr marL="228600" marR="0" lvl="0" indent="-228600" algn="l" defTabSz="914400" rtl="0" fontAlgn="auto" hangingPunct="1">
-              <a:lnSpc>
-                <a:spcPct val="90000"/>
-              </a:lnSpc>
+          <a:lstStyle/>
+          <a:p>
+            <a:pPr algn="l"/>
+            <a:r>
+              <a:rPr sz="1900" b="1" lang="vi-VN">
+                <a:solidFill>
+                  <a:srgbClr val="1F1F1F"/>
+                </a:solidFill>
+                <a:latin typeface="Arial"/>
+              </a:rPr>
+              <a:t>Đảm bảo chất lượng đầu vào</a:t>
+            </a:r>
+          </a:p>
+          <a:p>
+            <a:pPr>
               <a:spcBef>
-                <a:spcPts val="1000"/>
+                <a:spcPts val="800"/>
               </a:spcBef>
-              <a:spcAft>
-                <a:spcPts val="0"/>
-              </a:spcAft>
-              <a:buSzPct val="100000"/>
-              <a:buFont typeface="Arial" pitchFamily="34"/>
-              <a:buChar char="•"/>
-              <a:tabLst/>
-              <a:defRPr lang="vi-VN" sz="2800" b="0" i="0" u="none" strike="noStrike" kern="1200" cap="none" spc="0" baseline="0">
+            </a:pPr>
+            <a:r>
+              <a:rPr sz="1500" lang="vi-VN">
                 <a:solidFill>
-                  <a:srgbClr val="000000"/>
+                  <a:srgbClr val="555B58"/>
                 </a:solidFill>
-                <a:uFillTx/>
                 <a:latin typeface="Arial"/>
-              </a:defRPr>
-            </a:lvl1pPr>
-            <a:lvl2pPr marL="685800" marR="0" lvl="1" indent="-228600" algn="l" defTabSz="914400" rtl="0" fontAlgn="auto" hangingPunct="1">
-              <a:lnSpc>
-                <a:spcPct val="90000"/>
-              </a:lnSpc>
+              </a:rPr>
+              <a:t>Những CLB không thể đánh giá chất lượng đầu vào</a:t>
+            </a:r>
+          </a:p>
+        </p:txBody>
+      </p:sp>
+      <p:sp>
+        <p:nvSpPr>
+          <p:cNvPr id="13" name="Rounded Rectangle 12"/>
+          <p:cNvSpPr/>
+          <p:nvPr/>
+        </p:nvSpPr>
+        <p:spPr>
+          <a:xfrm>
+            <a:off x="841248" y="4206240"/>
+            <a:ext cx="5120640" cy="2103120"/>
+          </a:xfrm>
+          <a:prstGeom prst="roundRect">
+            <a:avLst>
+              <a:gd name="adj" fmla="val 6000"/>
+            </a:avLst>
+          </a:prstGeom>
+          <a:solidFill>
+            <a:srgbClr val="F3F4F1"/>
+          </a:solidFill>
+          <a:ln>
+            <a:noFill/>
+          </a:ln>
+          <a:effectLst/>
+        </p:spPr>
+        <p:style>
+          <a:lnRef idx="1">
+            <a:schemeClr val="accent1"/>
+          </a:lnRef>
+          <a:fillRef idx="3">
+            <a:schemeClr val="accent1"/>
+          </a:fillRef>
+          <a:effectRef idx="2">
+            <a:schemeClr val="accent1"/>
+          </a:effectRef>
+          <a:fontRef idx="minor">
+            <a:schemeClr val="lt1"/>
+          </a:fontRef>
+        </p:style>
+        <p:txBody>
+          <a:bodyPr rtlCol="0" anchor="ctr"/>
+          <a:lstStyle/>
+          <a:p/>
+        </p:txBody>
+      </p:sp>
+      <p:sp>
+        <p:nvSpPr>
+          <p:cNvPr id="14" name="Oval 13"/>
+          <p:cNvSpPr/>
+          <p:nvPr/>
+        </p:nvSpPr>
+        <p:spPr>
+          <a:xfrm>
+            <a:off x="1161288" y="4526279"/>
+            <a:ext cx="777240" cy="777240"/>
+          </a:xfrm>
+          <a:prstGeom prst="ellipse">
+            <a:avLst/>
+          </a:prstGeom>
+          <a:solidFill>
+            <a:srgbClr val="DCE9E0"/>
+          </a:solidFill>
+          <a:ln>
+            <a:noFill/>
+          </a:ln>
+          <a:effectLst/>
+        </p:spPr>
+        <p:style>
+          <a:lnRef idx="1">
+            <a:schemeClr val="accent1"/>
+          </a:lnRef>
+          <a:fillRef idx="3">
+            <a:schemeClr val="accent1"/>
+          </a:fillRef>
+          <a:effectRef idx="2">
+            <a:schemeClr val="accent1"/>
+          </a:effectRef>
+          <a:fontRef idx="minor">
+            <a:schemeClr val="lt1"/>
+          </a:fontRef>
+        </p:style>
+        <p:txBody>
+          <a:bodyPr rtlCol="0" anchor="ctr"/>
+          <a:lstStyle/>
+          <a:p>
+            <a:pPr algn="ctr"/>
+          </a:p>
+        </p:txBody>
+      </p:sp>
+      <p:pic>
+        <p:nvPicPr>
+          <p:cNvPr id="15" name="Picture 14" descr="hands_moss.png"/>
+          <p:cNvPicPr>
+            <a:picLocks noChangeAspect="1"/>
+          </p:cNvPicPr>
+          <p:nvPr/>
+        </p:nvPicPr>
+        <p:blipFill>
+          <a:blip r:embed="rId4"/>
+          <a:stretch>
+            <a:fillRect/>
+          </a:stretch>
+        </p:blipFill>
+        <p:spPr>
+          <a:xfrm>
+            <a:off x="1363370" y="4728362"/>
+            <a:ext cx="373075" cy="373075"/>
+          </a:xfrm>
+          <a:prstGeom prst="rect">
+            <a:avLst/>
+          </a:prstGeom>
+        </p:spPr>
+      </p:pic>
+      <p:sp>
+        <p:nvSpPr>
+          <p:cNvPr id="16" name="TextBox 15"/>
+          <p:cNvSpPr txBox="1"/>
+          <p:nvPr/>
+        </p:nvSpPr>
+        <p:spPr>
+          <a:xfrm>
+            <a:off x="2167128" y="4553712"/>
+            <a:ext cx="3474720" cy="1554479"/>
+          </a:xfrm>
+          <a:prstGeom prst="rect">
+            <a:avLst/>
+          </a:prstGeom>
+          <a:noFill/>
+        </p:spPr>
+        <p:txBody>
+          <a:bodyPr wrap="square" anchor="t" lIns="0" rIns="0" tIns="0" bIns="0">
+            <a:spAutoFit/>
+          </a:bodyPr>
+          <a:lstStyle/>
+          <a:p>
+            <a:pPr algn="l"/>
+            <a:r>
+              <a:rPr sz="1900" b="1" lang="vi-VN">
+                <a:solidFill>
+                  <a:srgbClr val="1F1F1F"/>
+                </a:solidFill>
+                <a:latin typeface="Arial"/>
+              </a:rPr>
+              <a:t>Cần phải hỗ trợ các HS có hoàn cảnh</a:t>
+            </a:r>
+          </a:p>
+          <a:p>
+            <a:pPr>
               <a:spcBef>
-                <a:spcPts val="500"/>
+                <a:spcPts val="800"/>
               </a:spcBef>
-              <a:spcAft>
-                <a:spcPts val="0"/>
-              </a:spcAft>
-              <a:buSzPct val="100000"/>
-              <a:buFont typeface="Arial" pitchFamily="34"/>
-              <a:buChar char="•"/>
-              <a:tabLst/>
-              <a:defRPr lang="vi-VN" sz="2400" b="0" i="0" u="none" strike="noStrike" kern="1200" cap="none" spc="0" baseline="0">
+            </a:pPr>
+            <a:r>
+              <a:rPr sz="1500" lang="vi-VN">
                 <a:solidFill>
-                  <a:srgbClr val="000000"/>
+                  <a:srgbClr val="555B58"/>
                 </a:solidFill>
-                <a:uFillTx/>
                 <a:latin typeface="Arial"/>
-              </a:defRPr>
-            </a:lvl2pPr>
-            <a:lvl3pPr marL="1143000" marR="0" lvl="2" indent="-228600" algn="l" defTabSz="914400" rtl="0" fontAlgn="auto" hangingPunct="1">
-              <a:lnSpc>
-                <a:spcPct val="90000"/>
-              </a:lnSpc>
+              </a:rPr>
+              <a:t>Lời giải cần tạo cách để ưu tiên các HS khó khăn vào CLB nếu cần thiết</a:t>
+            </a:r>
+          </a:p>
+        </p:txBody>
+      </p:sp>
+      <p:sp>
+        <p:nvSpPr>
+          <p:cNvPr id="17" name="Rounded Rectangle 16"/>
+          <p:cNvSpPr/>
+          <p:nvPr/>
+        </p:nvSpPr>
+        <p:spPr>
+          <a:xfrm>
+            <a:off x="6236207" y="4206240"/>
+            <a:ext cx="5120640" cy="2103120"/>
+          </a:xfrm>
+          <a:prstGeom prst="roundRect">
+            <a:avLst>
+              <a:gd name="adj" fmla="val 6000"/>
+            </a:avLst>
+          </a:prstGeom>
+          <a:solidFill>
+            <a:srgbClr val="F3F4F1"/>
+          </a:solidFill>
+          <a:ln>
+            <a:noFill/>
+          </a:ln>
+          <a:effectLst/>
+        </p:spPr>
+        <p:style>
+          <a:lnRef idx="1">
+            <a:schemeClr val="accent1"/>
+          </a:lnRef>
+          <a:fillRef idx="3">
+            <a:schemeClr val="accent1"/>
+          </a:fillRef>
+          <a:effectRef idx="2">
+            <a:schemeClr val="accent1"/>
+          </a:effectRef>
+          <a:fontRef idx="minor">
+            <a:schemeClr val="lt1"/>
+          </a:fontRef>
+        </p:style>
+        <p:txBody>
+          <a:bodyPr rtlCol="0" anchor="ctr"/>
+          <a:lstStyle/>
+          <a:p/>
+        </p:txBody>
+      </p:sp>
+      <p:sp>
+        <p:nvSpPr>
+          <p:cNvPr id="18" name="Oval 17"/>
+          <p:cNvSpPr/>
+          <p:nvPr/>
+        </p:nvSpPr>
+        <p:spPr>
+          <a:xfrm>
+            <a:off x="6556247" y="4526279"/>
+            <a:ext cx="777240" cy="777240"/>
+          </a:xfrm>
+          <a:prstGeom prst="ellipse">
+            <a:avLst/>
+          </a:prstGeom>
+          <a:solidFill>
+            <a:srgbClr val="DCE9E0"/>
+          </a:solidFill>
+          <a:ln>
+            <a:noFill/>
+          </a:ln>
+          <a:effectLst/>
+        </p:spPr>
+        <p:style>
+          <a:lnRef idx="1">
+            <a:schemeClr val="accent1"/>
+          </a:lnRef>
+          <a:fillRef idx="3">
+            <a:schemeClr val="accent1"/>
+          </a:fillRef>
+          <a:effectRef idx="2">
+            <a:schemeClr val="accent1"/>
+          </a:effectRef>
+          <a:fontRef idx="minor">
+            <a:schemeClr val="lt1"/>
+          </a:fontRef>
+        </p:style>
+        <p:txBody>
+          <a:bodyPr rtlCol="0" anchor="ctr"/>
+          <a:lstStyle/>
+          <a:p>
+            <a:pPr algn="ctr"/>
+          </a:p>
+        </p:txBody>
+      </p:sp>
+      <p:pic>
+        <p:nvPicPr>
+          <p:cNvPr id="19" name="Picture 18" descr="users_moss.png"/>
+          <p:cNvPicPr>
+            <a:picLocks noChangeAspect="1"/>
+          </p:cNvPicPr>
+          <p:nvPr/>
+        </p:nvPicPr>
+        <p:blipFill>
+          <a:blip r:embed="rId5"/>
+          <a:stretch>
+            <a:fillRect/>
+          </a:stretch>
+        </p:blipFill>
+        <p:spPr>
+          <a:xfrm>
+            <a:off x="6758330" y="4728362"/>
+            <a:ext cx="373075" cy="373075"/>
+          </a:xfrm>
+          <a:prstGeom prst="rect">
+            <a:avLst/>
+          </a:prstGeom>
+        </p:spPr>
+      </p:pic>
+      <p:sp>
+        <p:nvSpPr>
+          <p:cNvPr id="20" name="TextBox 19"/>
+          <p:cNvSpPr txBox="1"/>
+          <p:nvPr/>
+        </p:nvSpPr>
+        <p:spPr>
+          <a:xfrm>
+            <a:off x="7562088" y="4553712"/>
+            <a:ext cx="3474720" cy="1554479"/>
+          </a:xfrm>
+          <a:prstGeom prst="rect">
+            <a:avLst/>
+          </a:prstGeom>
+          <a:noFill/>
+        </p:spPr>
+        <p:txBody>
+          <a:bodyPr wrap="square" anchor="t" lIns="0" rIns="0" tIns="0" bIns="0">
+            <a:spAutoFit/>
+          </a:bodyPr>
+          <a:lstStyle/>
+          <a:p>
+            <a:pPr algn="l"/>
+            <a:r>
+              <a:rPr sz="1900" b="1" lang="vi-VN">
+                <a:solidFill>
+                  <a:srgbClr val="1F1F1F"/>
+                </a:solidFill>
+                <a:latin typeface="Arial"/>
+              </a:rPr>
+              <a:t>Số chỗ có thể ít hơn số lượng HS</a:t>
+            </a:r>
+          </a:p>
+          <a:p>
+            <a:pPr>
               <a:spcBef>
-                <a:spcPts val="500"/>
+                <a:spcPts val="800"/>
               </a:spcBef>
-              <a:spcAft>
-                <a:spcPts val="0"/>
-              </a:spcAft>
-              <a:buSzPct val="100000"/>
-              <a:buFont typeface="Arial" pitchFamily="34"/>
-              <a:buChar char="•"/>
-              <a:tabLst/>
-              <a:defRPr lang="vi-VN" sz="2000" b="0" i="0" u="none" strike="noStrike" kern="1200" cap="none" spc="0" baseline="0">
+            </a:pPr>
+            <a:r>
+              <a:rPr sz="1500" lang="vi-VN">
                 <a:solidFill>
-                  <a:srgbClr val="000000"/>
+                  <a:srgbClr val="555B58"/>
                 </a:solidFill>
-                <a:uFillTx/>
                 <a:latin typeface="Arial"/>
-              </a:defRPr>
-            </a:lvl3pPr>
-            <a:lvl4pPr marL="1600200" marR="0" lvl="3" indent="-228600" algn="l" defTabSz="914400" rtl="0" fontAlgn="auto" hangingPunct="1">
-              <a:lnSpc>
-                <a:spcPct val="90000"/>
-              </a:lnSpc>
-              <a:spcBef>
-                <a:spcPts val="500"/>
-              </a:spcBef>
-              <a:spcAft>
-                <a:spcPts val="0"/>
-              </a:spcAft>
-              <a:buSzPct val="100000"/>
-              <a:buFont typeface="Arial" pitchFamily="34"/>
-              <a:buChar char="•"/>
-              <a:tabLst/>
-              <a:defRPr lang="vi-VN" sz="1800" b="0" i="0" u="none" strike="noStrike" kern="1200" cap="none" spc="0" baseline="0">
-                <a:solidFill>
-                  <a:srgbClr val="000000"/>
-                </a:solidFill>
-                <a:uFillTx/>
-                <a:latin typeface="Arial"/>
-              </a:defRPr>
-            </a:lvl4pPr>
-            <a:lvl5pPr marL="2057400" marR="0" lvl="4" indent="-228600" algn="l" defTabSz="914400" rtl="0" fontAlgn="auto" hangingPunct="1">
-              <a:lnSpc>
-                <a:spcPct val="90000"/>
-              </a:lnSpc>
-              <a:spcBef>
-                <a:spcPts val="500"/>
-              </a:spcBef>
-              <a:spcAft>
-                <a:spcPts val="0"/>
-              </a:spcAft>
-              <a:buSzPct val="100000"/>
-              <a:buFont typeface="Arial" pitchFamily="34"/>
-              <a:buChar char="•"/>
-              <a:tabLst/>
-              <a:defRPr lang="vi-VN" sz="1800" b="0" i="0" u="none" strike="noStrike" kern="1200" cap="none" spc="0" baseline="0">
-                <a:solidFill>
-                  <a:srgbClr val="000000"/>
-                </a:solidFill>
-                <a:uFillTx/>
-                <a:latin typeface="Arial"/>
-              </a:defRPr>
-            </a:lvl5pPr>
-            <a:lvl6pPr marL="2514600" indent="-228600" algn="l" defTabSz="914400" rtl="0" eaLnBrk="1" latinLnBrk="0" hangingPunct="1">
-              <a:lnSpc>
-                <a:spcPct val="90000"/>
-              </a:lnSpc>
-              <a:spcBef>
-                <a:spcPts val="500"/>
-              </a:spcBef>
-              <a:buFont typeface="Arial" panose="020B0604020202020204" pitchFamily="34" charset="0"/>
-              <a:buChar char="•"/>
-              <a:defRPr sz="1800" kern="1200">
-                <a:solidFill>
-                  <a:schemeClr val="tx1"/>
-                </a:solidFill>
-                <a:latin typeface="+mn-lt"/>
-                <a:ea typeface="+mn-ea"/>
-                <a:cs typeface="+mn-cs"/>
-              </a:defRPr>
-            </a:lvl6pPr>
-            <a:lvl7pPr marL="2971800" indent="-228600" algn="l" defTabSz="914400" rtl="0" eaLnBrk="1" latinLnBrk="0" hangingPunct="1">
-              <a:lnSpc>
-                <a:spcPct val="90000"/>
-              </a:lnSpc>
-              <a:spcBef>
-                <a:spcPts val="500"/>
-              </a:spcBef>
-              <a:buFont typeface="Arial" panose="020B0604020202020204" pitchFamily="34" charset="0"/>
-              <a:buChar char="•"/>
-              <a:defRPr sz="1800" kern="1200">
-                <a:solidFill>
-                  <a:schemeClr val="tx1"/>
-                </a:solidFill>
-                <a:latin typeface="+mn-lt"/>
-                <a:ea typeface="+mn-ea"/>
-                <a:cs typeface="+mn-cs"/>
-              </a:defRPr>
-            </a:lvl7pPr>
-            <a:lvl8pPr marL="3429000" indent="-228600" algn="l" defTabSz="914400" rtl="0" eaLnBrk="1" latinLnBrk="0" hangingPunct="1">
-              <a:lnSpc>
-                <a:spcPct val="90000"/>
-              </a:lnSpc>
-              <a:spcBef>
-                <a:spcPts val="500"/>
-              </a:spcBef>
-              <a:buFont typeface="Arial" panose="020B0604020202020204" pitchFamily="34" charset="0"/>
-              <a:buChar char="•"/>
-              <a:defRPr sz="1800" kern="1200">
-                <a:solidFill>
-                  <a:schemeClr val="tx1"/>
-                </a:solidFill>
-                <a:latin typeface="+mn-lt"/>
-                <a:ea typeface="+mn-ea"/>
-                <a:cs typeface="+mn-cs"/>
-              </a:defRPr>
-            </a:lvl8pPr>
-            <a:lvl9pPr marL="3886200" indent="-228600" algn="l" defTabSz="914400" rtl="0" eaLnBrk="1" latinLnBrk="0" hangingPunct="1">
-              <a:lnSpc>
-                <a:spcPct val="90000"/>
-              </a:lnSpc>
-              <a:spcBef>
-                <a:spcPts val="500"/>
-              </a:spcBef>
-              <a:buFont typeface="Arial" panose="020B0604020202020204" pitchFamily="34" charset="0"/>
-              <a:buChar char="•"/>
-              <a:defRPr sz="1800" kern="1200">
-                <a:solidFill>
-                  <a:schemeClr val="tx1"/>
-                </a:solidFill>
-                <a:latin typeface="+mn-lt"/>
-                <a:ea typeface="+mn-ea"/>
-                <a:cs typeface="+mn-cs"/>
-              </a:defRPr>
-            </a:lvl9pPr>
-          </a:lstStyle>
-          <a:p>
-            <a:r>
-              <a:rPr lang="vi-VN"/>
-              <a:t>Có thể có ít chỗ hơn số lượng học sinh </a:t>
-            </a:r>
-            <a:endParaRPr lang="vi-VN" dirty="0"/>
+              </a:rPr>
+              <a:t>Có thể có ít chỗ hơn số lượng học sinh</a:t>
+            </a:r>
           </a:p>
         </p:txBody>
       </p:sp>
@@ -5758,45 +6009,635 @@
       </p:sp>
       <p:sp>
         <p:nvSpPr>
-          <p:cNvPr id="8" name="Content Placeholder 7">
-            <a:extLst>
-              <a:ext uri="{FF2B5EF4-FFF2-40B4-BE49-F238E27FC236}">
-                <a16:creationId xmlns:a16="http://schemas.microsoft.com/office/drawing/2014/main" id="{F467961C-FDD1-B8DB-45C0-11DDB90BEA01}"/>
-              </a:ext>
-            </a:extLst>
-          </p:cNvPr>
-          <p:cNvSpPr>
-            <a:spLocks noGrp="1"/>
-          </p:cNvSpPr>
-          <p:nvPr>
-            <p:ph idx="1"/>
-          </p:nvPr>
-        </p:nvSpPr>
-        <p:spPr/>
-        <p:txBody>
-          <a:bodyPr/>
-          <a:lstStyle/>
-          <a:p>
-            <a:r>
-              <a:rPr lang="vi-VN"/>
-              <a:t>Đầu vào: Nạp ba tệp excel chứa danh sách CLB, các CLB học sinh muốn thi và điểm tương ứng, thứ tự sắp xếp của học sinh</a:t>
-            </a:r>
-            <a:endParaRPr lang="vi-VN" dirty="0"/>
-          </a:p>
-          <a:p>
-            <a:r>
-              <a:rPr lang="vi-VN"/>
-              <a:t>Phần mềm sẽ: Xử lí các dữ liệu đó</a:t>
-            </a:r>
-          </a:p>
-          <a:p>
-            <a:r>
-              <a:rPr lang="vi-VN"/>
-              <a:t>Đầu ra: Hiển thị thông số như danh sách HS đạt các CLB, danh sách HS chưa có chỗ, thời khóa biểu CLB của học sinh,…</a:t>
-            </a:r>
-          </a:p>
-          <a:p>
-            <a:endParaRPr lang="vi-VN" dirty="0"/>
+          <p:cNvPr id="8" name="Rounded Rectangle 7"/>
+          <p:cNvSpPr/>
+          <p:nvPr/>
+        </p:nvSpPr>
+        <p:spPr>
+          <a:xfrm>
+            <a:off x="841248" y="1874519"/>
+            <a:ext cx="3108960" cy="4023360"/>
+          </a:xfrm>
+          <a:prstGeom prst="roundRect">
+            <a:avLst>
+              <a:gd name="adj" fmla="val 6000"/>
+            </a:avLst>
+          </a:prstGeom>
+          <a:solidFill>
+            <a:srgbClr val="F3F4F1"/>
+          </a:solidFill>
+          <a:ln>
+            <a:noFill/>
+          </a:ln>
+          <a:effectLst/>
+        </p:spPr>
+        <p:style>
+          <a:lnRef idx="1">
+            <a:schemeClr val="accent1"/>
+          </a:lnRef>
+          <a:fillRef idx="3">
+            <a:schemeClr val="accent1"/>
+          </a:fillRef>
+          <a:effectRef idx="2">
+            <a:schemeClr val="accent1"/>
+          </a:effectRef>
+          <a:fontRef idx="minor">
+            <a:schemeClr val="lt1"/>
+          </a:fontRef>
+        </p:style>
+        <p:txBody>
+          <a:bodyPr rtlCol="0" anchor="ctr"/>
+          <a:lstStyle/>
+          <a:p/>
+        </p:txBody>
+      </p:sp>
+      <p:sp>
+        <p:nvSpPr>
+          <p:cNvPr id="9" name="Oval 8"/>
+          <p:cNvSpPr/>
+          <p:nvPr/>
+        </p:nvSpPr>
+        <p:spPr>
+          <a:xfrm>
+            <a:off x="1161288" y="2240279"/>
+            <a:ext cx="914400" cy="914400"/>
+          </a:xfrm>
+          <a:prstGeom prst="ellipse">
+            <a:avLst/>
+          </a:prstGeom>
+          <a:solidFill>
+            <a:srgbClr val="DCE9E0"/>
+          </a:solidFill>
+          <a:ln>
+            <a:noFill/>
+          </a:ln>
+          <a:effectLst/>
+        </p:spPr>
+        <p:style>
+          <a:lnRef idx="1">
+            <a:schemeClr val="accent1"/>
+          </a:lnRef>
+          <a:fillRef idx="3">
+            <a:schemeClr val="accent1"/>
+          </a:fillRef>
+          <a:effectRef idx="2">
+            <a:schemeClr val="accent1"/>
+          </a:effectRef>
+          <a:fontRef idx="minor">
+            <a:schemeClr val="lt1"/>
+          </a:fontRef>
+        </p:style>
+        <p:txBody>
+          <a:bodyPr rtlCol="0" anchor="ctr"/>
+          <a:lstStyle/>
+          <a:p>
+            <a:pPr algn="ctr"/>
+          </a:p>
+        </p:txBody>
+      </p:sp>
+      <p:pic>
+        <p:nvPicPr>
+          <p:cNvPr id="10" name="Picture 9" descr="excel_moss.png"/>
+          <p:cNvPicPr>
+            <a:picLocks noChangeAspect="1"/>
+          </p:cNvPicPr>
+          <p:nvPr/>
+        </p:nvPicPr>
+        <p:blipFill>
+          <a:blip r:embed="rId2"/>
+          <a:stretch>
+            <a:fillRect/>
+          </a:stretch>
+        </p:blipFill>
+        <p:spPr>
+          <a:xfrm>
+            <a:off x="1399032" y="2478024"/>
+            <a:ext cx="438912" cy="438912"/>
+          </a:xfrm>
+          <a:prstGeom prst="rect">
+            <a:avLst/>
+          </a:prstGeom>
+        </p:spPr>
+      </p:pic>
+      <p:sp>
+        <p:nvSpPr>
+          <p:cNvPr id="11" name="TextBox 10"/>
+          <p:cNvSpPr txBox="1"/>
+          <p:nvPr/>
+        </p:nvSpPr>
+        <p:spPr>
+          <a:xfrm>
+            <a:off x="1161288" y="3383279"/>
+            <a:ext cx="2468880" cy="365760"/>
+          </a:xfrm>
+          <a:prstGeom prst="rect">
+            <a:avLst/>
+          </a:prstGeom>
+          <a:noFill/>
+        </p:spPr>
+        <p:txBody>
+          <a:bodyPr wrap="square" anchor="t" lIns="0" rIns="0" tIns="0" bIns="0">
+            <a:spAutoFit/>
+          </a:bodyPr>
+          <a:lstStyle/>
+          <a:p>
+            <a:pPr algn="l"/>
+            <a:r>
+              <a:rPr sz="1300" b="1" lang="vi-VN" spc="150">
+                <a:solidFill>
+                  <a:srgbClr val="3F6B52"/>
+                </a:solidFill>
+                <a:latin typeface="Arial"/>
+              </a:rPr>
+              <a:t>ĐẦU VÀO</a:t>
+            </a:r>
+          </a:p>
+        </p:txBody>
+      </p:sp>
+      <p:sp>
+        <p:nvSpPr>
+          <p:cNvPr id="12" name="TextBox 11"/>
+          <p:cNvSpPr txBox="1"/>
+          <p:nvPr/>
+        </p:nvSpPr>
+        <p:spPr>
+          <a:xfrm>
+            <a:off x="1161288" y="3794760"/>
+            <a:ext cx="2468880" cy="2011680"/>
+          </a:xfrm>
+          <a:prstGeom prst="rect">
+            <a:avLst/>
+          </a:prstGeom>
+          <a:noFill/>
+        </p:spPr>
+        <p:txBody>
+          <a:bodyPr wrap="square" anchor="t" lIns="0" rIns="0" tIns="0" bIns="0">
+            <a:spAutoFit/>
+          </a:bodyPr>
+          <a:lstStyle/>
+          <a:p>
+            <a:pPr algn="l"/>
+            <a:r>
+              <a:rPr sz="1600" b="0" lang="vi-VN">
+                <a:solidFill>
+                  <a:srgbClr val="1F1F1F"/>
+                </a:solidFill>
+                <a:latin typeface="Arial"/>
+              </a:rPr>
+              <a:t>Nạp ba tệp excel chứa danh sách CLB, các CLB học sinh muốn thi và điểm tương ứng, thứ tự sắp xếp của học sinh</a:t>
+            </a:r>
+          </a:p>
+        </p:txBody>
+      </p:sp>
+      <p:sp>
+        <p:nvSpPr>
+          <p:cNvPr id="13" name="Right Arrow 12"/>
+          <p:cNvSpPr/>
+          <p:nvPr/>
+        </p:nvSpPr>
+        <p:spPr>
+          <a:xfrm>
+            <a:off x="4059936" y="3703320"/>
+            <a:ext cx="374904" cy="365760"/>
+          </a:xfrm>
+          <a:prstGeom prst="rightArrow">
+            <a:avLst/>
+          </a:prstGeom>
+          <a:solidFill>
+            <a:srgbClr val="D5D8D2"/>
+          </a:solidFill>
+          <a:ln>
+            <a:noFill/>
+          </a:ln>
+          <a:effectLst/>
+        </p:spPr>
+        <p:style>
+          <a:lnRef idx="1">
+            <a:schemeClr val="accent1"/>
+          </a:lnRef>
+          <a:fillRef idx="3">
+            <a:schemeClr val="accent1"/>
+          </a:fillRef>
+          <a:effectRef idx="2">
+            <a:schemeClr val="accent1"/>
+          </a:effectRef>
+          <a:fontRef idx="minor">
+            <a:schemeClr val="lt1"/>
+          </a:fontRef>
+        </p:style>
+        <p:txBody>
+          <a:bodyPr rtlCol="0" anchor="ctr"/>
+          <a:lstStyle/>
+          <a:p>
+            <a:pPr algn="ctr"/>
+          </a:p>
+        </p:txBody>
+      </p:sp>
+      <p:sp>
+        <p:nvSpPr>
+          <p:cNvPr id="14" name="Rounded Rectangle 13"/>
+          <p:cNvSpPr/>
+          <p:nvPr/>
+        </p:nvSpPr>
+        <p:spPr>
+          <a:xfrm>
+            <a:off x="4544568" y="1874519"/>
+            <a:ext cx="3108960" cy="4023360"/>
+          </a:xfrm>
+          <a:prstGeom prst="roundRect">
+            <a:avLst>
+              <a:gd name="adj" fmla="val 6000"/>
+            </a:avLst>
+          </a:prstGeom>
+          <a:solidFill>
+            <a:srgbClr val="3F6B52"/>
+          </a:solidFill>
+          <a:ln>
+            <a:noFill/>
+          </a:ln>
+          <a:effectLst/>
+        </p:spPr>
+        <p:style>
+          <a:lnRef idx="1">
+            <a:schemeClr val="accent1"/>
+          </a:lnRef>
+          <a:fillRef idx="3">
+            <a:schemeClr val="accent1"/>
+          </a:fillRef>
+          <a:effectRef idx="2">
+            <a:schemeClr val="accent1"/>
+          </a:effectRef>
+          <a:fontRef idx="minor">
+            <a:schemeClr val="lt1"/>
+          </a:fontRef>
+        </p:style>
+        <p:txBody>
+          <a:bodyPr rtlCol="0" anchor="ctr"/>
+          <a:lstStyle/>
+          <a:p/>
+        </p:txBody>
+      </p:sp>
+      <p:sp>
+        <p:nvSpPr>
+          <p:cNvPr id="15" name="Oval 14"/>
+          <p:cNvSpPr/>
+          <p:nvPr/>
+        </p:nvSpPr>
+        <p:spPr>
+          <a:xfrm>
+            <a:off x="4864607" y="2240279"/>
+            <a:ext cx="914400" cy="914400"/>
+          </a:xfrm>
+          <a:prstGeom prst="ellipse">
+            <a:avLst/>
+          </a:prstGeom>
+          <a:solidFill>
+            <a:srgbClr val="2F523E"/>
+          </a:solidFill>
+          <a:ln>
+            <a:noFill/>
+          </a:ln>
+          <a:effectLst/>
+        </p:spPr>
+        <p:style>
+          <a:lnRef idx="1">
+            <a:schemeClr val="accent1"/>
+          </a:lnRef>
+          <a:fillRef idx="3">
+            <a:schemeClr val="accent1"/>
+          </a:fillRef>
+          <a:effectRef idx="2">
+            <a:schemeClr val="accent1"/>
+          </a:effectRef>
+          <a:fontRef idx="minor">
+            <a:schemeClr val="lt1"/>
+          </a:fontRef>
+        </p:style>
+        <p:txBody>
+          <a:bodyPr rtlCol="0" anchor="ctr"/>
+          <a:lstStyle/>
+          <a:p>
+            <a:pPr algn="ctr"/>
+          </a:p>
+        </p:txBody>
+      </p:sp>
+      <p:pic>
+        <p:nvPicPr>
+          <p:cNvPr id="16" name="Picture 15" descr="cogs_white.png"/>
+          <p:cNvPicPr>
+            <a:picLocks noChangeAspect="1"/>
+          </p:cNvPicPr>
+          <p:nvPr/>
+        </p:nvPicPr>
+        <p:blipFill>
+          <a:blip r:embed="rId3"/>
+          <a:stretch>
+            <a:fillRect/>
+          </a:stretch>
+        </p:blipFill>
+        <p:spPr>
+          <a:xfrm>
+            <a:off x="5102351" y="2478024"/>
+            <a:ext cx="438912" cy="438912"/>
+          </a:xfrm>
+          <a:prstGeom prst="rect">
+            <a:avLst/>
+          </a:prstGeom>
+        </p:spPr>
+      </p:pic>
+      <p:sp>
+        <p:nvSpPr>
+          <p:cNvPr id="17" name="TextBox 16"/>
+          <p:cNvSpPr txBox="1"/>
+          <p:nvPr/>
+        </p:nvSpPr>
+        <p:spPr>
+          <a:xfrm>
+            <a:off x="4864607" y="3383279"/>
+            <a:ext cx="2468880" cy="365760"/>
+          </a:xfrm>
+          <a:prstGeom prst="rect">
+            <a:avLst/>
+          </a:prstGeom>
+          <a:noFill/>
+        </p:spPr>
+        <p:txBody>
+          <a:bodyPr wrap="square" anchor="t" lIns="0" rIns="0" tIns="0" bIns="0">
+            <a:spAutoFit/>
+          </a:bodyPr>
+          <a:lstStyle/>
+          <a:p>
+            <a:pPr algn="l"/>
+            <a:r>
+              <a:rPr sz="1300" b="1" lang="vi-VN" spc="150">
+                <a:solidFill>
+                  <a:srgbClr val="DCE9E0"/>
+                </a:solidFill>
+                <a:latin typeface="Arial"/>
+              </a:rPr>
+              <a:t>PHẦN MỀM SẼ</a:t>
+            </a:r>
+          </a:p>
+        </p:txBody>
+      </p:sp>
+      <p:sp>
+        <p:nvSpPr>
+          <p:cNvPr id="18" name="TextBox 17"/>
+          <p:cNvSpPr txBox="1"/>
+          <p:nvPr/>
+        </p:nvSpPr>
+        <p:spPr>
+          <a:xfrm>
+            <a:off x="4864607" y="3794760"/>
+            <a:ext cx="2468880" cy="2011680"/>
+          </a:xfrm>
+          <a:prstGeom prst="rect">
+            <a:avLst/>
+          </a:prstGeom>
+          <a:noFill/>
+        </p:spPr>
+        <p:txBody>
+          <a:bodyPr wrap="square" anchor="t" lIns="0" rIns="0" tIns="0" bIns="0">
+            <a:spAutoFit/>
+          </a:bodyPr>
+          <a:lstStyle/>
+          <a:p>
+            <a:pPr algn="l"/>
+            <a:r>
+              <a:rPr sz="1600" b="1" lang="vi-VN">
+                <a:solidFill>
+                  <a:srgbClr val="FFFFFF"/>
+                </a:solidFill>
+                <a:latin typeface="Arial"/>
+              </a:rPr>
+              <a:t>Xử lí các dữ liệu đó</a:t>
+            </a:r>
+          </a:p>
+        </p:txBody>
+      </p:sp>
+      <p:sp>
+        <p:nvSpPr>
+          <p:cNvPr id="19" name="Right Arrow 18"/>
+          <p:cNvSpPr/>
+          <p:nvPr/>
+        </p:nvSpPr>
+        <p:spPr>
+          <a:xfrm>
+            <a:off x="7763255" y="3703320"/>
+            <a:ext cx="374904" cy="365760"/>
+          </a:xfrm>
+          <a:prstGeom prst="rightArrow">
+            <a:avLst/>
+          </a:prstGeom>
+          <a:solidFill>
+            <a:srgbClr val="D5D8D2"/>
+          </a:solidFill>
+          <a:ln>
+            <a:noFill/>
+          </a:ln>
+          <a:effectLst/>
+        </p:spPr>
+        <p:style>
+          <a:lnRef idx="1">
+            <a:schemeClr val="accent1"/>
+          </a:lnRef>
+          <a:fillRef idx="3">
+            <a:schemeClr val="accent1"/>
+          </a:fillRef>
+          <a:effectRef idx="2">
+            <a:schemeClr val="accent1"/>
+          </a:effectRef>
+          <a:fontRef idx="minor">
+            <a:schemeClr val="lt1"/>
+          </a:fontRef>
+        </p:style>
+        <p:txBody>
+          <a:bodyPr rtlCol="0" anchor="ctr"/>
+          <a:lstStyle/>
+          <a:p>
+            <a:pPr algn="ctr"/>
+          </a:p>
+        </p:txBody>
+      </p:sp>
+      <p:sp>
+        <p:nvSpPr>
+          <p:cNvPr id="20" name="Rounded Rectangle 19"/>
+          <p:cNvSpPr/>
+          <p:nvPr/>
+        </p:nvSpPr>
+        <p:spPr>
+          <a:xfrm>
+            <a:off x="8247888" y="1874519"/>
+            <a:ext cx="3108960" cy="4023360"/>
+          </a:xfrm>
+          <a:prstGeom prst="roundRect">
+            <a:avLst>
+              <a:gd name="adj" fmla="val 6000"/>
+            </a:avLst>
+          </a:prstGeom>
+          <a:solidFill>
+            <a:srgbClr val="F3F4F1"/>
+          </a:solidFill>
+          <a:ln>
+            <a:noFill/>
+          </a:ln>
+          <a:effectLst/>
+        </p:spPr>
+        <p:style>
+          <a:lnRef idx="1">
+            <a:schemeClr val="accent1"/>
+          </a:lnRef>
+          <a:fillRef idx="3">
+            <a:schemeClr val="accent1"/>
+          </a:fillRef>
+          <a:effectRef idx="2">
+            <a:schemeClr val="accent1"/>
+          </a:effectRef>
+          <a:fontRef idx="minor">
+            <a:schemeClr val="lt1"/>
+          </a:fontRef>
+        </p:style>
+        <p:txBody>
+          <a:bodyPr rtlCol="0" anchor="ctr"/>
+          <a:lstStyle/>
+          <a:p/>
+        </p:txBody>
+      </p:sp>
+      <p:sp>
+        <p:nvSpPr>
+          <p:cNvPr id="21" name="Oval 20"/>
+          <p:cNvSpPr/>
+          <p:nvPr/>
+        </p:nvSpPr>
+        <p:spPr>
+          <a:xfrm>
+            <a:off x="8567928" y="2240279"/>
+            <a:ext cx="914400" cy="914400"/>
+          </a:xfrm>
+          <a:prstGeom prst="ellipse">
+            <a:avLst/>
+          </a:prstGeom>
+          <a:solidFill>
+            <a:srgbClr val="DCE9E0"/>
+          </a:solidFill>
+          <a:ln>
+            <a:noFill/>
+          </a:ln>
+          <a:effectLst/>
+        </p:spPr>
+        <p:style>
+          <a:lnRef idx="1">
+            <a:schemeClr val="accent1"/>
+          </a:lnRef>
+          <a:fillRef idx="3">
+            <a:schemeClr val="accent1"/>
+          </a:fillRef>
+          <a:effectRef idx="2">
+            <a:schemeClr val="accent1"/>
+          </a:effectRef>
+          <a:fontRef idx="minor">
+            <a:schemeClr val="lt1"/>
+          </a:fontRef>
+        </p:style>
+        <p:txBody>
+          <a:bodyPr rtlCol="0" anchor="ctr"/>
+          <a:lstStyle/>
+          <a:p>
+            <a:pPr algn="ctr"/>
+          </a:p>
+        </p:txBody>
+      </p:sp>
+      <p:pic>
+        <p:nvPicPr>
+          <p:cNvPr id="22" name="Picture 21" descr="list_moss.png"/>
+          <p:cNvPicPr>
+            <a:picLocks noChangeAspect="1"/>
+          </p:cNvPicPr>
+          <p:nvPr/>
+        </p:nvPicPr>
+        <p:blipFill>
+          <a:blip r:embed="rId4"/>
+          <a:stretch>
+            <a:fillRect/>
+          </a:stretch>
+        </p:blipFill>
+        <p:spPr>
+          <a:xfrm>
+            <a:off x="8805672" y="2478024"/>
+            <a:ext cx="438912" cy="438912"/>
+          </a:xfrm>
+          <a:prstGeom prst="rect">
+            <a:avLst/>
+          </a:prstGeom>
+        </p:spPr>
+      </p:pic>
+      <p:sp>
+        <p:nvSpPr>
+          <p:cNvPr id="23" name="TextBox 22"/>
+          <p:cNvSpPr txBox="1"/>
+          <p:nvPr/>
+        </p:nvSpPr>
+        <p:spPr>
+          <a:xfrm>
+            <a:off x="8567928" y="3383279"/>
+            <a:ext cx="2468880" cy="365760"/>
+          </a:xfrm>
+          <a:prstGeom prst="rect">
+            <a:avLst/>
+          </a:prstGeom>
+          <a:noFill/>
+        </p:spPr>
+        <p:txBody>
+          <a:bodyPr wrap="square" anchor="t" lIns="0" rIns="0" tIns="0" bIns="0">
+            <a:spAutoFit/>
+          </a:bodyPr>
+          <a:lstStyle/>
+          <a:p>
+            <a:pPr algn="l"/>
+            <a:r>
+              <a:rPr sz="1300" b="1" lang="vi-VN" spc="150">
+                <a:solidFill>
+                  <a:srgbClr val="3F6B52"/>
+                </a:solidFill>
+                <a:latin typeface="Arial"/>
+              </a:rPr>
+              <a:t>ĐẦU RA</a:t>
+            </a:r>
+          </a:p>
+        </p:txBody>
+      </p:sp>
+      <p:sp>
+        <p:nvSpPr>
+          <p:cNvPr id="24" name="TextBox 23"/>
+          <p:cNvSpPr txBox="1"/>
+          <p:nvPr/>
+        </p:nvSpPr>
+        <p:spPr>
+          <a:xfrm>
+            <a:off x="8567928" y="3794760"/>
+            <a:ext cx="2468880" cy="2011680"/>
+          </a:xfrm>
+          <a:prstGeom prst="rect">
+            <a:avLst/>
+          </a:prstGeom>
+          <a:noFill/>
+        </p:spPr>
+        <p:txBody>
+          <a:bodyPr wrap="square" anchor="t" lIns="0" rIns="0" tIns="0" bIns="0">
+            <a:spAutoFit/>
+          </a:bodyPr>
+          <a:lstStyle/>
+          <a:p>
+            <a:pPr algn="l"/>
+            <a:r>
+              <a:rPr sz="1600" b="0" lang="vi-VN">
+                <a:solidFill>
+                  <a:srgbClr val="1F1F1F"/>
+                </a:solidFill>
+                <a:latin typeface="Arial"/>
+              </a:rPr>
+              <a:t>Hiển thị thông số như danh sách HS đạt các CLB, danh sách HS chưa có chỗ, thời khóa biểu CLB của học sinh,…</a:t>
+            </a:r>
           </a:p>
         </p:txBody>
       </p:sp>
@@ -5859,50 +6700,837 @@
           </a:p>
         </p:txBody>
       </p:sp>
-      <p:sp>
-        <p:nvSpPr>
-          <p:cNvPr id="3" name="Content Placeholder 2">
-            <a:extLst>
-              <a:ext uri="{FF2B5EF4-FFF2-40B4-BE49-F238E27FC236}">
-                <a16:creationId xmlns:a16="http://schemas.microsoft.com/office/drawing/2014/main" id="{559A7B5D-40E9-2B84-7259-39F19F33125D}"/>
-              </a:ext>
-            </a:extLst>
-          </p:cNvPr>
-          <p:cNvSpPr>
-            <a:spLocks noGrp="1"/>
-          </p:cNvSpPr>
-          <p:nvPr>
-            <p:ph idx="1"/>
-          </p:nvPr>
-        </p:nvSpPr>
-        <p:spPr/>
-        <p:txBody>
-          <a:bodyPr/>
-          <a:lstStyle/>
-          <a:p>
-            <a:r>
-              <a:rPr lang="vi-VN"/>
-              <a:t>1. Nạp ba tệp excel</a:t>
-            </a:r>
-          </a:p>
-          <a:p>
-            <a:r>
-              <a:rPr lang="vi-VN"/>
-              <a:t>2. Xem mục cảnh báo dữ liệu</a:t>
-            </a:r>
-            <a:endParaRPr lang="vi-VN" dirty="0"/>
-          </a:p>
-          <a:p>
-            <a:r>
-              <a:rPr lang="vi-VN"/>
-              <a:t>3.Bấm chạy sắp xếp</a:t>
-            </a:r>
-            <a:endParaRPr lang="vi-VN" dirty="0"/>
-          </a:p>
-          <a:p>
-            <a:r>
-              <a:rPr lang="vi-VN"/>
-              <a:t>4. Xuất file kết quả</a:t>
+      <p:cxnSp>
+        <p:nvCxnSpPr>
+          <p:cNvPr id="3" name="Connector 2"/>
+          <p:cNvCxnSpPr/>
+          <p:nvPr/>
+        </p:nvCxnSpPr>
+        <p:spPr>
+          <a:xfrm>
+            <a:off x="2155698" y="2560320"/>
+            <a:ext cx="7886700" cy="0"/>
+          </a:xfrm>
+          <a:prstGeom prst="line">
+            <a:avLst/>
+          </a:prstGeom>
+          <a:ln w="38100">
+            <a:solidFill>
+              <a:srgbClr val="D5D8D2"/>
+            </a:solidFill>
+          </a:ln>
+        </p:spPr>
+        <p:style>
+          <a:lnRef idx="2">
+            <a:schemeClr val="accent1"/>
+          </a:lnRef>
+          <a:fillRef idx="0">
+            <a:schemeClr val="accent1"/>
+          </a:fillRef>
+          <a:effectRef idx="1">
+            <a:schemeClr val="accent1"/>
+          </a:effectRef>
+          <a:fontRef idx="minor">
+            <a:schemeClr val="tx1"/>
+          </a:fontRef>
+        </p:style>
+      </p:cxnSp>
+      <p:sp>
+        <p:nvSpPr>
+          <p:cNvPr id="4" name="Oval 3"/>
+          <p:cNvSpPr/>
+          <p:nvPr/>
+        </p:nvSpPr>
+        <p:spPr>
+          <a:xfrm>
+            <a:off x="1744218" y="2148840"/>
+            <a:ext cx="822960" cy="822960"/>
+          </a:xfrm>
+          <a:prstGeom prst="ellipse">
+            <a:avLst/>
+          </a:prstGeom>
+          <a:solidFill>
+            <a:srgbClr val="1F1F1F"/>
+          </a:solidFill>
+          <a:ln>
+            <a:noFill/>
+          </a:ln>
+          <a:effectLst/>
+        </p:spPr>
+        <p:style>
+          <a:lnRef idx="1">
+            <a:schemeClr val="accent1"/>
+          </a:lnRef>
+          <a:fillRef idx="3">
+            <a:schemeClr val="accent1"/>
+          </a:fillRef>
+          <a:effectRef idx="2">
+            <a:schemeClr val="accent1"/>
+          </a:effectRef>
+          <a:fontRef idx="minor">
+            <a:schemeClr val="lt1"/>
+          </a:fontRef>
+        </p:style>
+        <p:txBody>
+          <a:bodyPr rtlCol="0" anchor="ctr" lIns="0" rIns="0" tIns="0" bIns="0"/>
+          <a:lstStyle/>
+          <a:p>
+            <a:pPr algn="ctr"/>
+            <a:r>
+              <a:rPr sz="2100" b="1">
+                <a:solidFill>
+                  <a:srgbClr val="FFFFFF"/>
+                </a:solidFill>
+                <a:latin typeface="Arial"/>
+              </a:rPr>
+              <a:t>1</a:t>
+            </a:r>
+          </a:p>
+        </p:txBody>
+      </p:sp>
+      <p:sp>
+        <p:nvSpPr>
+          <p:cNvPr id="5" name="Rounded Rectangle 4"/>
+          <p:cNvSpPr/>
+          <p:nvPr/>
+        </p:nvSpPr>
+        <p:spPr>
+          <a:xfrm>
+            <a:off x="950976" y="3429000"/>
+            <a:ext cx="2409444" cy="2377440"/>
+          </a:xfrm>
+          <a:prstGeom prst="roundRect">
+            <a:avLst>
+              <a:gd name="adj" fmla="val 6000"/>
+            </a:avLst>
+          </a:prstGeom>
+          <a:solidFill>
+            <a:srgbClr val="F3F4F1"/>
+          </a:solidFill>
+          <a:ln>
+            <a:noFill/>
+          </a:ln>
+          <a:effectLst/>
+        </p:spPr>
+        <p:style>
+          <a:lnRef idx="1">
+            <a:schemeClr val="accent1"/>
+          </a:lnRef>
+          <a:fillRef idx="3">
+            <a:schemeClr val="accent1"/>
+          </a:fillRef>
+          <a:effectRef idx="2">
+            <a:schemeClr val="accent1"/>
+          </a:effectRef>
+          <a:fontRef idx="minor">
+            <a:schemeClr val="lt1"/>
+          </a:fontRef>
+        </p:style>
+        <p:txBody>
+          <a:bodyPr rtlCol="0" anchor="ctr"/>
+          <a:lstStyle/>
+          <a:p/>
+        </p:txBody>
+      </p:sp>
+      <p:sp>
+        <p:nvSpPr>
+          <p:cNvPr id="6" name="Oval 5"/>
+          <p:cNvSpPr/>
+          <p:nvPr/>
+        </p:nvSpPr>
+        <p:spPr>
+          <a:xfrm>
+            <a:off x="1744218" y="3703320"/>
+            <a:ext cx="822960" cy="822960"/>
+          </a:xfrm>
+          <a:prstGeom prst="ellipse">
+            <a:avLst/>
+          </a:prstGeom>
+          <a:solidFill>
+            <a:srgbClr val="DCE9E0"/>
+          </a:solidFill>
+          <a:ln>
+            <a:noFill/>
+          </a:ln>
+          <a:effectLst/>
+        </p:spPr>
+        <p:style>
+          <a:lnRef idx="1">
+            <a:schemeClr val="accent1"/>
+          </a:lnRef>
+          <a:fillRef idx="3">
+            <a:schemeClr val="accent1"/>
+          </a:fillRef>
+          <a:effectRef idx="2">
+            <a:schemeClr val="accent1"/>
+          </a:effectRef>
+          <a:fontRef idx="minor">
+            <a:schemeClr val="lt1"/>
+          </a:fontRef>
+        </p:style>
+        <p:txBody>
+          <a:bodyPr rtlCol="0" anchor="ctr"/>
+          <a:lstStyle/>
+          <a:p>
+            <a:pPr algn="ctr"/>
+          </a:p>
+        </p:txBody>
+      </p:sp>
+      <p:pic>
+        <p:nvPicPr>
+          <p:cNvPr id="7" name="Picture 6" descr="excel_moss.png"/>
+          <p:cNvPicPr>
+            <a:picLocks noChangeAspect="1"/>
+          </p:cNvPicPr>
+          <p:nvPr/>
+        </p:nvPicPr>
+        <p:blipFill>
+          <a:blip r:embed="rId2"/>
+          <a:stretch>
+            <a:fillRect/>
+          </a:stretch>
+        </p:blipFill>
+        <p:spPr>
+          <a:xfrm>
+            <a:off x="1958187" y="3917289"/>
+            <a:ext cx="395020" cy="395020"/>
+          </a:xfrm>
+          <a:prstGeom prst="rect">
+            <a:avLst/>
+          </a:prstGeom>
+        </p:spPr>
+      </p:pic>
+      <p:sp>
+        <p:nvSpPr>
+          <p:cNvPr id="8" name="TextBox 7"/>
+          <p:cNvSpPr txBox="1"/>
+          <p:nvPr/>
+        </p:nvSpPr>
+        <p:spPr>
+          <a:xfrm>
+            <a:off x="1133856" y="4709160"/>
+            <a:ext cx="2043684" cy="914400"/>
+          </a:xfrm>
+          <a:prstGeom prst="rect">
+            <a:avLst/>
+          </a:prstGeom>
+          <a:noFill/>
+        </p:spPr>
+        <p:txBody>
+          <a:bodyPr wrap="square" anchor="t" lIns="0" rIns="0" tIns="0" bIns="0">
+            <a:spAutoFit/>
+          </a:bodyPr>
+          <a:lstStyle/>
+          <a:p>
+            <a:pPr algn="ctr"/>
+            <a:r>
+              <a:rPr sz="1800" b="1" lang="vi-VN">
+                <a:solidFill>
+                  <a:srgbClr val="1F1F1F"/>
+                </a:solidFill>
+                <a:latin typeface="Arial"/>
+              </a:rPr>
+              <a:t>Nạp ba tệp excel</a:t>
+            </a:r>
+          </a:p>
+        </p:txBody>
+      </p:sp>
+      <p:sp>
+        <p:nvSpPr>
+          <p:cNvPr id="9" name="Oval 8"/>
+          <p:cNvSpPr/>
+          <p:nvPr/>
+        </p:nvSpPr>
+        <p:spPr>
+          <a:xfrm>
+            <a:off x="4373118" y="2148840"/>
+            <a:ext cx="822960" cy="822960"/>
+          </a:xfrm>
+          <a:prstGeom prst="ellipse">
+            <a:avLst/>
+          </a:prstGeom>
+          <a:solidFill>
+            <a:srgbClr val="1F1F1F"/>
+          </a:solidFill>
+          <a:ln>
+            <a:noFill/>
+          </a:ln>
+          <a:effectLst/>
+        </p:spPr>
+        <p:style>
+          <a:lnRef idx="1">
+            <a:schemeClr val="accent1"/>
+          </a:lnRef>
+          <a:fillRef idx="3">
+            <a:schemeClr val="accent1"/>
+          </a:fillRef>
+          <a:effectRef idx="2">
+            <a:schemeClr val="accent1"/>
+          </a:effectRef>
+          <a:fontRef idx="minor">
+            <a:schemeClr val="lt1"/>
+          </a:fontRef>
+        </p:style>
+        <p:txBody>
+          <a:bodyPr rtlCol="0" anchor="ctr" lIns="0" rIns="0" tIns="0" bIns="0"/>
+          <a:lstStyle/>
+          <a:p>
+            <a:pPr algn="ctr"/>
+            <a:r>
+              <a:rPr sz="2100" b="1">
+                <a:solidFill>
+                  <a:srgbClr val="FFFFFF"/>
+                </a:solidFill>
+                <a:latin typeface="Arial"/>
+              </a:rPr>
+              <a:t>2</a:t>
+            </a:r>
+          </a:p>
+        </p:txBody>
+      </p:sp>
+      <p:sp>
+        <p:nvSpPr>
+          <p:cNvPr id="10" name="Rounded Rectangle 9"/>
+          <p:cNvSpPr/>
+          <p:nvPr/>
+        </p:nvSpPr>
+        <p:spPr>
+          <a:xfrm>
+            <a:off x="3579876" y="3429000"/>
+            <a:ext cx="2409444" cy="2377440"/>
+          </a:xfrm>
+          <a:prstGeom prst="roundRect">
+            <a:avLst>
+              <a:gd name="adj" fmla="val 6000"/>
+            </a:avLst>
+          </a:prstGeom>
+          <a:solidFill>
+            <a:srgbClr val="F3F4F1"/>
+          </a:solidFill>
+          <a:ln>
+            <a:noFill/>
+          </a:ln>
+          <a:effectLst/>
+        </p:spPr>
+        <p:style>
+          <a:lnRef idx="1">
+            <a:schemeClr val="accent1"/>
+          </a:lnRef>
+          <a:fillRef idx="3">
+            <a:schemeClr val="accent1"/>
+          </a:fillRef>
+          <a:effectRef idx="2">
+            <a:schemeClr val="accent1"/>
+          </a:effectRef>
+          <a:fontRef idx="minor">
+            <a:schemeClr val="lt1"/>
+          </a:fontRef>
+        </p:style>
+        <p:txBody>
+          <a:bodyPr rtlCol="0" anchor="ctr"/>
+          <a:lstStyle/>
+          <a:p/>
+        </p:txBody>
+      </p:sp>
+      <p:sp>
+        <p:nvSpPr>
+          <p:cNvPr id="11" name="Oval 10"/>
+          <p:cNvSpPr/>
+          <p:nvPr/>
+        </p:nvSpPr>
+        <p:spPr>
+          <a:xfrm>
+            <a:off x="4373118" y="3703320"/>
+            <a:ext cx="822960" cy="822960"/>
+          </a:xfrm>
+          <a:prstGeom prst="ellipse">
+            <a:avLst/>
+          </a:prstGeom>
+          <a:solidFill>
+            <a:srgbClr val="DCE9E0"/>
+          </a:solidFill>
+          <a:ln>
+            <a:noFill/>
+          </a:ln>
+          <a:effectLst/>
+        </p:spPr>
+        <p:style>
+          <a:lnRef idx="1">
+            <a:schemeClr val="accent1"/>
+          </a:lnRef>
+          <a:fillRef idx="3">
+            <a:schemeClr val="accent1"/>
+          </a:fillRef>
+          <a:effectRef idx="2">
+            <a:schemeClr val="accent1"/>
+          </a:effectRef>
+          <a:fontRef idx="minor">
+            <a:schemeClr val="lt1"/>
+          </a:fontRef>
+        </p:style>
+        <p:txBody>
+          <a:bodyPr rtlCol="0" anchor="ctr"/>
+          <a:lstStyle/>
+          <a:p>
+            <a:pPr algn="ctr"/>
+          </a:p>
+        </p:txBody>
+      </p:sp>
+      <p:pic>
+        <p:nvPicPr>
+          <p:cNvPr id="12" name="Picture 11" descr="warn_moss.png"/>
+          <p:cNvPicPr>
+            <a:picLocks noChangeAspect="1"/>
+          </p:cNvPicPr>
+          <p:nvPr/>
+        </p:nvPicPr>
+        <p:blipFill>
+          <a:blip r:embed="rId3"/>
+          <a:stretch>
+            <a:fillRect/>
+          </a:stretch>
+        </p:blipFill>
+        <p:spPr>
+          <a:xfrm>
+            <a:off x="4587087" y="3917289"/>
+            <a:ext cx="395020" cy="395020"/>
+          </a:xfrm>
+          <a:prstGeom prst="rect">
+            <a:avLst/>
+          </a:prstGeom>
+        </p:spPr>
+      </p:pic>
+      <p:sp>
+        <p:nvSpPr>
+          <p:cNvPr id="13" name="TextBox 12"/>
+          <p:cNvSpPr txBox="1"/>
+          <p:nvPr/>
+        </p:nvSpPr>
+        <p:spPr>
+          <a:xfrm>
+            <a:off x="3762756" y="4709160"/>
+            <a:ext cx="2043684" cy="914400"/>
+          </a:xfrm>
+          <a:prstGeom prst="rect">
+            <a:avLst/>
+          </a:prstGeom>
+          <a:noFill/>
+        </p:spPr>
+        <p:txBody>
+          <a:bodyPr wrap="square" anchor="t" lIns="0" rIns="0" tIns="0" bIns="0">
+            <a:spAutoFit/>
+          </a:bodyPr>
+          <a:lstStyle/>
+          <a:p>
+            <a:pPr algn="ctr"/>
+            <a:r>
+              <a:rPr sz="1800" b="1" lang="vi-VN">
+                <a:solidFill>
+                  <a:srgbClr val="1F1F1F"/>
+                </a:solidFill>
+                <a:latin typeface="Arial"/>
+              </a:rPr>
+              <a:t>Xem mục cảnh báo dữ liệu</a:t>
+            </a:r>
+          </a:p>
+        </p:txBody>
+      </p:sp>
+      <p:sp>
+        <p:nvSpPr>
+          <p:cNvPr id="14" name="Oval 13"/>
+          <p:cNvSpPr/>
+          <p:nvPr/>
+        </p:nvSpPr>
+        <p:spPr>
+          <a:xfrm>
+            <a:off x="7002018" y="2148840"/>
+            <a:ext cx="822960" cy="822960"/>
+          </a:xfrm>
+          <a:prstGeom prst="ellipse">
+            <a:avLst/>
+          </a:prstGeom>
+          <a:solidFill>
+            <a:srgbClr val="3F6B52"/>
+          </a:solidFill>
+          <a:ln>
+            <a:noFill/>
+          </a:ln>
+          <a:effectLst/>
+        </p:spPr>
+        <p:style>
+          <a:lnRef idx="1">
+            <a:schemeClr val="accent1"/>
+          </a:lnRef>
+          <a:fillRef idx="3">
+            <a:schemeClr val="accent1"/>
+          </a:fillRef>
+          <a:effectRef idx="2">
+            <a:schemeClr val="accent1"/>
+          </a:effectRef>
+          <a:fontRef idx="minor">
+            <a:schemeClr val="lt1"/>
+          </a:fontRef>
+        </p:style>
+        <p:txBody>
+          <a:bodyPr rtlCol="0" anchor="ctr" lIns="0" rIns="0" tIns="0" bIns="0"/>
+          <a:lstStyle/>
+          <a:p>
+            <a:pPr algn="ctr"/>
+            <a:r>
+              <a:rPr sz="2100" b="1">
+                <a:solidFill>
+                  <a:srgbClr val="FFFFFF"/>
+                </a:solidFill>
+                <a:latin typeface="Arial"/>
+              </a:rPr>
+              <a:t>3</a:t>
+            </a:r>
+          </a:p>
+        </p:txBody>
+      </p:sp>
+      <p:sp>
+        <p:nvSpPr>
+          <p:cNvPr id="15" name="Rounded Rectangle 14"/>
+          <p:cNvSpPr/>
+          <p:nvPr/>
+        </p:nvSpPr>
+        <p:spPr>
+          <a:xfrm>
+            <a:off x="6208776" y="3429000"/>
+            <a:ext cx="2409444" cy="2377440"/>
+          </a:xfrm>
+          <a:prstGeom prst="roundRect">
+            <a:avLst>
+              <a:gd name="adj" fmla="val 6000"/>
+            </a:avLst>
+          </a:prstGeom>
+          <a:solidFill>
+            <a:srgbClr val="F3F4F1"/>
+          </a:solidFill>
+          <a:ln>
+            <a:noFill/>
+          </a:ln>
+          <a:effectLst/>
+        </p:spPr>
+        <p:style>
+          <a:lnRef idx="1">
+            <a:schemeClr val="accent1"/>
+          </a:lnRef>
+          <a:fillRef idx="3">
+            <a:schemeClr val="accent1"/>
+          </a:fillRef>
+          <a:effectRef idx="2">
+            <a:schemeClr val="accent1"/>
+          </a:effectRef>
+          <a:fontRef idx="minor">
+            <a:schemeClr val="lt1"/>
+          </a:fontRef>
+        </p:style>
+        <p:txBody>
+          <a:bodyPr rtlCol="0" anchor="ctr"/>
+          <a:lstStyle/>
+          <a:p/>
+        </p:txBody>
+      </p:sp>
+      <p:sp>
+        <p:nvSpPr>
+          <p:cNvPr id="16" name="Oval 15"/>
+          <p:cNvSpPr/>
+          <p:nvPr/>
+        </p:nvSpPr>
+        <p:spPr>
+          <a:xfrm>
+            <a:off x="7002018" y="3703320"/>
+            <a:ext cx="822960" cy="822960"/>
+          </a:xfrm>
+          <a:prstGeom prst="ellipse">
+            <a:avLst/>
+          </a:prstGeom>
+          <a:solidFill>
+            <a:srgbClr val="DCE9E0"/>
+          </a:solidFill>
+          <a:ln>
+            <a:noFill/>
+          </a:ln>
+          <a:effectLst/>
+        </p:spPr>
+        <p:style>
+          <a:lnRef idx="1">
+            <a:schemeClr val="accent1"/>
+          </a:lnRef>
+          <a:fillRef idx="3">
+            <a:schemeClr val="accent1"/>
+          </a:fillRef>
+          <a:effectRef idx="2">
+            <a:schemeClr val="accent1"/>
+          </a:effectRef>
+          <a:fontRef idx="minor">
+            <a:schemeClr val="lt1"/>
+          </a:fontRef>
+        </p:style>
+        <p:txBody>
+          <a:bodyPr rtlCol="0" anchor="ctr"/>
+          <a:lstStyle/>
+          <a:p>
+            <a:pPr algn="ctr"/>
+          </a:p>
+        </p:txBody>
+      </p:sp>
+      <p:pic>
+        <p:nvPicPr>
+          <p:cNvPr id="17" name="Picture 16" descr="play_moss.png"/>
+          <p:cNvPicPr>
+            <a:picLocks noChangeAspect="1"/>
+          </p:cNvPicPr>
+          <p:nvPr/>
+        </p:nvPicPr>
+        <p:blipFill>
+          <a:blip r:embed="rId4"/>
+          <a:stretch>
+            <a:fillRect/>
+          </a:stretch>
+        </p:blipFill>
+        <p:spPr>
+          <a:xfrm>
+            <a:off x="7215987" y="3917289"/>
+            <a:ext cx="395020" cy="395020"/>
+          </a:xfrm>
+          <a:prstGeom prst="rect">
+            <a:avLst/>
+          </a:prstGeom>
+        </p:spPr>
+      </p:pic>
+      <p:sp>
+        <p:nvSpPr>
+          <p:cNvPr id="18" name="TextBox 17"/>
+          <p:cNvSpPr txBox="1"/>
+          <p:nvPr/>
+        </p:nvSpPr>
+        <p:spPr>
+          <a:xfrm>
+            <a:off x="6391656" y="4709160"/>
+            <a:ext cx="2043684" cy="914400"/>
+          </a:xfrm>
+          <a:prstGeom prst="rect">
+            <a:avLst/>
+          </a:prstGeom>
+          <a:noFill/>
+        </p:spPr>
+        <p:txBody>
+          <a:bodyPr wrap="square" anchor="t" lIns="0" rIns="0" tIns="0" bIns="0">
+            <a:spAutoFit/>
+          </a:bodyPr>
+          <a:lstStyle/>
+          <a:p>
+            <a:pPr algn="ctr"/>
+            <a:r>
+              <a:rPr sz="1800" b="1" lang="vi-VN">
+                <a:solidFill>
+                  <a:srgbClr val="1F1F1F"/>
+                </a:solidFill>
+                <a:latin typeface="Arial"/>
+              </a:rPr>
+              <a:t>Bấm chạy sắp xếp</a:t>
+            </a:r>
+          </a:p>
+        </p:txBody>
+      </p:sp>
+      <p:sp>
+        <p:nvSpPr>
+          <p:cNvPr id="19" name="Oval 18"/>
+          <p:cNvSpPr/>
+          <p:nvPr/>
+        </p:nvSpPr>
+        <p:spPr>
+          <a:xfrm>
+            <a:off x="9630918" y="2148840"/>
+            <a:ext cx="822960" cy="822960"/>
+          </a:xfrm>
+          <a:prstGeom prst="ellipse">
+            <a:avLst/>
+          </a:prstGeom>
+          <a:solidFill>
+            <a:srgbClr val="1F1F1F"/>
+          </a:solidFill>
+          <a:ln>
+            <a:noFill/>
+          </a:ln>
+          <a:effectLst/>
+        </p:spPr>
+        <p:style>
+          <a:lnRef idx="1">
+            <a:schemeClr val="accent1"/>
+          </a:lnRef>
+          <a:fillRef idx="3">
+            <a:schemeClr val="accent1"/>
+          </a:fillRef>
+          <a:effectRef idx="2">
+            <a:schemeClr val="accent1"/>
+          </a:effectRef>
+          <a:fontRef idx="minor">
+            <a:schemeClr val="lt1"/>
+          </a:fontRef>
+        </p:style>
+        <p:txBody>
+          <a:bodyPr rtlCol="0" anchor="ctr" lIns="0" rIns="0" tIns="0" bIns="0"/>
+          <a:lstStyle/>
+          <a:p>
+            <a:pPr algn="ctr"/>
+            <a:r>
+              <a:rPr sz="2100" b="1">
+                <a:solidFill>
+                  <a:srgbClr val="FFFFFF"/>
+                </a:solidFill>
+                <a:latin typeface="Arial"/>
+              </a:rPr>
+              <a:t>4</a:t>
+            </a:r>
+          </a:p>
+        </p:txBody>
+      </p:sp>
+      <p:sp>
+        <p:nvSpPr>
+          <p:cNvPr id="20" name="Rounded Rectangle 19"/>
+          <p:cNvSpPr/>
+          <p:nvPr/>
+        </p:nvSpPr>
+        <p:spPr>
+          <a:xfrm>
+            <a:off x="8837676" y="3429000"/>
+            <a:ext cx="2409444" cy="2377440"/>
+          </a:xfrm>
+          <a:prstGeom prst="roundRect">
+            <a:avLst>
+              <a:gd name="adj" fmla="val 6000"/>
+            </a:avLst>
+          </a:prstGeom>
+          <a:solidFill>
+            <a:srgbClr val="F3F4F1"/>
+          </a:solidFill>
+          <a:ln>
+            <a:noFill/>
+          </a:ln>
+          <a:effectLst/>
+        </p:spPr>
+        <p:style>
+          <a:lnRef idx="1">
+            <a:schemeClr val="accent1"/>
+          </a:lnRef>
+          <a:fillRef idx="3">
+            <a:schemeClr val="accent1"/>
+          </a:fillRef>
+          <a:effectRef idx="2">
+            <a:schemeClr val="accent1"/>
+          </a:effectRef>
+          <a:fontRef idx="minor">
+            <a:schemeClr val="lt1"/>
+          </a:fontRef>
+        </p:style>
+        <p:txBody>
+          <a:bodyPr rtlCol="0" anchor="ctr"/>
+          <a:lstStyle/>
+          <a:p/>
+        </p:txBody>
+      </p:sp>
+      <p:sp>
+        <p:nvSpPr>
+          <p:cNvPr id="21" name="Oval 20"/>
+          <p:cNvSpPr/>
+          <p:nvPr/>
+        </p:nvSpPr>
+        <p:spPr>
+          <a:xfrm>
+            <a:off x="9630918" y="3703320"/>
+            <a:ext cx="822960" cy="822960"/>
+          </a:xfrm>
+          <a:prstGeom prst="ellipse">
+            <a:avLst/>
+          </a:prstGeom>
+          <a:solidFill>
+            <a:srgbClr val="DCE9E0"/>
+          </a:solidFill>
+          <a:ln>
+            <a:noFill/>
+          </a:ln>
+          <a:effectLst/>
+        </p:spPr>
+        <p:style>
+          <a:lnRef idx="1">
+            <a:schemeClr val="accent1"/>
+          </a:lnRef>
+          <a:fillRef idx="3">
+            <a:schemeClr val="accent1"/>
+          </a:fillRef>
+          <a:effectRef idx="2">
+            <a:schemeClr val="accent1"/>
+          </a:effectRef>
+          <a:fontRef idx="minor">
+            <a:schemeClr val="lt1"/>
+          </a:fontRef>
+        </p:style>
+        <p:txBody>
+          <a:bodyPr rtlCol="0" anchor="ctr"/>
+          <a:lstStyle/>
+          <a:p>
+            <a:pPr algn="ctr"/>
+          </a:p>
+        </p:txBody>
+      </p:sp>
+      <p:pic>
+        <p:nvPicPr>
+          <p:cNvPr id="22" name="Picture 21" descr="export_moss.png"/>
+          <p:cNvPicPr>
+            <a:picLocks noChangeAspect="1"/>
+          </p:cNvPicPr>
+          <p:nvPr/>
+        </p:nvPicPr>
+        <p:blipFill>
+          <a:blip r:embed="rId5"/>
+          <a:stretch>
+            <a:fillRect/>
+          </a:stretch>
+        </p:blipFill>
+        <p:spPr>
+          <a:xfrm>
+            <a:off x="9844887" y="3917289"/>
+            <a:ext cx="395020" cy="395020"/>
+          </a:xfrm>
+          <a:prstGeom prst="rect">
+            <a:avLst/>
+          </a:prstGeom>
+        </p:spPr>
+      </p:pic>
+      <p:sp>
+        <p:nvSpPr>
+          <p:cNvPr id="23" name="TextBox 22"/>
+          <p:cNvSpPr txBox="1"/>
+          <p:nvPr/>
+        </p:nvSpPr>
+        <p:spPr>
+          <a:xfrm>
+            <a:off x="9020555" y="4709160"/>
+            <a:ext cx="2043684" cy="914400"/>
+          </a:xfrm>
+          <a:prstGeom prst="rect">
+            <a:avLst/>
+          </a:prstGeom>
+          <a:noFill/>
+        </p:spPr>
+        <p:txBody>
+          <a:bodyPr wrap="square" anchor="t" lIns="0" rIns="0" tIns="0" bIns="0">
+            <a:spAutoFit/>
+          </a:bodyPr>
+          <a:lstStyle/>
+          <a:p>
+            <a:pPr algn="ctr"/>
+            <a:r>
+              <a:rPr sz="1800" b="1" lang="vi-VN">
+                <a:solidFill>
+                  <a:srgbClr val="1F1F1F"/>
+                </a:solidFill>
+                <a:latin typeface="Arial"/>
+              </a:rPr>
+              <a:t>Xuất file kết quả</a:t>
             </a:r>
           </a:p>
         </p:txBody>

</xml_diff>

<commit_message>
Tidy the remaining slides of the science-fair deck, formatting only
Slides 1, 6, 7, 9 and 10 keep their plain template look. Body text is
larger with even paragraph spacing, empty trailing paragraphs are
removed, key labels and figures are bold, and the numbered list on
slide 10 no longer shows a bullet in front of each number. No shapes,
icons, colours or words were added.

Co-Authored-By: Claude Opus 5.5 <noreply@anthropic.com>
Claude-Session: https://claude.ai/code/session_01W1TN5sV8nD2mQymMCwHHSg
</commit_message>
<xml_diff>
--- a/THUYET_TRINH_KHKT_DA_SUA_FONT.pptx
+++ b/THUYET_TRINH_KHKT_DA_SUA_FONT.pptx
@@ -4221,29 +4221,45 @@
           <a:p>
             <a:pPr lvl="0"/>
             <a:r>
-              <a:rPr lang="vi-VN" sz="1700">
+              <a:rPr lang="vi-VN" sz="1800" b="1">
                 <a:solidFill>
                   <a:srgbClr val="FFFFFF"/>
                 </a:solidFill>
               </a:rPr>
-              <a:t>Đề tài: Áp dụng thuật toán chấp nhận trì hoãn vào việc sắp xếp học sinh vào các CLB tương ứng</a:t>
-            </a:r>
-          </a:p>
-          <a:p>
-            <a:pPr lvl="0"/>
-            <a:r>
-              <a:rPr lang="vi-VN" sz="1700">
+              <a:t>Đề tài:</a:t>
+            </a:r>
+            <a:r>
+              <a:rPr lang="vi-VN" sz="1800">
                 <a:solidFill>
                   <a:srgbClr val="FFFFFF"/>
                 </a:solidFill>
               </a:rPr>
-              <a:t>Thực hiện bởi: Nguyễn Phan Văn Trường 11H2 và Lê Hoàng Phương Vi 10H3</a:t>
+              <a:t> Áp dụng thuật toán chấp nhận trì hoãn vào việc sắp xếp học sinh vào các CLB tương ứng</a:t>
             </a:r>
           </a:p>
           <a:p>
             <a:pPr lvl="0"/>
             <a:r>
-              <a:rPr lang="vi-VN" sz="1700">
+              <a:rPr lang="vi-VN" sz="1800" b="1">
+                <a:solidFill>
+                  <a:srgbClr val="FFFFFF"/>
+                </a:solidFill>
+              </a:rPr>
+              <a:t>Thực hiện bởi:</a:t>
+            </a:r>
+            <a:r>
+              <a:rPr lang="vi-VN" sz="1800">
+                <a:solidFill>
+                  <a:srgbClr val="FFFFFF"/>
+                </a:solidFill>
+              </a:rPr>
+              <a:t> Nguyễn Phan Văn Trường 11H2 và Lê Hoàng Phương Vi 10H3</a:t>
+            </a:r>
+          </a:p>
+          <a:p>
+            <a:pPr lvl="0"/>
+            <a:r>
+              <a:rPr lang="vi-VN" sz="1800">
                 <a:solidFill>
                   <a:srgbClr val="FFFFFF"/>
                 </a:solidFill>
@@ -4473,29 +4489,65 @@
           <a:bodyPr/>
           <a:lstStyle/>
           <a:p>
-            <a:r>
-              <a:rPr lang="vi-VN"/>
+            <a:pPr marL="0" indent="0">
+              <a:lnSpc>
+                <a:spcPct val="110000"/>
+              </a:lnSpc>
+              <a:spcAft>
+                <a:spcPts val="2400"/>
+              </a:spcAft>
+              <a:buNone/>
+            </a:pPr>
+            <a:r>
+              <a:rPr lang="vi-VN" sz="3200"/>
               <a:t>1. Đa dạng các cách lựa chọn buổi</a:t>
             </a:r>
             <a:endParaRPr lang="vi-VN" dirty="0"/>
           </a:p>
           <a:p>
-            <a:r>
-              <a:rPr lang="vi-VN"/>
+            <a:pPr marL="0" indent="0">
+              <a:lnSpc>
+                <a:spcPct val="110000"/>
+              </a:lnSpc>
+              <a:spcAft>
+                <a:spcPts val="2400"/>
+              </a:spcAft>
+              <a:buNone/>
+            </a:pPr>
+            <a:r>
+              <a:rPr lang="vi-VN" sz="3200"/>
               <a:t>2. Thêm và chỉnh sửa thông số học sinh</a:t>
             </a:r>
             <a:endParaRPr lang="vi-VN" dirty="0"/>
           </a:p>
           <a:p>
-            <a:r>
-              <a:rPr lang="vi-VN"/>
+            <a:pPr marL="0" indent="0">
+              <a:lnSpc>
+                <a:spcPct val="110000"/>
+              </a:lnSpc>
+              <a:spcAft>
+                <a:spcPts val="2400"/>
+              </a:spcAft>
+              <a:buNone/>
+            </a:pPr>
+            <a:r>
+              <a:rPr lang="vi-VN" sz="3200"/>
               <a:t>3. Song ngữ Anh Việt</a:t>
             </a:r>
             <a:endParaRPr lang="vi-VN" dirty="0"/>
           </a:p>
           <a:p>
-            <a:r>
-              <a:rPr lang="vi-VN"/>
+            <a:pPr marL="0" indent="0">
+              <a:lnSpc>
+                <a:spcPct val="110000"/>
+              </a:lnSpc>
+              <a:spcAft>
+                <a:spcPts val="2400"/>
+              </a:spcAft>
+              <a:buNone/>
+            </a:pPr>
+            <a:r>
+              <a:rPr lang="vi-VN" sz="3200"/>
               <a:t>4. Có thể ưu tiên cho các học sinh khó khăn </a:t>
             </a:r>
           </a:p>
@@ -7615,19 +7667,40 @@
           <a:bodyPr/>
           <a:lstStyle/>
           <a:p>
-            <a:r>
-              <a:rPr lang="vi-VN"/>
-              <a:t>Tầng 1: Ưu tiên học sinh có thi CLB đó</a:t>
-            </a:r>
-          </a:p>
-          <a:p>
-            <a:r>
-              <a:rPr lang="vi-VN"/>
-              <a:t>Tầng 2: HS không thi thì xếp theo số bốc thăm</a:t>
-            </a:r>
-            <a:endParaRPr lang="vi-VN"/>
-          </a:p>
-          <a:p>
+            <a:pPr>
+              <a:lnSpc>
+                <a:spcPct val="110000"/>
+              </a:lnSpc>
+              <a:spcAft>
+                <a:spcPts val="3000"/>
+              </a:spcAft>
+            </a:pPr>
+            <a:r>
+              <a:rPr lang="vi-VN" b="1" sz="3200"/>
+              <a:t>Tầng 1:</a:t>
+            </a:r>
+            <a:r>
+              <a:rPr lang="vi-VN" sz="3200"/>
+              <a:t> Ưu tiên học sinh có thi CLB đó</a:t>
+            </a:r>
+          </a:p>
+          <a:p>
+            <a:pPr>
+              <a:lnSpc>
+                <a:spcPct val="110000"/>
+              </a:lnSpc>
+              <a:spcAft>
+                <a:spcPts val="3000"/>
+              </a:spcAft>
+            </a:pPr>
+            <a:r>
+              <a:rPr lang="vi-VN" b="1" sz="3200"/>
+              <a:t>Tầng 2:</a:t>
+            </a:r>
+            <a:r>
+              <a:rPr lang="vi-VN" sz="3200"/>
+              <a:t> HS không thi thì xếp theo số bốc thăm</a:t>
+            </a:r>
             <a:endParaRPr lang="vi-VN"/>
           </a:p>
         </p:txBody>
@@ -7711,26 +7784,47 @@
           <a:bodyPr/>
           <a:lstStyle/>
           <a:p>
-            <a:r>
-              <a:rPr lang="vi-VN"/>
+            <a:pPr>
+              <a:lnSpc>
+                <a:spcPct val="110000"/>
+              </a:lnSpc>
+              <a:spcAft>
+                <a:spcPts val="2400"/>
+              </a:spcAft>
+            </a:pPr>
+            <a:r>
+              <a:rPr lang="vi-VN" sz="3200"/>
               <a:t>Biết rõ mức lấp đầy cụ thể</a:t>
             </a:r>
           </a:p>
           <a:p>
-            <a:r>
-              <a:rPr lang="vi-VN"/>
+            <a:pPr>
+              <a:lnSpc>
+                <a:spcPct val="110000"/>
+              </a:lnSpc>
+              <a:spcAft>
+                <a:spcPts val="2400"/>
+              </a:spcAft>
+            </a:pPr>
+            <a:r>
+              <a:rPr lang="vi-VN" sz="3200"/>
               <a:t>Phân bổ nguyện vọng</a:t>
             </a:r>
             <a:endParaRPr lang="vi-VN" dirty="0"/>
           </a:p>
           <a:p>
-            <a:r>
-              <a:rPr lang="vi-VN"/>
+            <a:pPr>
+              <a:lnSpc>
+                <a:spcPct val="110000"/>
+              </a:lnSpc>
+              <a:spcAft>
+                <a:spcPts val="2400"/>
+              </a:spcAft>
+            </a:pPr>
+            <a:r>
+              <a:rPr lang="vi-VN" sz="3200"/>
               <a:t>Số học sinh cụ thể chưa có chỗ</a:t>
             </a:r>
-          </a:p>
-          <a:p>
-            <a:endParaRPr lang="vi-VN" dirty="0"/>
           </a:p>
         </p:txBody>
       </p:sp>
@@ -8260,29 +8354,63 @@
           <a:bodyPr/>
           <a:lstStyle/>
           <a:p>
-            <a:r>
-              <a:rPr lang="vi-VN"/>
-              <a:t>0 cặp học sinh và CLB muốn đổi kết quả</a:t>
-            </a:r>
-          </a:p>
-          <a:p>
-            <a:r>
-              <a:rPr lang="vi-VN"/>
-              <a:t>Chỉ 1,1% số học sinh có kết quả phụ thuộc bốc thăm</a:t>
+            <a:pPr>
+              <a:lnSpc>
+                <a:spcPct val="110000"/>
+              </a:lnSpc>
+              <a:spcAft>
+                <a:spcPts val="3000"/>
+              </a:spcAft>
+            </a:pPr>
+            <a:r>
+              <a:rPr lang="vi-VN" b="1" sz="3200"/>
+              <a:t>0</a:t>
+            </a:r>
+            <a:r>
+              <a:rPr lang="vi-VN" sz="3200"/>
+              <a:t> cặp học sinh và CLB muốn đổi kết quả</a:t>
+            </a:r>
+          </a:p>
+          <a:p>
+            <a:pPr>
+              <a:lnSpc>
+                <a:spcPct val="110000"/>
+              </a:lnSpc>
+              <a:spcAft>
+                <a:spcPts val="3000"/>
+              </a:spcAft>
+            </a:pPr>
+            <a:r>
+              <a:rPr lang="vi-VN" sz="3200"/>
+              <a:t>Chỉ </a:t>
+            </a:r>
+            <a:r>
+              <a:rPr lang="vi-VN" b="1" sz="3200"/>
+              <a:t>1,1%</a:t>
+            </a:r>
+            <a:r>
+              <a:rPr lang="vi-VN" sz="3200"/>
+              <a:t> số học sinh có kết quả phụ thuộc bốc thăm</a:t>
             </a:r>
             <a:endParaRPr lang="vi-VN" dirty="0"/>
           </a:p>
           <a:p>
-            <a:r>
-              <a:rPr lang="vi-VN"/>
-              <a:t>750+ chỉ báo trong phần mềm để đảm bảo phần mềm hoạt động</a:t>
-            </a:r>
-            <a:endParaRPr lang="vi-VN" dirty="0"/>
-          </a:p>
-          <a:p>
-            <a:endParaRPr lang="vi-VN" dirty="0"/>
-          </a:p>
-          <a:p>
+            <a:pPr>
+              <a:lnSpc>
+                <a:spcPct val="110000"/>
+              </a:lnSpc>
+              <a:spcAft>
+                <a:spcPts val="3000"/>
+              </a:spcAft>
+            </a:pPr>
+            <a:r>
+              <a:rPr lang="vi-VN" b="1" sz="3200"/>
+              <a:t>750+</a:t>
+            </a:r>
+            <a:r>
+              <a:rPr lang="vi-VN" sz="3200"/>
+              <a:t> chỉ báo trong phần mềm để đảm bảo phần mềm hoạt động</a:t>
+            </a:r>
             <a:endParaRPr lang="vi-VN" dirty="0"/>
           </a:p>
         </p:txBody>

</xml_diff>

<commit_message>
Add a slide on how the software runs to the science-fair deck
New slide 7, between the two-tier ranking slide and the output slide,
lists the six steps the software performs after Run is pressed: backup,
data check, lottery, algorithm with stability check, saving results,
and exporting files. The steps follow run_pipeline in api.py. The slide
uses the deck's plain Title and Content layout with no added styling.

Co-Authored-By: Claude Opus 5.5 <noreply@anthropic.com>
Claude-Session: https://claude.ai/code/session_01W1TN5sV8nD2mQymMCwHHSg
</commit_message>
<xml_diff>
--- a/THUYET_TRINH_KHKT_DA_SUA_FONT.pptx
+++ b/THUYET_TRINH_KHKT_DA_SUA_FONT.pptx
@@ -11,6 +11,7 @@
     <p:sldId id="259" r:id="rId5"/>
     <p:sldId id="261" r:id="rId6"/>
     <p:sldId id="260" r:id="rId7"/>
+    <p:sldId id="266" r:id="rId17"/>
     <p:sldId id="262" r:id="rId8"/>
     <p:sldId id="263" r:id="rId9"/>
     <p:sldId id="264" r:id="rId10"/>
@@ -728,6 +729,76 @@
           <a:p>
             <a:r>
               <a:t>Số liệu lấy từ phần mềm, chạy bộ du_lieu_test/bo_sach với hạt giống bốc thăm 42: 140 học sinh, 12 CLB, 150 chỗ, trong đó 16 suất dự trữ. Cả 140 học sinh đều có CLB; 9 trên 12 CLB kín chỗ, còn 10 chỗ trống. 54 học sinh (39%) được nguyện vọng 1. Tỉ lệ nguyện vọng 1 không cao vì bộ này cố ý cho mọi học sinh thi 4 CLB và ghi 6 nguyện vọng, nên nguyện vọng đầu cạnh tranh gắt. Đây là dữ liệu mô phỏng.</a:t>
+            </a:r>
+          </a:p>
+        </p:txBody>
+      </p:sp>
+      <p:sp>
+        <p:nvSpPr>
+          <p:cNvPr id="4" name="Slide Number Placeholder 3"/>
+          <p:cNvSpPr>
+            <a:spLocks noGrp="1"/>
+          </p:cNvSpPr>
+          <p:nvPr>
+            <p:ph type="sldNum" idx="5" sz="quarter"/>
+          </p:nvPr>
+        </p:nvSpPr>
+        <p:spPr/>
+      </p:sp>
+    </p:spTree>
+  </p:cSld>
+  <p:clrMapOvr>
+    <a:masterClrMapping/>
+  </p:clrMapOvr>
+</p:notes>
+</file>
+
+<file path=ppt/notesSlides/notesSlide2.xml><?xml version="1.0" encoding="utf-8"?>
+<p:notes xmlns:a="http://schemas.openxmlformats.org/drawingml/2006/main" xmlns:p="http://schemas.openxmlformats.org/presentationml/2006/main" xmlns:r="http://schemas.openxmlformats.org/officeDocument/2006/relationships">
+  <p:cSld>
+    <p:spTree>
+      <p:nvGrpSpPr>
+        <p:cNvPr id="1" name=""/>
+        <p:cNvGrpSpPr/>
+        <p:nvPr/>
+      </p:nvGrpSpPr>
+      <p:grpSpPr>
+        <a:xfrm>
+          <a:off x="0" y="0"/>
+          <a:ext cx="0" cy="0"/>
+          <a:chOff x="0" y="0"/>
+          <a:chExt cx="0" cy="0"/>
+        </a:xfrm>
+      </p:grpSpPr>
+      <p:sp>
+        <p:nvSpPr>
+          <p:cNvPr id="2" name="Slide Image Placeholder 1"/>
+          <p:cNvSpPr>
+            <a:spLocks noGrp="1"/>
+          </p:cNvSpPr>
+          <p:nvPr>
+            <p:ph type="sldImg" idx="2"/>
+          </p:nvPr>
+        </p:nvSpPr>
+        <p:spPr/>
+      </p:sp>
+      <p:sp>
+        <p:nvSpPr>
+          <p:cNvPr id="3" name="Notes Placeholder 2"/>
+          <p:cNvSpPr>
+            <a:spLocks noGrp="1"/>
+          </p:cNvSpPr>
+          <p:nvPr>
+            <p:ph type="body" idx="3" sz="quarter"/>
+          </p:nvPr>
+        </p:nvSpPr>
+        <p:spPr/>
+        <p:txBody>
+          <a:bodyPr/>
+          <a:lstStyle/>
+          <a:p>
+            <a:r>
+              <a:t>Đây là những gì phần mềm tự làm sau khi bấm Chạy sắp xếp. Bước 2 dừng ngay nếu dữ liệu sai, để không tốn một lần bốc thăm. Bước 4 kiểm tra không có cặp phá vỡ trước khi lưu. Nếu bất kỳ bước nào lỗi, phần mềm hủy toàn bộ lần chạy, dữ liệu cũ vẫn còn nguyên.</a:t>
             </a:r>
           </a:p>
         </p:txBody>
@@ -4559,6 +4630,176 @@
         <p14:creationId xmlns:p14="http://schemas.microsoft.com/office/powerpoint/2010/main" val="2665684633"/>
       </p:ext>
     </p:extLst>
+  </p:cSld>
+  <p:clrMapOvr>
+    <a:masterClrMapping/>
+  </p:clrMapOvr>
+</p:sld>
+</file>
+
+<file path=ppt/slides/slide11.xml><?xml version="1.0" encoding="utf-8"?>
+<p:sld xmlns:a="http://schemas.openxmlformats.org/drawingml/2006/main" xmlns:p="http://schemas.openxmlformats.org/presentationml/2006/main" xmlns:r="http://schemas.openxmlformats.org/officeDocument/2006/relationships">
+  <p:cSld>
+    <p:spTree>
+      <p:nvGrpSpPr>
+        <p:cNvPr id="1" name=""/>
+        <p:cNvGrpSpPr/>
+        <p:nvPr/>
+      </p:nvGrpSpPr>
+      <p:grpSpPr/>
+      <p:sp>
+        <p:nvSpPr>
+          <p:cNvPr id="2" name="Title 1"/>
+          <p:cNvSpPr>
+            <a:spLocks noGrp="1"/>
+          </p:cNvSpPr>
+          <p:nvPr>
+            <p:ph type="title"/>
+          </p:nvPr>
+        </p:nvSpPr>
+        <p:spPr/>
+        <p:txBody>
+          <a:bodyPr/>
+          <a:lstStyle/>
+          <a:p>
+            <a:r>
+              <a:rPr lang="vi-VN"/>
+              <a:t>Phần mềm vận hành qua 6 bước</a:t>
+            </a:r>
+          </a:p>
+        </p:txBody>
+      </p:sp>
+      <p:sp>
+        <p:nvSpPr>
+          <p:cNvPr id="3" name="Content Placeholder 2"/>
+          <p:cNvSpPr>
+            <a:spLocks noGrp="1"/>
+          </p:cNvSpPr>
+          <p:nvPr>
+            <p:ph idx="1"/>
+          </p:nvPr>
+        </p:nvSpPr>
+        <p:spPr/>
+        <p:txBody>
+          <a:bodyPr/>
+          <a:lstStyle/>
+          <a:p>
+            <a:pPr marL="0" indent="0">
+              <a:lnSpc>
+                <a:spcPct val="110000"/>
+              </a:lnSpc>
+              <a:spcAft>
+                <a:spcPts val="1400"/>
+              </a:spcAft>
+              <a:buNone/>
+            </a:pPr>
+            <a:r>
+              <a:rPr b="1" sz="2600" lang="vi-VN"/>
+              <a:t>1. Sao lưu:</a:t>
+            </a:r>
+            <a:r>
+              <a:rPr b="0" sz="2600" lang="vi-VN"/>
+              <a:t> tự lưu một bản dữ liệu trước khi chạy</a:t>
+            </a:r>
+          </a:p>
+          <a:p>
+            <a:pPr marL="0" indent="0">
+              <a:lnSpc>
+                <a:spcPct val="110000"/>
+              </a:lnSpc>
+              <a:spcAft>
+                <a:spcPts val="1400"/>
+              </a:spcAft>
+              <a:buNone/>
+            </a:pPr>
+            <a:r>
+              <a:rPr b="1" sz="2600" lang="vi-VN"/>
+              <a:t>2. Kiểm tra dữ liệu:</a:t>
+            </a:r>
+            <a:r>
+              <a:rPr b="0" sz="2600" lang="vi-VN"/>
+              <a:t> dữ liệu sai thì dừng lại, chưa bốc thăm</a:t>
+            </a:r>
+          </a:p>
+          <a:p>
+            <a:pPr marL="0" indent="0">
+              <a:lnSpc>
+                <a:spcPct val="110000"/>
+              </a:lnSpc>
+              <a:spcAft>
+                <a:spcPts val="1400"/>
+              </a:spcAft>
+              <a:buNone/>
+            </a:pPr>
+            <a:r>
+              <a:rPr b="1" sz="2600" lang="vi-VN"/>
+              <a:t>3. Bốc thăm:</a:t>
+            </a:r>
+            <a:r>
+              <a:rPr b="0" sz="2600" lang="vi-VN"/>
+              <a:t> tạo số bốc thăm cho học sinh, khóa lại sau lần đầu</a:t>
+            </a:r>
+          </a:p>
+          <a:p>
+            <a:pPr marL="0" indent="0">
+              <a:lnSpc>
+                <a:spcPct val="110000"/>
+              </a:lnSpc>
+              <a:spcAft>
+                <a:spcPts val="1400"/>
+              </a:spcAft>
+              <a:buNone/>
+            </a:pPr>
+            <a:r>
+              <a:rPr b="1" sz="2600" lang="vi-VN"/>
+              <a:t>4. Chạy thuật toán:</a:t>
+            </a:r>
+            <a:r>
+              <a:rPr b="0" sz="2600" lang="vi-VN"/>
+              <a:t> xếp học sinh vào CLB, kiểm tra kết quả ổn định</a:t>
+            </a:r>
+          </a:p>
+          <a:p>
+            <a:pPr marL="0" indent="0">
+              <a:lnSpc>
+                <a:spcPct val="110000"/>
+              </a:lnSpc>
+              <a:spcAft>
+                <a:spcPts val="1400"/>
+              </a:spcAft>
+              <a:buNone/>
+            </a:pPr>
+            <a:r>
+              <a:rPr b="1" sz="2600" lang="vi-VN"/>
+              <a:t>5. Ghi kết quả:</a:t>
+            </a:r>
+            <a:r>
+              <a:rPr b="0" sz="2600" lang="vi-VN"/>
+              <a:t> chỉ lưu khi mọi bước đều đạt, lỗi thì hủy toàn bộ</a:t>
+            </a:r>
+          </a:p>
+          <a:p>
+            <a:pPr marL="0" indent="0">
+              <a:lnSpc>
+                <a:spcPct val="110000"/>
+              </a:lnSpc>
+              <a:spcAft>
+                <a:spcPts val="1400"/>
+              </a:spcAft>
+              <a:buNone/>
+            </a:pPr>
+            <a:r>
+              <a:rPr b="1" sz="2600" lang="vi-VN"/>
+              <a:t>6. Xuất tệp:</a:t>
+            </a:r>
+            <a:r>
+              <a:rPr b="0" sz="2600" lang="vi-VN"/>
+              <a:t> tạo file kết quả cho nhà trường và từng CLB</a:t>
+            </a:r>
+          </a:p>
+        </p:txBody>
+      </p:sp>
+    </p:spTree>
   </p:cSld>
   <p:clrMapOvr>
     <a:masterClrMapping/>

</xml_diff>

<commit_message>
Explain the algorithm and the two tiers on slide 7 of the deck
Slide 7 keeps the six run steps in a left column and adds a right
column explaining step 4: students apply in preference order, each club
ranks applications in two tiers (tested by score, untested by lottery),
holds only as many as it has seats, and rejected students apply to
their next choice. A two-round example table shows a later, stronger
applicant displacing a held one. Plain styling, no added colour.

Co-Authored-By: Claude Opus 5.5 <noreply@anthropic.com>
Claude-Session: https://claude.ai/code/session_01W1TN5sV8nD2mQymMCwHHSg
</commit_message>
<xml_diff>
--- a/THUYET_TRINH_KHKT_DA_SUA_FONT.pptx
+++ b/THUYET_TRINH_KHKT_DA_SUA_FONT.pptx
@@ -798,7 +798,7 @@
           <a:lstStyle/>
           <a:p>
             <a:r>
-              <a:t>Đây là những gì phần mềm tự làm sau khi bấm Chạy sắp xếp. Bước 2 dừng ngay nếu dữ liệu sai, để không tốn một lần bốc thăm. Bước 4 kiểm tra không có cặp phá vỡ trước khi lưu. Nếu bất kỳ bước nào lỗi, phần mềm hủy toàn bộ lần chạy, dữ liệu cũ vẫn còn nguyên.</a:t>
+              <a:t>Bên trái là 6 bước phần mềm tự làm sau khi bấm Chạy sắp xếp. Bên phải giải thích bước 4. Nhấn mạnh chữ giữ tạm: ở vòng 2, Dũng đến sau nhưng điểm cao hơn nên vẫn vào được, Chi bị đẩy ra và nộp tiếp nguyện vọng 2. Bình không thi nên ở Tầng 2, luôn đứng sau các học sinh đã thi. CLB không biết học sinh xếp mình ở nguyện vọng mấy. Nếu bước 4 phát hiện kết quả không ổn định, phần mềm hủy toàn bộ lần chạy.</a:t>
             </a:r>
           </a:p>
         </p:txBody>
@@ -4516,6 +4516,147 @@
           <p:cNvPr id="2" name="Title 1">
             <a:extLst>
               <a:ext uri="{FF2B5EF4-FFF2-40B4-BE49-F238E27FC236}">
+                <a16:creationId xmlns:a16="http://schemas.microsoft.com/office/drawing/2014/main" id="{FED7EA77-B499-B89C-F3A5-57074CDEE67E}"/>
+              </a:ext>
+            </a:extLst>
+          </p:cNvPr>
+          <p:cNvSpPr>
+            <a:spLocks noGrp="1"/>
+          </p:cNvSpPr>
+          <p:nvPr>
+            <p:ph type="title"/>
+          </p:nvPr>
+        </p:nvSpPr>
+        <p:spPr/>
+        <p:txBody>
+          <a:bodyPr/>
+          <a:lstStyle/>
+          <a:p>
+            <a:r>
+              <a:rPr lang="vi-VN"/>
+              <a:t>Số liệu chứng minh công bằng</a:t>
+            </a:r>
+            <a:endParaRPr lang="vi-VN" dirty="0"/>
+          </a:p>
+        </p:txBody>
+      </p:sp>
+      <p:sp>
+        <p:nvSpPr>
+          <p:cNvPr id="3" name="Content Placeholder 2">
+            <a:extLst>
+              <a:ext uri="{FF2B5EF4-FFF2-40B4-BE49-F238E27FC236}">
+                <a16:creationId xmlns:a16="http://schemas.microsoft.com/office/drawing/2014/main" id="{1403EA8F-8A5D-9DCB-17FE-E89082138456}"/>
+              </a:ext>
+            </a:extLst>
+          </p:cNvPr>
+          <p:cNvSpPr>
+            <a:spLocks noGrp="1"/>
+          </p:cNvSpPr>
+          <p:nvPr>
+            <p:ph idx="1"/>
+          </p:nvPr>
+        </p:nvSpPr>
+        <p:spPr/>
+        <p:txBody>
+          <a:bodyPr/>
+          <a:lstStyle/>
+          <a:p>
+            <a:pPr>
+              <a:lnSpc>
+                <a:spcPct val="110000"/>
+              </a:lnSpc>
+              <a:spcAft>
+                <a:spcPts val="3000"/>
+              </a:spcAft>
+            </a:pPr>
+            <a:r>
+              <a:rPr lang="vi-VN" b="1" sz="3200"/>
+              <a:t>0</a:t>
+            </a:r>
+            <a:r>
+              <a:rPr lang="vi-VN" sz="3200"/>
+              <a:t> cặp học sinh và CLB muốn đổi kết quả</a:t>
+            </a:r>
+          </a:p>
+          <a:p>
+            <a:pPr>
+              <a:lnSpc>
+                <a:spcPct val="110000"/>
+              </a:lnSpc>
+              <a:spcAft>
+                <a:spcPts val="3000"/>
+              </a:spcAft>
+            </a:pPr>
+            <a:r>
+              <a:rPr lang="vi-VN" sz="3200"/>
+              <a:t>Chỉ </a:t>
+            </a:r>
+            <a:r>
+              <a:rPr lang="vi-VN" b="1" sz="3200"/>
+              <a:t>1,1%</a:t>
+            </a:r>
+            <a:r>
+              <a:rPr lang="vi-VN" sz="3200"/>
+              <a:t> số học sinh có kết quả phụ thuộc bốc thăm</a:t>
+            </a:r>
+            <a:endParaRPr lang="vi-VN" dirty="0"/>
+          </a:p>
+          <a:p>
+            <a:pPr>
+              <a:lnSpc>
+                <a:spcPct val="110000"/>
+              </a:lnSpc>
+              <a:spcAft>
+                <a:spcPts val="3000"/>
+              </a:spcAft>
+            </a:pPr>
+            <a:r>
+              <a:rPr lang="vi-VN" b="1" sz="3200"/>
+              <a:t>750+</a:t>
+            </a:r>
+            <a:r>
+              <a:rPr lang="vi-VN" sz="3200"/>
+              <a:t> chỉ báo trong phần mềm để đảm bảo phần mềm hoạt động</a:t>
+            </a:r>
+            <a:endParaRPr lang="vi-VN" dirty="0"/>
+          </a:p>
+        </p:txBody>
+      </p:sp>
+    </p:spTree>
+    <p:extLst>
+      <p:ext uri="{BB962C8B-B14F-4D97-AF65-F5344CB8AC3E}">
+        <p14:creationId xmlns:p14="http://schemas.microsoft.com/office/powerpoint/2010/main" val="3931215587"/>
+      </p:ext>
+    </p:extLst>
+  </p:cSld>
+  <p:clrMapOvr>
+    <a:masterClrMapping/>
+  </p:clrMapOvr>
+</p:sld>
+</file>
+
+<file path=ppt/slides/slide11.xml><?xml version="1.0" encoding="utf-8"?>
+<p:sld xmlns:a="http://schemas.openxmlformats.org/drawingml/2006/main" xmlns:r="http://schemas.openxmlformats.org/officeDocument/2006/relationships" xmlns:p="http://schemas.openxmlformats.org/presentationml/2006/main">
+  <p:cSld>
+    <p:spTree>
+      <p:nvGrpSpPr>
+        <p:cNvPr id="1" name=""/>
+        <p:cNvGrpSpPr/>
+        <p:nvPr/>
+      </p:nvGrpSpPr>
+      <p:grpSpPr>
+        <a:xfrm>
+          <a:off x="0" y="0"/>
+          <a:ext cx="0" cy="0"/>
+          <a:chOff x="0" y="0"/>
+          <a:chExt cx="0" cy="0"/>
+        </a:xfrm>
+      </p:grpSpPr>
+      <p:sp>
+        <p:nvSpPr>
+          <p:cNvPr id="2" name="Title 1">
+            <a:extLst>
+              <a:ext uri="{FF2B5EF4-FFF2-40B4-BE49-F238E27FC236}">
                 <a16:creationId xmlns:a16="http://schemas.microsoft.com/office/drawing/2014/main" id="{87BC7C06-118C-D344-F61B-8E28B0441353}"/>
               </a:ext>
             </a:extLst>
@@ -4630,176 +4771,6 @@
         <p14:creationId xmlns:p14="http://schemas.microsoft.com/office/powerpoint/2010/main" val="2665684633"/>
       </p:ext>
     </p:extLst>
-  </p:cSld>
-  <p:clrMapOvr>
-    <a:masterClrMapping/>
-  </p:clrMapOvr>
-</p:sld>
-</file>
-
-<file path=ppt/slides/slide11.xml><?xml version="1.0" encoding="utf-8"?>
-<p:sld xmlns:a="http://schemas.openxmlformats.org/drawingml/2006/main" xmlns:p="http://schemas.openxmlformats.org/presentationml/2006/main" xmlns:r="http://schemas.openxmlformats.org/officeDocument/2006/relationships">
-  <p:cSld>
-    <p:spTree>
-      <p:nvGrpSpPr>
-        <p:cNvPr id="1" name=""/>
-        <p:cNvGrpSpPr/>
-        <p:nvPr/>
-      </p:nvGrpSpPr>
-      <p:grpSpPr/>
-      <p:sp>
-        <p:nvSpPr>
-          <p:cNvPr id="2" name="Title 1"/>
-          <p:cNvSpPr>
-            <a:spLocks noGrp="1"/>
-          </p:cNvSpPr>
-          <p:nvPr>
-            <p:ph type="title"/>
-          </p:nvPr>
-        </p:nvSpPr>
-        <p:spPr/>
-        <p:txBody>
-          <a:bodyPr/>
-          <a:lstStyle/>
-          <a:p>
-            <a:r>
-              <a:rPr lang="vi-VN"/>
-              <a:t>Phần mềm vận hành qua 6 bước</a:t>
-            </a:r>
-          </a:p>
-        </p:txBody>
-      </p:sp>
-      <p:sp>
-        <p:nvSpPr>
-          <p:cNvPr id="3" name="Content Placeholder 2"/>
-          <p:cNvSpPr>
-            <a:spLocks noGrp="1"/>
-          </p:cNvSpPr>
-          <p:nvPr>
-            <p:ph idx="1"/>
-          </p:nvPr>
-        </p:nvSpPr>
-        <p:spPr/>
-        <p:txBody>
-          <a:bodyPr/>
-          <a:lstStyle/>
-          <a:p>
-            <a:pPr marL="0" indent="0">
-              <a:lnSpc>
-                <a:spcPct val="110000"/>
-              </a:lnSpc>
-              <a:spcAft>
-                <a:spcPts val="1400"/>
-              </a:spcAft>
-              <a:buNone/>
-            </a:pPr>
-            <a:r>
-              <a:rPr b="1" sz="2600" lang="vi-VN"/>
-              <a:t>1. Sao lưu:</a:t>
-            </a:r>
-            <a:r>
-              <a:rPr b="0" sz="2600" lang="vi-VN"/>
-              <a:t> tự lưu một bản dữ liệu trước khi chạy</a:t>
-            </a:r>
-          </a:p>
-          <a:p>
-            <a:pPr marL="0" indent="0">
-              <a:lnSpc>
-                <a:spcPct val="110000"/>
-              </a:lnSpc>
-              <a:spcAft>
-                <a:spcPts val="1400"/>
-              </a:spcAft>
-              <a:buNone/>
-            </a:pPr>
-            <a:r>
-              <a:rPr b="1" sz="2600" lang="vi-VN"/>
-              <a:t>2. Kiểm tra dữ liệu:</a:t>
-            </a:r>
-            <a:r>
-              <a:rPr b="0" sz="2600" lang="vi-VN"/>
-              <a:t> dữ liệu sai thì dừng lại, chưa bốc thăm</a:t>
-            </a:r>
-          </a:p>
-          <a:p>
-            <a:pPr marL="0" indent="0">
-              <a:lnSpc>
-                <a:spcPct val="110000"/>
-              </a:lnSpc>
-              <a:spcAft>
-                <a:spcPts val="1400"/>
-              </a:spcAft>
-              <a:buNone/>
-            </a:pPr>
-            <a:r>
-              <a:rPr b="1" sz="2600" lang="vi-VN"/>
-              <a:t>3. Bốc thăm:</a:t>
-            </a:r>
-            <a:r>
-              <a:rPr b="0" sz="2600" lang="vi-VN"/>
-              <a:t> tạo số bốc thăm cho học sinh, khóa lại sau lần đầu</a:t>
-            </a:r>
-          </a:p>
-          <a:p>
-            <a:pPr marL="0" indent="0">
-              <a:lnSpc>
-                <a:spcPct val="110000"/>
-              </a:lnSpc>
-              <a:spcAft>
-                <a:spcPts val="1400"/>
-              </a:spcAft>
-              <a:buNone/>
-            </a:pPr>
-            <a:r>
-              <a:rPr b="1" sz="2600" lang="vi-VN"/>
-              <a:t>4. Chạy thuật toán:</a:t>
-            </a:r>
-            <a:r>
-              <a:rPr b="0" sz="2600" lang="vi-VN"/>
-              <a:t> xếp học sinh vào CLB, kiểm tra kết quả ổn định</a:t>
-            </a:r>
-          </a:p>
-          <a:p>
-            <a:pPr marL="0" indent="0">
-              <a:lnSpc>
-                <a:spcPct val="110000"/>
-              </a:lnSpc>
-              <a:spcAft>
-                <a:spcPts val="1400"/>
-              </a:spcAft>
-              <a:buNone/>
-            </a:pPr>
-            <a:r>
-              <a:rPr b="1" sz="2600" lang="vi-VN"/>
-              <a:t>5. Ghi kết quả:</a:t>
-            </a:r>
-            <a:r>
-              <a:rPr b="0" sz="2600" lang="vi-VN"/>
-              <a:t> chỉ lưu khi mọi bước đều đạt, lỗi thì hủy toàn bộ</a:t>
-            </a:r>
-          </a:p>
-          <a:p>
-            <a:pPr marL="0" indent="0">
-              <a:lnSpc>
-                <a:spcPct val="110000"/>
-              </a:lnSpc>
-              <a:spcAft>
-                <a:spcPts val="1400"/>
-              </a:spcAft>
-              <a:buNone/>
-            </a:pPr>
-            <a:r>
-              <a:rPr b="1" sz="2600" lang="vi-VN"/>
-              <a:t>6. Xuất tệp:</a:t>
-            </a:r>
-            <a:r>
-              <a:rPr b="0" sz="2600" lang="vi-VN"/>
-              <a:t> tạo file kết quả cho nhà trường và từng CLB</a:t>
-            </a:r>
-          </a:p>
-        </p:txBody>
-      </p:sp>
-    </p:spTree>
   </p:cSld>
   <p:clrMapOvr>
     <a:masterClrMapping/>
@@ -7960,7 +7931,7 @@
 </file>
 
 <file path=ppt/slides/slide7.xml><?xml version="1.0" encoding="utf-8"?>
-<p:sld xmlns:a="http://schemas.openxmlformats.org/drawingml/2006/main" xmlns:r="http://schemas.openxmlformats.org/officeDocument/2006/relationships" xmlns:p="http://schemas.openxmlformats.org/presentationml/2006/main">
+<p:sld xmlns:a="http://schemas.openxmlformats.org/drawingml/2006/main" xmlns:p="http://schemas.openxmlformats.org/presentationml/2006/main" xmlns:r="http://schemas.openxmlformats.org/officeDocument/2006/relationships">
   <p:cSld>
     <p:spTree>
       <p:nvGrpSpPr>
@@ -7968,23 +7939,10 @@
         <p:cNvGrpSpPr/>
         <p:nvPr/>
       </p:nvGrpSpPr>
-      <p:grpSpPr>
-        <a:xfrm>
-          <a:off x="0" y="0"/>
-          <a:ext cx="0" cy="0"/>
-          <a:chOff x="0" y="0"/>
-          <a:chExt cx="0" cy="0"/>
-        </a:xfrm>
-      </p:grpSpPr>
-      <p:sp>
-        <p:nvSpPr>
-          <p:cNvPr id="2" name="Title 1">
-            <a:extLst>
-              <a:ext uri="{FF2B5EF4-FFF2-40B4-BE49-F238E27FC236}">
-                <a16:creationId xmlns:a16="http://schemas.microsoft.com/office/drawing/2014/main" id="{6232FEA5-37DE-2025-46C4-C5C7E5C675D6}"/>
-              </a:ext>
-            </a:extLst>
-          </p:cNvPr>
+      <p:grpSpPr/>
+      <p:sp>
+        <p:nvSpPr>
+          <p:cNvPr id="2" name="Title 1"/>
           <p:cNvSpPr>
             <a:spLocks noGrp="1"/>
           </p:cNvSpPr>
@@ -7999,20 +7957,14 @@
           <a:p>
             <a:r>
               <a:rPr lang="vi-VN"/>
-              <a:t>Thông số đầu đủ</a:t>
-            </a:r>
-          </a:p>
-        </p:txBody>
-      </p:sp>
-      <p:sp>
-        <p:nvSpPr>
-          <p:cNvPr id="3" name="Content Placeholder 2">
-            <a:extLst>
-              <a:ext uri="{FF2B5EF4-FFF2-40B4-BE49-F238E27FC236}">
-                <a16:creationId xmlns:a16="http://schemas.microsoft.com/office/drawing/2014/main" id="{105DC52C-12DF-E812-8654-D1DBCCBDA6CC}"/>
-              </a:ext>
-            </a:extLst>
-          </p:cNvPr>
+              <a:t>Phần mềm vận hành qua 6 bước</a:t>
+            </a:r>
+          </a:p>
+        </p:txBody>
+      </p:sp>
+      <p:sp>
+        <p:nvSpPr>
+          <p:cNvPr id="3" name="Content Placeholder 2"/>
           <p:cNvSpPr>
             <a:spLocks noGrp="1"/>
           </p:cNvSpPr>
@@ -8020,61 +7972,535 @@
             <p:ph idx="1"/>
           </p:nvPr>
         </p:nvSpPr>
-        <p:spPr/>
+        <p:spPr>
+          <a:xfrm>
+            <a:off x="841248" y="1828800"/>
+            <a:ext cx="4846320" cy="4480560"/>
+          </a:xfrm>
+        </p:spPr>
         <p:txBody>
           <a:bodyPr/>
           <a:lstStyle/>
           <a:p>
-            <a:pPr>
+            <a:pPr marL="0" indent="0">
               <a:lnSpc>
                 <a:spcPct val="110000"/>
               </a:lnSpc>
               <a:spcAft>
-                <a:spcPts val="2400"/>
+                <a:spcPts val="1000"/>
               </a:spcAft>
+              <a:buNone/>
             </a:pPr>
             <a:r>
-              <a:rPr lang="vi-VN" sz="3200"/>
-              <a:t>Biết rõ mức lấp đầy cụ thể</a:t>
-            </a:r>
-          </a:p>
-          <a:p>
-            <a:pPr>
+              <a:rPr b="1" sz="1800" lang="vi-VN"/>
+              <a:t>1. Sao lưu:</a:t>
+            </a:r>
+            <a:r>
+              <a:rPr b="0" sz="1800" lang="vi-VN"/>
+              <a:t> tự lưu một bản dữ liệu trước khi chạy</a:t>
+            </a:r>
+          </a:p>
+          <a:p>
+            <a:pPr marL="0" indent="0">
               <a:lnSpc>
                 <a:spcPct val="110000"/>
               </a:lnSpc>
               <a:spcAft>
-                <a:spcPts val="2400"/>
+                <a:spcPts val="1000"/>
               </a:spcAft>
+              <a:buNone/>
             </a:pPr>
             <a:r>
-              <a:rPr lang="vi-VN" sz="3200"/>
-              <a:t>Phân bổ nguyện vọng</a:t>
-            </a:r>
-            <a:endParaRPr lang="vi-VN" dirty="0"/>
-          </a:p>
-          <a:p>
-            <a:pPr>
+              <a:rPr b="1" sz="1800" lang="vi-VN"/>
+              <a:t>2. Kiểm tra dữ liệu:</a:t>
+            </a:r>
+            <a:r>
+              <a:rPr b="0" sz="1800" lang="vi-VN"/>
+              <a:t> dữ liệu sai thì dừng lại, chưa bốc thăm</a:t>
+            </a:r>
+          </a:p>
+          <a:p>
+            <a:pPr marL="0" indent="0">
               <a:lnSpc>
                 <a:spcPct val="110000"/>
               </a:lnSpc>
               <a:spcAft>
-                <a:spcPts val="2400"/>
+                <a:spcPts val="1000"/>
+              </a:spcAft>
+              <a:buNone/>
+            </a:pPr>
+            <a:r>
+              <a:rPr b="1" sz="1800" lang="vi-VN"/>
+              <a:t>3. Bốc thăm:</a:t>
+            </a:r>
+            <a:r>
+              <a:rPr b="0" sz="1800" lang="vi-VN"/>
+              <a:t> tạo số bốc thăm cho học sinh, khóa lại sau lần đầu</a:t>
+            </a:r>
+          </a:p>
+          <a:p>
+            <a:pPr marL="0" indent="0">
+              <a:lnSpc>
+                <a:spcPct val="110000"/>
+              </a:lnSpc>
+              <a:spcAft>
+                <a:spcPts val="1000"/>
+              </a:spcAft>
+              <a:buNone/>
+            </a:pPr>
+            <a:r>
+              <a:rPr b="1" sz="1800" lang="vi-VN"/>
+              <a:t>4. Chạy thuật toán:</a:t>
+            </a:r>
+            <a:r>
+              <a:rPr b="0" sz="1800" lang="vi-VN"/>
+              <a:t> xếp học sinh vào CLB, kiểm tra kết quả ổn định</a:t>
+            </a:r>
+          </a:p>
+          <a:p>
+            <a:pPr marL="0" indent="0">
+              <a:lnSpc>
+                <a:spcPct val="110000"/>
+              </a:lnSpc>
+              <a:spcAft>
+                <a:spcPts val="1000"/>
+              </a:spcAft>
+              <a:buNone/>
+            </a:pPr>
+            <a:r>
+              <a:rPr b="1" sz="1800" lang="vi-VN"/>
+              <a:t>5. Ghi kết quả:</a:t>
+            </a:r>
+            <a:r>
+              <a:rPr b="0" sz="1800" lang="vi-VN"/>
+              <a:t> chỉ lưu khi mọi bước đều đạt, lỗi thì hủy toàn bộ</a:t>
+            </a:r>
+          </a:p>
+          <a:p>
+            <a:pPr marL="0" indent="0">
+              <a:lnSpc>
+                <a:spcPct val="110000"/>
+              </a:lnSpc>
+              <a:spcAft>
+                <a:spcPts val="1000"/>
+              </a:spcAft>
+              <a:buNone/>
+            </a:pPr>
+            <a:r>
+              <a:rPr b="1" sz="1800" lang="vi-VN"/>
+              <a:t>6. Xuất tệp:</a:t>
+            </a:r>
+            <a:r>
+              <a:rPr b="0" sz="1800" lang="vi-VN"/>
+              <a:t> tạo file kết quả cho nhà trường và từng CLB</a:t>
+            </a:r>
+          </a:p>
+        </p:txBody>
+      </p:sp>
+      <p:sp>
+        <p:nvSpPr>
+          <p:cNvPr id="4" name="TextBox 3"/>
+          <p:cNvSpPr txBox="1"/>
+          <p:nvPr/>
+        </p:nvSpPr>
+        <p:spPr>
+          <a:xfrm>
+            <a:off x="6172200" y="1828800"/>
+            <a:ext cx="5184648" cy="2514600"/>
+          </a:xfrm>
+          <a:prstGeom prst="rect">
+            <a:avLst/>
+          </a:prstGeom>
+          <a:noFill/>
+        </p:spPr>
+        <p:txBody>
+          <a:bodyPr wrap="square" lIns="0" rIns="0" tIns="0" bIns="0">
+            <a:spAutoFit/>
+          </a:bodyPr>
+          <a:lstStyle/>
+          <a:p>
+            <a:pPr>
+              <a:spcAft>
+                <a:spcPts val="1000"/>
               </a:spcAft>
             </a:pPr>
             <a:r>
-              <a:rPr lang="vi-VN" sz="3200"/>
-              <a:t>Số học sinh cụ thể chưa có chỗ</a:t>
-            </a:r>
-          </a:p>
-        </p:txBody>
-      </p:sp>
+              <a:rPr b="1" sz="2000" lang="vi-VN">
+                <a:solidFill>
+                  <a:srgbClr val="1F1F1F"/>
+                </a:solidFill>
+              </a:rPr>
+              <a:t>Bước 4 diễn ra thế nào</a:t>
+            </a:r>
+          </a:p>
+          <a:p>
+            <a:pPr>
+              <a:spcAft>
+                <a:spcPts val="800"/>
+              </a:spcAft>
+            </a:pPr>
+            <a:r>
+              <a:rPr b="1" sz="1600" lang="vi-VN">
+                <a:solidFill>
+                  <a:srgbClr val="1F1F1F"/>
+                </a:solidFill>
+              </a:rPr>
+              <a:t>Nộp đơn: </a:t>
+            </a:r>
+            <a:r>
+              <a:rPr b="0" sz="1600" lang="vi-VN">
+                <a:solidFill>
+                  <a:srgbClr val="1F1F1F"/>
+                </a:solidFill>
+              </a:rPr>
+              <a:t>học sinh nộp đơn vào CLB theo thứ tự nguyện vọng.</a:t>
+            </a:r>
+          </a:p>
+          <a:p>
+            <a:pPr>
+              <a:spcAft>
+                <a:spcPts val="800"/>
+              </a:spcAft>
+            </a:pPr>
+            <a:r>
+              <a:rPr b="1" sz="1600" lang="vi-VN">
+                <a:solidFill>
+                  <a:srgbClr val="1F1F1F"/>
+                </a:solidFill>
+              </a:rPr>
+              <a:t>Xếp hạng hai tầng: </a:t>
+            </a:r>
+            <a:r>
+              <a:rPr b="0" sz="1600" lang="vi-VN">
+                <a:solidFill>
+                  <a:srgbClr val="1F1F1F"/>
+                </a:solidFill>
+              </a:rPr>
+              <a:t>Tầng 1 là học sinh đã thi, xếp theo điểm; Tầng 2 là học sinh không thi, xếp theo bốc thăm.</a:t>
+            </a:r>
+          </a:p>
+          <a:p>
+            <a:pPr>
+              <a:spcAft>
+                <a:spcPts val="800"/>
+              </a:spcAft>
+            </a:pPr>
+            <a:r>
+              <a:rPr b="1" sz="1600" lang="vi-VN">
+                <a:solidFill>
+                  <a:srgbClr val="1F1F1F"/>
+                </a:solidFill>
+              </a:rPr>
+              <a:t>Giữ tạm: </a:t>
+            </a:r>
+            <a:r>
+              <a:rPr b="0" sz="1600" lang="vi-VN">
+                <a:solidFill>
+                  <a:srgbClr val="1F1F1F"/>
+                </a:solidFill>
+              </a:rPr>
+              <a:t>CLB giữ tạm đủ số chỗ, từ chối phần còn lại.</a:t>
+            </a:r>
+          </a:p>
+          <a:p>
+            <a:pPr>
+              <a:spcAft>
+                <a:spcPts val="800"/>
+              </a:spcAft>
+            </a:pPr>
+            <a:r>
+              <a:rPr b="1" sz="1600" lang="vi-VN">
+                <a:solidFill>
+                  <a:srgbClr val="1F1F1F"/>
+                </a:solidFill>
+              </a:rPr>
+              <a:t>Lặp lại: </a:t>
+            </a:r>
+            <a:r>
+              <a:rPr b="0" sz="1600" lang="vi-VN">
+                <a:solidFill>
+                  <a:srgbClr val="1F1F1F"/>
+                </a:solidFill>
+              </a:rPr>
+              <a:t>học sinh bị từ chối nộp tiếp nguyện vọng sau, tới khi không còn ai nộp.</a:t>
+            </a:r>
+          </a:p>
+        </p:txBody>
+      </p:sp>
+      <p:sp>
+        <p:nvSpPr>
+          <p:cNvPr id="5" name="TextBox 4"/>
+          <p:cNvSpPr txBox="1"/>
+          <p:nvPr/>
+        </p:nvSpPr>
+        <p:spPr>
+          <a:xfrm>
+            <a:off x="6172200" y="4526280"/>
+            <a:ext cx="5184648" cy="320040"/>
+          </a:xfrm>
+          <a:prstGeom prst="rect">
+            <a:avLst/>
+          </a:prstGeom>
+          <a:noFill/>
+        </p:spPr>
+        <p:txBody>
+          <a:bodyPr wrap="square" lIns="0" rIns="0" tIns="0" bIns="0"/>
+          <a:lstStyle/>
+          <a:p>
+            <a:pPr algn="l" marL="0" indent="0"/>
+            <a:r>
+              <a:rPr b="1" sz="1500" lang="vi-VN">
+                <a:solidFill>
+                  <a:srgbClr val="1F1F1F"/>
+                </a:solidFill>
+              </a:rPr>
+              <a:t>Ví dụ: CLB Tin học có 2 chỗ</a:t>
+            </a:r>
+          </a:p>
+        </p:txBody>
+      </p:sp>
+      <p:graphicFrame>
+        <p:nvGraphicFramePr>
+          <p:cNvPr id="6" name="Table 5"/>
+          <p:cNvGraphicFramePr>
+            <a:graphicFrameLocks noGrp="1"/>
+          </p:cNvGraphicFramePr>
+          <p:nvPr/>
+        </p:nvGraphicFramePr>
+        <p:xfrm>
+          <a:off x="6172200" y="4892040"/>
+          <a:ext cx="5184648" cy="1280160"/>
+        </p:xfrm>
+        <a:graphic>
+          <a:graphicData uri="http://schemas.openxmlformats.org/drawingml/2006/table">
+            <a:tbl>
+              <a:tblPr firstRow="0" bandRow="0">
+                <a:tableStyleId>{5940675A-B579-460E-94D1-54222C63F5DA}</a:tableStyleId>
+              </a:tblPr>
+              <a:tblGrid>
+                <a:gridCol w="640080"/>
+                <a:gridCol w="2624328"/>
+                <a:gridCol w="960120"/>
+                <a:gridCol w="960120"/>
+              </a:tblGrid>
+              <a:tr h="426720">
+                <a:tc>
+                  <a:txBody>
+                    <a:bodyPr wrap="square"/>
+                    <a:lstStyle/>
+                    <a:p>
+                      <a:pPr algn="ctr"/>
+                      <a:r>
+                        <a:rPr sz="1300" b="1" lang="vi-VN">
+                          <a:solidFill>
+                            <a:srgbClr val="1F1F1F"/>
+                          </a:solidFill>
+                        </a:rPr>
+                        <a:t>Vòng</a:t>
+                      </a:r>
+                    </a:p>
+                  </a:txBody>
+                  <a:tcPr marL="54864" marR="54864" marT="27432" marB="27432"/>
+                </a:tc>
+                <a:tc>
+                  <a:txBody>
+                    <a:bodyPr wrap="square"/>
+                    <a:lstStyle/>
+                    <a:p>
+                      <a:r>
+                        <a:rPr sz="1300" b="1" lang="vi-VN">
+                          <a:solidFill>
+                            <a:srgbClr val="1F1F1F"/>
+                          </a:solidFill>
+                        </a:rPr>
+                        <a:t>Đơn đang xét</a:t>
+                      </a:r>
+                    </a:p>
+                  </a:txBody>
+                  <a:tcPr marL="54864" marR="54864" marT="27432" marB="27432"/>
+                </a:tc>
+                <a:tc>
+                  <a:txBody>
+                    <a:bodyPr wrap="square"/>
+                    <a:lstStyle/>
+                    <a:p>
+                      <a:r>
+                        <a:rPr sz="1300" b="1" lang="vi-VN">
+                          <a:solidFill>
+                            <a:srgbClr val="1F1F1F"/>
+                          </a:solidFill>
+                        </a:rPr>
+                        <a:t>Giữ tạm</a:t>
+                      </a:r>
+                    </a:p>
+                  </a:txBody>
+                  <a:tcPr marL="54864" marR="54864" marT="27432" marB="27432"/>
+                </a:tc>
+                <a:tc>
+                  <a:txBody>
+                    <a:bodyPr wrap="square"/>
+                    <a:lstStyle/>
+                    <a:p>
+                      <a:r>
+                        <a:rPr sz="1300" b="1" lang="vi-VN">
+                          <a:solidFill>
+                            <a:srgbClr val="1F1F1F"/>
+                          </a:solidFill>
+                        </a:rPr>
+                        <a:t>Bị từ chối</a:t>
+                      </a:r>
+                    </a:p>
+                  </a:txBody>
+                  <a:tcPr marL="54864" marR="54864" marT="27432" marB="27432"/>
+                </a:tc>
+              </a:tr>
+              <a:tr h="426720">
+                <a:tc>
+                  <a:txBody>
+                    <a:bodyPr wrap="square"/>
+                    <a:lstStyle/>
+                    <a:p>
+                      <a:pPr algn="ctr"/>
+                      <a:r>
+                        <a:rPr sz="1300" b="0" lang="vi-VN">
+                          <a:solidFill>
+                            <a:srgbClr val="1F1F1F"/>
+                          </a:solidFill>
+                        </a:rPr>
+                        <a:t>1</a:t>
+                      </a:r>
+                    </a:p>
+                  </a:txBody>
+                  <a:tcPr marL="54864" marR="54864" marT="27432" marB="27432"/>
+                </a:tc>
+                <a:tc>
+                  <a:txBody>
+                    <a:bodyPr wrap="square"/>
+                    <a:lstStyle/>
+                    <a:p>
+                      <a:r>
+                        <a:rPr sz="1300" b="0" lang="vi-VN">
+                          <a:solidFill>
+                            <a:srgbClr val="1F1F1F"/>
+                          </a:solidFill>
+                        </a:rPr>
+                        <a:t>An (thi, 8 điểm), Chi (thi, 7 điểm), Bình (không thi)</a:t>
+                      </a:r>
+                    </a:p>
+                  </a:txBody>
+                  <a:tcPr marL="54864" marR="54864" marT="27432" marB="27432"/>
+                </a:tc>
+                <a:tc>
+                  <a:txBody>
+                    <a:bodyPr wrap="square"/>
+                    <a:lstStyle/>
+                    <a:p>
+                      <a:r>
+                        <a:rPr sz="1300" b="0" lang="vi-VN">
+                          <a:solidFill>
+                            <a:srgbClr val="1F1F1F"/>
+                          </a:solidFill>
+                        </a:rPr>
+                        <a:t>An, Chi</a:t>
+                      </a:r>
+                    </a:p>
+                  </a:txBody>
+                  <a:tcPr marL="54864" marR="54864" marT="27432" marB="27432"/>
+                </a:tc>
+                <a:tc>
+                  <a:txBody>
+                    <a:bodyPr wrap="square"/>
+                    <a:lstStyle/>
+                    <a:p>
+                      <a:r>
+                        <a:rPr sz="1300" b="0" lang="vi-VN">
+                          <a:solidFill>
+                            <a:srgbClr val="1F1F1F"/>
+                          </a:solidFill>
+                        </a:rPr>
+                        <a:t>Bình</a:t>
+                      </a:r>
+                    </a:p>
+                  </a:txBody>
+                  <a:tcPr marL="54864" marR="54864" marT="27432" marB="27432"/>
+                </a:tc>
+              </a:tr>
+              <a:tr h="426720">
+                <a:tc>
+                  <a:txBody>
+                    <a:bodyPr wrap="square"/>
+                    <a:lstStyle/>
+                    <a:p>
+                      <a:pPr algn="ctr"/>
+                      <a:r>
+                        <a:rPr sz="1300" b="0" lang="vi-VN">
+                          <a:solidFill>
+                            <a:srgbClr val="1F1F1F"/>
+                          </a:solidFill>
+                        </a:rPr>
+                        <a:t>2</a:t>
+                      </a:r>
+                    </a:p>
+                  </a:txBody>
+                  <a:tcPr marL="54864" marR="54864" marT="27432" marB="27432"/>
+                </a:tc>
+                <a:tc>
+                  <a:txBody>
+                    <a:bodyPr wrap="square"/>
+                    <a:lstStyle/>
+                    <a:p>
+                      <a:r>
+                        <a:rPr sz="1300" b="0" lang="vi-VN">
+                          <a:solidFill>
+                            <a:srgbClr val="1F1F1F"/>
+                          </a:solidFill>
+                        </a:rPr>
+                        <a:t>Thêm Dũng (thi, 9 điểm)</a:t>
+                      </a:r>
+                    </a:p>
+                  </a:txBody>
+                  <a:tcPr marL="54864" marR="54864" marT="27432" marB="27432"/>
+                </a:tc>
+                <a:tc>
+                  <a:txBody>
+                    <a:bodyPr wrap="square"/>
+                    <a:lstStyle/>
+                    <a:p>
+                      <a:r>
+                        <a:rPr sz="1300" b="0" lang="vi-VN">
+                          <a:solidFill>
+                            <a:srgbClr val="1F1F1F"/>
+                          </a:solidFill>
+                        </a:rPr>
+                        <a:t>Dũng, An</a:t>
+                      </a:r>
+                    </a:p>
+                  </a:txBody>
+                  <a:tcPr marL="54864" marR="54864" marT="27432" marB="27432"/>
+                </a:tc>
+                <a:tc>
+                  <a:txBody>
+                    <a:bodyPr wrap="square"/>
+                    <a:lstStyle/>
+                    <a:p>
+                      <a:r>
+                        <a:rPr sz="1300" b="0" lang="vi-VN">
+                          <a:solidFill>
+                            <a:srgbClr val="1F1F1F"/>
+                          </a:solidFill>
+                        </a:rPr>
+                        <a:t>Chi</a:t>
+                      </a:r>
+                    </a:p>
+                  </a:txBody>
+                  <a:tcPr marL="54864" marR="54864" marT="27432" marB="27432"/>
+                </a:tc>
+              </a:tr>
+            </a:tbl>
+          </a:graphicData>
+        </a:graphic>
+      </p:graphicFrame>
     </p:spTree>
-    <p:extLst>
-      <p:ext uri="{BB962C8B-B14F-4D97-AF65-F5344CB8AC3E}">
-        <p14:creationId xmlns:p14="http://schemas.microsoft.com/office/powerpoint/2010/main" val="156299913"/>
-      </p:ext>
-    </p:extLst>
   </p:cSld>
   <p:clrMapOvr>
     <a:masterClrMapping/>
@@ -8104,7 +8530,7 @@
           <p:cNvPr id="2" name="Title 1">
             <a:extLst>
               <a:ext uri="{FF2B5EF4-FFF2-40B4-BE49-F238E27FC236}">
-                <a16:creationId xmlns:a16="http://schemas.microsoft.com/office/drawing/2014/main" id="{D0164522-D64D-59BE-2844-B2191806B6A3}"/>
+                <a16:creationId xmlns:a16="http://schemas.microsoft.com/office/drawing/2014/main" id="{6232FEA5-37DE-2025-46C4-C5C7E5C675D6}"/>
               </a:ext>
             </a:extLst>
           </p:cNvPr>
@@ -8121,396 +8547,73 @@
           <a:lstStyle/>
           <a:p>
             <a:r>
-              <a:rPr lang="vi-VN" sz="3800"/>
-              <a:t>Thử nghiệm với 140 HS, 12 CLB, 150 suất</a:t>
+              <a:rPr lang="vi-VN"/>
+              <a:t>Thông số đầu đủ</a:t>
+            </a:r>
+          </a:p>
+        </p:txBody>
+      </p:sp>
+      <p:sp>
+        <p:nvSpPr>
+          <p:cNvPr id="3" name="Content Placeholder 2">
+            <a:extLst>
+              <a:ext uri="{FF2B5EF4-FFF2-40B4-BE49-F238E27FC236}">
+                <a16:creationId xmlns:a16="http://schemas.microsoft.com/office/drawing/2014/main" id="{105DC52C-12DF-E812-8654-D1DBCCBDA6CC}"/>
+              </a:ext>
+            </a:extLst>
+          </p:cNvPr>
+          <p:cNvSpPr>
+            <a:spLocks noGrp="1"/>
+          </p:cNvSpPr>
+          <p:nvPr>
+            <p:ph idx="1"/>
+          </p:nvPr>
+        </p:nvSpPr>
+        <p:spPr/>
+        <p:txBody>
+          <a:bodyPr/>
+          <a:lstStyle/>
+          <a:p>
+            <a:pPr>
+              <a:lnSpc>
+                <a:spcPct val="110000"/>
+              </a:lnSpc>
+              <a:spcAft>
+                <a:spcPts val="2400"/>
+              </a:spcAft>
+            </a:pPr>
+            <a:r>
+              <a:rPr lang="vi-VN" sz="3200"/>
+              <a:t>Biết rõ mức lấp đầy cụ thể</a:t>
+            </a:r>
+          </a:p>
+          <a:p>
+            <a:pPr>
+              <a:lnSpc>
+                <a:spcPct val="110000"/>
+              </a:lnSpc>
+              <a:spcAft>
+                <a:spcPts val="2400"/>
+              </a:spcAft>
+            </a:pPr>
+            <a:r>
+              <a:rPr lang="vi-VN" sz="3200"/>
+              <a:t>Phân bổ nguyện vọng</a:t>
             </a:r>
             <a:endParaRPr lang="vi-VN" dirty="0"/>
           </a:p>
-        </p:txBody>
-      </p:sp>
-      <p:pic>
-        <p:nvPicPr>
-          <p:cNvPr id="3" name="Picture 2" descr="c_sach_results.png"/>
-          <p:cNvPicPr>
-            <a:picLocks noChangeAspect="1"/>
-          </p:cNvPicPr>
-          <p:nvPr/>
-        </p:nvPicPr>
-        <p:blipFill>
-          <a:blip r:embed="rId2"/>
-          <a:stretch>
-            <a:fillRect/>
-          </a:stretch>
-        </p:blipFill>
-        <p:spPr>
-          <a:xfrm>
-            <a:off x="841248" y="1783080"/>
-            <a:ext cx="5120640" cy="3778679"/>
-          </a:xfrm>
-          <a:prstGeom prst="rect">
-            <a:avLst/>
-          </a:prstGeom>
-          <a:ln w="9525">
-            <a:solidFill>
-              <a:srgbClr val="D0D0D0"/>
-            </a:solidFill>
-          </a:ln>
-        </p:spPr>
-      </p:pic>
-      <p:sp>
-        <p:nvSpPr>
-          <p:cNvPr id="4" name="TextBox 3"/>
-          <p:cNvSpPr txBox="1"/>
-          <p:nvPr/>
-        </p:nvSpPr>
-        <p:spPr>
-          <a:xfrm>
-            <a:off x="841248" y="5634911"/>
-            <a:ext cx="5120640" cy="274320"/>
-          </a:xfrm>
-          <a:prstGeom prst="rect">
-            <a:avLst/>
-          </a:prstGeom>
-          <a:noFill/>
-        </p:spPr>
-        <p:txBody>
-          <a:bodyPr wrap="square" lIns="0" rIns="0" tIns="0" bIns="0">
-            <a:spAutoFit/>
-          </a:bodyPr>
-          <a:lstStyle/>
-          <a:p>
-            <a:r>
-              <a:rPr sz="1100" b="0" i="1" lang="vi-VN">
-                <a:solidFill>
-                  <a:srgbClr val="595959"/>
-                </a:solidFill>
-                <a:latin typeface="Arial"/>
-              </a:rPr>
-              <a:t>Màn hình Kết quả của phần mềm. Xanh: xét chung. Vàng: vào bằng suất dự trữ.</a:t>
-            </a:r>
-          </a:p>
-        </p:txBody>
-      </p:sp>
-      <p:sp>
-        <p:nvSpPr>
-          <p:cNvPr id="5" name="TextBox 4"/>
-          <p:cNvSpPr txBox="1"/>
-          <p:nvPr/>
-        </p:nvSpPr>
-        <p:spPr>
-          <a:xfrm>
-            <a:off x="6355080" y="1783080"/>
-            <a:ext cx="2377440" cy="457200"/>
-          </a:xfrm>
-          <a:prstGeom prst="rect">
-            <a:avLst/>
-          </a:prstGeom>
-          <a:noFill/>
-        </p:spPr>
-        <p:txBody>
-          <a:bodyPr wrap="square" lIns="0" rIns="0" tIns="0" bIns="0">
-            <a:spAutoFit/>
-          </a:bodyPr>
-          <a:lstStyle/>
-          <a:p>
-            <a:r>
-              <a:rPr sz="2600" b="1" i="0" lang="vi-VN">
-                <a:solidFill>
-                  <a:srgbClr val="3F6B52"/>
-                </a:solidFill>
-                <a:latin typeface="Arial"/>
-              </a:rPr>
-              <a:t>140/140</a:t>
-            </a:r>
-          </a:p>
-        </p:txBody>
-      </p:sp>
-      <p:sp>
-        <p:nvSpPr>
-          <p:cNvPr id="6" name="TextBox 5"/>
-          <p:cNvSpPr txBox="1"/>
-          <p:nvPr/>
-        </p:nvSpPr>
-        <p:spPr>
-          <a:xfrm>
-            <a:off x="6355080" y="2240280"/>
-            <a:ext cx="2377440" cy="320040"/>
-          </a:xfrm>
-          <a:prstGeom prst="rect">
-            <a:avLst/>
-          </a:prstGeom>
-          <a:noFill/>
-        </p:spPr>
-        <p:txBody>
-          <a:bodyPr wrap="square" lIns="0" rIns="0" tIns="0" bIns="0">
-            <a:spAutoFit/>
-          </a:bodyPr>
-          <a:lstStyle/>
-          <a:p>
-            <a:r>
-              <a:rPr sz="1200" b="0" i="0" lang="vi-VN">
-                <a:solidFill>
-                  <a:srgbClr val="595959"/>
-                </a:solidFill>
-                <a:latin typeface="Arial"/>
-              </a:rPr>
-              <a:t>học sinh có CLB</a:t>
-            </a:r>
-          </a:p>
-        </p:txBody>
-      </p:sp>
-      <p:sp>
-        <p:nvSpPr>
-          <p:cNvPr id="7" name="TextBox 6"/>
-          <p:cNvSpPr txBox="1"/>
-          <p:nvPr/>
-        </p:nvSpPr>
-        <p:spPr>
-          <a:xfrm>
-            <a:off x="8869680" y="1783080"/>
-            <a:ext cx="2377440" cy="457200"/>
-          </a:xfrm>
-          <a:prstGeom prst="rect">
-            <a:avLst/>
-          </a:prstGeom>
-          <a:noFill/>
-        </p:spPr>
-        <p:txBody>
-          <a:bodyPr wrap="square" lIns="0" rIns="0" tIns="0" bIns="0">
-            <a:spAutoFit/>
-          </a:bodyPr>
-          <a:lstStyle/>
-          <a:p>
-            <a:r>
-              <a:rPr sz="2600" b="1" i="0" lang="vi-VN">
-                <a:solidFill>
-                  <a:srgbClr val="3F6B52"/>
-                </a:solidFill>
-                <a:latin typeface="Arial"/>
-              </a:rPr>
-              <a:t>39%</a:t>
-            </a:r>
-          </a:p>
-        </p:txBody>
-      </p:sp>
-      <p:sp>
-        <p:nvSpPr>
-          <p:cNvPr id="8" name="TextBox 7"/>
-          <p:cNvSpPr txBox="1"/>
-          <p:nvPr/>
-        </p:nvSpPr>
-        <p:spPr>
-          <a:xfrm>
-            <a:off x="8869680" y="2240280"/>
-            <a:ext cx="2377440" cy="320040"/>
-          </a:xfrm>
-          <a:prstGeom prst="rect">
-            <a:avLst/>
-          </a:prstGeom>
-          <a:noFill/>
-        </p:spPr>
-        <p:txBody>
-          <a:bodyPr wrap="square" lIns="0" rIns="0" tIns="0" bIns="0">
-            <a:spAutoFit/>
-          </a:bodyPr>
-          <a:lstStyle/>
-          <a:p>
-            <a:r>
-              <a:rPr sz="1200" b="0" i="0" lang="vi-VN">
-                <a:solidFill>
-                  <a:srgbClr val="595959"/>
-                </a:solidFill>
-                <a:latin typeface="Arial"/>
-              </a:rPr>
-              <a:t>được nguyện vọng 1</a:t>
-            </a:r>
-          </a:p>
-        </p:txBody>
-      </p:sp>
-      <p:sp>
-        <p:nvSpPr>
-          <p:cNvPr id="9" name="TextBox 8"/>
-          <p:cNvSpPr txBox="1"/>
-          <p:nvPr/>
-        </p:nvSpPr>
-        <p:spPr>
-          <a:xfrm>
-            <a:off x="6355080" y="2651760"/>
-            <a:ext cx="2377440" cy="457200"/>
-          </a:xfrm>
-          <a:prstGeom prst="rect">
-            <a:avLst/>
-          </a:prstGeom>
-          <a:noFill/>
-        </p:spPr>
-        <p:txBody>
-          <a:bodyPr wrap="square" lIns="0" rIns="0" tIns="0" bIns="0">
-            <a:spAutoFit/>
-          </a:bodyPr>
-          <a:lstStyle/>
-          <a:p>
-            <a:r>
-              <a:rPr sz="2600" b="1" i="0" lang="vi-VN">
-                <a:solidFill>
-                  <a:srgbClr val="3F6B52"/>
-                </a:solidFill>
-                <a:latin typeface="Arial"/>
-              </a:rPr>
-              <a:t>16</a:t>
-            </a:r>
-          </a:p>
-        </p:txBody>
-      </p:sp>
-      <p:sp>
-        <p:nvSpPr>
-          <p:cNvPr id="10" name="TextBox 9"/>
-          <p:cNvSpPr txBox="1"/>
-          <p:nvPr/>
-        </p:nvSpPr>
-        <p:spPr>
-          <a:xfrm>
-            <a:off x="6355080" y="3108960"/>
-            <a:ext cx="2377440" cy="320040"/>
-          </a:xfrm>
-          <a:prstGeom prst="rect">
-            <a:avLst/>
-          </a:prstGeom>
-          <a:noFill/>
-        </p:spPr>
-        <p:txBody>
-          <a:bodyPr wrap="square" lIns="0" rIns="0" tIns="0" bIns="0">
-            <a:spAutoFit/>
-          </a:bodyPr>
-          <a:lstStyle/>
-          <a:p>
-            <a:r>
-              <a:rPr sz="1200" b="0" i="0" lang="vi-VN">
-                <a:solidFill>
-                  <a:srgbClr val="595959"/>
-                </a:solidFill>
-                <a:latin typeface="Arial"/>
-              </a:rPr>
-              <a:t>học sinh vào bằng suất dự trữ</a:t>
-            </a:r>
-          </a:p>
-        </p:txBody>
-      </p:sp>
-      <p:sp>
-        <p:nvSpPr>
-          <p:cNvPr id="11" name="TextBox 10"/>
-          <p:cNvSpPr txBox="1"/>
-          <p:nvPr/>
-        </p:nvSpPr>
-        <p:spPr>
-          <a:xfrm>
-            <a:off x="8869680" y="2651760"/>
-            <a:ext cx="2377440" cy="457200"/>
-          </a:xfrm>
-          <a:prstGeom prst="rect">
-            <a:avLst/>
-          </a:prstGeom>
-          <a:noFill/>
-        </p:spPr>
-        <p:txBody>
-          <a:bodyPr wrap="square" lIns="0" rIns="0" tIns="0" bIns="0">
-            <a:spAutoFit/>
-          </a:bodyPr>
-          <a:lstStyle/>
-          <a:p>
-            <a:r>
-              <a:rPr sz="2600" b="1" i="0" lang="vi-VN">
-                <a:solidFill>
-                  <a:srgbClr val="3F6B52"/>
-                </a:solidFill>
-                <a:latin typeface="Arial"/>
-              </a:rPr>
-              <a:t>0,02 giây</a:t>
-            </a:r>
-          </a:p>
-        </p:txBody>
-      </p:sp>
-      <p:sp>
-        <p:nvSpPr>
-          <p:cNvPr id="12" name="TextBox 11"/>
-          <p:cNvSpPr txBox="1"/>
-          <p:nvPr/>
-        </p:nvSpPr>
-        <p:spPr>
-          <a:xfrm>
-            <a:off x="8869680" y="3108960"/>
-            <a:ext cx="2377440" cy="320040"/>
-          </a:xfrm>
-          <a:prstGeom prst="rect">
-            <a:avLst/>
-          </a:prstGeom>
-          <a:noFill/>
-        </p:spPr>
-        <p:txBody>
-          <a:bodyPr wrap="square" lIns="0" rIns="0" tIns="0" bIns="0">
-            <a:spAutoFit/>
-          </a:bodyPr>
-          <a:lstStyle/>
-          <a:p>
-            <a:r>
-              <a:rPr sz="1200" b="0" i="0" lang="vi-VN">
-                <a:solidFill>
-                  <a:srgbClr val="595959"/>
-                </a:solidFill>
-                <a:latin typeface="Arial"/>
-              </a:rPr>
-              <a:t>thời gian chạy sắp xếp</a:t>
-            </a:r>
-          </a:p>
-        </p:txBody>
-      </p:sp>
-      <p:graphicFrame>
-        <p:nvGraphicFramePr>
-          <p:cNvPr id="13" name="Chart 12"/>
-          <p:cNvGraphicFramePr>
-            <a:graphicFrameLocks noGrp="1"/>
-          </p:cNvGraphicFramePr>
-          <p:nvPr/>
-        </p:nvGraphicFramePr>
-        <p:xfrm>
-          <a:off x="6355080" y="3611880"/>
-          <a:ext cx="5001768" cy="2331720"/>
-        </p:xfrm>
-        <a:graphic>
-          <a:graphicData uri="http://schemas.openxmlformats.org/drawingml/2006/chart">
-            <c:chart xmlns:c="http://schemas.openxmlformats.org/drawingml/2006/chart" r:id="rId3"/>
-          </a:graphicData>
-        </a:graphic>
-      </p:graphicFrame>
-      <p:sp>
-        <p:nvSpPr>
-          <p:cNvPr id="14" name="TextBox 13"/>
-          <p:cNvSpPr txBox="1"/>
-          <p:nvPr/>
-        </p:nvSpPr>
-        <p:spPr>
-          <a:xfrm>
-            <a:off x="841248" y="6144768"/>
-            <a:ext cx="10515600" cy="274320"/>
-          </a:xfrm>
-          <a:prstGeom prst="rect">
-            <a:avLst/>
-          </a:prstGeom>
-          <a:noFill/>
-        </p:spPr>
-        <p:txBody>
-          <a:bodyPr wrap="square" lIns="0" rIns="0" tIns="0" bIns="0">
-            <a:spAutoFit/>
-          </a:bodyPr>
-          <a:lstStyle/>
-          <a:p>
-            <a:r>
-              <a:rPr sz="1100" b="0" i="1" lang="vi-VN">
-                <a:solidFill>
-                  <a:srgbClr val="B84A3E"/>
-                </a:solidFill>
-                <a:latin typeface="Arial"/>
-              </a:rPr>
-              <a:t>Dữ liệu mô phỏng do máy tạo ra (bộ bo_sach), không phải học sinh thật. Mỗi học sinh thi 4 CLB và ghi 6 nguyện vọng.</a:t>
+          <a:p>
+            <a:pPr>
+              <a:lnSpc>
+                <a:spcPct val="110000"/>
+              </a:lnSpc>
+              <a:spcAft>
+                <a:spcPts val="2400"/>
+              </a:spcAft>
+            </a:pPr>
+            <a:r>
+              <a:rPr lang="vi-VN" sz="3200"/>
+              <a:t>Số học sinh cụ thể chưa có chỗ</a:t>
             </a:r>
           </a:p>
         </p:txBody>
@@ -8518,7 +8621,7 @@
     </p:spTree>
     <p:extLst>
       <p:ext uri="{BB962C8B-B14F-4D97-AF65-F5344CB8AC3E}">
-        <p14:creationId xmlns:p14="http://schemas.microsoft.com/office/powerpoint/2010/main" val="603483598"/>
+        <p14:creationId xmlns:p14="http://schemas.microsoft.com/office/powerpoint/2010/main" val="156299913"/>
       </p:ext>
     </p:extLst>
   </p:cSld>
@@ -8550,7 +8653,7 @@
           <p:cNvPr id="2" name="Title 1">
             <a:extLst>
               <a:ext uri="{FF2B5EF4-FFF2-40B4-BE49-F238E27FC236}">
-                <a16:creationId xmlns:a16="http://schemas.microsoft.com/office/drawing/2014/main" id="{FED7EA77-B499-B89C-F3A5-57074CDEE67E}"/>
+                <a16:creationId xmlns:a16="http://schemas.microsoft.com/office/drawing/2014/main" id="{D0164522-D64D-59BE-2844-B2191806B6A3}"/>
               </a:ext>
             </a:extLst>
           </p:cNvPr>
@@ -8567,99 +8670,404 @@
           <a:lstStyle/>
           <a:p>
             <a:r>
-              <a:rPr lang="vi-VN"/>
-              <a:t>Số liệu chứng minh công bằng</a:t>
+              <a:rPr lang="vi-VN" sz="3800"/>
+              <a:t>Thử nghiệm với 140 HS, 12 CLB, 150 suất</a:t>
             </a:r>
             <a:endParaRPr lang="vi-VN" dirty="0"/>
           </a:p>
         </p:txBody>
       </p:sp>
-      <p:sp>
-        <p:nvSpPr>
-          <p:cNvPr id="3" name="Content Placeholder 2">
-            <a:extLst>
-              <a:ext uri="{FF2B5EF4-FFF2-40B4-BE49-F238E27FC236}">
-                <a16:creationId xmlns:a16="http://schemas.microsoft.com/office/drawing/2014/main" id="{1403EA8F-8A5D-9DCB-17FE-E89082138456}"/>
-              </a:ext>
-            </a:extLst>
-          </p:cNvPr>
-          <p:cNvSpPr>
-            <a:spLocks noGrp="1"/>
-          </p:cNvSpPr>
-          <p:nvPr>
-            <p:ph idx="1"/>
-          </p:nvPr>
-        </p:nvSpPr>
-        <p:spPr/>
-        <p:txBody>
-          <a:bodyPr/>
-          <a:lstStyle/>
-          <a:p>
-            <a:pPr>
-              <a:lnSpc>
-                <a:spcPct val="110000"/>
-              </a:lnSpc>
-              <a:spcAft>
-                <a:spcPts val="3000"/>
-              </a:spcAft>
-            </a:pPr>
-            <a:r>
-              <a:rPr lang="vi-VN" b="1" sz="3200"/>
-              <a:t>0</a:t>
-            </a:r>
-            <a:r>
-              <a:rPr lang="vi-VN" sz="3200"/>
-              <a:t> cặp học sinh và CLB muốn đổi kết quả</a:t>
-            </a:r>
-          </a:p>
-          <a:p>
-            <a:pPr>
-              <a:lnSpc>
-                <a:spcPct val="110000"/>
-              </a:lnSpc>
-              <a:spcAft>
-                <a:spcPts val="3000"/>
-              </a:spcAft>
-            </a:pPr>
-            <a:r>
-              <a:rPr lang="vi-VN" sz="3200"/>
-              <a:t>Chỉ </a:t>
-            </a:r>
-            <a:r>
-              <a:rPr lang="vi-VN" b="1" sz="3200"/>
-              <a:t>1,1%</a:t>
-            </a:r>
-            <a:r>
-              <a:rPr lang="vi-VN" sz="3200"/>
-              <a:t> số học sinh có kết quả phụ thuộc bốc thăm</a:t>
-            </a:r>
-            <a:endParaRPr lang="vi-VN" dirty="0"/>
-          </a:p>
-          <a:p>
-            <a:pPr>
-              <a:lnSpc>
-                <a:spcPct val="110000"/>
-              </a:lnSpc>
-              <a:spcAft>
-                <a:spcPts val="3000"/>
-              </a:spcAft>
-            </a:pPr>
-            <a:r>
-              <a:rPr lang="vi-VN" b="1" sz="3200"/>
-              <a:t>750+</a:t>
-            </a:r>
-            <a:r>
-              <a:rPr lang="vi-VN" sz="3200"/>
-              <a:t> chỉ báo trong phần mềm để đảm bảo phần mềm hoạt động</a:t>
-            </a:r>
-            <a:endParaRPr lang="vi-VN" dirty="0"/>
+      <p:pic>
+        <p:nvPicPr>
+          <p:cNvPr id="3" name="Picture 2" descr="c_sach_results.png"/>
+          <p:cNvPicPr>
+            <a:picLocks noChangeAspect="1"/>
+          </p:cNvPicPr>
+          <p:nvPr/>
+        </p:nvPicPr>
+        <p:blipFill>
+          <a:blip r:embed="rId2"/>
+          <a:stretch>
+            <a:fillRect/>
+          </a:stretch>
+        </p:blipFill>
+        <p:spPr>
+          <a:xfrm>
+            <a:off x="841248" y="1783080"/>
+            <a:ext cx="5120640" cy="3778679"/>
+          </a:xfrm>
+          <a:prstGeom prst="rect">
+            <a:avLst/>
+          </a:prstGeom>
+          <a:ln w="9525">
+            <a:solidFill>
+              <a:srgbClr val="D0D0D0"/>
+            </a:solidFill>
+          </a:ln>
+        </p:spPr>
+      </p:pic>
+      <p:sp>
+        <p:nvSpPr>
+          <p:cNvPr id="4" name="TextBox 3"/>
+          <p:cNvSpPr txBox="1"/>
+          <p:nvPr/>
+        </p:nvSpPr>
+        <p:spPr>
+          <a:xfrm>
+            <a:off x="841248" y="5634911"/>
+            <a:ext cx="5120640" cy="274320"/>
+          </a:xfrm>
+          <a:prstGeom prst="rect">
+            <a:avLst/>
+          </a:prstGeom>
+          <a:noFill/>
+        </p:spPr>
+        <p:txBody>
+          <a:bodyPr wrap="square" lIns="0" rIns="0" tIns="0" bIns="0">
+            <a:spAutoFit/>
+          </a:bodyPr>
+          <a:lstStyle/>
+          <a:p>
+            <a:r>
+              <a:rPr sz="1100" b="0" i="1" lang="vi-VN">
+                <a:solidFill>
+                  <a:srgbClr val="595959"/>
+                </a:solidFill>
+                <a:latin typeface="Arial"/>
+              </a:rPr>
+              <a:t>Màn hình Kết quả của phần mềm. Xanh: xét chung. Vàng: vào bằng suất dự trữ.</a:t>
+            </a:r>
+          </a:p>
+        </p:txBody>
+      </p:sp>
+      <p:sp>
+        <p:nvSpPr>
+          <p:cNvPr id="5" name="TextBox 4"/>
+          <p:cNvSpPr txBox="1"/>
+          <p:nvPr/>
+        </p:nvSpPr>
+        <p:spPr>
+          <a:xfrm>
+            <a:off x="6355080" y="1783080"/>
+            <a:ext cx="2377440" cy="457200"/>
+          </a:xfrm>
+          <a:prstGeom prst="rect">
+            <a:avLst/>
+          </a:prstGeom>
+          <a:noFill/>
+        </p:spPr>
+        <p:txBody>
+          <a:bodyPr wrap="square" lIns="0" rIns="0" tIns="0" bIns="0">
+            <a:spAutoFit/>
+          </a:bodyPr>
+          <a:lstStyle/>
+          <a:p>
+            <a:r>
+              <a:rPr sz="2600" b="1" i="0" lang="vi-VN">
+                <a:solidFill>
+                  <a:srgbClr val="3F6B52"/>
+                </a:solidFill>
+                <a:latin typeface="Arial"/>
+              </a:rPr>
+              <a:t>140/140</a:t>
+            </a:r>
+          </a:p>
+        </p:txBody>
+      </p:sp>
+      <p:sp>
+        <p:nvSpPr>
+          <p:cNvPr id="6" name="TextBox 5"/>
+          <p:cNvSpPr txBox="1"/>
+          <p:nvPr/>
+        </p:nvSpPr>
+        <p:spPr>
+          <a:xfrm>
+            <a:off x="6355080" y="2240280"/>
+            <a:ext cx="2377440" cy="320040"/>
+          </a:xfrm>
+          <a:prstGeom prst="rect">
+            <a:avLst/>
+          </a:prstGeom>
+          <a:noFill/>
+        </p:spPr>
+        <p:txBody>
+          <a:bodyPr wrap="square" lIns="0" rIns="0" tIns="0" bIns="0">
+            <a:spAutoFit/>
+          </a:bodyPr>
+          <a:lstStyle/>
+          <a:p>
+            <a:r>
+              <a:rPr sz="1200" b="0" i="0" lang="vi-VN">
+                <a:solidFill>
+                  <a:srgbClr val="595959"/>
+                </a:solidFill>
+                <a:latin typeface="Arial"/>
+              </a:rPr>
+              <a:t>học sinh có CLB</a:t>
+            </a:r>
+          </a:p>
+        </p:txBody>
+      </p:sp>
+      <p:sp>
+        <p:nvSpPr>
+          <p:cNvPr id="7" name="TextBox 6"/>
+          <p:cNvSpPr txBox="1"/>
+          <p:nvPr/>
+        </p:nvSpPr>
+        <p:spPr>
+          <a:xfrm>
+            <a:off x="8869680" y="1783080"/>
+            <a:ext cx="2377440" cy="457200"/>
+          </a:xfrm>
+          <a:prstGeom prst="rect">
+            <a:avLst/>
+          </a:prstGeom>
+          <a:noFill/>
+        </p:spPr>
+        <p:txBody>
+          <a:bodyPr wrap="square" lIns="0" rIns="0" tIns="0" bIns="0">
+            <a:spAutoFit/>
+          </a:bodyPr>
+          <a:lstStyle/>
+          <a:p>
+            <a:r>
+              <a:rPr sz="2600" b="1" i="0" lang="vi-VN">
+                <a:solidFill>
+                  <a:srgbClr val="3F6B52"/>
+                </a:solidFill>
+                <a:latin typeface="Arial"/>
+              </a:rPr>
+              <a:t>39%</a:t>
+            </a:r>
+          </a:p>
+        </p:txBody>
+      </p:sp>
+      <p:sp>
+        <p:nvSpPr>
+          <p:cNvPr id="8" name="TextBox 7"/>
+          <p:cNvSpPr txBox="1"/>
+          <p:nvPr/>
+        </p:nvSpPr>
+        <p:spPr>
+          <a:xfrm>
+            <a:off x="8869680" y="2240280"/>
+            <a:ext cx="2377440" cy="320040"/>
+          </a:xfrm>
+          <a:prstGeom prst="rect">
+            <a:avLst/>
+          </a:prstGeom>
+          <a:noFill/>
+        </p:spPr>
+        <p:txBody>
+          <a:bodyPr wrap="square" lIns="0" rIns="0" tIns="0" bIns="0">
+            <a:spAutoFit/>
+          </a:bodyPr>
+          <a:lstStyle/>
+          <a:p>
+            <a:r>
+              <a:rPr sz="1200" b="0" i="0" lang="vi-VN">
+                <a:solidFill>
+                  <a:srgbClr val="595959"/>
+                </a:solidFill>
+                <a:latin typeface="Arial"/>
+              </a:rPr>
+              <a:t>được nguyện vọng 1</a:t>
+            </a:r>
+          </a:p>
+        </p:txBody>
+      </p:sp>
+      <p:sp>
+        <p:nvSpPr>
+          <p:cNvPr id="9" name="TextBox 8"/>
+          <p:cNvSpPr txBox="1"/>
+          <p:nvPr/>
+        </p:nvSpPr>
+        <p:spPr>
+          <a:xfrm>
+            <a:off x="6355080" y="2651760"/>
+            <a:ext cx="2377440" cy="457200"/>
+          </a:xfrm>
+          <a:prstGeom prst="rect">
+            <a:avLst/>
+          </a:prstGeom>
+          <a:noFill/>
+        </p:spPr>
+        <p:txBody>
+          <a:bodyPr wrap="square" lIns="0" rIns="0" tIns="0" bIns="0">
+            <a:spAutoFit/>
+          </a:bodyPr>
+          <a:lstStyle/>
+          <a:p>
+            <a:r>
+              <a:rPr sz="2600" b="1" i="0" lang="vi-VN">
+                <a:solidFill>
+                  <a:srgbClr val="3F6B52"/>
+                </a:solidFill>
+                <a:latin typeface="Arial"/>
+              </a:rPr>
+              <a:t>16</a:t>
+            </a:r>
+          </a:p>
+        </p:txBody>
+      </p:sp>
+      <p:sp>
+        <p:nvSpPr>
+          <p:cNvPr id="10" name="TextBox 9"/>
+          <p:cNvSpPr txBox="1"/>
+          <p:nvPr/>
+        </p:nvSpPr>
+        <p:spPr>
+          <a:xfrm>
+            <a:off x="6355080" y="3108960"/>
+            <a:ext cx="2377440" cy="320040"/>
+          </a:xfrm>
+          <a:prstGeom prst="rect">
+            <a:avLst/>
+          </a:prstGeom>
+          <a:noFill/>
+        </p:spPr>
+        <p:txBody>
+          <a:bodyPr wrap="square" lIns="0" rIns="0" tIns="0" bIns="0">
+            <a:spAutoFit/>
+          </a:bodyPr>
+          <a:lstStyle/>
+          <a:p>
+            <a:r>
+              <a:rPr sz="1200" b="0" i="0" lang="vi-VN">
+                <a:solidFill>
+                  <a:srgbClr val="595959"/>
+                </a:solidFill>
+                <a:latin typeface="Arial"/>
+              </a:rPr>
+              <a:t>học sinh vào bằng suất dự trữ</a:t>
+            </a:r>
+          </a:p>
+        </p:txBody>
+      </p:sp>
+      <p:sp>
+        <p:nvSpPr>
+          <p:cNvPr id="11" name="TextBox 10"/>
+          <p:cNvSpPr txBox="1"/>
+          <p:nvPr/>
+        </p:nvSpPr>
+        <p:spPr>
+          <a:xfrm>
+            <a:off x="8869680" y="2651760"/>
+            <a:ext cx="2377440" cy="457200"/>
+          </a:xfrm>
+          <a:prstGeom prst="rect">
+            <a:avLst/>
+          </a:prstGeom>
+          <a:noFill/>
+        </p:spPr>
+        <p:txBody>
+          <a:bodyPr wrap="square" lIns="0" rIns="0" tIns="0" bIns="0">
+            <a:spAutoFit/>
+          </a:bodyPr>
+          <a:lstStyle/>
+          <a:p>
+            <a:r>
+              <a:rPr sz="2600" b="1" i="0" lang="vi-VN">
+                <a:solidFill>
+                  <a:srgbClr val="3F6B52"/>
+                </a:solidFill>
+                <a:latin typeface="Arial"/>
+              </a:rPr>
+              <a:t>0,02 giây</a:t>
+            </a:r>
+          </a:p>
+        </p:txBody>
+      </p:sp>
+      <p:sp>
+        <p:nvSpPr>
+          <p:cNvPr id="12" name="TextBox 11"/>
+          <p:cNvSpPr txBox="1"/>
+          <p:nvPr/>
+        </p:nvSpPr>
+        <p:spPr>
+          <a:xfrm>
+            <a:off x="8869680" y="3108960"/>
+            <a:ext cx="2377440" cy="320040"/>
+          </a:xfrm>
+          <a:prstGeom prst="rect">
+            <a:avLst/>
+          </a:prstGeom>
+          <a:noFill/>
+        </p:spPr>
+        <p:txBody>
+          <a:bodyPr wrap="square" lIns="0" rIns="0" tIns="0" bIns="0">
+            <a:spAutoFit/>
+          </a:bodyPr>
+          <a:lstStyle/>
+          <a:p>
+            <a:r>
+              <a:rPr sz="1200" b="0" i="0" lang="vi-VN">
+                <a:solidFill>
+                  <a:srgbClr val="595959"/>
+                </a:solidFill>
+                <a:latin typeface="Arial"/>
+              </a:rPr>
+              <a:t>thời gian chạy sắp xếp</a:t>
+            </a:r>
+          </a:p>
+        </p:txBody>
+      </p:sp>
+      <p:graphicFrame>
+        <p:nvGraphicFramePr>
+          <p:cNvPr id="13" name="Chart 12"/>
+          <p:cNvGraphicFramePr>
+            <a:graphicFrameLocks noGrp="1"/>
+          </p:cNvGraphicFramePr>
+          <p:nvPr/>
+        </p:nvGraphicFramePr>
+        <p:xfrm>
+          <a:off x="6355080" y="3611880"/>
+          <a:ext cx="5001768" cy="2331720"/>
+        </p:xfrm>
+        <a:graphic>
+          <a:graphicData uri="http://schemas.openxmlformats.org/drawingml/2006/chart">
+            <c:chart xmlns:c="http://schemas.openxmlformats.org/drawingml/2006/chart" r:id="rId3"/>
+          </a:graphicData>
+        </a:graphic>
+      </p:graphicFrame>
+      <p:sp>
+        <p:nvSpPr>
+          <p:cNvPr id="14" name="TextBox 13"/>
+          <p:cNvSpPr txBox="1"/>
+          <p:nvPr/>
+        </p:nvSpPr>
+        <p:spPr>
+          <a:xfrm>
+            <a:off x="841248" y="6144768"/>
+            <a:ext cx="10515600" cy="274320"/>
+          </a:xfrm>
+          <a:prstGeom prst="rect">
+            <a:avLst/>
+          </a:prstGeom>
+          <a:noFill/>
+        </p:spPr>
+        <p:txBody>
+          <a:bodyPr wrap="square" lIns="0" rIns="0" tIns="0" bIns="0">
+            <a:spAutoFit/>
+          </a:bodyPr>
+          <a:lstStyle/>
+          <a:p>
+            <a:r>
+              <a:rPr sz="1100" b="0" i="1" lang="vi-VN">
+                <a:solidFill>
+                  <a:srgbClr val="B84A3E"/>
+                </a:solidFill>
+                <a:latin typeface="Arial"/>
+              </a:rPr>
+              <a:t>Dữ liệu mô phỏng do máy tạo ra (bộ bo_sach), không phải học sinh thật. Mỗi học sinh thi 4 CLB và ghi 6 nguyện vọng.</a:t>
+            </a:r>
           </a:p>
         </p:txBody>
       </p:sp>
     </p:spTree>
     <p:extLst>
       <p:ext uri="{BB962C8B-B14F-4D97-AF65-F5344CB8AC3E}">
-        <p14:creationId xmlns:p14="http://schemas.microsoft.com/office/powerpoint/2010/main" val="3931215587"/>
+        <p14:creationId xmlns:p14="http://schemas.microsoft.com/office/powerpoint/2010/main" val="603483598"/>
       </p:ext>
     </p:extLst>
   </p:cSld>

</xml_diff>

<commit_message>
Add software screenshots to three slides of the science-fair deck
Slide 6 (two tiers) shows the blind scoring screen, slide 8 (output)
shows the results panel of placements by preference rank for the
140-student dataset, and slide 11 (flexible scheduling) shows the
session picker from the six-session dataset. Each has a one-line
caption; the text around them is unchanged apart from spacing on
slide 11. The results screenshot hides one helper sentence of the app.

Co-Authored-By: Claude Opus 5.5 <noreply@anthropic.com>
Claude-Session: https://claude.ai/code/session_01W1TN5sV8nD2mQymMCwHHSg
</commit_message>
<xml_diff>
--- a/THUYET_TRINH_KHKT_DA_SUA_FONT.pptx
+++ b/THUYET_TRINH_KHKT_DA_SUA_FONT.pptx
@@ -4696,7 +4696,12 @@
             <p:ph idx="1"/>
           </p:nvPr>
         </p:nvSpPr>
-        <p:spPr/>
+        <p:spPr>
+          <a:xfrm>
+            <a:off x="841248" y="1828800"/>
+            <a:ext cx="10515600" cy="2834640"/>
+          </a:xfrm>
+        </p:spPr>
         <p:txBody>
           <a:bodyPr/>
           <a:lstStyle/>
@@ -4706,12 +4711,12 @@
                 <a:spcPct val="110000"/>
               </a:lnSpc>
               <a:spcAft>
-                <a:spcPts val="2400"/>
+                <a:spcPts val="1200"/>
               </a:spcAft>
               <a:buNone/>
             </a:pPr>
             <a:r>
-              <a:rPr lang="vi-VN" sz="3200"/>
+              <a:rPr lang="vi-VN" sz="2800"/>
               <a:t>1. Đa dạng các cách lựa chọn buổi</a:t>
             </a:r>
             <a:endParaRPr lang="vi-VN" dirty="0"/>
@@ -4722,12 +4727,12 @@
                 <a:spcPct val="110000"/>
               </a:lnSpc>
               <a:spcAft>
-                <a:spcPts val="2400"/>
+                <a:spcPts val="1200"/>
               </a:spcAft>
               <a:buNone/>
             </a:pPr>
             <a:r>
-              <a:rPr lang="vi-VN" sz="3200"/>
+              <a:rPr lang="vi-VN" sz="2800"/>
               <a:t>2. Thêm và chỉnh sửa thông số học sinh</a:t>
             </a:r>
             <a:endParaRPr lang="vi-VN" dirty="0"/>
@@ -4738,12 +4743,12 @@
                 <a:spcPct val="110000"/>
               </a:lnSpc>
               <a:spcAft>
-                <a:spcPts val="2400"/>
+                <a:spcPts val="1200"/>
               </a:spcAft>
               <a:buNone/>
             </a:pPr>
             <a:r>
-              <a:rPr lang="vi-VN" sz="3200"/>
+              <a:rPr lang="vi-VN" sz="2800"/>
               <a:t>3. Song ngữ Anh Việt</a:t>
             </a:r>
             <a:endParaRPr lang="vi-VN" dirty="0"/>
@@ -4754,13 +4759,76 @@
                 <a:spcPct val="110000"/>
               </a:lnSpc>
               <a:spcAft>
-                <a:spcPts val="2400"/>
+                <a:spcPts val="1200"/>
               </a:spcAft>
               <a:buNone/>
             </a:pPr>
             <a:r>
-              <a:rPr lang="vi-VN" sz="3200"/>
+              <a:rPr lang="vi-VN" sz="2800"/>
               <a:t>4. Có thể ưu tiên cho các học sinh khó khăn </a:t>
+            </a:r>
+          </a:p>
+        </p:txBody>
+      </p:sp>
+      <p:pic>
+        <p:nvPicPr>
+          <p:cNvPr id="4" name="Picture 3" descr="el_buoi.png"/>
+          <p:cNvPicPr>
+            <a:picLocks noChangeAspect="1"/>
+          </p:cNvPicPr>
+          <p:nvPr/>
+        </p:nvPicPr>
+        <p:blipFill>
+          <a:blip r:embed="rId2"/>
+          <a:stretch>
+            <a:fillRect/>
+          </a:stretch>
+        </p:blipFill>
+        <p:spPr>
+          <a:xfrm>
+            <a:off x="841248" y="4800600"/>
+            <a:ext cx="8046720" cy="1076998"/>
+          </a:xfrm>
+          <a:prstGeom prst="rect">
+            <a:avLst/>
+          </a:prstGeom>
+          <a:ln w="9525">
+            <a:solidFill>
+              <a:srgbClr val="D0D0D0"/>
+            </a:solidFill>
+          </a:ln>
+        </p:spPr>
+      </p:pic>
+      <p:sp>
+        <p:nvSpPr>
+          <p:cNvPr id="5" name="TextBox 4"/>
+          <p:cNvSpPr txBox="1"/>
+          <p:nvPr/>
+        </p:nvSpPr>
+        <p:spPr>
+          <a:xfrm>
+            <a:off x="841248" y="5969038"/>
+            <a:ext cx="8046720" cy="274320"/>
+          </a:xfrm>
+          <a:prstGeom prst="rect">
+            <a:avLst/>
+          </a:prstGeom>
+          <a:noFill/>
+        </p:spPr>
+        <p:txBody>
+          <a:bodyPr wrap="square" lIns="0" rIns="0" tIns="0" bIns="0">
+            <a:spAutoFit/>
+          </a:bodyPr>
+          <a:lstStyle/>
+          <a:p>
+            <a:r>
+              <a:rPr sz="1200" i="1" lang="vi-VN">
+                <a:solidFill>
+                  <a:srgbClr val="595959"/>
+                </a:solidFill>
+                <a:latin typeface="Arial"/>
+              </a:rPr>
+              <a:t>Màn hình Vận hành: chọn các buổi cần xếp trong tuần.</a:t>
             </a:r>
           </a:p>
         </p:txBody>
@@ -7874,7 +7942,12 @@
             <p:ph idx="1"/>
           </p:nvPr>
         </p:nvSpPr>
-        <p:spPr/>
+        <p:spPr>
+          <a:xfrm>
+            <a:off x="841248" y="1828800"/>
+            <a:ext cx="4846320" cy="4352544"/>
+          </a:xfrm>
+        </p:spPr>
         <p:txBody>
           <a:bodyPr/>
           <a:lstStyle/>
@@ -7914,6 +7987,69 @@
               <a:t> HS không thi thì xếp theo số bốc thăm</a:t>
             </a:r>
             <a:endParaRPr lang="vi-VN"/>
+          </a:p>
+        </p:txBody>
+      </p:sp>
+      <p:pic>
+        <p:nvPicPr>
+          <p:cNvPr id="4" name="Picture 3" descr="el_scoring_c.png"/>
+          <p:cNvPicPr>
+            <a:picLocks noChangeAspect="1"/>
+          </p:cNvPicPr>
+          <p:nvPr/>
+        </p:nvPicPr>
+        <p:blipFill>
+          <a:blip r:embed="rId2"/>
+          <a:stretch>
+            <a:fillRect/>
+          </a:stretch>
+        </p:blipFill>
+        <p:spPr>
+          <a:xfrm>
+            <a:off x="5961888" y="1874519"/>
+            <a:ext cx="5394960" cy="3132557"/>
+          </a:xfrm>
+          <a:prstGeom prst="rect">
+            <a:avLst/>
+          </a:prstGeom>
+          <a:ln w="9525">
+            <a:solidFill>
+              <a:srgbClr val="D0D0D0"/>
+            </a:solidFill>
+          </a:ln>
+        </p:spPr>
+      </p:pic>
+      <p:sp>
+        <p:nvSpPr>
+          <p:cNvPr id="5" name="TextBox 4"/>
+          <p:cNvSpPr txBox="1"/>
+          <p:nvPr/>
+        </p:nvSpPr>
+        <p:spPr>
+          <a:xfrm>
+            <a:off x="5961888" y="5098517"/>
+            <a:ext cx="5394960" cy="274320"/>
+          </a:xfrm>
+          <a:prstGeom prst="rect">
+            <a:avLst/>
+          </a:prstGeom>
+          <a:noFill/>
+        </p:spPr>
+        <p:txBody>
+          <a:bodyPr wrap="square" lIns="0" rIns="0" tIns="0" bIns="0">
+            <a:spAutoFit/>
+          </a:bodyPr>
+          <a:lstStyle/>
+          <a:p>
+            <a:r>
+              <a:rPr sz="1200" i="1" lang="vi-VN">
+                <a:solidFill>
+                  <a:srgbClr val="595959"/>
+                </a:solidFill>
+                <a:latin typeface="Arial"/>
+              </a:rPr>
+              <a:t>Màn hình Nhập điểm: giáo viên chỉ thấy mã và họ tên học sinh.</a:t>
+            </a:r>
           </a:p>
         </p:txBody>
       </p:sp>
@@ -8569,7 +8705,12 @@
             <p:ph idx="1"/>
           </p:nvPr>
         </p:nvSpPr>
-        <p:spPr/>
+        <p:spPr>
+          <a:xfrm>
+            <a:off x="841248" y="1828800"/>
+            <a:ext cx="10515600" cy="2423160"/>
+          </a:xfrm>
+        </p:spPr>
         <p:txBody>
           <a:bodyPr/>
           <a:lstStyle/>
@@ -8614,6 +8755,69 @@
             <a:r>
               <a:rPr lang="vi-VN" sz="3200"/>
               <a:t>Số học sinh cụ thể chưa có chỗ</a:t>
+            </a:r>
+          </a:p>
+        </p:txBody>
+      </p:sp>
+      <p:pic>
+        <p:nvPicPr>
+          <p:cNvPr id="4" name="Picture 3" descr="el_nv.png"/>
+          <p:cNvPicPr>
+            <a:picLocks noChangeAspect="1"/>
+          </p:cNvPicPr>
+          <p:nvPr/>
+        </p:nvPicPr>
+        <p:blipFill>
+          <a:blip r:embed="rId2"/>
+          <a:stretch>
+            <a:fillRect/>
+          </a:stretch>
+        </p:blipFill>
+        <p:spPr>
+          <a:xfrm>
+            <a:off x="841248" y="4572000"/>
+            <a:ext cx="5486400" cy="1732547"/>
+          </a:xfrm>
+          <a:prstGeom prst="rect">
+            <a:avLst/>
+          </a:prstGeom>
+          <a:ln w="9525">
+            <a:solidFill>
+              <a:srgbClr val="D0D0D0"/>
+            </a:solidFill>
+          </a:ln>
+        </p:spPr>
+      </p:pic>
+      <p:sp>
+        <p:nvSpPr>
+          <p:cNvPr id="5" name="TextBox 4"/>
+          <p:cNvSpPr txBox="1"/>
+          <p:nvPr/>
+        </p:nvSpPr>
+        <p:spPr>
+          <a:xfrm>
+            <a:off x="841248" y="6377699"/>
+            <a:ext cx="5486400" cy="274320"/>
+          </a:xfrm>
+          <a:prstGeom prst="rect">
+            <a:avLst/>
+          </a:prstGeom>
+          <a:noFill/>
+        </p:spPr>
+        <p:txBody>
+          <a:bodyPr wrap="square" lIns="0" rIns="0" tIns="0" bIns="0">
+            <a:spAutoFit/>
+          </a:bodyPr>
+          <a:lstStyle/>
+          <a:p>
+            <a:r>
+              <a:rPr sz="1200" i="1" lang="vi-VN">
+                <a:solidFill>
+                  <a:srgbClr val="595959"/>
+                </a:solidFill>
+                <a:latin typeface="Arial"/>
+              </a:rPr>
+              <a:t>Màn hình Kết quả, bộ 140 học sinh (dữ liệu mô phỏng).</a:t>
             </a:r>
           </a:p>
         </p:txBody>

</xml_diff>

<commit_message>
Mention reserved places on slide 7 of the science-fair deck
Starts from the student's latest upload, which adds a future-directions
slide and a closing slide. On slide 7 the step-4 explanation gains one
line on reserved places: a club can set aside seats for a priority
group, and unused reserved seats return to the general pool. The
example caption and table move down to make room; speaker notes explain
the two-pass check. No other slide is changed.

Co-Authored-By: Claude Opus 5.5 <noreply@anthropic.com>
Claude-Session: https://claude.ai/code/session_01W1TN5sV8nD2mQymMCwHHSg
</commit_message>
<xml_diff>
--- a/THUYET_TRINH_KHKT_DA_SUA_FONT.pptx
+++ b/THUYET_TRINH_KHKT_DA_SUA_FONT.pptx
@@ -4,6 +4,9 @@
   <p:sldMasterIdLst>
     <p:sldMasterId id="2147483648" r:id="rId1"/>
   </p:sldMasterIdLst>
+  <p:notesMasterIdLst>
+    <p:notesMasterId r:id="rId15"/>
+  </p:notesMasterIdLst>
   <p:sldIdLst>
     <p:sldId id="256" r:id="rId2"/>
     <p:sldId id="257" r:id="rId3"/>
@@ -11,11 +14,13 @@
     <p:sldId id="259" r:id="rId5"/>
     <p:sldId id="261" r:id="rId6"/>
     <p:sldId id="260" r:id="rId7"/>
-    <p:sldId id="266" r:id="rId17"/>
-    <p:sldId id="262" r:id="rId8"/>
-    <p:sldId id="263" r:id="rId9"/>
-    <p:sldId id="264" r:id="rId10"/>
-    <p:sldId id="265" r:id="rId11"/>
+    <p:sldId id="266" r:id="rId8"/>
+    <p:sldId id="262" r:id="rId9"/>
+    <p:sldId id="263" r:id="rId10"/>
+    <p:sldId id="264" r:id="rId11"/>
+    <p:sldId id="265" r:id="rId12"/>
+    <p:sldId id="267" r:id="rId13"/>
+    <p:sldId id="268" r:id="rId14"/>
   </p:sldIdLst>
   <p:sldSz cx="12192000" cy="6858000"/>
   <p:notesSz cx="6858000" cy="9144000"/>
@@ -114,12 +119,20 @@
       </a:defRPr>
     </a:lvl9pPr>
   </p:defaultTextStyle>
+  <p:extLst>
+    <p:ext uri="{EFAFB233-063F-42B5-8137-9DF3F51BA10A}">
+      <p15:sldGuideLst xmlns:p15="http://schemas.microsoft.com/office/powerpoint/2012/main"/>
+    </p:ext>
+  </p:extLst>
 </p:presentation>
 </file>
 
 <file path=ppt/charts/chart1.xml><?xml version="1.0" encoding="utf-8"?>
-<c:chartSpace xmlns:c="http://schemas.openxmlformats.org/drawingml/2006/chart" xmlns:a="http://schemas.openxmlformats.org/drawingml/2006/main" xmlns:r="http://schemas.openxmlformats.org/officeDocument/2006/relationships">
+<c:chartSpace xmlns:c="http://schemas.openxmlformats.org/drawingml/2006/chart" xmlns:a="http://schemas.openxmlformats.org/drawingml/2006/main" xmlns:r="http://schemas.openxmlformats.org/officeDocument/2006/relationships" xmlns:c16r2="http://schemas.microsoft.com/office/drawing/2015/06/chart">
   <c:date1904 val="0"/>
+  <c:lang val="en-US"/>
+  <c:roundedCorners val="1"/>
+  <c:style val="2"/>
   <c:chart>
     <c:title>
       <c:tx>
@@ -128,7 +141,7 @@
           <a:lstStyle/>
           <a:p>
             <a:r>
-              <a:rPr sz="1200" b="1">
+              <a:rPr lang="vi-VN" sz="1200" b="1">
                 <a:solidFill>
                   <a:srgbClr val="1F1F1F"/>
                 </a:solidFill>
@@ -139,14 +152,15 @@
           </a:p>
         </c:rich>
       </c:tx>
-      <c:layout/>
       <c:overlay val="0"/>
     </c:title>
     <c:autoTitleDeleted val="0"/>
     <c:plotArea>
+      <c:layout/>
       <c:barChart>
         <c:barDir val="col"/>
         <c:grouping val="clustered"/>
+        <c:varyColors val="1"/>
         <c:ser>
           <c:idx val="0"/>
           <c:order val="0"/>
@@ -166,6 +180,42 @@
               <a:srgbClr val="3F6B52"/>
             </a:solidFill>
           </c:spPr>
+          <c:invertIfNegative val="1"/>
+          <c:dLbls>
+            <c:numFmt formatCode="0" sourceLinked="0"/>
+            <c:spPr>
+              <a:noFill/>
+              <a:ln>
+                <a:noFill/>
+              </a:ln>
+              <a:effectLst/>
+            </c:spPr>
+            <c:txPr>
+              <a:bodyPr/>
+              <a:lstStyle/>
+              <a:p>
+                <a:pPr>
+                  <a:defRPr sz="1100">
+                    <a:latin typeface="Arial"/>
+                  </a:defRPr>
+                </a:pPr>
+                <a:endParaRPr lang="en-US"/>
+              </a:p>
+            </c:txPr>
+            <c:dLblPos val="outEnd"/>
+            <c:showLegendKey val="0"/>
+            <c:showVal val="1"/>
+            <c:showCatName val="0"/>
+            <c:showSerName val="0"/>
+            <c:showPercent val="0"/>
+            <c:showBubbleSize val="0"/>
+            <c:showLeaderLines val="0"/>
+            <c:extLst>
+              <c:ext xmlns:c15="http://schemas.microsoft.com/office/drawing/2012/chart" uri="{CE6537A1-D6FC-4f65-9D91-7224C49458BB}">
+                <c15:showLeaderLines val="0"/>
+              </c:ext>
+            </c:extLst>
+          </c:dLbls>
           <c:cat>
             <c:strRef>
               <c:f>Sheet1!$A$2:$A$7</c:f>
@@ -219,20 +269,22 @@
               </c:numCache>
             </c:numRef>
           </c:val>
+          <c:extLst>
+            <c:ext xmlns:c14="http://schemas.microsoft.com/office/drawing/2007/8/2/chart" uri="{6F2FDCE9-48DA-4B69-8628-5D25D57E5C99}">
+              <c14:invertSolidFillFmt>
+                <c14:spPr xmlns:c14="http://schemas.microsoft.com/office/drawing/2007/8/2/chart">
+                  <a:solidFill>
+                    <a:srgbClr val="FFFFFF"/>
+                  </a:solidFill>
+                </c14:spPr>
+              </c14:invertSolidFillFmt>
+            </c:ext>
+            <c:ext xmlns:c16="http://schemas.microsoft.com/office/drawing/2014/chart" uri="{C3380CC4-5D6E-409C-BE32-E72D297353CC}">
+              <c16:uniqueId val="{00000000-B6AD-4CAA-8EDC-E7414E52B2AA}"/>
+            </c:ext>
+          </c:extLst>
         </c:ser>
         <c:dLbls>
-          <c:numFmt formatCode="0" sourceLinked="0"/>
-          <c:txPr>
-            <a:bodyPr/>
-            <a:lstStyle/>
-            <a:p>
-              <a:pPr>
-                <a:defRPr sz="1100">
-                  <a:latin typeface="Arial"/>
-                </a:defRPr>
-              </a:pPr>
-            </a:p>
-          </c:txPr>
           <c:dLblPos val="outEnd"/>
           <c:showLegendKey val="0"/>
           <c:showVal val="1"/>
@@ -240,7 +292,6 @@
           <c:showSerName val="0"/>
           <c:showPercent val="0"/>
           <c:showBubbleSize val="0"/>
-          <c:showLeaderLines val="1"/>
         </c:dLbls>
         <c:gapWidth val="60"/>
         <c:axId val="-2068027336"/>
@@ -253,6 +304,7 @@
         </c:scaling>
         <c:delete val="0"/>
         <c:axPos val="b"/>
+        <c:numFmt formatCode="General" sourceLinked="0"/>
         <c:majorTickMark val="out"/>
         <c:minorTickMark val="none"/>
         <c:tickLblPos val="nextTo"/>
@@ -267,6 +319,7 @@
                 </a:solidFill>
               </a:defRPr>
             </a:pPr>
+            <a:endParaRPr lang="en-US"/>
           </a:p>
         </c:txPr>
         <c:crossAx val="-2113994440"/>
@@ -278,7 +331,9 @@
       </c:catAx>
       <c:valAx>
         <c:axId val="-2113994440"/>
-        <c:scaling/>
+        <c:scaling>
+          <c:orientation val="minMax"/>
+        </c:scaling>
         <c:delete val="0"/>
         <c:axPos val="l"/>
         <c:majorGridlines>
@@ -290,6 +345,7 @@
             </a:ln>
           </c:spPr>
         </c:majorGridlines>
+        <c:numFmt formatCode="General" sourceLinked="1"/>
         <c:majorTickMark val="out"/>
         <c:minorTickMark val="none"/>
         <c:tickLblPos val="nextTo"/>
@@ -309,13 +365,17 @@
                 </a:solidFill>
               </a:defRPr>
             </a:pPr>
+            <a:endParaRPr lang="en-US"/>
           </a:p>
         </c:txPr>
         <c:crossAx val="-2068027336"/>
         <c:crosses val="autoZero"/>
+        <c:crossBetween val="between"/>
       </c:valAx>
     </c:plotArea>
+    <c:plotVisOnly val="1"/>
     <c:dispBlanksAs val="gap"/>
+    <c:showDLblsOverMax val="1"/>
   </c:chart>
   <c:txPr>
     <a:bodyPr/>
@@ -334,7 +394,7 @@
 </file>
 
 <file path=ppt/notesMasters/notesMaster1.xml><?xml version="1.0" encoding="utf-8"?>
-<p:notesMaster xmlns:a="http://schemas.openxmlformats.org/drawingml/2006/main" xmlns:p="http://schemas.openxmlformats.org/presentationml/2006/main" xmlns:r="http://schemas.openxmlformats.org/officeDocument/2006/relationships">
+<p:notesMaster xmlns:a="http://schemas.openxmlformats.org/drawingml/2006/main" xmlns:r="http://schemas.openxmlformats.org/officeDocument/2006/relationships" xmlns:p="http://schemas.openxmlformats.org/presentationml/2006/main">
   <p:cSld>
     <p:bg>
       <p:bgRef idx="1001">
@@ -368,7 +428,7 @@
         <p:spPr>
           <a:xfrm>
             <a:off x="0" y="0"/>
-            <a:ext cx="2971800" cy="457200"/>
+            <a:ext cx="2971800" cy="458788"/>
           </a:xfrm>
           <a:prstGeom prst="rect">
             <a:avLst/>
@@ -399,7 +459,7 @@
         <p:spPr>
           <a:xfrm>
             <a:off x="3884613" y="0"/>
-            <a:ext cx="2971800" cy="457200"/>
+            <a:ext cx="2971800" cy="458788"/>
           </a:xfrm>
           <a:prstGeom prst="rect">
             <a:avLst/>
@@ -413,9 +473,9 @@
             </a:lvl1pPr>
           </a:lstStyle>
           <a:p>
-            <a:fld id="{0F89C1C7-3DCD-1040-A9CF-14679D8B5DDD}" type="datetimeFigureOut">
+            <a:fld id="{5E031DF7-A598-4BE1-8BBD-413E1E50381D}" type="datetimeFigureOut">
               <a:rPr lang="en-US" smtClean="0"/>
-              <a:t>10/17/16</a:t>
+              <a:t>9/25/2026</a:t>
             </a:fld>
             <a:endParaRPr lang="en-US"/>
           </a:p>
@@ -433,8 +493,8 @@
         </p:nvSpPr>
         <p:spPr>
           <a:xfrm>
-            <a:off x="1143000" y="685800"/>
-            <a:ext cx="4572000" cy="3429000"/>
+            <a:off x="685800" y="1143000"/>
+            <a:ext cx="5486400" cy="3086100"/>
           </a:xfrm>
           <a:prstGeom prst="rect">
             <a:avLst/>
@@ -466,8 +526,8 @@
         </p:nvSpPr>
         <p:spPr>
           <a:xfrm>
-            <a:off x="685800" y="4343400"/>
-            <a:ext cx="5486400" cy="4114800"/>
+            <a:off x="685800" y="4400550"/>
+            <a:ext cx="5486400" cy="3600450"/>
           </a:xfrm>
           <a:prstGeom prst="rect">
             <a:avLst/>
@@ -479,38 +539,37 @@
           <a:p>
             <a:pPr lvl="0"/>
             <a:r>
-              <a:rPr lang="en-US" smtClean="0"/>
+              <a:rPr lang="en-US"/>
               <a:t>Click to edit Master text styles</a:t>
             </a:r>
           </a:p>
           <a:p>
             <a:pPr lvl="1"/>
             <a:r>
-              <a:rPr lang="en-US" smtClean="0"/>
+              <a:rPr lang="en-US"/>
               <a:t>Second level</a:t>
             </a:r>
           </a:p>
           <a:p>
             <a:pPr lvl="2"/>
             <a:r>
-              <a:rPr lang="en-US" smtClean="0"/>
+              <a:rPr lang="en-US"/>
               <a:t>Third level</a:t>
             </a:r>
           </a:p>
           <a:p>
             <a:pPr lvl="3"/>
             <a:r>
-              <a:rPr lang="en-US" smtClean="0"/>
+              <a:rPr lang="en-US"/>
               <a:t>Fourth level</a:t>
             </a:r>
           </a:p>
           <a:p>
             <a:pPr lvl="4"/>
             <a:r>
-              <a:rPr lang="en-US" smtClean="0"/>
+              <a:rPr lang="en-US"/>
               <a:t>Fifth level</a:t>
             </a:r>
-            <a:endParaRPr lang="en-US"/>
           </a:p>
         </p:txBody>
       </p:sp>
@@ -527,7 +586,7 @@
         <p:spPr>
           <a:xfrm>
             <a:off x="0" y="8685213"/>
-            <a:ext cx="2971800" cy="457200"/>
+            <a:ext cx="2971800" cy="458787"/>
           </a:xfrm>
           <a:prstGeom prst="rect">
             <a:avLst/>
@@ -558,7 +617,7 @@
         <p:spPr>
           <a:xfrm>
             <a:off x="3884613" y="8685213"/>
-            <a:ext cx="2971800" cy="457200"/>
+            <a:ext cx="2971800" cy="458787"/>
           </a:xfrm>
           <a:prstGeom prst="rect">
             <a:avLst/>
@@ -572,7 +631,7 @@
             </a:lvl1pPr>
           </a:lstStyle>
           <a:p>
-            <a:fld id="{BB5E49A5-4136-284D-997B-48E1D791AD67}" type="slidenum">
+            <a:fld id="{277EF391-9EC8-46DA-9374-EF11EAFE716E}" type="slidenum">
               <a:rPr lang="en-US" smtClean="0"/>
               <a:t>‹#›</a:t>
             </a:fld>
@@ -583,13 +642,13 @@
     </p:spTree>
     <p:extLst>
       <p:ext uri="{BB962C8B-B14F-4D97-AF65-F5344CB8AC3E}">
-        <p14:creationId xmlns:p14="http://schemas.microsoft.com/office/powerpoint/2010/main" val="2623252185"/>
+        <p14:creationId xmlns:p14="http://schemas.microsoft.com/office/powerpoint/2010/main" val="2916366802"/>
       </p:ext>
     </p:extLst>
   </p:cSld>
   <p:clrMap bg1="lt1" tx1="dk1" bg2="lt2" tx2="dk2" accent1="accent1" accent2="accent2" accent3="accent3" accent4="accent4" accent5="accent5" accent6="accent6" hlink="hlink" folHlink="folHlink"/>
   <p:notesStyle>
-    <a:lvl1pPr marL="0" algn="l" defTabSz="457200" rtl="0" eaLnBrk="1" latinLnBrk="0" hangingPunct="1">
+    <a:lvl1pPr marL="0" algn="l" defTabSz="914400" rtl="0" eaLnBrk="1" latinLnBrk="0" hangingPunct="1">
       <a:defRPr sz="1200" kern="1200">
         <a:solidFill>
           <a:schemeClr val="tx1"/>
@@ -599,7 +658,7 @@
         <a:cs typeface="+mn-cs"/>
       </a:defRPr>
     </a:lvl1pPr>
-    <a:lvl2pPr marL="457200" algn="l" defTabSz="457200" rtl="0" eaLnBrk="1" latinLnBrk="0" hangingPunct="1">
+    <a:lvl2pPr marL="457200" algn="l" defTabSz="914400" rtl="0" eaLnBrk="1" latinLnBrk="0" hangingPunct="1">
       <a:defRPr sz="1200" kern="1200">
         <a:solidFill>
           <a:schemeClr val="tx1"/>
@@ -609,7 +668,7 @@
         <a:cs typeface="+mn-cs"/>
       </a:defRPr>
     </a:lvl2pPr>
-    <a:lvl3pPr marL="914400" algn="l" defTabSz="457200" rtl="0" eaLnBrk="1" latinLnBrk="0" hangingPunct="1">
+    <a:lvl3pPr marL="914400" algn="l" defTabSz="914400" rtl="0" eaLnBrk="1" latinLnBrk="0" hangingPunct="1">
       <a:defRPr sz="1200" kern="1200">
         <a:solidFill>
           <a:schemeClr val="tx1"/>
@@ -619,7 +678,7 @@
         <a:cs typeface="+mn-cs"/>
       </a:defRPr>
     </a:lvl3pPr>
-    <a:lvl4pPr marL="1371600" algn="l" defTabSz="457200" rtl="0" eaLnBrk="1" latinLnBrk="0" hangingPunct="1">
+    <a:lvl4pPr marL="1371600" algn="l" defTabSz="914400" rtl="0" eaLnBrk="1" latinLnBrk="0" hangingPunct="1">
       <a:defRPr sz="1200" kern="1200">
         <a:solidFill>
           <a:schemeClr val="tx1"/>
@@ -629,7 +688,7 @@
         <a:cs typeface="+mn-cs"/>
       </a:defRPr>
     </a:lvl4pPr>
-    <a:lvl5pPr marL="1828800" algn="l" defTabSz="457200" rtl="0" eaLnBrk="1" latinLnBrk="0" hangingPunct="1">
+    <a:lvl5pPr marL="1828800" algn="l" defTabSz="914400" rtl="0" eaLnBrk="1" latinLnBrk="0" hangingPunct="1">
       <a:defRPr sz="1200" kern="1200">
         <a:solidFill>
           <a:schemeClr val="tx1"/>
@@ -639,7 +698,7 @@
         <a:cs typeface="+mn-cs"/>
       </a:defRPr>
     </a:lvl5pPr>
-    <a:lvl6pPr marL="2286000" algn="l" defTabSz="457200" rtl="0" eaLnBrk="1" latinLnBrk="0" hangingPunct="1">
+    <a:lvl6pPr marL="2286000" algn="l" defTabSz="914400" rtl="0" eaLnBrk="1" latinLnBrk="0" hangingPunct="1">
       <a:defRPr sz="1200" kern="1200">
         <a:solidFill>
           <a:schemeClr val="tx1"/>
@@ -649,7 +708,7 @@
         <a:cs typeface="+mn-cs"/>
       </a:defRPr>
     </a:lvl6pPr>
-    <a:lvl7pPr marL="2743200" algn="l" defTabSz="457200" rtl="0" eaLnBrk="1" latinLnBrk="0" hangingPunct="1">
+    <a:lvl7pPr marL="2743200" algn="l" defTabSz="914400" rtl="0" eaLnBrk="1" latinLnBrk="0" hangingPunct="1">
       <a:defRPr sz="1200" kern="1200">
         <a:solidFill>
           <a:schemeClr val="tx1"/>
@@ -659,7 +718,7 @@
         <a:cs typeface="+mn-cs"/>
       </a:defRPr>
     </a:lvl7pPr>
-    <a:lvl8pPr marL="3200400" algn="l" defTabSz="457200" rtl="0" eaLnBrk="1" latinLnBrk="0" hangingPunct="1">
+    <a:lvl8pPr marL="3200400" algn="l" defTabSz="914400" rtl="0" eaLnBrk="1" latinLnBrk="0" hangingPunct="1">
       <a:defRPr sz="1200" kern="1200">
         <a:solidFill>
           <a:schemeClr val="tx1"/>
@@ -669,7 +728,7 @@
         <a:cs typeface="+mn-cs"/>
       </a:defRPr>
     </a:lvl8pPr>
-    <a:lvl9pPr marL="3657600" algn="l" defTabSz="457200" rtl="0" eaLnBrk="1" latinLnBrk="0" hangingPunct="1">
+    <a:lvl9pPr marL="3657600" algn="l" defTabSz="914400" rtl="0" eaLnBrk="1" latinLnBrk="0" hangingPunct="1">
       <a:defRPr sz="1200" kern="1200">
         <a:solidFill>
           <a:schemeClr val="tx1"/>
@@ -684,7 +743,7 @@
 </file>
 
 <file path=ppt/notesSlides/notesSlide1.xml><?xml version="1.0" encoding="utf-8"?>
-<p:notes xmlns:a="http://schemas.openxmlformats.org/drawingml/2006/main" xmlns:p="http://schemas.openxmlformats.org/presentationml/2006/main" xmlns:r="http://schemas.openxmlformats.org/officeDocument/2006/relationships">
+<p:notes xmlns:a="http://schemas.openxmlformats.org/drawingml/2006/main" xmlns:r="http://schemas.openxmlformats.org/officeDocument/2006/relationships" xmlns:p="http://schemas.openxmlformats.org/presentationml/2006/main">
   <p:cSld>
     <p:spTree>
       <p:nvGrpSpPr>
@@ -704,7 +763,7 @@
         <p:nvSpPr>
           <p:cNvPr id="2" name="Slide Image Placeholder 1"/>
           <p:cNvSpPr>
-            <a:spLocks noGrp="1"/>
+            <a:spLocks noGrp="1" noRot="1" noChangeAspect="1"/>
           </p:cNvSpPr>
           <p:nvPr>
             <p:ph type="sldImg" idx="2"/>
@@ -719,7 +778,7 @@
             <a:spLocks noGrp="1"/>
           </p:cNvSpPr>
           <p:nvPr>
-            <p:ph type="body" idx="3" sz="quarter"/>
+            <p:ph type="body" sz="quarter" idx="3"/>
           </p:nvPr>
         </p:nvSpPr>
         <p:spPr/>
@@ -728,7 +787,7 @@
           <a:lstStyle/>
           <a:p>
             <a:r>
-              <a:t>Số liệu lấy từ phần mềm, chạy bộ du_lieu_test/bo_sach với hạt giống bốc thăm 42: 140 học sinh, 12 CLB, 150 chỗ, trong đó 16 suất dự trữ. Cả 140 học sinh đều có CLB; 9 trên 12 CLB kín chỗ, còn 10 chỗ trống. 54 học sinh (39%) được nguyện vọng 1. Tỉ lệ nguyện vọng 1 không cao vì bộ này cố ý cho mọi học sinh thi 4 CLB và ghi 6 nguyện vọng, nên nguyện vọng đầu cạnh tranh gắt. Đây là dữ liệu mô phỏng.</a:t>
+              <a:t>Bên trái là 6 bước phần mềm tự làm sau khi bấm Chạy sắp xếp. Bên phải giải thích bước 4. Nhấn mạnh chữ giữ tạm: ở vòng 2, Dũng đến sau nhưng điểm cao hơn nên vẫn vào được, Chi bị đẩy ra và nộp tiếp nguyện vọng 2. Bình không thi nên ở Tầng 2, luôn đứng sau các học sinh đã thi. CLB không biết học sinh xếp mình ở nguyện vọng mấy. Nếu bước 4 phát hiện kết quả không ổn định, phần mềm hủy toàn bộ lần chạy. Suất dự trữ: nhà trường có thể dành một số chỗ ở mỗi CLB cho một nhóm, ví dụ học sinh diện chính sách hoặc khối 10. CLB xét nhóm này trước, lấy tối đa bằng số suất dự trữ; sau đó xét chung toàn bộ phần còn lại. Suất dự trữ là mềm: không đủ học sinh thuộc nhóm thì chỗ thừa tự trả lại cho xét chung, CLB không bị trống chỗ.</a:t>
             </a:r>
           </a:p>
         </p:txBody>
@@ -740,7 +799,7 @@
             <a:spLocks noGrp="1"/>
           </p:cNvSpPr>
           <p:nvPr>
-            <p:ph type="sldNum" idx="5" sz="quarter"/>
+            <p:ph type="sldNum" sz="quarter" idx="5"/>
           </p:nvPr>
         </p:nvSpPr>
         <p:spPr/>
@@ -754,7 +813,7 @@
 </file>
 
 <file path=ppt/notesSlides/notesSlide2.xml><?xml version="1.0" encoding="utf-8"?>
-<p:notes xmlns:a="http://schemas.openxmlformats.org/drawingml/2006/main" xmlns:p="http://schemas.openxmlformats.org/presentationml/2006/main" xmlns:r="http://schemas.openxmlformats.org/officeDocument/2006/relationships">
+<p:notes xmlns:a="http://schemas.openxmlformats.org/drawingml/2006/main" xmlns:r="http://schemas.openxmlformats.org/officeDocument/2006/relationships" xmlns:p="http://schemas.openxmlformats.org/presentationml/2006/main">
   <p:cSld>
     <p:spTree>
       <p:nvGrpSpPr>
@@ -774,7 +833,7 @@
         <p:nvSpPr>
           <p:cNvPr id="2" name="Slide Image Placeholder 1"/>
           <p:cNvSpPr>
-            <a:spLocks noGrp="1"/>
+            <a:spLocks noGrp="1" noRot="1" noChangeAspect="1"/>
           </p:cNvSpPr>
           <p:nvPr>
             <p:ph type="sldImg" idx="2"/>
@@ -789,7 +848,7 @@
             <a:spLocks noGrp="1"/>
           </p:cNvSpPr>
           <p:nvPr>
-            <p:ph type="body" idx="3" sz="quarter"/>
+            <p:ph type="body" sz="quarter" idx="3"/>
           </p:nvPr>
         </p:nvSpPr>
         <p:spPr/>
@@ -798,7 +857,7 @@
           <a:lstStyle/>
           <a:p>
             <a:r>
-              <a:t>Bên trái là 6 bước phần mềm tự làm sau khi bấm Chạy sắp xếp. Bên phải giải thích bước 4. Nhấn mạnh chữ giữ tạm: ở vòng 2, Dũng đến sau nhưng điểm cao hơn nên vẫn vào được, Chi bị đẩy ra và nộp tiếp nguyện vọng 2. Bình không thi nên ở Tầng 2, luôn đứng sau các học sinh đã thi. CLB không biết học sinh xếp mình ở nguyện vọng mấy. Nếu bước 4 phát hiện kết quả không ổn định, phần mềm hủy toàn bộ lần chạy.</a:t>
+              <a:t>Số liệu lấy từ phần mềm, chạy bộ du_lieu_test/bo_sach với hạt giống bốc thăm 42: 140 học sinh, 12 CLB, 150 chỗ, trong đó 16 suất dự trữ. Cả 140 học sinh đều có CLB; 9 trên 12 CLB kín chỗ, còn 10 chỗ trống. 54 học sinh (39%) được nguyện vọng 1. Tỉ lệ nguyện vọng 1 không cao vì bộ này cố ý cho mọi học sinh thi 4 CLB và ghi 6 nguyện vọng, nên nguyện vọng đầu cạnh tranh gắt. Đây là dữ liệu mô phỏng.</a:t>
             </a:r>
           </a:p>
         </p:txBody>
@@ -810,7 +869,7 @@
             <a:spLocks noGrp="1"/>
           </p:cNvSpPr>
           <p:nvPr>
-            <p:ph type="sldNum" idx="5" sz="quarter"/>
+            <p:ph type="sldNum" sz="quarter" idx="5"/>
           </p:nvPr>
         </p:nvSpPr>
         <p:spPr/>
@@ -946,7 +1005,7 @@
             <a:fld id="{7AA33932-D5B9-4B57-9B2F-FE62C4F2C626}" type="datetime1">
               <a:rPr lang="vi-VN"/>
               <a:pPr lvl="0"/>
-              <a:t>9/25/2026</a:t>
+              <a:t>25/09/2026</a:t>
             </a:fld>
             <a:endParaRPr lang="vi-VN"/>
           </a:p>
@@ -1181,7 +1240,7 @@
             <a:fld id="{78B4C40A-811F-4F22-A37C-05332F897169}" type="datetime1">
               <a:rPr lang="vi-VN"/>
               <a:pPr lvl="0"/>
-              <a:t>9/25/2026</a:t>
+              <a:t>25/09/2026</a:t>
             </a:fld>
             <a:endParaRPr lang="vi-VN"/>
           </a:p>
@@ -1425,7 +1484,7 @@
             <a:fld id="{736D23F0-1C05-473C-AD3E-8D134A4420F7}" type="datetime1">
               <a:rPr lang="vi-VN"/>
               <a:pPr lvl="0"/>
-              <a:t>9/25/2026</a:t>
+              <a:t>25/09/2026</a:t>
             </a:fld>
             <a:endParaRPr lang="vi-VN"/>
           </a:p>
@@ -1659,7 +1718,7 @@
             <a:fld id="{BC7BCD62-19D0-4E77-943B-FA0DC0EBA3BF}" type="datetime1">
               <a:rPr lang="vi-VN"/>
               <a:pPr lvl="0"/>
-              <a:t>9/25/2026</a:t>
+              <a:t>25/09/2026</a:t>
             </a:fld>
             <a:endParaRPr lang="vi-VN"/>
           </a:p>
@@ -1869,7 +1928,7 @@
             <a:fld id="{22F8731B-6AE6-4397-96E4-4309FE7F3D37}" type="datetime1">
               <a:rPr lang="vi-VN"/>
               <a:pPr lvl="0"/>
-              <a:t>9/25/2026</a:t>
+              <a:t>25/09/2026</a:t>
             </a:fld>
             <a:endParaRPr lang="vi-VN"/>
           </a:p>
@@ -2186,7 +2245,7 @@
             <a:fld id="{DF937529-2119-4D4A-A075-9F8CB5AADCC7}" type="datetime1">
               <a:rPr lang="vi-VN"/>
               <a:pPr lvl="0"/>
-              <a:t>9/25/2026</a:t>
+              <a:t>25/09/2026</a:t>
             </a:fld>
             <a:endParaRPr lang="vi-VN"/>
           </a:p>
@@ -2586,7 +2645,7 @@
             <a:fld id="{C03B2482-B273-4E34-AC74-7799B9C714FF}" type="datetime1">
               <a:rPr lang="vi-VN"/>
               <a:pPr lvl="0"/>
-              <a:t>9/25/2026</a:t>
+              <a:t>25/09/2026</a:t>
             </a:fld>
             <a:endParaRPr lang="vi-VN"/>
           </a:p>
@@ -2747,7 +2806,7 @@
             <a:fld id="{474D79C0-10C1-4697-AA7B-3901AB52AB50}" type="datetime1">
               <a:rPr lang="vi-VN"/>
               <a:pPr lvl="0"/>
-              <a:t>9/25/2026</a:t>
+              <a:t>25/09/2026</a:t>
             </a:fld>
             <a:endParaRPr lang="vi-VN"/>
           </a:p>
@@ -2875,7 +2934,7 @@
             <a:fld id="{BDC194AB-0501-47B8-819C-171406D01325}" type="datetime1">
               <a:rPr lang="vi-VN"/>
               <a:pPr lvl="0"/>
-              <a:t>9/25/2026</a:t>
+              <a:t>25/09/2026</a:t>
             </a:fld>
             <a:endParaRPr lang="vi-VN"/>
           </a:p>
@@ -3158,7 +3217,7 @@
             <a:fld id="{D74B0DAC-5760-4BA2-849E-1CE31FC71832}" type="datetime1">
               <a:rPr lang="vi-VN"/>
               <a:pPr lvl="0"/>
-              <a:t>9/25/2026</a:t>
+              <a:t>25/09/2026</a:t>
             </a:fld>
             <a:endParaRPr lang="vi-VN"/>
           </a:p>
@@ -3399,7 +3458,7 @@
             <a:fld id="{F6D8F105-1F3A-4B1F-A93B-D14C0903D25D}" type="datetime1">
               <a:rPr lang="vi-VN"/>
               <a:pPr lvl="0"/>
-              <a:t>9/25/2026</a:t>
+              <a:t>25/09/2026</a:t>
             </a:fld>
             <a:endParaRPr lang="vi-VN"/>
           </a:p>
@@ -3680,7 +3739,7 @@
             <a:fld id="{C8339D3A-A655-4913-B670-677049566522}" type="datetime1">
               <a:rPr lang="vi-VN"/>
               <a:pPr lvl="0"/>
-              <a:t>9/25/2026</a:t>
+              <a:t>25/09/2026</a:t>
             </a:fld>
             <a:endParaRPr lang="vi-VN"/>
           </a:p>
@@ -4287,7 +4346,9 @@
           </a:xfrm>
         </p:spPr>
         <p:txBody>
-          <a:bodyPr/>
+          <a:bodyPr>
+            <a:normAutofit lnSpcReduction="10000"/>
+          </a:bodyPr>
           <a:lstStyle/>
           <a:p>
             <a:pPr lvl="0"/>
@@ -4570,7 +4631,7 @@
               </a:spcAft>
             </a:pPr>
             <a:r>
-              <a:rPr lang="vi-VN" b="1" sz="3200"/>
+              <a:rPr lang="vi-VN" sz="3200" b="1"/>
               <a:t>0</a:t>
             </a:r>
             <a:r>
@@ -4592,7 +4653,7 @@
               <a:t>Chỉ </a:t>
             </a:r>
             <a:r>
-              <a:rPr lang="vi-VN" b="1" sz="3200"/>
+              <a:rPr lang="vi-VN" sz="3200" b="1"/>
               <a:t>1,1%</a:t>
             </a:r>
             <a:r>
@@ -4611,7 +4672,7 @@
               </a:spcAft>
             </a:pPr>
             <a:r>
-              <a:rPr lang="vi-VN" b="1" sz="3200"/>
+              <a:rPr lang="vi-VN" sz="3200" b="1"/>
               <a:t>750+</a:t>
             </a:r>
             <a:r>
@@ -4816,13 +4877,13 @@
           <a:noFill/>
         </p:spPr>
         <p:txBody>
-          <a:bodyPr wrap="square" lIns="0" rIns="0" tIns="0" bIns="0">
+          <a:bodyPr wrap="square" lIns="0" tIns="0" rIns="0" bIns="0">
             <a:spAutoFit/>
           </a:bodyPr>
           <a:lstStyle/>
           <a:p>
             <a:r>
-              <a:rPr sz="1200" i="1" lang="vi-VN">
+              <a:rPr lang="vi-VN" sz="1200" i="1">
                 <a:solidFill>
                   <a:srgbClr val="595959"/>
                 </a:solidFill>
@@ -4843,6 +4904,948 @@
   <p:clrMapOvr>
     <a:masterClrMapping/>
   </p:clrMapOvr>
+</p:sld>
+</file>
+
+<file path=ppt/slides/slide12.xml><?xml version="1.0" encoding="utf-8"?>
+<p:sld xmlns:a="http://schemas.openxmlformats.org/drawingml/2006/main" xmlns:r="http://schemas.openxmlformats.org/officeDocument/2006/relationships" xmlns:p="http://schemas.openxmlformats.org/presentationml/2006/main">
+  <p:cSld>
+    <p:spTree>
+      <p:nvGrpSpPr>
+        <p:cNvPr id="1" name=""/>
+        <p:cNvGrpSpPr/>
+        <p:nvPr/>
+      </p:nvGrpSpPr>
+      <p:grpSpPr>
+        <a:xfrm>
+          <a:off x="0" y="0"/>
+          <a:ext cx="0" cy="0"/>
+          <a:chOff x="0" y="0"/>
+          <a:chExt cx="0" cy="0"/>
+        </a:xfrm>
+      </p:grpSpPr>
+      <p:sp>
+        <p:nvSpPr>
+          <p:cNvPr id="2" name="Title 1">
+            <a:extLst>
+              <a:ext uri="{FF2B5EF4-FFF2-40B4-BE49-F238E27FC236}">
+                <a16:creationId xmlns:a16="http://schemas.microsoft.com/office/drawing/2014/main" id="{BF6EC58A-6E53-D3CB-81E2-EA9D298FF4C0}"/>
+              </a:ext>
+            </a:extLst>
+          </p:cNvPr>
+          <p:cNvSpPr>
+            <a:spLocks noGrp="1"/>
+          </p:cNvSpPr>
+          <p:nvPr>
+            <p:ph type="title"/>
+          </p:nvPr>
+        </p:nvSpPr>
+        <p:spPr/>
+        <p:txBody>
+          <a:bodyPr/>
+          <a:lstStyle/>
+          <a:p>
+            <a:r>
+              <a:rPr lang="en-US" dirty="0" err="1"/>
+              <a:t>Định</a:t>
+            </a:r>
+            <a:r>
+              <a:rPr lang="en-US" dirty="0"/>
+              <a:t> </a:t>
+            </a:r>
+            <a:r>
+              <a:rPr lang="en-US" dirty="0" err="1"/>
+              <a:t>hướng</a:t>
+            </a:r>
+            <a:r>
+              <a:rPr lang="en-US" dirty="0"/>
+              <a:t> </a:t>
+            </a:r>
+            <a:r>
+              <a:rPr lang="en-US" dirty="0" err="1"/>
+              <a:t>tương</a:t>
+            </a:r>
+            <a:r>
+              <a:rPr lang="en-US" dirty="0"/>
+              <a:t> lai </a:t>
+            </a:r>
+          </a:p>
+        </p:txBody>
+      </p:sp>
+      <p:sp>
+        <p:nvSpPr>
+          <p:cNvPr id="3" name="Content Placeholder 2">
+            <a:extLst>
+              <a:ext uri="{FF2B5EF4-FFF2-40B4-BE49-F238E27FC236}">
+                <a16:creationId xmlns:a16="http://schemas.microsoft.com/office/drawing/2014/main" id="{C0ACB314-224B-9617-34CA-CA0897CAC418}"/>
+              </a:ext>
+            </a:extLst>
+          </p:cNvPr>
+          <p:cNvSpPr>
+            <a:spLocks noGrp="1"/>
+          </p:cNvSpPr>
+          <p:nvPr>
+            <p:ph idx="1"/>
+          </p:nvPr>
+        </p:nvSpPr>
+        <p:spPr/>
+        <p:txBody>
+          <a:bodyPr/>
+          <a:lstStyle/>
+          <a:p>
+            <a:r>
+              <a:rPr lang="en-US" dirty="0" err="1"/>
+              <a:t>Cải</a:t>
+            </a:r>
+            <a:r>
+              <a:rPr lang="en-US" dirty="0"/>
+              <a:t> </a:t>
+            </a:r>
+            <a:r>
+              <a:rPr lang="en-US" dirty="0" err="1"/>
+              <a:t>thiện</a:t>
+            </a:r>
+            <a:r>
+              <a:rPr lang="en-US" dirty="0"/>
+              <a:t> </a:t>
+            </a:r>
+            <a:r>
+              <a:rPr lang="en-US" dirty="0" err="1"/>
+              <a:t>tương</a:t>
+            </a:r>
+            <a:r>
+              <a:rPr lang="en-US" dirty="0"/>
+              <a:t> </a:t>
+            </a:r>
+            <a:r>
+              <a:rPr lang="en-US" dirty="0" err="1"/>
+              <a:t>tác</a:t>
+            </a:r>
+            <a:r>
+              <a:rPr lang="en-US" dirty="0"/>
+              <a:t> </a:t>
+            </a:r>
+            <a:r>
+              <a:rPr lang="en-US" dirty="0" err="1"/>
+              <a:t>với</a:t>
+            </a:r>
+            <a:r>
+              <a:rPr lang="en-US" dirty="0"/>
+              <a:t> </a:t>
+            </a:r>
+            <a:r>
+              <a:rPr lang="en-US" dirty="0" err="1"/>
+              <a:t>người</a:t>
+            </a:r>
+            <a:r>
+              <a:rPr lang="en-US" dirty="0"/>
+              <a:t> </a:t>
+            </a:r>
+            <a:r>
+              <a:rPr lang="en-US" dirty="0" err="1"/>
+              <a:t>dùng</a:t>
+            </a:r>
+            <a:endParaRPr lang="en-US" dirty="0"/>
+          </a:p>
+          <a:p>
+            <a:r>
+              <a:rPr lang="en-US" dirty="0" err="1"/>
+              <a:t>Nghiên</a:t>
+            </a:r>
+            <a:r>
+              <a:rPr lang="en-US" dirty="0"/>
+              <a:t> </a:t>
+            </a:r>
+            <a:r>
+              <a:rPr lang="en-US" dirty="0" err="1"/>
+              <a:t>cứu</a:t>
+            </a:r>
+            <a:r>
+              <a:rPr lang="en-US" dirty="0"/>
+              <a:t> </a:t>
+            </a:r>
+            <a:r>
+              <a:rPr lang="en-US" dirty="0" err="1"/>
+              <a:t>thay</a:t>
+            </a:r>
+            <a:r>
+              <a:rPr lang="en-US" dirty="0"/>
+              <a:t> </a:t>
+            </a:r>
+            <a:r>
+              <a:rPr lang="en-US" dirty="0" err="1"/>
+              <a:t>đổi</a:t>
+            </a:r>
+            <a:r>
+              <a:rPr lang="en-US" dirty="0"/>
+              <a:t> </a:t>
+            </a:r>
+            <a:r>
+              <a:rPr lang="en-US" dirty="0" err="1"/>
+              <a:t>xét</a:t>
+            </a:r>
+            <a:r>
+              <a:rPr lang="en-US" dirty="0"/>
+              <a:t> </a:t>
+            </a:r>
+            <a:r>
+              <a:rPr lang="en-US" dirty="0" err="1"/>
+              <a:t>bằng</a:t>
+            </a:r>
+            <a:r>
+              <a:rPr lang="en-US" dirty="0"/>
+              <a:t> </a:t>
+            </a:r>
+            <a:r>
+              <a:rPr lang="en-US" dirty="0" err="1"/>
+              <a:t>sô</a:t>
+            </a:r>
+            <a:r>
+              <a:rPr lang="en-US" dirty="0"/>
+              <a:t>́ </a:t>
+            </a:r>
+            <a:r>
+              <a:rPr lang="en-US" dirty="0" err="1"/>
+              <a:t>bốc</a:t>
+            </a:r>
+            <a:r>
+              <a:rPr lang="en-US" dirty="0"/>
+              <a:t> </a:t>
+            </a:r>
+            <a:r>
+              <a:rPr lang="en-US" dirty="0" err="1"/>
+              <a:t>thăm</a:t>
+            </a:r>
+            <a:r>
+              <a:rPr lang="en-US" dirty="0"/>
+              <a:t> </a:t>
+            </a:r>
+            <a:r>
+              <a:rPr lang="en-US" dirty="0" err="1"/>
+              <a:t>bằng</a:t>
+            </a:r>
+            <a:r>
+              <a:rPr lang="en-US" dirty="0"/>
+              <a:t> </a:t>
+            </a:r>
+            <a:r>
+              <a:rPr lang="en-US" dirty="0" err="1"/>
+              <a:t>cách</a:t>
+            </a:r>
+            <a:r>
+              <a:rPr lang="en-US" dirty="0"/>
+              <a:t> </a:t>
+            </a:r>
+            <a:r>
+              <a:rPr lang="en-US" dirty="0" err="1"/>
+              <a:t>khác</a:t>
+            </a:r>
+            <a:r>
+              <a:rPr lang="en-US" dirty="0"/>
+              <a:t> </a:t>
+            </a:r>
+          </a:p>
+          <a:p>
+            <a:endParaRPr lang="en-US" dirty="0"/>
+          </a:p>
+        </p:txBody>
+      </p:sp>
+    </p:spTree>
+    <p:extLst>
+      <p:ext uri="{BB962C8B-B14F-4D97-AF65-F5344CB8AC3E}">
+        <p14:creationId xmlns:p14="http://schemas.microsoft.com/office/powerpoint/2010/main" val="1964196510"/>
+      </p:ext>
+    </p:extLst>
+  </p:cSld>
+  <p:clrMapOvr>
+    <a:masterClrMapping/>
+  </p:clrMapOvr>
+</p:sld>
+</file>
+
+<file path=ppt/slides/slide13.xml><?xml version="1.0" encoding="utf-8"?>
+<p:sld xmlns:a="http://schemas.openxmlformats.org/drawingml/2006/main" xmlns:r="http://schemas.openxmlformats.org/officeDocument/2006/relationships" xmlns:p="http://schemas.openxmlformats.org/presentationml/2006/main">
+  <p:cSld>
+    <p:bg>
+      <p:bgPr>
+        <a:solidFill>
+          <a:schemeClr val="bg1"/>
+        </a:solidFill>
+        <a:effectLst/>
+      </p:bgPr>
+    </p:bg>
+    <p:spTree>
+      <p:nvGrpSpPr>
+        <p:cNvPr id="1" name=""/>
+        <p:cNvGrpSpPr/>
+        <p:nvPr/>
+      </p:nvGrpSpPr>
+      <p:grpSpPr>
+        <a:xfrm>
+          <a:off x="0" y="0"/>
+          <a:ext cx="0" cy="0"/>
+          <a:chOff x="0" y="0"/>
+          <a:chExt cx="0" cy="0"/>
+        </a:xfrm>
+      </p:grpSpPr>
+      <p:sp useBgFill="1">
+        <p:nvSpPr>
+          <p:cNvPr id="10" name="Rectangle 9">
+            <a:extLst>
+              <a:ext uri="{FF2B5EF4-FFF2-40B4-BE49-F238E27FC236}">
+                <a16:creationId xmlns:a16="http://schemas.microsoft.com/office/drawing/2014/main" id="{F13C74B1-5B17-4795-BED0-7140497B445A}"/>
+              </a:ext>
+              <a:ext uri="{C183D7F6-B498-43B3-948B-1728B52AA6E4}">
+                <adec:decorative xmlns:adec="http://schemas.microsoft.com/office/drawing/2017/decorative" val="1"/>
+              </a:ext>
+            </a:extLst>
+          </p:cNvPr>
+          <p:cNvSpPr>
+            <a:spLocks noGrp="1" noRot="1" noChangeAspect="1" noMove="1" noResize="1" noEditPoints="1" noAdjustHandles="1" noChangeArrowheads="1" noChangeShapeType="1" noTextEdit="1"/>
+          </p:cNvSpPr>
+          <p:nvPr>
+            <p:extLst>
+              <p:ext uri="{386F3935-93C4-4BCD-93E2-E3B085C9AB24}">
+                <p16:designElem xmlns:p16="http://schemas.microsoft.com/office/powerpoint/2015/main" val="1"/>
+              </p:ext>
+            </p:extLst>
+          </p:nvPr>
+        </p:nvSpPr>
+        <p:spPr>
+          <a:xfrm>
+            <a:off x="0" y="0"/>
+            <a:ext cx="12188952" cy="6858000"/>
+          </a:xfrm>
+          <a:prstGeom prst="rect">
+            <a:avLst/>
+          </a:prstGeom>
+          <a:ln>
+            <a:noFill/>
+          </a:ln>
+        </p:spPr>
+        <p:style>
+          <a:lnRef idx="2">
+            <a:schemeClr val="accent1">
+              <a:shade val="50000"/>
+            </a:schemeClr>
+          </a:lnRef>
+          <a:fillRef idx="1">
+            <a:schemeClr val="accent1"/>
+          </a:fillRef>
+          <a:effectRef idx="0">
+            <a:schemeClr val="accent1"/>
+          </a:effectRef>
+          <a:fontRef idx="minor">
+            <a:schemeClr val="lt1"/>
+          </a:fontRef>
+        </p:style>
+        <p:txBody>
+          <a:bodyPr rtlCol="0" anchor="ctr"/>
+          <a:lstStyle/>
+          <a:p>
+            <a:pPr algn="ctr"/>
+            <a:endParaRPr lang="en-US"/>
+          </a:p>
+        </p:txBody>
+      </p:sp>
+      <p:sp>
+        <p:nvSpPr>
+          <p:cNvPr id="2" name="Title 1">
+            <a:extLst>
+              <a:ext uri="{FF2B5EF4-FFF2-40B4-BE49-F238E27FC236}">
+                <a16:creationId xmlns:a16="http://schemas.microsoft.com/office/drawing/2014/main" id="{39603B36-5E03-9395-91DE-0CF6E483CB11}"/>
+              </a:ext>
+            </a:extLst>
+          </p:cNvPr>
+          <p:cNvSpPr>
+            <a:spLocks noGrp="1"/>
+          </p:cNvSpPr>
+          <p:nvPr>
+            <p:ph type="title"/>
+          </p:nvPr>
+        </p:nvSpPr>
+        <p:spPr>
+          <a:xfrm>
+            <a:off x="640080" y="325369"/>
+            <a:ext cx="4368602" cy="1956841"/>
+          </a:xfrm>
+        </p:spPr>
+        <p:txBody>
+          <a:bodyPr anchor="b">
+            <a:normAutofit/>
+          </a:bodyPr>
+          <a:lstStyle/>
+          <a:p>
+            <a:r>
+              <a:rPr lang="en-US" sz="4200"/>
+              <a:t>Cảm ơn mọi người đã lắng nghe </a:t>
+            </a:r>
+          </a:p>
+        </p:txBody>
+      </p:sp>
+      <p:sp>
+        <p:nvSpPr>
+          <p:cNvPr id="12" name="sketchy line">
+            <a:extLst>
+              <a:ext uri="{FF2B5EF4-FFF2-40B4-BE49-F238E27FC236}">
+                <a16:creationId xmlns:a16="http://schemas.microsoft.com/office/drawing/2014/main" id="{D4974D33-8DC5-464E-8C6D-BE58F0669C17}"/>
+              </a:ext>
+              <a:ext uri="{C183D7F6-B498-43B3-948B-1728B52AA6E4}">
+                <adec:decorative xmlns:adec="http://schemas.microsoft.com/office/drawing/2017/decorative" val="1"/>
+              </a:ext>
+            </a:extLst>
+          </p:cNvPr>
+          <p:cNvSpPr>
+            <a:spLocks noGrp="1" noRot="1" noChangeAspect="1" noMove="1" noResize="1" noEditPoints="1" noAdjustHandles="1" noChangeArrowheads="1" noChangeShapeType="1" noTextEdit="1"/>
+          </p:cNvSpPr>
+          <p:nvPr>
+            <p:extLst>
+              <p:ext uri="{386F3935-93C4-4BCD-93E2-E3B085C9AB24}">
+                <p16:designElem xmlns:p16="http://schemas.microsoft.com/office/powerpoint/2015/main" val="1"/>
+              </p:ext>
+            </p:extLst>
+          </p:nvPr>
+        </p:nvSpPr>
+        <p:spPr>
+          <a:xfrm>
+            <a:off x="640080" y="2586994"/>
+            <a:ext cx="3474720" cy="18288"/>
+          </a:xfrm>
+          <a:custGeom>
+            <a:avLst/>
+            <a:gdLst>
+              <a:gd name="csX0" fmla="*/ 0 w 3474720"/>
+              <a:gd name="csY0" fmla="*/ 0 h 18288"/>
+              <a:gd name="csX1" fmla="*/ 694944 w 3474720"/>
+              <a:gd name="csY1" fmla="*/ 0 h 18288"/>
+              <a:gd name="csX2" fmla="*/ 1355141 w 3474720"/>
+              <a:gd name="csY2" fmla="*/ 0 h 18288"/>
+              <a:gd name="csX3" fmla="*/ 2015338 w 3474720"/>
+              <a:gd name="csY3" fmla="*/ 0 h 18288"/>
+              <a:gd name="csX4" fmla="*/ 2779776 w 3474720"/>
+              <a:gd name="csY4" fmla="*/ 0 h 18288"/>
+              <a:gd name="csX5" fmla="*/ 3474720 w 3474720"/>
+              <a:gd name="csY5" fmla="*/ 0 h 18288"/>
+              <a:gd name="csX6" fmla="*/ 3474720 w 3474720"/>
+              <a:gd name="csY6" fmla="*/ 18288 h 18288"/>
+              <a:gd name="csX7" fmla="*/ 2779776 w 3474720"/>
+              <a:gd name="csY7" fmla="*/ 18288 h 18288"/>
+              <a:gd name="csX8" fmla="*/ 2189074 w 3474720"/>
+              <a:gd name="csY8" fmla="*/ 18288 h 18288"/>
+              <a:gd name="csX9" fmla="*/ 1528877 w 3474720"/>
+              <a:gd name="csY9" fmla="*/ 18288 h 18288"/>
+              <a:gd name="csX10" fmla="*/ 868680 w 3474720"/>
+              <a:gd name="csY10" fmla="*/ 18288 h 18288"/>
+              <a:gd name="csX11" fmla="*/ 0 w 3474720"/>
+              <a:gd name="csY11" fmla="*/ 18288 h 18288"/>
+              <a:gd name="csX12" fmla="*/ 0 w 3474720"/>
+              <a:gd name="csY12" fmla="*/ 0 h 18288"/>
+            </a:gdLst>
+            <a:ahLst/>
+            <a:cxnLst>
+              <a:cxn ang="0">
+                <a:pos x="csX0" y="csY0"/>
+              </a:cxn>
+              <a:cxn ang="0">
+                <a:pos x="csX1" y="csY1"/>
+              </a:cxn>
+              <a:cxn ang="0">
+                <a:pos x="csX2" y="csY2"/>
+              </a:cxn>
+              <a:cxn ang="0">
+                <a:pos x="csX3" y="csY3"/>
+              </a:cxn>
+              <a:cxn ang="0">
+                <a:pos x="csX4" y="csY4"/>
+              </a:cxn>
+              <a:cxn ang="0">
+                <a:pos x="csX5" y="csY5"/>
+              </a:cxn>
+              <a:cxn ang="0">
+                <a:pos x="csX6" y="csY6"/>
+              </a:cxn>
+              <a:cxn ang="0">
+                <a:pos x="csX7" y="csY7"/>
+              </a:cxn>
+              <a:cxn ang="0">
+                <a:pos x="csX8" y="csY8"/>
+              </a:cxn>
+              <a:cxn ang="0">
+                <a:pos x="csX9" y="csY9"/>
+              </a:cxn>
+              <a:cxn ang="0">
+                <a:pos x="csX10" y="csY10"/>
+              </a:cxn>
+              <a:cxn ang="0">
+                <a:pos x="csX11" y="csY11"/>
+              </a:cxn>
+              <a:cxn ang="0">
+                <a:pos x="csX12" y="csY12"/>
+              </a:cxn>
+            </a:cxnLst>
+            <a:rect l="l" t="t" r="r" b="b"/>
+            <a:pathLst>
+              <a:path w="3474720" h="18288" fill="none" extrusionOk="0">
+                <a:moveTo>
+                  <a:pt x="0" y="0"/>
+                </a:moveTo>
+                <a:cubicBezTo>
+                  <a:pt x="224454" y="-14544"/>
+                  <a:pt x="495407" y="26540"/>
+                  <a:pt x="694944" y="0"/>
+                </a:cubicBezTo>
+                <a:cubicBezTo>
+                  <a:pt x="894481" y="-26540"/>
+                  <a:pt x="1130063" y="24713"/>
+                  <a:pt x="1355141" y="0"/>
+                </a:cubicBezTo>
+                <a:cubicBezTo>
+                  <a:pt x="1580219" y="-24713"/>
+                  <a:pt x="1820099" y="26695"/>
+                  <a:pt x="2015338" y="0"/>
+                </a:cubicBezTo>
+                <a:cubicBezTo>
+                  <a:pt x="2210577" y="-26695"/>
+                  <a:pt x="2402045" y="165"/>
+                  <a:pt x="2779776" y="0"/>
+                </a:cubicBezTo>
+                <a:cubicBezTo>
+                  <a:pt x="3157507" y="-165"/>
+                  <a:pt x="3286859" y="-15571"/>
+                  <a:pt x="3474720" y="0"/>
+                </a:cubicBezTo>
+                <a:cubicBezTo>
+                  <a:pt x="3474286" y="7551"/>
+                  <a:pt x="3474253" y="9822"/>
+                  <a:pt x="3474720" y="18288"/>
+                </a:cubicBezTo>
+                <a:cubicBezTo>
+                  <a:pt x="3233904" y="29845"/>
+                  <a:pt x="2945134" y="-5256"/>
+                  <a:pt x="2779776" y="18288"/>
+                </a:cubicBezTo>
+                <a:cubicBezTo>
+                  <a:pt x="2614418" y="41832"/>
+                  <a:pt x="2339768" y="22709"/>
+                  <a:pt x="2189074" y="18288"/>
+                </a:cubicBezTo>
+                <a:cubicBezTo>
+                  <a:pt x="2038380" y="13867"/>
+                  <a:pt x="1817434" y="-4947"/>
+                  <a:pt x="1528877" y="18288"/>
+                </a:cubicBezTo>
+                <a:cubicBezTo>
+                  <a:pt x="1240320" y="41523"/>
+                  <a:pt x="1042447" y="37198"/>
+                  <a:pt x="868680" y="18288"/>
+                </a:cubicBezTo>
+                <a:cubicBezTo>
+                  <a:pt x="694913" y="-622"/>
+                  <a:pt x="233232" y="44909"/>
+                  <a:pt x="0" y="18288"/>
+                </a:cubicBezTo>
+                <a:cubicBezTo>
+                  <a:pt x="60" y="11696"/>
+                  <a:pt x="66" y="3758"/>
+                  <a:pt x="0" y="0"/>
+                </a:cubicBezTo>
+                <a:close/>
+              </a:path>
+              <a:path w="3474720" h="18288" stroke="0" extrusionOk="0">
+                <a:moveTo>
+                  <a:pt x="0" y="0"/>
+                </a:moveTo>
+                <a:cubicBezTo>
+                  <a:pt x="202328" y="-14716"/>
+                  <a:pt x="332722" y="-11499"/>
+                  <a:pt x="625450" y="0"/>
+                </a:cubicBezTo>
+                <a:cubicBezTo>
+                  <a:pt x="918178" y="11499"/>
+                  <a:pt x="1096688" y="5123"/>
+                  <a:pt x="1389888" y="0"/>
+                </a:cubicBezTo>
+                <a:cubicBezTo>
+                  <a:pt x="1683088" y="-5123"/>
+                  <a:pt x="1835981" y="-14038"/>
+                  <a:pt x="1980590" y="0"/>
+                </a:cubicBezTo>
+                <a:cubicBezTo>
+                  <a:pt x="2125199" y="14038"/>
+                  <a:pt x="2396099" y="-7203"/>
+                  <a:pt x="2571293" y="0"/>
+                </a:cubicBezTo>
+                <a:cubicBezTo>
+                  <a:pt x="2746487" y="7203"/>
+                  <a:pt x="3041609" y="-12036"/>
+                  <a:pt x="3474720" y="0"/>
+                </a:cubicBezTo>
+                <a:cubicBezTo>
+                  <a:pt x="3474638" y="4406"/>
+                  <a:pt x="3474631" y="9982"/>
+                  <a:pt x="3474720" y="18288"/>
+                </a:cubicBezTo>
+                <a:cubicBezTo>
+                  <a:pt x="3324873" y="21876"/>
+                  <a:pt x="3136771" y="12587"/>
+                  <a:pt x="2814523" y="18288"/>
+                </a:cubicBezTo>
+                <a:cubicBezTo>
+                  <a:pt x="2492275" y="23989"/>
+                  <a:pt x="2294402" y="47111"/>
+                  <a:pt x="2154326" y="18288"/>
+                </a:cubicBezTo>
+                <a:cubicBezTo>
+                  <a:pt x="2014250" y="-10535"/>
+                  <a:pt x="1820317" y="33903"/>
+                  <a:pt x="1494130" y="18288"/>
+                </a:cubicBezTo>
+                <a:cubicBezTo>
+                  <a:pt x="1167943" y="2673"/>
+                  <a:pt x="948432" y="14868"/>
+                  <a:pt x="729691" y="18288"/>
+                </a:cubicBezTo>
+                <a:cubicBezTo>
+                  <a:pt x="510950" y="21708"/>
+                  <a:pt x="264032" y="24354"/>
+                  <a:pt x="0" y="18288"/>
+                </a:cubicBezTo>
+                <a:cubicBezTo>
+                  <a:pt x="189" y="14288"/>
+                  <a:pt x="-703" y="3747"/>
+                  <a:pt x="0" y="0"/>
+                </a:cubicBezTo>
+                <a:close/>
+              </a:path>
+            </a:pathLst>
+          </a:custGeom>
+          <a:solidFill>
+            <a:schemeClr val="accent2"/>
+          </a:solidFill>
+          <a:ln w="44450" cap="rnd">
+            <a:solidFill>
+              <a:schemeClr val="accent2"/>
+            </a:solidFill>
+            <a:round/>
+            <a:extLst>
+              <a:ext uri="{C807C97D-BFC1-408E-A445-0C87EB9F89A2}">
+                <ask:lineSketchStyleProps xmlns:ask="http://schemas.microsoft.com/office/drawing/2018/sketchyshapes" sd="2863741219">
+                  <a:prstGeom prst="rect">
+                    <a:avLst/>
+                  </a:prstGeom>
+                  <ask:type>
+                    <ask:lineSketchFreehand/>
+                  </ask:type>
+                </ask:lineSketchStyleProps>
+              </a:ext>
+            </a:extLst>
+          </a:ln>
+        </p:spPr>
+        <p:style>
+          <a:lnRef idx="2">
+            <a:schemeClr val="accent1">
+              <a:shade val="50000"/>
+            </a:schemeClr>
+          </a:lnRef>
+          <a:fillRef idx="1">
+            <a:schemeClr val="accent1"/>
+          </a:fillRef>
+          <a:effectRef idx="0">
+            <a:schemeClr val="accent1"/>
+          </a:effectRef>
+          <a:fontRef idx="minor">
+            <a:schemeClr val="lt1"/>
+          </a:fontRef>
+        </p:style>
+        <p:txBody>
+          <a:bodyPr rtlCol="0" anchor="ctr"/>
+          <a:lstStyle/>
+          <a:p>
+            <a:pPr algn="ctr"/>
+            <a:endParaRPr lang="en-US"/>
+          </a:p>
+        </p:txBody>
+      </p:sp>
+      <p:sp>
+        <p:nvSpPr>
+          <p:cNvPr id="3" name="Content Placeholder 2">
+            <a:extLst>
+              <a:ext uri="{FF2B5EF4-FFF2-40B4-BE49-F238E27FC236}">
+                <a16:creationId xmlns:a16="http://schemas.microsoft.com/office/drawing/2014/main" id="{95F9CFC5-6AAB-5EC3-3C4C-D733C245024A}"/>
+              </a:ext>
+            </a:extLst>
+          </p:cNvPr>
+          <p:cNvSpPr>
+            <a:spLocks noGrp="1"/>
+          </p:cNvSpPr>
+          <p:nvPr>
+            <p:ph idx="1"/>
+          </p:nvPr>
+        </p:nvSpPr>
+        <p:spPr>
+          <a:xfrm>
+            <a:off x="640080" y="2872899"/>
+            <a:ext cx="4243589" cy="3320668"/>
+          </a:xfrm>
+        </p:spPr>
+        <p:txBody>
+          <a:bodyPr>
+            <a:normAutofit/>
+          </a:bodyPr>
+          <a:lstStyle/>
+          <a:p>
+            <a:r>
+              <a:rPr lang="en-US" sz="2200"/>
+              <a:t>Cảm ơn mọi người đã dành thời gian </a:t>
+            </a:r>
+          </a:p>
+        </p:txBody>
+      </p:sp>
+      <p:pic>
+        <p:nvPicPr>
+          <p:cNvPr id="5" name="Picture 4" descr="Hơn 97.000 Thank You ảnh, hình chụp &amp; hình ảnh trả phí bản quyền một lần sẵn có - iStock">
+            <a:extLst>
+              <a:ext uri="{FF2B5EF4-FFF2-40B4-BE49-F238E27FC236}">
+                <a16:creationId xmlns:a16="http://schemas.microsoft.com/office/drawing/2014/main" id="{049FC74D-749F-A52B-80D1-3EA68BD331A5}"/>
+              </a:ext>
+            </a:extLst>
+          </p:cNvPr>
+          <p:cNvPicPr>
+            <a:picLocks noChangeAspect="1"/>
+          </p:cNvPicPr>
+          <p:nvPr/>
+        </p:nvPicPr>
+        <p:blipFill>
+          <a:blip r:embed="rId2"/>
+          <a:srcRect b="303"/>
+          <a:stretch>
+            <a:fillRect/>
+          </a:stretch>
+        </p:blipFill>
+        <p:spPr>
+          <a:xfrm>
+            <a:off x="5311702" y="10"/>
+            <a:ext cx="6878775" cy="6857990"/>
+          </a:xfrm>
+          <a:custGeom>
+            <a:avLst/>
+            <a:gdLst/>
+            <a:ahLst/>
+            <a:cxnLst/>
+            <a:rect l="l" t="t" r="r" b="b"/>
+            <a:pathLst>
+              <a:path w="6878775" h="6858000">
+                <a:moveTo>
+                  <a:pt x="1102973" y="0"/>
+                </a:moveTo>
+                <a:lnTo>
+                  <a:pt x="1160688" y="0"/>
+                </a:lnTo>
+                <a:lnTo>
+                  <a:pt x="983189" y="331786"/>
+                </a:lnTo>
+                <a:cubicBezTo>
+                  <a:pt x="914866" y="469145"/>
+                  <a:pt x="850355" y="608712"/>
+                  <a:pt x="789261" y="750263"/>
+                </a:cubicBezTo>
+                <a:cubicBezTo>
+                  <a:pt x="774307" y="784928"/>
+                  <a:pt x="759992" y="819849"/>
+                  <a:pt x="745295" y="854514"/>
+                </a:cubicBezTo>
+                <a:cubicBezTo>
+                  <a:pt x="756682" y="845393"/>
+                  <a:pt x="765489" y="833492"/>
+                  <a:pt x="770857" y="819975"/>
+                </a:cubicBezTo>
+                <a:cubicBezTo>
+                  <a:pt x="879943" y="589569"/>
+                  <a:pt x="999605" y="365513"/>
+                  <a:pt x="1131329" y="148742"/>
+                </a:cubicBezTo>
+                <a:lnTo>
+                  <a:pt x="1227589" y="0"/>
+                </a:lnTo>
+                <a:lnTo>
+                  <a:pt x="6878775" y="0"/>
+                </a:lnTo>
+                <a:lnTo>
+                  <a:pt x="6878775" y="6858000"/>
+                </a:lnTo>
+                <a:lnTo>
+                  <a:pt x="713521" y="6858000"/>
+                </a:lnTo>
+                <a:lnTo>
+                  <a:pt x="625642" y="6670527"/>
+                </a:lnTo>
+                <a:cubicBezTo>
+                  <a:pt x="507232" y="6398531"/>
+                  <a:pt x="403083" y="6118381"/>
+                  <a:pt x="312785" y="5830359"/>
+                </a:cubicBezTo>
+                <a:cubicBezTo>
+                  <a:pt x="278149" y="5719759"/>
+                  <a:pt x="248879" y="5607635"/>
+                  <a:pt x="212198" y="5480401"/>
+                </a:cubicBezTo>
+                <a:cubicBezTo>
+                  <a:pt x="212208" y="5491601"/>
+                  <a:pt x="212803" y="5502788"/>
+                  <a:pt x="213988" y="5513923"/>
+                </a:cubicBezTo>
+                <a:cubicBezTo>
+                  <a:pt x="264089" y="5723695"/>
+                  <a:pt x="307290" y="5935370"/>
+                  <a:pt x="365826" y="6142729"/>
+                </a:cubicBezTo>
+                <a:cubicBezTo>
+                  <a:pt x="433152" y="6380817"/>
+                  <a:pt x="510068" y="6614016"/>
+                  <a:pt x="597975" y="6841549"/>
+                </a:cubicBezTo>
+                <a:lnTo>
+                  <a:pt x="604824" y="6858000"/>
+                </a:lnTo>
+                <a:lnTo>
+                  <a:pt x="552056" y="6858000"/>
+                </a:lnTo>
+                <a:lnTo>
+                  <a:pt x="539576" y="6828295"/>
+                </a:lnTo>
+                <a:cubicBezTo>
+                  <a:pt x="380597" y="6414594"/>
+                  <a:pt x="260223" y="5988893"/>
+                  <a:pt x="171555" y="5552906"/>
+                </a:cubicBezTo>
+                <a:cubicBezTo>
+                  <a:pt x="91163" y="5157998"/>
+                  <a:pt x="43746" y="4758899"/>
+                  <a:pt x="12305" y="4357388"/>
+                </a:cubicBezTo>
+                <a:cubicBezTo>
+                  <a:pt x="-14281" y="4013908"/>
+                  <a:pt x="4507" y="3672965"/>
+                  <a:pt x="46684" y="3331516"/>
+                </a:cubicBezTo>
+                <a:cubicBezTo>
+                  <a:pt x="127203" y="2664286"/>
+                  <a:pt x="277819" y="2007265"/>
+                  <a:pt x="496065" y="1371196"/>
+                </a:cubicBezTo>
+                <a:cubicBezTo>
+                  <a:pt x="636273" y="966066"/>
+                  <a:pt x="800445" y="573253"/>
+                  <a:pt x="995723" y="196614"/>
+                </a:cubicBezTo>
+                <a:close/>
+              </a:path>
+            </a:pathLst>
+          </a:custGeom>
+        </p:spPr>
+      </p:pic>
+    </p:spTree>
+    <p:extLst>
+      <p:ext uri="{BB962C8B-B14F-4D97-AF65-F5344CB8AC3E}">
+        <p14:creationId xmlns:p14="http://schemas.microsoft.com/office/powerpoint/2010/main" val="2673900543"/>
+      </p:ext>
+    </p:extLst>
+  </p:cSld>
+  <p:clrMapOvr>
+    <a:masterClrMapping/>
+  </p:clrMapOvr>
+  <p:timing>
+    <p:tnLst>
+      <p:par>
+        <p:cTn id="1" dur="indefinite" restart="never" nodeType="tmRoot">
+          <p:childTnLst>
+            <p:seq concurrent="1" nextAc="seek">
+              <p:cTn id="2" dur="indefinite" nodeType="mainSeq">
+                <p:childTnLst>
+                  <p:par>
+                    <p:cTn id="3" fill="hold">
+                      <p:stCondLst>
+                        <p:cond delay="indefinite"/>
+                        <p:cond evt="onBegin" delay="0">
+                          <p:tn val="2"/>
+                        </p:cond>
+                      </p:stCondLst>
+                      <p:childTnLst>
+                        <p:par>
+                          <p:cTn id="4" fill="hold">
+                            <p:stCondLst>
+                              <p:cond delay="0"/>
+                            </p:stCondLst>
+                            <p:childTnLst>
+                              <p:par>
+                                <p:cTn id="5" presetID="10" presetClass="entr" presetSubtype="0" fill="hold" grpId="0" nodeType="withEffect">
+                                  <p:stCondLst>
+                                    <p:cond delay="1000"/>
+                                  </p:stCondLst>
+                                  <p:iterate>
+                                    <p:tmPct val="10000"/>
+                                  </p:iterate>
+                                  <p:childTnLst>
+                                    <p:set>
+                                      <p:cBhvr>
+                                        <p:cTn id="6" dur="1" fill="hold">
+                                          <p:stCondLst>
+                                            <p:cond delay="0"/>
+                                          </p:stCondLst>
+                                        </p:cTn>
+                                        <p:tgtEl>
+                                          <p:spTgt spid="2"/>
+                                        </p:tgtEl>
+                                        <p:attrNameLst>
+                                          <p:attrName>style.visibility</p:attrName>
+                                        </p:attrNameLst>
+                                      </p:cBhvr>
+                                      <p:to>
+                                        <p:strVal val="visible"/>
+                                      </p:to>
+                                    </p:set>
+                                    <p:animEffect transition="in" filter="fade">
+                                      <p:cBhvr>
+                                        <p:cTn id="7" dur="700"/>
+                                        <p:tgtEl>
+                                          <p:spTgt spid="2"/>
+                                        </p:tgtEl>
+                                      </p:cBhvr>
+                                    </p:animEffect>
+                                  </p:childTnLst>
+                                </p:cTn>
+                              </p:par>
+                            </p:childTnLst>
+                          </p:cTn>
+                        </p:par>
+                      </p:childTnLst>
+                    </p:cTn>
+                  </p:par>
+                </p:childTnLst>
+              </p:cTn>
+              <p:prevCondLst>
+                <p:cond evt="onPrev" delay="0">
+                  <p:tgtEl>
+                    <p:sldTgt/>
+                  </p:tgtEl>
+                </p:cond>
+              </p:prevCondLst>
+              <p:nextCondLst>
+                <p:cond evt="onNext" delay="0">
+                  <p:tgtEl>
+                    <p:sldTgt/>
+                  </p:tgtEl>
+                </p:cond>
+              </p:nextCondLst>
+            </p:seq>
+          </p:childTnLst>
+        </p:cTn>
+      </p:par>
+    </p:tnLst>
+    <p:bldLst>
+      <p:bldP spid="2" grpId="0"/>
+    </p:bldLst>
+  </p:timing>
 </p:sld>
 </file>
 
@@ -4932,7 +5935,9 @@
         <p:txBody>
           <a:bodyPr rtlCol="0" anchor="ctr"/>
           <a:lstStyle/>
-          <a:p/>
+          <a:p>
+            <a:endParaRPr/>
+          </a:p>
         </p:txBody>
       </p:sp>
       <p:sp>
@@ -4952,14 +5957,14 @@
           <a:noFill/>
         </p:spPr>
         <p:txBody>
-          <a:bodyPr wrap="square" anchor="t" lIns="0" rIns="0" tIns="0" bIns="0">
+          <a:bodyPr wrap="square" lIns="0" tIns="0" rIns="0" bIns="0" anchor="t">
             <a:spAutoFit/>
           </a:bodyPr>
           <a:lstStyle/>
           <a:p>
             <a:pPr algn="l"/>
             <a:r>
-              <a:rPr sz="4000" b="1" lang="vi-VN">
+              <a:rPr lang="vi-VN" sz="4000" b="1">
                 <a:solidFill>
                   <a:srgbClr val="3F6B52"/>
                 </a:solidFill>
@@ -4987,14 +5992,14 @@
           <a:noFill/>
         </p:spPr>
         <p:txBody>
-          <a:bodyPr wrap="square" anchor="t" lIns="0" rIns="0" tIns="0" bIns="0">
+          <a:bodyPr wrap="square" lIns="0" tIns="0" rIns="0" bIns="0" anchor="t">
             <a:spAutoFit/>
           </a:bodyPr>
           <a:lstStyle/>
           <a:p>
             <a:pPr algn="l"/>
             <a:r>
-              <a:rPr sz="2000" b="1" lang="vi-VN">
+              <a:rPr lang="vi-VN" sz="2000" b="1">
                 <a:solidFill>
                   <a:srgbClr val="1F1F1F"/>
                 </a:solidFill>
@@ -5046,7 +6051,9 @@
         <p:txBody>
           <a:bodyPr rtlCol="0" anchor="ctr"/>
           <a:lstStyle/>
-          <a:p/>
+          <a:p>
+            <a:endParaRPr/>
+          </a:p>
         </p:txBody>
       </p:sp>
       <p:sp>
@@ -5066,14 +6073,14 @@
           <a:noFill/>
         </p:spPr>
         <p:txBody>
-          <a:bodyPr wrap="square" anchor="t" lIns="0" rIns="0" tIns="0" bIns="0">
+          <a:bodyPr wrap="square" lIns="0" tIns="0" rIns="0" bIns="0" anchor="t">
             <a:spAutoFit/>
           </a:bodyPr>
           <a:lstStyle/>
           <a:p>
             <a:pPr algn="l"/>
             <a:r>
-              <a:rPr sz="4000" b="1" lang="vi-VN">
+              <a:rPr lang="vi-VN" sz="4000" b="1">
                 <a:solidFill>
                   <a:srgbClr val="3F6B52"/>
                 </a:solidFill>
@@ -5101,14 +6108,14 @@
           <a:noFill/>
         </p:spPr>
         <p:txBody>
-          <a:bodyPr wrap="square" anchor="t" lIns="0" rIns="0" tIns="0" bIns="0">
+          <a:bodyPr wrap="square" lIns="0" tIns="0" rIns="0" bIns="0" anchor="t">
             <a:spAutoFit/>
           </a:bodyPr>
           <a:lstStyle/>
           <a:p>
             <a:pPr algn="l"/>
             <a:r>
-              <a:rPr sz="2000" b="1" lang="vi-VN">
+              <a:rPr lang="vi-VN" sz="2000" b="1">
                 <a:solidFill>
                   <a:srgbClr val="1F1F1F"/>
                 </a:solidFill>
@@ -5160,7 +6167,9 @@
         <p:txBody>
           <a:bodyPr rtlCol="0" anchor="ctr"/>
           <a:lstStyle/>
-          <a:p/>
+          <a:p>
+            <a:endParaRPr/>
+          </a:p>
         </p:txBody>
       </p:sp>
       <p:sp>
@@ -5180,14 +6189,14 @@
           <a:noFill/>
         </p:spPr>
         <p:txBody>
-          <a:bodyPr wrap="square" anchor="t" lIns="0" rIns="0" tIns="0" bIns="0">
+          <a:bodyPr wrap="square" lIns="0" tIns="0" rIns="0" bIns="0" anchor="t">
             <a:spAutoFit/>
           </a:bodyPr>
           <a:lstStyle/>
           <a:p>
             <a:pPr algn="l"/>
             <a:r>
-              <a:rPr sz="4000" b="1" lang="vi-VN">
+              <a:rPr lang="vi-VN" sz="4000" b="1">
                 <a:solidFill>
                   <a:srgbClr val="3F6B52"/>
                 </a:solidFill>
@@ -5215,14 +6224,14 @@
           <a:noFill/>
         </p:spPr>
         <p:txBody>
-          <a:bodyPr wrap="square" anchor="t" lIns="0" rIns="0" tIns="0" bIns="0">
+          <a:bodyPr wrap="square" lIns="0" tIns="0" rIns="0" bIns="0" anchor="t">
             <a:spAutoFit/>
           </a:bodyPr>
           <a:lstStyle/>
           <a:p>
             <a:pPr algn="l"/>
             <a:r>
-              <a:rPr sz="2000" b="1" lang="vi-VN">
+              <a:rPr lang="vi-VN" sz="2000" b="1">
                 <a:solidFill>
                   <a:srgbClr val="1F1F1F"/>
                 </a:solidFill>
@@ -5274,7 +6283,9 @@
         <p:txBody>
           <a:bodyPr rtlCol="0" anchor="ctr"/>
           <a:lstStyle/>
-          <a:p/>
+          <a:p>
+            <a:endParaRPr/>
+          </a:p>
         </p:txBody>
       </p:sp>
       <p:sp>
@@ -5294,14 +6305,14 @@
           <a:noFill/>
         </p:spPr>
         <p:txBody>
-          <a:bodyPr wrap="square" anchor="t" lIns="0" rIns="0" tIns="0" bIns="0">
+          <a:bodyPr wrap="square" lIns="0" tIns="0" rIns="0" bIns="0" anchor="t">
             <a:spAutoFit/>
           </a:bodyPr>
           <a:lstStyle/>
           <a:p>
             <a:pPr algn="l"/>
             <a:r>
-              <a:rPr sz="4000" b="1" lang="vi-VN">
+              <a:rPr lang="vi-VN" sz="4000" b="1">
                 <a:solidFill>
                   <a:srgbClr val="3F6B52"/>
                 </a:solidFill>
@@ -5329,14 +6340,14 @@
           <a:noFill/>
         </p:spPr>
         <p:txBody>
-          <a:bodyPr wrap="square" anchor="t" lIns="0" rIns="0" tIns="0" bIns="0">
+          <a:bodyPr wrap="square" lIns="0" tIns="0" rIns="0" bIns="0" anchor="t">
             <a:spAutoFit/>
           </a:bodyPr>
           <a:lstStyle/>
           <a:p>
             <a:pPr algn="l"/>
             <a:r>
-              <a:rPr sz="2000" b="1" lang="vi-VN">
+              <a:rPr lang="vi-VN" sz="2000" b="1">
                 <a:solidFill>
                   <a:srgbClr val="1F1F1F"/>
                 </a:solidFill>
@@ -5388,7 +6399,9 @@
         <p:txBody>
           <a:bodyPr rtlCol="0" anchor="ctr"/>
           <a:lstStyle/>
-          <a:p/>
+          <a:p>
+            <a:endParaRPr/>
+          </a:p>
         </p:txBody>
       </p:sp>
       <p:sp>
@@ -5408,14 +6421,14 @@
           <a:noFill/>
         </p:spPr>
         <p:txBody>
-          <a:bodyPr wrap="square" anchor="t" lIns="0" rIns="0" tIns="0" bIns="0">
+          <a:bodyPr wrap="square" lIns="0" tIns="0" rIns="0" bIns="0" anchor="t">
             <a:spAutoFit/>
           </a:bodyPr>
           <a:lstStyle/>
           <a:p>
             <a:pPr algn="l"/>
             <a:r>
-              <a:rPr sz="4000" b="1" lang="vi-VN">
+              <a:rPr lang="vi-VN" sz="4000" b="1">
                 <a:solidFill>
                   <a:srgbClr val="3F6B52"/>
                 </a:solidFill>
@@ -5443,14 +6456,14 @@
           <a:noFill/>
         </p:spPr>
         <p:txBody>
-          <a:bodyPr wrap="square" anchor="t" lIns="0" rIns="0" tIns="0" bIns="0">
+          <a:bodyPr wrap="square" lIns="0" tIns="0" rIns="0" bIns="0" anchor="t">
             <a:spAutoFit/>
           </a:bodyPr>
           <a:lstStyle/>
           <a:p>
             <a:pPr algn="l"/>
             <a:r>
-              <a:rPr sz="2000" b="1" lang="vi-VN">
+              <a:rPr lang="vi-VN" sz="2000" b="1">
                 <a:solidFill>
                   <a:srgbClr val="1F1F1F"/>
                 </a:solidFill>
@@ -5502,7 +6515,9 @@
         <p:txBody>
           <a:bodyPr rtlCol="0" anchor="ctr"/>
           <a:lstStyle/>
-          <a:p/>
+          <a:p>
+            <a:endParaRPr/>
+          </a:p>
         </p:txBody>
       </p:sp>
       <p:sp>
@@ -5522,14 +6537,14 @@
           <a:noFill/>
         </p:spPr>
         <p:txBody>
-          <a:bodyPr wrap="square" anchor="t" lIns="0" rIns="0" tIns="0" bIns="0">
+          <a:bodyPr wrap="square" lIns="0" tIns="0" rIns="0" bIns="0" anchor="t">
             <a:spAutoFit/>
           </a:bodyPr>
           <a:lstStyle/>
           <a:p>
             <a:pPr algn="l"/>
             <a:r>
-              <a:rPr sz="4000" b="1" lang="vi-VN">
+              <a:rPr lang="vi-VN" sz="4000" b="1">
                 <a:solidFill>
                   <a:srgbClr val="3F6B52"/>
                 </a:solidFill>
@@ -5557,14 +6572,14 @@
           <a:noFill/>
         </p:spPr>
         <p:txBody>
-          <a:bodyPr wrap="square" anchor="t" lIns="0" rIns="0" tIns="0" bIns="0">
+          <a:bodyPr wrap="square" lIns="0" tIns="0" rIns="0" bIns="0" anchor="t">
             <a:spAutoFit/>
           </a:bodyPr>
           <a:lstStyle/>
           <a:p>
             <a:pPr algn="l"/>
             <a:r>
-              <a:rPr sz="2000" b="1" lang="vi-VN">
+              <a:rPr lang="vi-VN" sz="2000" b="1">
                 <a:solidFill>
                   <a:srgbClr val="1F1F1F"/>
                 </a:solidFill>
@@ -5669,7 +6684,9 @@
         <p:txBody>
           <a:bodyPr rtlCol="0" anchor="ctr"/>
           <a:lstStyle/>
-          <a:p/>
+          <a:p>
+            <a:endParaRPr/>
+          </a:p>
         </p:txBody>
       </p:sp>
       <p:sp>
@@ -5713,6 +6730,7 @@
           <a:lstStyle/>
           <a:p>
             <a:pPr algn="ctr"/>
+            <a:endParaRPr/>
           </a:p>
         </p:txBody>
       </p:sp>
@@ -5757,14 +6775,14 @@
           <a:noFill/>
         </p:spPr>
         <p:txBody>
-          <a:bodyPr wrap="square" anchor="t" lIns="0" rIns="0" tIns="0" bIns="0">
+          <a:bodyPr wrap="square" lIns="0" tIns="0" rIns="0" bIns="0" anchor="t">
             <a:spAutoFit/>
           </a:bodyPr>
           <a:lstStyle/>
           <a:p>
             <a:pPr algn="l"/>
             <a:r>
-              <a:rPr sz="1900" b="1" lang="vi-VN">
+              <a:rPr lang="vi-VN" sz="1900" b="1">
                 <a:solidFill>
                   <a:srgbClr val="1F1F1F"/>
                 </a:solidFill>
@@ -5780,7 +6798,7 @@
               </a:spcBef>
             </a:pPr>
             <a:r>
-              <a:rPr sz="1500" lang="vi-VN">
+              <a:rPr lang="vi-VN" sz="1500">
                 <a:solidFill>
                   <a:srgbClr val="555B58"/>
                 </a:solidFill>
@@ -5832,7 +6850,9 @@
         <p:txBody>
           <a:bodyPr rtlCol="0" anchor="ctr"/>
           <a:lstStyle/>
-          <a:p/>
+          <a:p>
+            <a:endParaRPr/>
+          </a:p>
         </p:txBody>
       </p:sp>
       <p:sp>
@@ -5876,6 +6896,7 @@
           <a:lstStyle/>
           <a:p>
             <a:pPr algn="ctr"/>
+            <a:endParaRPr/>
           </a:p>
         </p:txBody>
       </p:sp>
@@ -5920,14 +6941,14 @@
           <a:noFill/>
         </p:spPr>
         <p:txBody>
-          <a:bodyPr wrap="square" anchor="t" lIns="0" rIns="0" tIns="0" bIns="0">
+          <a:bodyPr wrap="square" lIns="0" tIns="0" rIns="0" bIns="0" anchor="t">
             <a:spAutoFit/>
           </a:bodyPr>
           <a:lstStyle/>
           <a:p>
             <a:pPr algn="l"/>
             <a:r>
-              <a:rPr sz="1900" b="1" lang="vi-VN">
+              <a:rPr lang="vi-VN" sz="1900" b="1">
                 <a:solidFill>
                   <a:srgbClr val="1F1F1F"/>
                 </a:solidFill>
@@ -5943,7 +6964,7 @@
               </a:spcBef>
             </a:pPr>
             <a:r>
-              <a:rPr sz="1500" lang="vi-VN">
+              <a:rPr lang="vi-VN" sz="1500">
                 <a:solidFill>
                   <a:srgbClr val="555B58"/>
                 </a:solidFill>
@@ -5995,7 +7016,9 @@
         <p:txBody>
           <a:bodyPr rtlCol="0" anchor="ctr"/>
           <a:lstStyle/>
-          <a:p/>
+          <a:p>
+            <a:endParaRPr/>
+          </a:p>
         </p:txBody>
       </p:sp>
       <p:sp>
@@ -6039,6 +7062,7 @@
           <a:lstStyle/>
           <a:p>
             <a:pPr algn="ctr"/>
+            <a:endParaRPr/>
           </a:p>
         </p:txBody>
       </p:sp>
@@ -6083,14 +7107,14 @@
           <a:noFill/>
         </p:spPr>
         <p:txBody>
-          <a:bodyPr wrap="square" anchor="t" lIns="0" rIns="0" tIns="0" bIns="0">
+          <a:bodyPr wrap="square" lIns="0" tIns="0" rIns="0" bIns="0" anchor="t">
             <a:spAutoFit/>
           </a:bodyPr>
           <a:lstStyle/>
           <a:p>
             <a:pPr algn="l"/>
             <a:r>
-              <a:rPr sz="1900" b="1" lang="vi-VN">
+              <a:rPr lang="vi-VN" sz="1900" b="1">
                 <a:solidFill>
                   <a:srgbClr val="1F1F1F"/>
                 </a:solidFill>
@@ -6106,7 +7130,7 @@
               </a:spcBef>
             </a:pPr>
             <a:r>
-              <a:rPr sz="1500" lang="vi-VN">
+              <a:rPr lang="vi-VN" sz="1500">
                 <a:solidFill>
                   <a:srgbClr val="555B58"/>
                 </a:solidFill>
@@ -6158,7 +7182,9 @@
         <p:txBody>
           <a:bodyPr rtlCol="0" anchor="ctr"/>
           <a:lstStyle/>
-          <a:p/>
+          <a:p>
+            <a:endParaRPr/>
+          </a:p>
         </p:txBody>
       </p:sp>
       <p:sp>
@@ -6202,6 +7228,7 @@
           <a:lstStyle/>
           <a:p>
             <a:pPr algn="ctr"/>
+            <a:endParaRPr/>
           </a:p>
         </p:txBody>
       </p:sp>
@@ -6246,14 +7273,14 @@
           <a:noFill/>
         </p:spPr>
         <p:txBody>
-          <a:bodyPr wrap="square" anchor="t" lIns="0" rIns="0" tIns="0" bIns="0">
+          <a:bodyPr wrap="square" lIns="0" tIns="0" rIns="0" bIns="0" anchor="t">
             <a:spAutoFit/>
           </a:bodyPr>
           <a:lstStyle/>
           <a:p>
             <a:pPr algn="l"/>
             <a:r>
-              <a:rPr sz="1900" b="1" lang="vi-VN">
+              <a:rPr lang="vi-VN" sz="1900" b="1">
                 <a:solidFill>
                   <a:srgbClr val="1F1F1F"/>
                 </a:solidFill>
@@ -6269,7 +7296,7 @@
               </a:spcBef>
             </a:pPr>
             <a:r>
-              <a:rPr sz="1500" lang="vi-VN">
+              <a:rPr lang="vi-VN" sz="1500">
                 <a:solidFill>
                   <a:srgbClr val="555B58"/>
                 </a:solidFill>
@@ -6380,7 +7407,9 @@
         <p:txBody>
           <a:bodyPr rtlCol="0" anchor="ctr"/>
           <a:lstStyle/>
-          <a:p/>
+          <a:p>
+            <a:endParaRPr/>
+          </a:p>
         </p:txBody>
       </p:sp>
       <p:sp>
@@ -6424,6 +7453,7 @@
           <a:lstStyle/>
           <a:p>
             <a:pPr algn="ctr"/>
+            <a:endParaRPr/>
           </a:p>
         </p:txBody>
       </p:sp>
@@ -6468,14 +7498,14 @@
           <a:noFill/>
         </p:spPr>
         <p:txBody>
-          <a:bodyPr wrap="square" anchor="t" lIns="0" rIns="0" tIns="0" bIns="0">
+          <a:bodyPr wrap="square" lIns="0" tIns="0" rIns="0" bIns="0" anchor="t">
             <a:spAutoFit/>
           </a:bodyPr>
           <a:lstStyle/>
           <a:p>
             <a:pPr algn="l"/>
             <a:r>
-              <a:rPr sz="1300" b="1" lang="vi-VN" spc="150">
+              <a:rPr lang="vi-VN" sz="1300" b="1" spc="150">
                 <a:solidFill>
                   <a:srgbClr val="3F6B52"/>
                 </a:solidFill>
@@ -6503,14 +7533,14 @@
           <a:noFill/>
         </p:spPr>
         <p:txBody>
-          <a:bodyPr wrap="square" anchor="t" lIns="0" rIns="0" tIns="0" bIns="0">
+          <a:bodyPr wrap="square" lIns="0" tIns="0" rIns="0" bIns="0" anchor="t">
             <a:spAutoFit/>
           </a:bodyPr>
           <a:lstStyle/>
           <a:p>
             <a:pPr algn="l"/>
             <a:r>
-              <a:rPr sz="1600" b="0" lang="vi-VN">
+              <a:rPr lang="vi-VN" sz="1600" b="0">
                 <a:solidFill>
                   <a:srgbClr val="1F1F1F"/>
                 </a:solidFill>
@@ -6562,6 +7592,7 @@
           <a:lstStyle/>
           <a:p>
             <a:pPr algn="ctr"/>
+            <a:endParaRPr/>
           </a:p>
         </p:txBody>
       </p:sp>
@@ -6606,7 +7637,9 @@
         <p:txBody>
           <a:bodyPr rtlCol="0" anchor="ctr"/>
           <a:lstStyle/>
-          <a:p/>
+          <a:p>
+            <a:endParaRPr/>
+          </a:p>
         </p:txBody>
       </p:sp>
       <p:sp>
@@ -6650,6 +7683,7 @@
           <a:lstStyle/>
           <a:p>
             <a:pPr algn="ctr"/>
+            <a:endParaRPr/>
           </a:p>
         </p:txBody>
       </p:sp>
@@ -6694,14 +7728,14 @@
           <a:noFill/>
         </p:spPr>
         <p:txBody>
-          <a:bodyPr wrap="square" anchor="t" lIns="0" rIns="0" tIns="0" bIns="0">
+          <a:bodyPr wrap="square" lIns="0" tIns="0" rIns="0" bIns="0" anchor="t">
             <a:spAutoFit/>
           </a:bodyPr>
           <a:lstStyle/>
           <a:p>
             <a:pPr algn="l"/>
             <a:r>
-              <a:rPr sz="1300" b="1" lang="vi-VN" spc="150">
+              <a:rPr lang="vi-VN" sz="1300" b="1" spc="150">
                 <a:solidFill>
                   <a:srgbClr val="DCE9E0"/>
                 </a:solidFill>
@@ -6729,14 +7763,14 @@
           <a:noFill/>
         </p:spPr>
         <p:txBody>
-          <a:bodyPr wrap="square" anchor="t" lIns="0" rIns="0" tIns="0" bIns="0">
+          <a:bodyPr wrap="square" lIns="0" tIns="0" rIns="0" bIns="0" anchor="t">
             <a:spAutoFit/>
           </a:bodyPr>
           <a:lstStyle/>
           <a:p>
             <a:pPr algn="l"/>
             <a:r>
-              <a:rPr sz="1600" b="1" lang="vi-VN">
+              <a:rPr lang="vi-VN" sz="1600" b="1">
                 <a:solidFill>
                   <a:srgbClr val="FFFFFF"/>
                 </a:solidFill>
@@ -6788,6 +7822,7 @@
           <a:lstStyle/>
           <a:p>
             <a:pPr algn="ctr"/>
+            <a:endParaRPr/>
           </a:p>
         </p:txBody>
       </p:sp>
@@ -6832,7 +7867,9 @@
         <p:txBody>
           <a:bodyPr rtlCol="0" anchor="ctr"/>
           <a:lstStyle/>
-          <a:p/>
+          <a:p>
+            <a:endParaRPr/>
+          </a:p>
         </p:txBody>
       </p:sp>
       <p:sp>
@@ -6876,6 +7913,7 @@
           <a:lstStyle/>
           <a:p>
             <a:pPr algn="ctr"/>
+            <a:endParaRPr/>
           </a:p>
         </p:txBody>
       </p:sp>
@@ -6920,14 +7958,14 @@
           <a:noFill/>
         </p:spPr>
         <p:txBody>
-          <a:bodyPr wrap="square" anchor="t" lIns="0" rIns="0" tIns="0" bIns="0">
+          <a:bodyPr wrap="square" lIns="0" tIns="0" rIns="0" bIns="0" anchor="t">
             <a:spAutoFit/>
           </a:bodyPr>
           <a:lstStyle/>
           <a:p>
             <a:pPr algn="l"/>
             <a:r>
-              <a:rPr sz="1300" b="1" lang="vi-VN" spc="150">
+              <a:rPr lang="vi-VN" sz="1300" b="1" spc="150">
                 <a:solidFill>
                   <a:srgbClr val="3F6B52"/>
                 </a:solidFill>
@@ -6955,14 +7993,14 @@
           <a:noFill/>
         </p:spPr>
         <p:txBody>
-          <a:bodyPr wrap="square" anchor="t" lIns="0" rIns="0" tIns="0" bIns="0">
+          <a:bodyPr wrap="square" lIns="0" tIns="0" rIns="0" bIns="0" anchor="t">
             <a:spAutoFit/>
           </a:bodyPr>
           <a:lstStyle/>
           <a:p>
             <a:pPr algn="l"/>
             <a:r>
-              <a:rPr sz="1600" b="0" lang="vi-VN">
+              <a:rPr lang="vi-VN" sz="1600" b="0">
                 <a:solidFill>
                   <a:srgbClr val="1F1F1F"/>
                 </a:solidFill>
@@ -7104,7 +8142,7 @@
           </a:fontRef>
         </p:style>
         <p:txBody>
-          <a:bodyPr rtlCol="0" anchor="ctr" lIns="0" rIns="0" tIns="0" bIns="0"/>
+          <a:bodyPr lIns="0" tIns="0" rIns="0" bIns="0" rtlCol="0" anchor="ctr"/>
           <a:lstStyle/>
           <a:p>
             <a:pPr algn="ctr"/>
@@ -7161,7 +8199,9 @@
         <p:txBody>
           <a:bodyPr rtlCol="0" anchor="ctr"/>
           <a:lstStyle/>
-          <a:p/>
+          <a:p>
+            <a:endParaRPr/>
+          </a:p>
         </p:txBody>
       </p:sp>
       <p:sp>
@@ -7205,6 +8245,7 @@
           <a:lstStyle/>
           <a:p>
             <a:pPr algn="ctr"/>
+            <a:endParaRPr/>
           </a:p>
         </p:txBody>
       </p:sp>
@@ -7249,14 +8290,14 @@
           <a:noFill/>
         </p:spPr>
         <p:txBody>
-          <a:bodyPr wrap="square" anchor="t" lIns="0" rIns="0" tIns="0" bIns="0">
+          <a:bodyPr wrap="square" lIns="0" tIns="0" rIns="0" bIns="0" anchor="t">
             <a:spAutoFit/>
           </a:bodyPr>
           <a:lstStyle/>
           <a:p>
             <a:pPr algn="ctr"/>
             <a:r>
-              <a:rPr sz="1800" b="1" lang="vi-VN">
+              <a:rPr lang="vi-VN" sz="1800" b="1">
                 <a:solidFill>
                   <a:srgbClr val="1F1F1F"/>
                 </a:solidFill>
@@ -7304,7 +8345,7 @@
           </a:fontRef>
         </p:style>
         <p:txBody>
-          <a:bodyPr rtlCol="0" anchor="ctr" lIns="0" rIns="0" tIns="0" bIns="0"/>
+          <a:bodyPr lIns="0" tIns="0" rIns="0" bIns="0" rtlCol="0" anchor="ctr"/>
           <a:lstStyle/>
           <a:p>
             <a:pPr algn="ctr"/>
@@ -7361,7 +8402,9 @@
         <p:txBody>
           <a:bodyPr rtlCol="0" anchor="ctr"/>
           <a:lstStyle/>
-          <a:p/>
+          <a:p>
+            <a:endParaRPr/>
+          </a:p>
         </p:txBody>
       </p:sp>
       <p:sp>
@@ -7405,6 +8448,7 @@
           <a:lstStyle/>
           <a:p>
             <a:pPr algn="ctr"/>
+            <a:endParaRPr/>
           </a:p>
         </p:txBody>
       </p:sp>
@@ -7449,14 +8493,14 @@
           <a:noFill/>
         </p:spPr>
         <p:txBody>
-          <a:bodyPr wrap="square" anchor="t" lIns="0" rIns="0" tIns="0" bIns="0">
+          <a:bodyPr wrap="square" lIns="0" tIns="0" rIns="0" bIns="0" anchor="t">
             <a:spAutoFit/>
           </a:bodyPr>
           <a:lstStyle/>
           <a:p>
             <a:pPr algn="ctr"/>
             <a:r>
-              <a:rPr sz="1800" b="1" lang="vi-VN">
+              <a:rPr lang="vi-VN" sz="1800" b="1">
                 <a:solidFill>
                   <a:srgbClr val="1F1F1F"/>
                 </a:solidFill>
@@ -7504,7 +8548,7 @@
           </a:fontRef>
         </p:style>
         <p:txBody>
-          <a:bodyPr rtlCol="0" anchor="ctr" lIns="0" rIns="0" tIns="0" bIns="0"/>
+          <a:bodyPr lIns="0" tIns="0" rIns="0" bIns="0" rtlCol="0" anchor="ctr"/>
           <a:lstStyle/>
           <a:p>
             <a:pPr algn="ctr"/>
@@ -7561,7 +8605,9 @@
         <p:txBody>
           <a:bodyPr rtlCol="0" anchor="ctr"/>
           <a:lstStyle/>
-          <a:p/>
+          <a:p>
+            <a:endParaRPr/>
+          </a:p>
         </p:txBody>
       </p:sp>
       <p:sp>
@@ -7605,6 +8651,7 @@
           <a:lstStyle/>
           <a:p>
             <a:pPr algn="ctr"/>
+            <a:endParaRPr/>
           </a:p>
         </p:txBody>
       </p:sp>
@@ -7649,14 +8696,14 @@
           <a:noFill/>
         </p:spPr>
         <p:txBody>
-          <a:bodyPr wrap="square" anchor="t" lIns="0" rIns="0" tIns="0" bIns="0">
+          <a:bodyPr wrap="square" lIns="0" tIns="0" rIns="0" bIns="0" anchor="t">
             <a:spAutoFit/>
           </a:bodyPr>
           <a:lstStyle/>
           <a:p>
             <a:pPr algn="ctr"/>
             <a:r>
-              <a:rPr sz="1800" b="1" lang="vi-VN">
+              <a:rPr lang="vi-VN" sz="1800" b="1">
                 <a:solidFill>
                   <a:srgbClr val="1F1F1F"/>
                 </a:solidFill>
@@ -7704,7 +8751,7 @@
           </a:fontRef>
         </p:style>
         <p:txBody>
-          <a:bodyPr rtlCol="0" anchor="ctr" lIns="0" rIns="0" tIns="0" bIns="0"/>
+          <a:bodyPr lIns="0" tIns="0" rIns="0" bIns="0" rtlCol="0" anchor="ctr"/>
           <a:lstStyle/>
           <a:p>
             <a:pPr algn="ctr"/>
@@ -7761,7 +8808,9 @@
         <p:txBody>
           <a:bodyPr rtlCol="0" anchor="ctr"/>
           <a:lstStyle/>
-          <a:p/>
+          <a:p>
+            <a:endParaRPr/>
+          </a:p>
         </p:txBody>
       </p:sp>
       <p:sp>
@@ -7805,6 +8854,7 @@
           <a:lstStyle/>
           <a:p>
             <a:pPr algn="ctr"/>
+            <a:endParaRPr/>
           </a:p>
         </p:txBody>
       </p:sp>
@@ -7849,14 +8899,14 @@
           <a:noFill/>
         </p:spPr>
         <p:txBody>
-          <a:bodyPr wrap="square" anchor="t" lIns="0" rIns="0" tIns="0" bIns="0">
+          <a:bodyPr wrap="square" lIns="0" tIns="0" rIns="0" bIns="0" anchor="t">
             <a:spAutoFit/>
           </a:bodyPr>
           <a:lstStyle/>
           <a:p>
             <a:pPr algn="ctr"/>
             <a:r>
-              <a:rPr sz="1800" b="1" lang="vi-VN">
+              <a:rPr lang="vi-VN" sz="1800" b="1">
                 <a:solidFill>
                   <a:srgbClr val="1F1F1F"/>
                 </a:solidFill>
@@ -7961,7 +9011,7 @@
               </a:spcAft>
             </a:pPr>
             <a:r>
-              <a:rPr lang="vi-VN" b="1" sz="3200"/>
+              <a:rPr lang="vi-VN" sz="3200" b="1"/>
               <a:t>Tầng 1:</a:t>
             </a:r>
             <a:r>
@@ -7979,7 +9029,7 @@
               </a:spcAft>
             </a:pPr>
             <a:r>
-              <a:rPr lang="vi-VN" b="1" sz="3200"/>
+              <a:rPr lang="vi-VN" sz="3200" b="1"/>
               <a:t>Tầng 2:</a:t>
             </a:r>
             <a:r>
@@ -8036,13 +9086,13 @@
           <a:noFill/>
         </p:spPr>
         <p:txBody>
-          <a:bodyPr wrap="square" lIns="0" rIns="0" tIns="0" bIns="0">
+          <a:bodyPr wrap="square" lIns="0" tIns="0" rIns="0" bIns="0">
             <a:spAutoFit/>
           </a:bodyPr>
           <a:lstStyle/>
           <a:p>
             <a:r>
-              <a:rPr sz="1200" i="1" lang="vi-VN">
+              <a:rPr lang="vi-VN" sz="1200" i="1">
                 <a:solidFill>
                   <a:srgbClr val="595959"/>
                 </a:solidFill>
@@ -8067,7 +9117,7 @@
 </file>
 
 <file path=ppt/slides/slide7.xml><?xml version="1.0" encoding="utf-8"?>
-<p:sld xmlns:a="http://schemas.openxmlformats.org/drawingml/2006/main" xmlns:p="http://schemas.openxmlformats.org/presentationml/2006/main" xmlns:r="http://schemas.openxmlformats.org/officeDocument/2006/relationships">
+<p:sld xmlns:a="http://schemas.openxmlformats.org/drawingml/2006/main" xmlns:r="http://schemas.openxmlformats.org/officeDocument/2006/relationships" xmlns:p="http://schemas.openxmlformats.org/presentationml/2006/main">
   <p:cSld>
     <p:spTree>
       <p:nvGrpSpPr>
@@ -8075,7 +9125,14 @@
         <p:cNvGrpSpPr/>
         <p:nvPr/>
       </p:nvGrpSpPr>
-      <p:grpSpPr/>
+      <p:grpSpPr>
+        <a:xfrm>
+          <a:off x="0" y="0"/>
+          <a:ext cx="0" cy="0"/>
+          <a:chOff x="0" y="0"/>
+          <a:chExt cx="0" cy="0"/>
+        </a:xfrm>
+      </p:grpSpPr>
       <p:sp>
         <p:nvSpPr>
           <p:cNvPr id="2" name="Title 1"/>
@@ -8115,7 +9172,9 @@
           </a:xfrm>
         </p:spPr>
         <p:txBody>
-          <a:bodyPr/>
+          <a:bodyPr>
+            <a:normAutofit fontScale="92500" lnSpcReduction="10000"/>
+          </a:bodyPr>
           <a:lstStyle/>
           <a:p>
             <a:pPr marL="0" indent="0">
@@ -8128,11 +9187,11 @@
               <a:buNone/>
             </a:pPr>
             <a:r>
-              <a:rPr b="1" sz="1800" lang="vi-VN"/>
+              <a:rPr lang="vi-VN" sz="1800" b="1"/>
               <a:t>1. Sao lưu:</a:t>
             </a:r>
             <a:r>
-              <a:rPr b="0" sz="1800" lang="vi-VN"/>
+              <a:rPr lang="vi-VN" sz="1800" b="0"/>
               <a:t> tự lưu một bản dữ liệu trước khi chạy</a:t>
             </a:r>
           </a:p>
@@ -8147,11 +9206,11 @@
               <a:buNone/>
             </a:pPr>
             <a:r>
-              <a:rPr b="1" sz="1800" lang="vi-VN"/>
+              <a:rPr lang="vi-VN" sz="1800" b="1"/>
               <a:t>2. Kiểm tra dữ liệu:</a:t>
             </a:r>
             <a:r>
-              <a:rPr b="0" sz="1800" lang="vi-VN"/>
+              <a:rPr lang="vi-VN" sz="1800" b="0"/>
               <a:t> dữ liệu sai thì dừng lại, chưa bốc thăm</a:t>
             </a:r>
           </a:p>
@@ -8166,11 +9225,11 @@
               <a:buNone/>
             </a:pPr>
             <a:r>
-              <a:rPr b="1" sz="1800" lang="vi-VN"/>
+              <a:rPr lang="vi-VN" sz="1800" b="1"/>
               <a:t>3. Bốc thăm:</a:t>
             </a:r>
             <a:r>
-              <a:rPr b="0" sz="1800" lang="vi-VN"/>
+              <a:rPr lang="vi-VN" sz="1800" b="0"/>
               <a:t> tạo số bốc thăm cho học sinh, khóa lại sau lần đầu</a:t>
             </a:r>
           </a:p>
@@ -8185,11 +9244,11 @@
               <a:buNone/>
             </a:pPr>
             <a:r>
-              <a:rPr b="1" sz="1800" lang="vi-VN"/>
+              <a:rPr lang="vi-VN" sz="1800" b="1"/>
               <a:t>4. Chạy thuật toán:</a:t>
             </a:r>
             <a:r>
-              <a:rPr b="0" sz="1800" lang="vi-VN"/>
+              <a:rPr lang="vi-VN" sz="1800" b="0"/>
               <a:t> xếp học sinh vào CLB, kiểm tra kết quả ổn định</a:t>
             </a:r>
           </a:p>
@@ -8204,11 +9263,11 @@
               <a:buNone/>
             </a:pPr>
             <a:r>
-              <a:rPr b="1" sz="1800" lang="vi-VN"/>
+              <a:rPr lang="vi-VN" sz="1800" b="1"/>
               <a:t>5. Ghi kết quả:</a:t>
             </a:r>
             <a:r>
-              <a:rPr b="0" sz="1800" lang="vi-VN"/>
+              <a:rPr lang="vi-VN" sz="1800" b="0"/>
               <a:t> chỉ lưu khi mọi bước đều đạt, lỗi thì hủy toàn bộ</a:t>
             </a:r>
           </a:p>
@@ -8223,11 +9282,11 @@
               <a:buNone/>
             </a:pPr>
             <a:r>
-              <a:rPr b="1" sz="1800" lang="vi-VN"/>
+              <a:rPr lang="vi-VN" sz="1800" b="1"/>
               <a:t>6. Xuất tệp:</a:t>
             </a:r>
             <a:r>
-              <a:rPr b="0" sz="1800" lang="vi-VN"/>
+              <a:rPr lang="vi-VN" sz="1800" b="0"/>
               <a:t> tạo file kết quả cho nhà trường và từng CLB</a:t>
             </a:r>
           </a:p>
@@ -8242,7 +9301,7 @@
         <p:spPr>
           <a:xfrm>
             <a:off x="6172200" y="1828800"/>
-            <a:ext cx="5184648" cy="2514600"/>
+            <a:ext cx="5184648" cy="2926080"/>
           </a:xfrm>
           <a:prstGeom prst="rect">
             <a:avLst/>
@@ -8250,7 +9309,7 @@
           <a:noFill/>
         </p:spPr>
         <p:txBody>
-          <a:bodyPr wrap="square" lIns="0" rIns="0" tIns="0" bIns="0">
+          <a:bodyPr wrap="square" lIns="0" tIns="0" rIns="0" bIns="0">
             <a:spAutoFit/>
           </a:bodyPr>
           <a:lstStyle/>
@@ -8261,7 +9320,7 @@
               </a:spcAft>
             </a:pPr>
             <a:r>
-              <a:rPr b="1" sz="2000" lang="vi-VN">
+              <a:rPr lang="vi-VN" sz="2000" b="1" dirty="0">
                 <a:solidFill>
                   <a:srgbClr val="1F1F1F"/>
                 </a:solidFill>
@@ -8272,11 +9331,11 @@
           <a:p>
             <a:pPr>
               <a:spcAft>
-                <a:spcPts val="800"/>
+                <a:spcPts val="600"/>
               </a:spcAft>
             </a:pPr>
             <a:r>
-              <a:rPr b="1" sz="1600" lang="vi-VN">
+              <a:rPr lang="vi-VN" sz="1500" b="1" dirty="0">
                 <a:solidFill>
                   <a:srgbClr val="1F1F1F"/>
                 </a:solidFill>
@@ -8284,7 +9343,7 @@
               <a:t>Nộp đơn: </a:t>
             </a:r>
             <a:r>
-              <a:rPr b="0" sz="1600" lang="vi-VN">
+              <a:rPr lang="vi-VN" sz="1500" b="0" dirty="0">
                 <a:solidFill>
                   <a:srgbClr val="1F1F1F"/>
                 </a:solidFill>
@@ -8295,11 +9354,11 @@
           <a:p>
             <a:pPr>
               <a:spcAft>
-                <a:spcPts val="800"/>
+                <a:spcPts val="600"/>
               </a:spcAft>
             </a:pPr>
             <a:r>
-              <a:rPr b="1" sz="1600" lang="vi-VN">
+              <a:rPr lang="vi-VN" sz="1500" b="1" dirty="0">
                 <a:solidFill>
                   <a:srgbClr val="1F1F1F"/>
                 </a:solidFill>
@@ -8307,7 +9366,7 @@
               <a:t>Xếp hạng hai tầng: </a:t>
             </a:r>
             <a:r>
-              <a:rPr b="0" sz="1600" lang="vi-VN">
+              <a:rPr lang="vi-VN" sz="1500" b="0" dirty="0">
                 <a:solidFill>
                   <a:srgbClr val="1F1F1F"/>
                 </a:solidFill>
@@ -8318,11 +9377,34 @@
           <a:p>
             <a:pPr>
               <a:spcAft>
-                <a:spcPts val="800"/>
+                <a:spcPts val="600"/>
               </a:spcAft>
             </a:pPr>
             <a:r>
-              <a:rPr b="1" sz="1600" lang="vi-VN">
+              <a:rPr lang="vi-VN" sz="1500" b="1" dirty="0">
+                <a:solidFill>
+                  <a:srgbClr val="1F1F1F"/>
+                </a:solidFill>
+              </a:rPr>
+              <a:t>Suất dự trữ: </a:t>
+            </a:r>
+            <a:r>
+              <a:rPr lang="vi-VN" sz="1500" b="0" dirty="0">
+                <a:solidFill>
+                  <a:srgbClr val="1F1F1F"/>
+                </a:solidFill>
+              </a:rPr>
+              <a:t>CLB có thể dành trước một số chỗ cho nhóm ưu tiên; không đủ học sinh thuộc nhóm thì chỗ thừa trả lại cho xét chung.</a:t>
+            </a:r>
+          </a:p>
+          <a:p>
+            <a:pPr>
+              <a:spcAft>
+                <a:spcPts val="600"/>
+              </a:spcAft>
+            </a:pPr>
+            <a:r>
+              <a:rPr lang="vi-VN" sz="1500" b="1" dirty="0">
                 <a:solidFill>
                   <a:srgbClr val="1F1F1F"/>
                 </a:solidFill>
@@ -8330,7 +9412,7 @@
               <a:t>Giữ tạm: </a:t>
             </a:r>
             <a:r>
-              <a:rPr b="0" sz="1600" lang="vi-VN">
+              <a:rPr lang="vi-VN" sz="1500" b="0" dirty="0">
                 <a:solidFill>
                   <a:srgbClr val="1F1F1F"/>
                 </a:solidFill>
@@ -8341,11 +9423,11 @@
           <a:p>
             <a:pPr>
               <a:spcAft>
-                <a:spcPts val="800"/>
+                <a:spcPts val="600"/>
               </a:spcAft>
             </a:pPr>
             <a:r>
-              <a:rPr b="1" sz="1600" lang="vi-VN">
+              <a:rPr lang="vi-VN" sz="1500" b="1" dirty="0">
                 <a:solidFill>
                   <a:srgbClr val="1F1F1F"/>
                 </a:solidFill>
@@ -8353,7 +9435,7 @@
               <a:t>Lặp lại: </a:t>
             </a:r>
             <a:r>
-              <a:rPr b="0" sz="1600" lang="vi-VN">
+              <a:rPr lang="vi-VN" sz="1500" b="0" dirty="0">
                 <a:solidFill>
                   <a:srgbClr val="1F1F1F"/>
                 </a:solidFill>
@@ -8371,7 +9453,7 @@
         </p:nvSpPr>
         <p:spPr>
           <a:xfrm>
-            <a:off x="6172200" y="4526280"/>
+            <a:off x="6172200" y="5029200"/>
             <a:ext cx="5184648" cy="320040"/>
           </a:xfrm>
           <a:prstGeom prst="rect">
@@ -8380,12 +9462,12 @@
           <a:noFill/>
         </p:spPr>
         <p:txBody>
-          <a:bodyPr wrap="square" lIns="0" rIns="0" tIns="0" bIns="0"/>
+          <a:bodyPr wrap="square" lIns="0" tIns="0" rIns="0" bIns="0"/>
           <a:lstStyle/>
           <a:p>
-            <a:pPr algn="l" marL="0" indent="0"/>
-            <a:r>
-              <a:rPr b="1" sz="1500" lang="vi-VN">
+            <a:pPr marL="0" indent="0" algn="l"/>
+            <a:r>
+              <a:rPr lang="vi-VN" sz="1500" b="1">
                 <a:solidFill>
                   <a:srgbClr val="1F1F1F"/>
                 </a:solidFill>
@@ -8404,30 +9486,54 @@
           <p:nvPr/>
         </p:nvGraphicFramePr>
         <p:xfrm>
-          <a:off x="6172200" y="4892040"/>
-          <a:ext cx="5184648" cy="1280160"/>
+          <a:off x="6172200" y="5349240"/>
+          <a:ext cx="5184648" cy="1304544"/>
         </p:xfrm>
         <a:graphic>
           <a:graphicData uri="http://schemas.openxmlformats.org/drawingml/2006/table">
             <a:tbl>
-              <a:tblPr firstRow="0" bandRow="0">
+              <a:tblPr>
                 <a:tableStyleId>{5940675A-B579-460E-94D1-54222C63F5DA}</a:tableStyleId>
               </a:tblPr>
               <a:tblGrid>
-                <a:gridCol w="640080"/>
-                <a:gridCol w="2624328"/>
-                <a:gridCol w="960120"/>
-                <a:gridCol w="960120"/>
+                <a:gridCol w="640080">
+                  <a:extLst>
+                    <a:ext uri="{9D8B030D-6E8A-4147-A177-3AD203B41FA5}">
+                      <a16:colId xmlns:a16="http://schemas.microsoft.com/office/drawing/2014/main" val="20000"/>
+                    </a:ext>
+                  </a:extLst>
+                </a:gridCol>
+                <a:gridCol w="2624328">
+                  <a:extLst>
+                    <a:ext uri="{9D8B030D-6E8A-4147-A177-3AD203B41FA5}">
+                      <a16:colId xmlns:a16="http://schemas.microsoft.com/office/drawing/2014/main" val="20001"/>
+                    </a:ext>
+                  </a:extLst>
+                </a:gridCol>
+                <a:gridCol w="960120">
+                  <a:extLst>
+                    <a:ext uri="{9D8B030D-6E8A-4147-A177-3AD203B41FA5}">
+                      <a16:colId xmlns:a16="http://schemas.microsoft.com/office/drawing/2014/main" val="20002"/>
+                    </a:ext>
+                  </a:extLst>
+                </a:gridCol>
+                <a:gridCol w="960120">
+                  <a:extLst>
+                    <a:ext uri="{9D8B030D-6E8A-4147-A177-3AD203B41FA5}">
+                      <a16:colId xmlns:a16="http://schemas.microsoft.com/office/drawing/2014/main" val="20003"/>
+                    </a:ext>
+                  </a:extLst>
+                </a:gridCol>
               </a:tblGrid>
               <a:tr h="426720">
                 <a:tc>
                   <a:txBody>
-                    <a:bodyPr wrap="square"/>
+                    <a:bodyPr/>
                     <a:lstStyle/>
                     <a:p>
                       <a:pPr algn="ctr"/>
                       <a:r>
-                        <a:rPr sz="1300" b="1" lang="vi-VN">
+                        <a:rPr lang="vi-VN" sz="1300" b="1">
                           <a:solidFill>
                             <a:srgbClr val="1F1F1F"/>
                           </a:solidFill>
@@ -8440,11 +9546,11 @@
                 </a:tc>
                 <a:tc>
                   <a:txBody>
-                    <a:bodyPr wrap="square"/>
+                    <a:bodyPr/>
                     <a:lstStyle/>
                     <a:p>
                       <a:r>
-                        <a:rPr sz="1300" b="1" lang="vi-VN">
+                        <a:rPr lang="vi-VN" sz="1300" b="1">
                           <a:solidFill>
                             <a:srgbClr val="1F1F1F"/>
                           </a:solidFill>
@@ -8457,11 +9563,11 @@
                 </a:tc>
                 <a:tc>
                   <a:txBody>
-                    <a:bodyPr wrap="square"/>
+                    <a:bodyPr/>
                     <a:lstStyle/>
                     <a:p>
                       <a:r>
-                        <a:rPr sz="1300" b="1" lang="vi-VN">
+                        <a:rPr lang="vi-VN" sz="1300" b="1">
                           <a:solidFill>
                             <a:srgbClr val="1F1F1F"/>
                           </a:solidFill>
@@ -8474,11 +9580,11 @@
                 </a:tc>
                 <a:tc>
                   <a:txBody>
-                    <a:bodyPr wrap="square"/>
+                    <a:bodyPr/>
                     <a:lstStyle/>
                     <a:p>
                       <a:r>
-                        <a:rPr sz="1300" b="1" lang="vi-VN">
+                        <a:rPr lang="vi-VN" sz="1300" b="1">
                           <a:solidFill>
                             <a:srgbClr val="1F1F1F"/>
                           </a:solidFill>
@@ -8489,16 +9595,21 @@
                   </a:txBody>
                   <a:tcPr marL="54864" marR="54864" marT="27432" marB="27432"/>
                 </a:tc>
+                <a:extLst>
+                  <a:ext uri="{0D108BD9-81ED-4DB2-BD59-A6C34878D82A}">
+                    <a16:rowId xmlns:a16="http://schemas.microsoft.com/office/drawing/2014/main" val="10000"/>
+                  </a:ext>
+                </a:extLst>
               </a:tr>
               <a:tr h="426720">
                 <a:tc>
                   <a:txBody>
-                    <a:bodyPr wrap="square"/>
+                    <a:bodyPr/>
                     <a:lstStyle/>
                     <a:p>
                       <a:pPr algn="ctr"/>
                       <a:r>
-                        <a:rPr sz="1300" b="0" lang="vi-VN">
+                        <a:rPr lang="vi-VN" sz="1300" b="0">
                           <a:solidFill>
                             <a:srgbClr val="1F1F1F"/>
                           </a:solidFill>
@@ -8511,11 +9622,11 @@
                 </a:tc>
                 <a:tc>
                   <a:txBody>
-                    <a:bodyPr wrap="square"/>
+                    <a:bodyPr/>
                     <a:lstStyle/>
                     <a:p>
                       <a:r>
-                        <a:rPr sz="1300" b="0" lang="vi-VN">
+                        <a:rPr lang="vi-VN" sz="1300" b="0">
                           <a:solidFill>
                             <a:srgbClr val="1F1F1F"/>
                           </a:solidFill>
@@ -8528,11 +9639,11 @@
                 </a:tc>
                 <a:tc>
                   <a:txBody>
-                    <a:bodyPr wrap="square"/>
+                    <a:bodyPr/>
                     <a:lstStyle/>
                     <a:p>
                       <a:r>
-                        <a:rPr sz="1300" b="0" lang="vi-VN">
+                        <a:rPr lang="vi-VN" sz="1300" b="0">
                           <a:solidFill>
                             <a:srgbClr val="1F1F1F"/>
                           </a:solidFill>
@@ -8545,11 +9656,11 @@
                 </a:tc>
                 <a:tc>
                   <a:txBody>
-                    <a:bodyPr wrap="square"/>
+                    <a:bodyPr/>
                     <a:lstStyle/>
                     <a:p>
                       <a:r>
-                        <a:rPr sz="1300" b="0" lang="vi-VN">
+                        <a:rPr lang="vi-VN" sz="1300" b="0">
                           <a:solidFill>
                             <a:srgbClr val="1F1F1F"/>
                           </a:solidFill>
@@ -8560,16 +9671,21 @@
                   </a:txBody>
                   <a:tcPr marL="54864" marR="54864" marT="27432" marB="27432"/>
                 </a:tc>
+                <a:extLst>
+                  <a:ext uri="{0D108BD9-81ED-4DB2-BD59-A6C34878D82A}">
+                    <a16:rowId xmlns:a16="http://schemas.microsoft.com/office/drawing/2014/main" val="10001"/>
+                  </a:ext>
+                </a:extLst>
               </a:tr>
               <a:tr h="426720">
                 <a:tc>
                   <a:txBody>
-                    <a:bodyPr wrap="square"/>
+                    <a:bodyPr/>
                     <a:lstStyle/>
                     <a:p>
                       <a:pPr algn="ctr"/>
                       <a:r>
-                        <a:rPr sz="1300" b="0" lang="vi-VN">
+                        <a:rPr lang="vi-VN" sz="1300" b="0">
                           <a:solidFill>
                             <a:srgbClr val="1F1F1F"/>
                           </a:solidFill>
@@ -8582,11 +9698,11 @@
                 </a:tc>
                 <a:tc>
                   <a:txBody>
-                    <a:bodyPr wrap="square"/>
+                    <a:bodyPr/>
                     <a:lstStyle/>
                     <a:p>
                       <a:r>
-                        <a:rPr sz="1300" b="0" lang="vi-VN">
+                        <a:rPr lang="vi-VN" sz="1300" b="0">
                           <a:solidFill>
                             <a:srgbClr val="1F1F1F"/>
                           </a:solidFill>
@@ -8599,11 +9715,11 @@
                 </a:tc>
                 <a:tc>
                   <a:txBody>
-                    <a:bodyPr wrap="square"/>
+                    <a:bodyPr/>
                     <a:lstStyle/>
                     <a:p>
                       <a:r>
-                        <a:rPr sz="1300" b="0" lang="vi-VN">
+                        <a:rPr lang="vi-VN" sz="1300" b="0">
                           <a:solidFill>
                             <a:srgbClr val="1F1F1F"/>
                           </a:solidFill>
@@ -8616,11 +9732,11 @@
                 </a:tc>
                 <a:tc>
                   <a:txBody>
-                    <a:bodyPr wrap="square"/>
+                    <a:bodyPr/>
                     <a:lstStyle/>
                     <a:p>
                       <a:r>
-                        <a:rPr sz="1300" b="0" lang="vi-VN">
+                        <a:rPr lang="vi-VN" sz="1300" b="0">
                           <a:solidFill>
                             <a:srgbClr val="1F1F1F"/>
                           </a:solidFill>
@@ -8631,6 +9747,11 @@
                   </a:txBody>
                   <a:tcPr marL="54864" marR="54864" marT="27432" marB="27432"/>
                 </a:tc>
+                <a:extLst>
+                  <a:ext uri="{0D108BD9-81ED-4DB2-BD59-A6C34878D82A}">
+                    <a16:rowId xmlns:a16="http://schemas.microsoft.com/office/drawing/2014/main" val="10002"/>
+                  </a:ext>
+                </a:extLst>
               </a:tr>
             </a:tbl>
           </a:graphicData>
@@ -8712,7 +9833,9 @@
           </a:xfrm>
         </p:spPr>
         <p:txBody>
-          <a:bodyPr/>
+          <a:bodyPr>
+            <a:normAutofit lnSpcReduction="10000"/>
+          </a:bodyPr>
           <a:lstStyle/>
           <a:p>
             <a:pPr>
@@ -8805,13 +9928,13 @@
           <a:noFill/>
         </p:spPr>
         <p:txBody>
-          <a:bodyPr wrap="square" lIns="0" rIns="0" tIns="0" bIns="0">
+          <a:bodyPr wrap="square" lIns="0" tIns="0" rIns="0" bIns="0">
             <a:spAutoFit/>
           </a:bodyPr>
           <a:lstStyle/>
           <a:p>
             <a:r>
-              <a:rPr sz="1200" i="1" lang="vi-VN">
+              <a:rPr lang="vi-VN" sz="1200" i="1">
                 <a:solidFill>
                   <a:srgbClr val="595959"/>
                 </a:solidFill>
@@ -8890,7 +10013,7 @@
           <p:nvPr/>
         </p:nvPicPr>
         <p:blipFill>
-          <a:blip r:embed="rId2"/>
+          <a:blip r:embed="rId3"/>
           <a:stretch>
             <a:fillRect/>
           </a:stretch>
@@ -8927,13 +10050,13 @@
           <a:noFill/>
         </p:spPr>
         <p:txBody>
-          <a:bodyPr wrap="square" lIns="0" rIns="0" tIns="0" bIns="0">
+          <a:bodyPr wrap="square" lIns="0" tIns="0" rIns="0" bIns="0">
             <a:spAutoFit/>
           </a:bodyPr>
           <a:lstStyle/>
           <a:p>
             <a:r>
-              <a:rPr sz="1100" b="0" i="1" lang="vi-VN">
+              <a:rPr lang="vi-VN" sz="1100" b="0" i="1">
                 <a:solidFill>
                   <a:srgbClr val="595959"/>
                 </a:solidFill>
@@ -8961,13 +10084,13 @@
           <a:noFill/>
         </p:spPr>
         <p:txBody>
-          <a:bodyPr wrap="square" lIns="0" rIns="0" tIns="0" bIns="0">
+          <a:bodyPr wrap="square" lIns="0" tIns="0" rIns="0" bIns="0">
             <a:spAutoFit/>
           </a:bodyPr>
           <a:lstStyle/>
           <a:p>
             <a:r>
-              <a:rPr sz="2600" b="1" i="0" lang="vi-VN">
+              <a:rPr lang="vi-VN" sz="2600" b="1" i="0">
                 <a:solidFill>
                   <a:srgbClr val="3F6B52"/>
                 </a:solidFill>
@@ -8995,13 +10118,13 @@
           <a:noFill/>
         </p:spPr>
         <p:txBody>
-          <a:bodyPr wrap="square" lIns="0" rIns="0" tIns="0" bIns="0">
+          <a:bodyPr wrap="square" lIns="0" tIns="0" rIns="0" bIns="0">
             <a:spAutoFit/>
           </a:bodyPr>
           <a:lstStyle/>
           <a:p>
             <a:r>
-              <a:rPr sz="1200" b="0" i="0" lang="vi-VN">
+              <a:rPr lang="vi-VN" sz="1200" b="0" i="0">
                 <a:solidFill>
                   <a:srgbClr val="595959"/>
                 </a:solidFill>
@@ -9029,13 +10152,13 @@
           <a:noFill/>
         </p:spPr>
         <p:txBody>
-          <a:bodyPr wrap="square" lIns="0" rIns="0" tIns="0" bIns="0">
+          <a:bodyPr wrap="square" lIns="0" tIns="0" rIns="0" bIns="0">
             <a:spAutoFit/>
           </a:bodyPr>
           <a:lstStyle/>
           <a:p>
             <a:r>
-              <a:rPr sz="2600" b="1" i="0" lang="vi-VN">
+              <a:rPr lang="vi-VN" sz="2600" b="1" i="0">
                 <a:solidFill>
                   <a:srgbClr val="3F6B52"/>
                 </a:solidFill>
@@ -9063,13 +10186,13 @@
           <a:noFill/>
         </p:spPr>
         <p:txBody>
-          <a:bodyPr wrap="square" lIns="0" rIns="0" tIns="0" bIns="0">
+          <a:bodyPr wrap="square" lIns="0" tIns="0" rIns="0" bIns="0">
             <a:spAutoFit/>
           </a:bodyPr>
           <a:lstStyle/>
           <a:p>
             <a:r>
-              <a:rPr sz="1200" b="0" i="0" lang="vi-VN">
+              <a:rPr lang="vi-VN" sz="1200" b="0" i="0">
                 <a:solidFill>
                   <a:srgbClr val="595959"/>
                 </a:solidFill>
@@ -9097,13 +10220,13 @@
           <a:noFill/>
         </p:spPr>
         <p:txBody>
-          <a:bodyPr wrap="square" lIns="0" rIns="0" tIns="0" bIns="0">
+          <a:bodyPr wrap="square" lIns="0" tIns="0" rIns="0" bIns="0">
             <a:spAutoFit/>
           </a:bodyPr>
           <a:lstStyle/>
           <a:p>
             <a:r>
-              <a:rPr sz="2600" b="1" i="0" lang="vi-VN">
+              <a:rPr lang="vi-VN" sz="2600" b="1" i="0">
                 <a:solidFill>
                   <a:srgbClr val="3F6B52"/>
                 </a:solidFill>
@@ -9131,13 +10254,13 @@
           <a:noFill/>
         </p:spPr>
         <p:txBody>
-          <a:bodyPr wrap="square" lIns="0" rIns="0" tIns="0" bIns="0">
+          <a:bodyPr wrap="square" lIns="0" tIns="0" rIns="0" bIns="0">
             <a:spAutoFit/>
           </a:bodyPr>
           <a:lstStyle/>
           <a:p>
             <a:r>
-              <a:rPr sz="1200" b="0" i="0" lang="vi-VN">
+              <a:rPr lang="vi-VN" sz="1200" b="0" i="0">
                 <a:solidFill>
                   <a:srgbClr val="595959"/>
                 </a:solidFill>
@@ -9165,13 +10288,13 @@
           <a:noFill/>
         </p:spPr>
         <p:txBody>
-          <a:bodyPr wrap="square" lIns="0" rIns="0" tIns="0" bIns="0">
+          <a:bodyPr wrap="square" lIns="0" tIns="0" rIns="0" bIns="0">
             <a:spAutoFit/>
           </a:bodyPr>
           <a:lstStyle/>
           <a:p>
             <a:r>
-              <a:rPr sz="2600" b="1" i="0" lang="vi-VN">
+              <a:rPr lang="vi-VN" sz="2600" b="1" i="0">
                 <a:solidFill>
                   <a:srgbClr val="3F6B52"/>
                 </a:solidFill>
@@ -9199,13 +10322,13 @@
           <a:noFill/>
         </p:spPr>
         <p:txBody>
-          <a:bodyPr wrap="square" lIns="0" rIns="0" tIns="0" bIns="0">
+          <a:bodyPr wrap="square" lIns="0" tIns="0" rIns="0" bIns="0">
             <a:spAutoFit/>
           </a:bodyPr>
           <a:lstStyle/>
           <a:p>
             <a:r>
-              <a:rPr sz="1200" b="0" i="0" lang="vi-VN">
+              <a:rPr lang="vi-VN" sz="1200" b="0" i="0">
                 <a:solidFill>
                   <a:srgbClr val="595959"/>
                 </a:solidFill>
@@ -9230,7 +10353,7 @@
         </p:xfrm>
         <a:graphic>
           <a:graphicData uri="http://schemas.openxmlformats.org/drawingml/2006/chart">
-            <c:chart xmlns:c="http://schemas.openxmlformats.org/drawingml/2006/chart" r:id="rId3"/>
+            <c:chart xmlns:c="http://schemas.openxmlformats.org/drawingml/2006/chart" xmlns:r="http://schemas.openxmlformats.org/officeDocument/2006/relationships" r:id="rId4"/>
           </a:graphicData>
         </a:graphic>
       </p:graphicFrame>
@@ -9251,13 +10374,13 @@
           <a:noFill/>
         </p:spPr>
         <p:txBody>
-          <a:bodyPr wrap="square" lIns="0" rIns="0" tIns="0" bIns="0">
+          <a:bodyPr wrap="square" lIns="0" tIns="0" rIns="0" bIns="0">
             <a:spAutoFit/>
           </a:bodyPr>
           <a:lstStyle/>
           <a:p>
             <a:r>
-              <a:rPr sz="1100" b="0" i="1" lang="vi-VN">
+              <a:rPr lang="vi-VN" sz="1100" b="0" i="1">
                 <a:solidFill>
                   <a:srgbClr val="B84A3E"/>
                 </a:solidFill>
@@ -9607,44 +10730,44 @@
         <a:sysClr val="window" lastClr="FFFFFF"/>
       </a:lt1>
       <a:dk2>
-        <a:srgbClr val="1F497D"/>
+        <a:srgbClr val="0E2841"/>
       </a:dk2>
       <a:lt2>
-        <a:srgbClr val="EEECE1"/>
+        <a:srgbClr val="E8E8E8"/>
       </a:lt2>
       <a:accent1>
-        <a:srgbClr val="4F81BD"/>
+        <a:srgbClr val="156082"/>
       </a:accent1>
       <a:accent2>
-        <a:srgbClr val="C0504D"/>
+        <a:srgbClr val="E97132"/>
       </a:accent2>
       <a:accent3>
-        <a:srgbClr val="9BBB59"/>
+        <a:srgbClr val="196B24"/>
       </a:accent3>
       <a:accent4>
-        <a:srgbClr val="8064A2"/>
+        <a:srgbClr val="0F9ED5"/>
       </a:accent4>
       <a:accent5>
-        <a:srgbClr val="4BACC6"/>
+        <a:srgbClr val="A02B93"/>
       </a:accent5>
       <a:accent6>
-        <a:srgbClr val="F79646"/>
+        <a:srgbClr val="4EA72E"/>
       </a:accent6>
       <a:hlink>
-        <a:srgbClr val="0000FF"/>
+        <a:srgbClr val="467886"/>
       </a:hlink>
       <a:folHlink>
-        <a:srgbClr val="800080"/>
+        <a:srgbClr val="96607D"/>
       </a:folHlink>
     </a:clrScheme>
     <a:fontScheme name="Office">
       <a:majorFont>
-        <a:latin typeface="Calibri"/>
+        <a:latin typeface="Aptos Display" panose="02110004020202020204"/>
         <a:ea typeface=""/>
         <a:cs typeface=""/>
-        <a:font script="Jpan" typeface="ＭＳ Ｐゴシック"/>
+        <a:font script="Jpan" typeface="游ゴシック Light"/>
         <a:font script="Hang" typeface="맑은 고딕"/>
-        <a:font script="Hans" typeface="宋体"/>
+        <a:font script="Hans" typeface="等线 Light"/>
         <a:font script="Hant" typeface="新細明體"/>
         <a:font script="Arab" typeface="Times New Roman"/>
         <a:font script="Hebr" typeface="Times New Roman"/>
@@ -9672,14 +10795,31 @@
         <a:font script="Viet" typeface="Times New Roman"/>
         <a:font script="Uigh" typeface="Microsoft Uighur"/>
         <a:font script="Geor" typeface="Sylfaen"/>
+        <a:font script="Armn" typeface="Arial"/>
+        <a:font script="Bugi" typeface="Leelawadee UI"/>
+        <a:font script="Bopo" typeface="Microsoft JhengHei"/>
+        <a:font script="Java" typeface="Javanese Text"/>
+        <a:font script="Lisu" typeface="Segoe UI"/>
+        <a:font script="Mymr" typeface="Myanmar Text"/>
+        <a:font script="Nkoo" typeface="Ebrima"/>
+        <a:font script="Olck" typeface="Nirmala UI"/>
+        <a:font script="Osma" typeface="Ebrima"/>
+        <a:font script="Phag" typeface="Phagspa"/>
+        <a:font script="Syrn" typeface="Estrangelo Edessa"/>
+        <a:font script="Syrj" typeface="Estrangelo Edessa"/>
+        <a:font script="Syre" typeface="Estrangelo Edessa"/>
+        <a:font script="Sora" typeface="Nirmala UI"/>
+        <a:font script="Tale" typeface="Microsoft Tai Le"/>
+        <a:font script="Talu" typeface="Microsoft New Tai Lue"/>
+        <a:font script="Tfng" typeface="Ebrima"/>
       </a:majorFont>
       <a:minorFont>
-        <a:latin typeface="Calibri"/>
+        <a:latin typeface="Aptos" panose="02110004020202020204"/>
         <a:ea typeface=""/>
         <a:cs typeface=""/>
-        <a:font script="Jpan" typeface="ＭＳ Ｐゴシック"/>
+        <a:font script="Jpan" typeface="游ゴシック"/>
         <a:font script="Hang" typeface="맑은 고딕"/>
-        <a:font script="Hans" typeface="宋体"/>
+        <a:font script="Hans" typeface="等线"/>
         <a:font script="Hant" typeface="新細明體"/>
         <a:font script="Arab" typeface="Arial"/>
         <a:font script="Hebr" typeface="Arial"/>
@@ -9707,6 +10847,23 @@
         <a:font script="Viet" typeface="Arial"/>
         <a:font script="Uigh" typeface="Microsoft Uighur"/>
         <a:font script="Geor" typeface="Sylfaen"/>
+        <a:font script="Armn" typeface="Arial"/>
+        <a:font script="Bugi" typeface="Leelawadee UI"/>
+        <a:font script="Bopo" typeface="Microsoft JhengHei"/>
+        <a:font script="Java" typeface="Javanese Text"/>
+        <a:font script="Lisu" typeface="Segoe UI"/>
+        <a:font script="Mymr" typeface="Myanmar Text"/>
+        <a:font script="Nkoo" typeface="Ebrima"/>
+        <a:font script="Olck" typeface="Nirmala UI"/>
+        <a:font script="Osma" typeface="Ebrima"/>
+        <a:font script="Phag" typeface="Phagspa"/>
+        <a:font script="Syrn" typeface="Estrangelo Edessa"/>
+        <a:font script="Syrj" typeface="Estrangelo Edessa"/>
+        <a:font script="Syre" typeface="Estrangelo Edessa"/>
+        <a:font script="Sora" typeface="Nirmala UI"/>
+        <a:font script="Tale" typeface="Microsoft Tai Le"/>
+        <a:font script="Talu" typeface="Microsoft New Tai Lue"/>
+        <a:font script="Tfng" typeface="Ebrima"/>
       </a:minorFont>
     </a:fontScheme>
     <a:fmtScheme name="Office">
@@ -9718,180 +10875,136 @@
           <a:gsLst>
             <a:gs pos="0">
               <a:schemeClr val="phClr">
-                <a:tint val="50000"/>
-                <a:satMod val="300000"/>
+                <a:lumMod val="110000"/>
+                <a:satMod val="105000"/>
+                <a:tint val="67000"/>
               </a:schemeClr>
             </a:gs>
-            <a:gs pos="35000">
+            <a:gs pos="50000">
               <a:schemeClr val="phClr">
-                <a:tint val="37000"/>
-                <a:satMod val="300000"/>
+                <a:lumMod val="105000"/>
+                <a:satMod val="103000"/>
+                <a:tint val="73000"/>
               </a:schemeClr>
             </a:gs>
             <a:gs pos="100000">
               <a:schemeClr val="phClr">
-                <a:tint val="15000"/>
-                <a:satMod val="350000"/>
+                <a:lumMod val="105000"/>
+                <a:satMod val="109000"/>
+                <a:tint val="81000"/>
               </a:schemeClr>
             </a:gs>
           </a:gsLst>
-          <a:lin ang="16200000" scaled="1"/>
+          <a:lin ang="5400000" scaled="0"/>
         </a:gradFill>
         <a:gradFill rotWithShape="1">
           <a:gsLst>
             <a:gs pos="0">
               <a:schemeClr val="phClr">
-                <a:tint val="100000"/>
+                <a:satMod val="103000"/>
+                <a:lumMod val="102000"/>
+                <a:tint val="94000"/>
+              </a:schemeClr>
+            </a:gs>
+            <a:gs pos="50000">
+              <a:schemeClr val="phClr">
+                <a:satMod val="110000"/>
+                <a:lumMod val="100000"/>
                 <a:shade val="100000"/>
-                <a:satMod val="130000"/>
               </a:schemeClr>
             </a:gs>
             <a:gs pos="100000">
               <a:schemeClr val="phClr">
-                <a:tint val="50000"/>
-                <a:shade val="100000"/>
-                <a:satMod val="350000"/>
+                <a:lumMod val="99000"/>
+                <a:satMod val="120000"/>
+                <a:shade val="78000"/>
               </a:schemeClr>
             </a:gs>
           </a:gsLst>
-          <a:lin ang="16200000" scaled="0"/>
+          <a:lin ang="5400000" scaled="0"/>
         </a:gradFill>
       </a:fillStyleLst>
       <a:lnStyleLst>
-        <a:ln w="9525" cap="flat" cmpd="sng" algn="ctr">
+        <a:ln w="12700" cap="flat" cmpd="sng" algn="ctr">
           <a:solidFill>
-            <a:schemeClr val="phClr">
-              <a:shade val="95000"/>
-              <a:satMod val="105000"/>
-            </a:schemeClr>
+            <a:schemeClr val="phClr"/>
           </a:solidFill>
           <a:prstDash val="solid"/>
+          <a:miter lim="800000"/>
+        </a:ln>
+        <a:ln w="19050" cap="flat" cmpd="sng" algn="ctr">
+          <a:solidFill>
+            <a:schemeClr val="phClr"/>
+          </a:solidFill>
+          <a:prstDash val="solid"/>
+          <a:miter lim="800000"/>
         </a:ln>
         <a:ln w="25400" cap="flat" cmpd="sng" algn="ctr">
           <a:solidFill>
             <a:schemeClr val="phClr"/>
           </a:solidFill>
           <a:prstDash val="solid"/>
-        </a:ln>
-        <a:ln w="38100" cap="flat" cmpd="sng" algn="ctr">
-          <a:solidFill>
-            <a:schemeClr val="phClr"/>
-          </a:solidFill>
-          <a:prstDash val="solid"/>
+          <a:miter lim="800000"/>
         </a:ln>
       </a:lnStyleLst>
       <a:effectStyleLst>
         <a:effectStyle>
+          <a:effectLst/>
+        </a:effectStyle>
+        <a:effectStyle>
+          <a:effectLst/>
+        </a:effectStyle>
+        <a:effectStyle>
           <a:effectLst>
-            <a:outerShdw blurRad="40000" dist="20000" dir="5400000" rotWithShape="0">
+            <a:outerShdw blurRad="57150" dist="19050" dir="5400000" algn="ctr" rotWithShape="0">
               <a:srgbClr val="000000">
-                <a:alpha val="38000"/>
+                <a:alpha val="63000"/>
               </a:srgbClr>
             </a:outerShdw>
           </a:effectLst>
-        </a:effectStyle>
-        <a:effectStyle>
-          <a:effectLst>
-            <a:outerShdw blurRad="40000" dist="23000" dir="5400000" rotWithShape="0">
-              <a:srgbClr val="000000">
-                <a:alpha val="35000"/>
-              </a:srgbClr>
-            </a:outerShdw>
-          </a:effectLst>
-        </a:effectStyle>
-        <a:effectStyle>
-          <a:effectLst>
-            <a:outerShdw blurRad="40000" dist="23000" dir="5400000" rotWithShape="0">
-              <a:srgbClr val="000000">
-                <a:alpha val="35000"/>
-              </a:srgbClr>
-            </a:outerShdw>
-          </a:effectLst>
-          <a:scene3d>
-            <a:camera prst="orthographicFront">
-              <a:rot lat="0" lon="0" rev="0"/>
-            </a:camera>
-            <a:lightRig rig="threePt" dir="t">
-              <a:rot lat="0" lon="0" rev="1200000"/>
-            </a:lightRig>
-          </a:scene3d>
-          <a:sp3d>
-            <a:bevelT w="63500" h="25400"/>
-          </a:sp3d>
         </a:effectStyle>
       </a:effectStyleLst>
       <a:bgFillStyleLst>
         <a:solidFill>
           <a:schemeClr val="phClr"/>
         </a:solidFill>
+        <a:solidFill>
+          <a:schemeClr val="phClr">
+            <a:tint val="95000"/>
+            <a:satMod val="170000"/>
+          </a:schemeClr>
+        </a:solidFill>
         <a:gradFill rotWithShape="1">
           <a:gsLst>
             <a:gs pos="0">
               <a:schemeClr val="phClr">
-                <a:tint val="40000"/>
-                <a:satMod val="350000"/>
+                <a:tint val="93000"/>
+                <a:satMod val="150000"/>
+                <a:shade val="98000"/>
+                <a:lumMod val="102000"/>
               </a:schemeClr>
             </a:gs>
-            <a:gs pos="40000">
+            <a:gs pos="50000">
               <a:schemeClr val="phClr">
-                <a:tint val="45000"/>
-                <a:shade val="99000"/>
-                <a:satMod val="350000"/>
+                <a:tint val="98000"/>
+                <a:satMod val="130000"/>
+                <a:shade val="90000"/>
+                <a:lumMod val="103000"/>
               </a:schemeClr>
             </a:gs>
             <a:gs pos="100000">
               <a:schemeClr val="phClr">
-                <a:shade val="20000"/>
-                <a:satMod val="255000"/>
+                <a:shade val="63000"/>
+                <a:satMod val="120000"/>
               </a:schemeClr>
             </a:gs>
           </a:gsLst>
-          <a:path path="circle">
-            <a:fillToRect l="50000" t="-80000" r="50000" b="180000"/>
-          </a:path>
-        </a:gradFill>
-        <a:gradFill rotWithShape="1">
-          <a:gsLst>
-            <a:gs pos="0">
-              <a:schemeClr val="phClr">
-                <a:tint val="80000"/>
-                <a:satMod val="300000"/>
-              </a:schemeClr>
-            </a:gs>
-            <a:gs pos="100000">
-              <a:schemeClr val="phClr">
-                <a:shade val="30000"/>
-                <a:satMod val="200000"/>
-              </a:schemeClr>
-            </a:gs>
-          </a:gsLst>
-          <a:path path="circle">
-            <a:fillToRect l="50000" t="50000" r="50000" b="50000"/>
-          </a:path>
+          <a:lin ang="5400000" scaled="0"/>
         </a:gradFill>
       </a:bgFillStyleLst>
     </a:fmtScheme>
   </a:themeElements>
   <a:objectDefaults>
-    <a:spDef>
-      <a:spPr/>
-      <a:bodyPr/>
-      <a:lstStyle/>
-      <a:style>
-        <a:lnRef idx="1">
-          <a:schemeClr val="accent1"/>
-        </a:lnRef>
-        <a:fillRef idx="3">
-          <a:schemeClr val="accent1"/>
-        </a:fillRef>
-        <a:effectRef idx="2">
-          <a:schemeClr val="accent1"/>
-        </a:effectRef>
-        <a:fontRef idx="minor">
-          <a:schemeClr val="lt1"/>
-        </a:fontRef>
-      </a:style>
-    </a:spDef>
     <a:lnDef>
       <a:spPr/>
       <a:bodyPr/>
@@ -9913,5 +11026,10 @@
     </a:lnDef>
   </a:objectDefaults>
   <a:extraClrSchemeLst/>
+  <a:extLst>
+    <a:ext uri="{05A4C25C-085E-4340-85A3-A5531E510DB2}">
+      <thm15:themeFamily xmlns:thm15="http://schemas.microsoft.com/office/thememl/2012/main" name="Office Theme" id="{2E142A2C-CD16-42D6-873A-C26D2A0506FA}" vid="{1BDDFF52-6CD6-40A5-AB3C-68EB2F1E4D0A}"/>
+    </a:ext>
+  </a:extLst>
 </a:theme>
 </file>
</xml_diff>

<commit_message>
Show competition ratio and fill rate on slide 8 of the deck
Slide 8 becomes a two-by-two grid: the three existing lines, the
per-club fill chart, the per-club table with its competition-ratio
column, and the existing preference-rank chart. All screenshots come
from the software running the 140-student dataset, with one shared
caption marking the data as simulated. Speaker notes explain how to
read each part.

Co-Authored-By: Claude Opus 5.5 <noreply@anthropic.com>
Claude-Session: https://claude.ai/code/session_01W1TN5sV8nD2mQymMCwHHSg
</commit_message>
<xml_diff>
--- a/THUYET_TRINH_KHKT_DA_SUA_FONT.pptx
+++ b/THUYET_TRINH_KHKT_DA_SUA_FONT.pptx
@@ -870,6 +870,76 @@
           </p:cNvSpPr>
           <p:nvPr>
             <p:ph type="sldNum" sz="quarter" idx="5"/>
+          </p:nvPr>
+        </p:nvSpPr>
+        <p:spPr/>
+      </p:sp>
+    </p:spTree>
+  </p:cSld>
+  <p:clrMapOvr>
+    <a:masterClrMapping/>
+  </p:clrMapOvr>
+</p:notes>
+</file>
+
+<file path=ppt/notesSlides/notesSlide3.xml><?xml version="1.0" encoding="utf-8"?>
+<p:notes xmlns:a="http://schemas.openxmlformats.org/drawingml/2006/main" xmlns:p="http://schemas.openxmlformats.org/presentationml/2006/main" xmlns:r="http://schemas.openxmlformats.org/officeDocument/2006/relationships">
+  <p:cSld>
+    <p:spTree>
+      <p:nvGrpSpPr>
+        <p:cNvPr id="1" name=""/>
+        <p:cNvGrpSpPr/>
+        <p:nvPr/>
+      </p:nvGrpSpPr>
+      <p:grpSpPr>
+        <a:xfrm>
+          <a:off x="0" y="0"/>
+          <a:ext cx="0" cy="0"/>
+          <a:chOff x="0" y="0"/>
+          <a:chExt cx="0" cy="0"/>
+        </a:xfrm>
+      </p:grpSpPr>
+      <p:sp>
+        <p:nvSpPr>
+          <p:cNvPr id="2" name="Slide Image Placeholder 1"/>
+          <p:cNvSpPr>
+            <a:spLocks noGrp="1"/>
+          </p:cNvSpPr>
+          <p:nvPr>
+            <p:ph type="sldImg" idx="2"/>
+          </p:nvPr>
+        </p:nvSpPr>
+        <p:spPr/>
+      </p:sp>
+      <p:sp>
+        <p:nvSpPr>
+          <p:cNvPr id="3" name="Notes Placeholder 2"/>
+          <p:cNvSpPr>
+            <a:spLocks noGrp="1"/>
+          </p:cNvSpPr>
+          <p:nvPr>
+            <p:ph type="body" idx="3" sz="quarter"/>
+          </p:nvPr>
+        </p:nvSpPr>
+        <p:spPr/>
+        <p:txBody>
+          <a:bodyPr/>
+          <a:lstStyle/>
+          <a:p>
+            <a:r>
+              <a:t>Bốn góc của slide: góc trên bên trái là ba thông số phần mềm cho biết; dưới bên trái là tỉ lệ lấp đầy từng CLB, phần màu vàng là chỗ vào bằng suất dự trữ; trên bên phải là bảng theo từng CLB với cột Tỉ lệ chọi, bằng số học sinh đăng ký chia cho số chỗ, ví dụ CLB Cờ vua 67 học sinh cho 4 chỗ nên tỉ lệ chọi 16,75; dưới bên phải là số học sinh được nguyện vọng 1, 2, 3 và từ 4 trở lên. Tất cả là dữ liệu mô phỏng.</a:t>
+            </a:r>
+          </a:p>
+        </p:txBody>
+      </p:sp>
+      <p:sp>
+        <p:nvSpPr>
+          <p:cNvPr id="4" name="Slide Number Placeholder 3"/>
+          <p:cNvSpPr>
+            <a:spLocks noGrp="1"/>
+          </p:cNvSpPr>
+          <p:nvPr>
+            <p:ph type="sldNum" idx="5" sz="quarter"/>
           </p:nvPr>
         </p:nvSpPr>
         <p:spPr/>
@@ -9828,8 +9898,8 @@
         </p:nvSpPr>
         <p:spPr>
           <a:xfrm>
-            <a:off x="841248" y="1828800"/>
-            <a:ext cx="10515600" cy="2423160"/>
+            <a:off x="841248" y="1783080"/>
+            <a:ext cx="4572000" cy="1874519"/>
           </a:xfrm>
         </p:spPr>
         <p:txBody>
@@ -9843,11 +9913,11 @@
                 <a:spcPct val="110000"/>
               </a:lnSpc>
               <a:spcAft>
-                <a:spcPts val="2400"/>
+                <a:spcPts val="1000"/>
               </a:spcAft>
             </a:pPr>
             <a:r>
-              <a:rPr lang="vi-VN" sz="3200"/>
+              <a:rPr lang="vi-VN" sz="2400"/>
               <a:t>Biết rõ mức lấp đầy cụ thể</a:t>
             </a:r>
           </a:p>
@@ -9857,11 +9927,11 @@
                 <a:spcPct val="110000"/>
               </a:lnSpc>
               <a:spcAft>
-                <a:spcPts val="2400"/>
+                <a:spcPts val="1000"/>
               </a:spcAft>
             </a:pPr>
             <a:r>
-              <a:rPr lang="vi-VN" sz="3200"/>
+              <a:rPr lang="vi-VN" sz="2400"/>
               <a:t>Phân bổ nguyện vọng</a:t>
             </a:r>
             <a:endParaRPr lang="vi-VN" dirty="0"/>
@@ -9872,11 +9942,11 @@
                 <a:spcPct val="110000"/>
               </a:lnSpc>
               <a:spcAft>
-                <a:spcPts val="2400"/>
+                <a:spcPts val="1000"/>
               </a:spcAft>
             </a:pPr>
             <a:r>
-              <a:rPr lang="vi-VN" sz="3200"/>
+              <a:rPr lang="vi-VN" sz="2400"/>
               <a:t>Số học sinh cụ thể chưa có chỗ</a:t>
             </a:r>
           </a:p>
@@ -9884,7 +9954,65 @@
       </p:sp>
       <p:pic>
         <p:nvPicPr>
-          <p:cNvPr id="4" name="Picture 3" descr="el_nv.png"/>
+          <p:cNvPr id="4" name="Picture 3" descr="el_fillPanel.png"/>
+          <p:cNvPicPr>
+            <a:picLocks noChangeAspect="1"/>
+          </p:cNvPicPr>
+          <p:nvPr/>
+        </p:nvPicPr>
+        <p:blipFill>
+          <a:blip r:embed="rId3"/>
+          <a:stretch>
+            <a:fillRect/>
+          </a:stretch>
+        </p:blipFill>
+        <p:spPr>
+          <a:xfrm>
+            <a:off x="841248" y="3767328"/>
+            <a:ext cx="4480560" cy="2699506"/>
+          </a:xfrm>
+          <a:prstGeom prst="rect">
+            <a:avLst/>
+          </a:prstGeom>
+          <a:ln w="9525">
+            <a:solidFill>
+              <a:srgbClr val="D0D0D0"/>
+            </a:solidFill>
+          </a:ln>
+        </p:spPr>
+      </p:pic>
+      <p:pic>
+        <p:nvPicPr>
+          <p:cNvPr id="5" name="Picture 4" descr="el_clb_c.png"/>
+          <p:cNvPicPr>
+            <a:picLocks noChangeAspect="1"/>
+          </p:cNvPicPr>
+          <p:nvPr/>
+        </p:nvPicPr>
+        <p:blipFill>
+          <a:blip r:embed="rId4"/>
+          <a:stretch>
+            <a:fillRect/>
+          </a:stretch>
+        </p:blipFill>
+        <p:spPr>
+          <a:xfrm>
+            <a:off x="5577840" y="1783080"/>
+            <a:ext cx="5779008" cy="3016694"/>
+          </a:xfrm>
+          <a:prstGeom prst="rect">
+            <a:avLst/>
+          </a:prstGeom>
+          <a:ln w="9525">
+            <a:solidFill>
+              <a:srgbClr val="D0D0D0"/>
+            </a:solidFill>
+          </a:ln>
+        </p:spPr>
+      </p:pic>
+      <p:pic>
+        <p:nvPicPr>
+          <p:cNvPr id="6" name="Picture 5" descr="image.png"/>
           <p:cNvPicPr>
             <a:picLocks noChangeAspect="1"/>
           </p:cNvPicPr>
@@ -9898,8 +10026,8 @@
         </p:blipFill>
         <p:spPr>
           <a:xfrm>
-            <a:off x="841248" y="4572000"/>
-            <a:ext cx="5486400" cy="1732547"/>
+            <a:off x="5577840" y="4983480"/>
+            <a:ext cx="4572000" cy="1443789"/>
           </a:xfrm>
           <a:prstGeom prst="rect">
             <a:avLst/>
@@ -9913,14 +10041,14 @@
       </p:pic>
       <p:sp>
         <p:nvSpPr>
-          <p:cNvPr id="5" name="TextBox 4"/>
+          <p:cNvPr id="7" name="TextBox 6"/>
           <p:cNvSpPr txBox="1"/>
           <p:nvPr/>
         </p:nvSpPr>
         <p:spPr>
           <a:xfrm>
-            <a:off x="841248" y="6377699"/>
-            <a:ext cx="5486400" cy="274320"/>
+            <a:off x="841248" y="6492240"/>
+            <a:ext cx="10515600" cy="256032"/>
           </a:xfrm>
           <a:prstGeom prst="rect">
             <a:avLst/>
@@ -9928,19 +10056,19 @@
           <a:noFill/>
         </p:spPr>
         <p:txBody>
-          <a:bodyPr wrap="square" lIns="0" tIns="0" rIns="0" bIns="0">
+          <a:bodyPr wrap="square" lIns="0" rIns="0" tIns="0" bIns="0">
             <a:spAutoFit/>
           </a:bodyPr>
           <a:lstStyle/>
           <a:p>
             <a:r>
-              <a:rPr lang="vi-VN" sz="1200" i="1">
+              <a:rPr sz="1100" i="1" lang="vi-VN">
                 <a:solidFill>
                   <a:srgbClr val="595959"/>
                 </a:solidFill>
                 <a:latin typeface="Arial"/>
               </a:rPr>
-              <a:t>Màn hình Kết quả, bộ 140 học sinh (dữ liệu mô phỏng).</a:t>
+              <a:t>Ảnh chụp từ phần mềm, bộ 140 học sinh, 12 CLB (dữ liệu mô phỏng).</a:t>
             </a:r>
           </a:p>
         </p:txBody>

</xml_diff>

<commit_message>
Correct and back up the fairness figures on slide 10
The 1.1% line said the students' results depended on the lottery; the
measurement is narrower: for 3 of 270 students, whether they get a
place at all depends on it (more students can change club). The
'750+ indicators' line becomes the test suite, run today: 757 of 757
pass. A plain table beside the claims gives the per-dataset figures
from 200 lottery seeds, with the 5,000-student load test and a
definition of a blocking pair.

Co-Authored-By: Claude Opus 5.5 <noreply@anthropic.com>
Claude-Session: https://claude.ai/code/session_01W1TN5sV8nD2mQymMCwHHSg
</commit_message>
<xml_diff>
--- a/THUYET_TRINH_KHKT_DA_SUA_FONT.pptx
+++ b/THUYET_TRINH_KHKT_DA_SUA_FONT.pptx
@@ -928,6 +928,76 @@
           <a:p>
             <a:r>
               <a:t>Bốn góc của slide: góc trên bên trái là ba thông số phần mềm cho biết; dưới bên trái là tỉ lệ lấp đầy từng CLB, phần màu vàng là chỗ vào bằng suất dự trữ; trên bên phải là bảng theo từng CLB với cột Tỉ lệ chọi, bằng số học sinh đăng ký chia cho số chỗ, ví dụ CLB Cờ vua 67 học sinh cho 4 chỗ nên tỉ lệ chọi 16,75; dưới bên phải là số học sinh được nguyện vọng 1, 2, 3 và từ 4 trở lên. Tất cả là dữ liệu mô phỏng.</a:t>
+            </a:r>
+          </a:p>
+        </p:txBody>
+      </p:sp>
+      <p:sp>
+        <p:nvSpPr>
+          <p:cNvPr id="4" name="Slide Number Placeholder 3"/>
+          <p:cNvSpPr>
+            <a:spLocks noGrp="1"/>
+          </p:cNvSpPr>
+          <p:nvPr>
+            <p:ph type="sldNum" idx="5" sz="quarter"/>
+          </p:nvPr>
+        </p:nvSpPr>
+        <p:spPr/>
+      </p:sp>
+    </p:spTree>
+  </p:cSld>
+  <p:clrMapOvr>
+    <a:masterClrMapping/>
+  </p:clrMapOvr>
+</p:notes>
+</file>
+
+<file path=ppt/notesSlides/notesSlide4.xml><?xml version="1.0" encoding="utf-8"?>
+<p:notes xmlns:a="http://schemas.openxmlformats.org/drawingml/2006/main" xmlns:p="http://schemas.openxmlformats.org/presentationml/2006/main" xmlns:r="http://schemas.openxmlformats.org/officeDocument/2006/relationships">
+  <p:cSld>
+    <p:spTree>
+      <p:nvGrpSpPr>
+        <p:cNvPr id="1" name=""/>
+        <p:cNvGrpSpPr/>
+        <p:nvPr/>
+      </p:nvGrpSpPr>
+      <p:grpSpPr>
+        <a:xfrm>
+          <a:off x="0" y="0"/>
+          <a:ext cx="0" cy="0"/>
+          <a:chOff x="0" y="0"/>
+          <a:chExt cx="0" cy="0"/>
+        </a:xfrm>
+      </p:grpSpPr>
+      <p:sp>
+        <p:nvSpPr>
+          <p:cNvPr id="2" name="Slide Image Placeholder 1"/>
+          <p:cNvSpPr>
+            <a:spLocks noGrp="1"/>
+          </p:cNvSpPr>
+          <p:nvPr>
+            <p:ph type="sldImg" idx="2"/>
+          </p:nvPr>
+        </p:nvSpPr>
+        <p:spPr/>
+      </p:sp>
+      <p:sp>
+        <p:nvSpPr>
+          <p:cNvPr id="3" name="Notes Placeholder 2"/>
+          <p:cNvSpPr>
+            <a:spLocks noGrp="1"/>
+          </p:cNvSpPr>
+          <p:nvPr>
+            <p:ph type="body" idx="3" sz="quarter"/>
+          </p:nvPr>
+        </p:nvSpPr>
+        <p:spPr/>
+        <p:txBody>
+          <a:bodyPr/>
+          <a:lstStyle/>
+          <a:p>
+            <a:r>
+              <a:t>Bảng bên phải là bằng chứng cho hai con số bên trái. Mỗi bộ dữ liệu được chạy lại với 200 hạt giống bốc thăm khác nhau. Không lần nào có cặp phá vỡ. Trên tổng 270 học sinh, chỉ 3 học sinh có lúc có chỗ, có lúc không, tùy lần bốc thăm, tức 1,1%. Lưu ý: số học sinh có thể đổi sang CLB khác khi đổi bốc thăm thì nhiều hơn, nhưng các học sinh đó vẫn luôn có chỗ. Nguồn: du_lieu_test/SO_LIEU_DA_KIEM_CHUNG.md mục 3c, thử tải trong du_lieu_test/thu_tai, và bộ kiểm thử chạy ngày 25/09: 757 bài đều đạt.</a:t>
             </a:r>
           </a:p>
         </p:txBody>
@@ -4687,7 +4757,12 @@
             <p:ph idx="1"/>
           </p:nvPr>
         </p:nvSpPr>
-        <p:spPr/>
+        <p:spPr>
+          <a:xfrm>
+            <a:off x="841248" y="1828800"/>
+            <a:ext cx="4846320" cy="4389120"/>
+          </a:xfrm>
+        </p:spPr>
         <p:txBody>
           <a:bodyPr/>
           <a:lstStyle/>
@@ -4697,15 +4772,15 @@
                 <a:spcPct val="110000"/>
               </a:lnSpc>
               <a:spcAft>
-                <a:spcPts val="3000"/>
+                <a:spcPts val="1800"/>
               </a:spcAft>
             </a:pPr>
             <a:r>
-              <a:rPr lang="vi-VN" sz="3200" b="1"/>
+              <a:rPr lang="vi-VN" sz="2600" b="1"/>
               <a:t>0</a:t>
             </a:r>
             <a:r>
-              <a:rPr lang="vi-VN" sz="3200"/>
+              <a:rPr lang="vi-VN" sz="2600"/>
               <a:t> cặp học sinh và CLB muốn đổi kết quả</a:t>
             </a:r>
           </a:p>
@@ -4715,20 +4790,20 @@
                 <a:spcPct val="110000"/>
               </a:lnSpc>
               <a:spcAft>
-                <a:spcPts val="3000"/>
+                <a:spcPts val="1800"/>
               </a:spcAft>
             </a:pPr>
             <a:r>
-              <a:rPr lang="vi-VN" sz="3200"/>
+              <a:rPr lang="vi-VN" sz="2600"/>
               <a:t>Chỉ </a:t>
             </a:r>
             <a:r>
-              <a:rPr lang="vi-VN" sz="3200" b="1"/>
+              <a:rPr lang="vi-VN" sz="2600" b="1"/>
               <a:t>1,1%</a:t>
             </a:r>
             <a:r>
-              <a:rPr lang="vi-VN" sz="3200"/>
-              <a:t> số học sinh có kết quả phụ thuộc bốc thăm</a:t>
+              <a:rPr lang="vi-VN" sz="2600"/>
+              <a:t> số học sinh có chỗ hay không phụ thuộc bốc thăm</a:t>
             </a:r>
             <a:endParaRPr lang="vi-VN" dirty="0"/>
           </a:p>
@@ -4738,18 +4813,552 @@
                 <a:spcPct val="110000"/>
               </a:lnSpc>
               <a:spcAft>
-                <a:spcPts val="3000"/>
+                <a:spcPts val="1800"/>
               </a:spcAft>
             </a:pPr>
             <a:r>
-              <a:rPr lang="vi-VN" sz="3200" b="1"/>
-              <a:t>750+</a:t>
-            </a:r>
-            <a:r>
-              <a:rPr lang="vi-VN" sz="3200"/>
-              <a:t> chỉ báo trong phần mềm để đảm bảo phần mềm hoạt động</a:t>
+              <a:rPr lang="vi-VN" sz="2600" b="1"/>
+              <a:t>757</a:t>
+            </a:r>
+            <a:r>
+              <a:rPr lang="vi-VN" sz="2600"/>
+              <a:t> bài kiểm thử tự động đều đạt, đảm bảo phần mềm hoạt động đúng</a:t>
             </a:r>
             <a:endParaRPr lang="vi-VN" dirty="0"/>
+          </a:p>
+        </p:txBody>
+      </p:sp>
+      <p:sp>
+        <p:nvSpPr>
+          <p:cNvPr id="4" name="TextBox 3"/>
+          <p:cNvSpPr txBox="1"/>
+          <p:nvPr/>
+        </p:nvSpPr>
+        <p:spPr>
+          <a:xfrm>
+            <a:off x="5989320" y="1828800"/>
+            <a:ext cx="5367528" cy="365760"/>
+          </a:xfrm>
+          <a:prstGeom prst="rect">
+            <a:avLst/>
+          </a:prstGeom>
+          <a:noFill/>
+        </p:spPr>
+        <p:txBody>
+          <a:bodyPr wrap="square" lIns="0" rIns="0" tIns="0" bIns="0">
+            <a:spAutoFit/>
+          </a:bodyPr>
+          <a:lstStyle/>
+          <a:p>
+            <a:r>
+              <a:rPr sz="1600" b="1" i="0" lang="vi-VN">
+                <a:solidFill>
+                  <a:srgbClr val="1F1F1F"/>
+                </a:solidFill>
+                <a:latin typeface="Arial"/>
+              </a:rPr>
+              <a:t>Đổi số bốc thăm 200 lần trên mỗi bộ dữ liệu</a:t>
+            </a:r>
+          </a:p>
+        </p:txBody>
+      </p:sp>
+      <p:graphicFrame>
+        <p:nvGraphicFramePr>
+          <p:cNvPr id="5" name="Table 4"/>
+          <p:cNvGraphicFramePr>
+            <a:graphicFrameLocks noGrp="1"/>
+          </p:cNvGraphicFramePr>
+          <p:nvPr/>
+        </p:nvGraphicFramePr>
+        <p:xfrm>
+          <a:off x="5989320" y="2286000"/>
+          <a:ext cx="5367528" cy="2011680"/>
+        </p:xfrm>
+        <a:graphic>
+          <a:graphicData uri="http://schemas.openxmlformats.org/drawingml/2006/table">
+            <a:tbl>
+              <a:tblPr firstRow="0" bandRow="0">
+                <a:tableStyleId>{5940675A-B579-460E-94D1-54222C63F5DA}</a:tableStyleId>
+              </a:tblPr>
+              <a:tblGrid>
+                <a:gridCol w="1481328"/>
+                <a:gridCol w="868680"/>
+                <a:gridCol w="1234440"/>
+                <a:gridCol w="1783080"/>
+              </a:tblGrid>
+              <a:tr h="402336">
+                <a:tc>
+                  <a:txBody>
+                    <a:bodyPr/>
+                    <a:lstStyle/>
+                    <a:p>
+                      <a:pPr algn="l"/>
+                      <a:r>
+                        <a:rPr sz="1400" b="1" lang="vi-VN">
+                          <a:solidFill>
+                            <a:srgbClr val="1F1F1F"/>
+                          </a:solidFill>
+                        </a:rPr>
+                        <a:t>Bộ dữ liệu</a:t>
+                      </a:r>
+                    </a:p>
+                  </a:txBody>
+                  <a:tcPr marL="73152" marR="73152"/>
+                </a:tc>
+                <a:tc>
+                  <a:txBody>
+                    <a:bodyPr/>
+                    <a:lstStyle/>
+                    <a:p>
+                      <a:pPr algn="r"/>
+                      <a:r>
+                        <a:rPr sz="1400" b="1" lang="vi-VN">
+                          <a:solidFill>
+                            <a:srgbClr val="1F1F1F"/>
+                          </a:solidFill>
+                        </a:rPr>
+                        <a:t>Học sinh</a:t>
+                      </a:r>
+                    </a:p>
+                  </a:txBody>
+                  <a:tcPr marL="73152" marR="73152"/>
+                </a:tc>
+                <a:tc>
+                  <a:txBody>
+                    <a:bodyPr/>
+                    <a:lstStyle/>
+                    <a:p>
+                      <a:pPr algn="r"/>
+                      <a:r>
+                        <a:rPr sz="1400" b="1" lang="vi-VN">
+                          <a:solidFill>
+                            <a:srgbClr val="1F1F1F"/>
+                          </a:solidFill>
+                        </a:rPr>
+                        <a:t>Cặp phá vỡ</a:t>
+                      </a:r>
+                    </a:p>
+                  </a:txBody>
+                  <a:tcPr marL="73152" marR="73152"/>
+                </a:tc>
+                <a:tc>
+                  <a:txBody>
+                    <a:bodyPr/>
+                    <a:lstStyle/>
+                    <a:p>
+                      <a:pPr algn="r"/>
+                      <a:r>
+                        <a:rPr sz="1400" b="1" lang="vi-VN">
+                          <a:solidFill>
+                            <a:srgbClr val="1F1F1F"/>
+                          </a:solidFill>
+                        </a:rPr>
+                        <a:t>Phụ thuộc bốc thăm</a:t>
+                      </a:r>
+                    </a:p>
+                  </a:txBody>
+                  <a:tcPr marL="73152" marR="73152"/>
+                </a:tc>
+              </a:tr>
+              <a:tr h="402336">
+                <a:tc>
+                  <a:txBody>
+                    <a:bodyPr/>
+                    <a:lstStyle/>
+                    <a:p>
+                      <a:pPr algn="l"/>
+                      <a:r>
+                        <a:rPr sz="1400" b="0" lang="vi-VN">
+                          <a:solidFill>
+                            <a:srgbClr val="1F1F1F"/>
+                          </a:solidFill>
+                        </a:rPr>
+                        <a:t>Bộ ví dụ</a:t>
+                      </a:r>
+                    </a:p>
+                  </a:txBody>
+                  <a:tcPr marL="73152" marR="73152"/>
+                </a:tc>
+                <a:tc>
+                  <a:txBody>
+                    <a:bodyPr/>
+                    <a:lstStyle/>
+                    <a:p>
+                      <a:pPr algn="r"/>
+                      <a:r>
+                        <a:rPr sz="1400" b="0" lang="vi-VN">
+                          <a:solidFill>
+                            <a:srgbClr val="1F1F1F"/>
+                          </a:solidFill>
+                        </a:rPr>
+                        <a:t>10</a:t>
+                      </a:r>
+                    </a:p>
+                  </a:txBody>
+                  <a:tcPr marL="73152" marR="73152"/>
+                </a:tc>
+                <a:tc>
+                  <a:txBody>
+                    <a:bodyPr/>
+                    <a:lstStyle/>
+                    <a:p>
+                      <a:pPr algn="r"/>
+                      <a:r>
+                        <a:rPr sz="1400" b="0" lang="vi-VN">
+                          <a:solidFill>
+                            <a:srgbClr val="1F1F1F"/>
+                          </a:solidFill>
+                        </a:rPr>
+                        <a:t>0</a:t>
+                      </a:r>
+                    </a:p>
+                  </a:txBody>
+                  <a:tcPr marL="73152" marR="73152"/>
+                </a:tc>
+                <a:tc>
+                  <a:txBody>
+                    <a:bodyPr/>
+                    <a:lstStyle/>
+                    <a:p>
+                      <a:pPr algn="r"/>
+                      <a:r>
+                        <a:rPr sz="1400" b="0" lang="vi-VN">
+                          <a:solidFill>
+                            <a:srgbClr val="1F1F1F"/>
+                          </a:solidFill>
+                        </a:rPr>
+                        <a:t>0</a:t>
+                      </a:r>
+                    </a:p>
+                  </a:txBody>
+                  <a:tcPr marL="73152" marR="73152"/>
+                </a:tc>
+              </a:tr>
+              <a:tr h="402336">
+                <a:tc>
+                  <a:txBody>
+                    <a:bodyPr/>
+                    <a:lstStyle/>
+                    <a:p>
+                      <a:pPr algn="l"/>
+                      <a:r>
+                        <a:rPr sz="1400" b="0" lang="vi-VN">
+                          <a:solidFill>
+                            <a:srgbClr val="1F1F1F"/>
+                          </a:solidFill>
+                        </a:rPr>
+                        <a:t>Bộ 140 học sinh</a:t>
+                      </a:r>
+                    </a:p>
+                  </a:txBody>
+                  <a:tcPr marL="73152" marR="73152"/>
+                </a:tc>
+                <a:tc>
+                  <a:txBody>
+                    <a:bodyPr/>
+                    <a:lstStyle/>
+                    <a:p>
+                      <a:pPr algn="r"/>
+                      <a:r>
+                        <a:rPr sz="1400" b="0" lang="vi-VN">
+                          <a:solidFill>
+                            <a:srgbClr val="1F1F1F"/>
+                          </a:solidFill>
+                        </a:rPr>
+                        <a:t>140</a:t>
+                      </a:r>
+                    </a:p>
+                  </a:txBody>
+                  <a:tcPr marL="73152" marR="73152"/>
+                </a:tc>
+                <a:tc>
+                  <a:txBody>
+                    <a:bodyPr/>
+                    <a:lstStyle/>
+                    <a:p>
+                      <a:pPr algn="r"/>
+                      <a:r>
+                        <a:rPr sz="1400" b="0" lang="vi-VN">
+                          <a:solidFill>
+                            <a:srgbClr val="1F1F1F"/>
+                          </a:solidFill>
+                        </a:rPr>
+                        <a:t>0</a:t>
+                      </a:r>
+                    </a:p>
+                  </a:txBody>
+                  <a:tcPr marL="73152" marR="73152"/>
+                </a:tc>
+                <a:tc>
+                  <a:txBody>
+                    <a:bodyPr/>
+                    <a:lstStyle/>
+                    <a:p>
+                      <a:pPr algn="r"/>
+                      <a:r>
+                        <a:rPr sz="1400" b="0" lang="vi-VN">
+                          <a:solidFill>
+                            <a:srgbClr val="1F1F1F"/>
+                          </a:solidFill>
+                        </a:rPr>
+                        <a:t>1</a:t>
+                      </a:r>
+                    </a:p>
+                  </a:txBody>
+                  <a:tcPr marL="73152" marR="73152"/>
+                </a:tc>
+              </a:tr>
+              <a:tr h="402336">
+                <a:tc>
+                  <a:txBody>
+                    <a:bodyPr/>
+                    <a:lstStyle/>
+                    <a:p>
+                      <a:pPr algn="l"/>
+                      <a:r>
+                        <a:rPr sz="1400" b="0" lang="vi-VN">
+                          <a:solidFill>
+                            <a:srgbClr val="1F1F1F"/>
+                          </a:solidFill>
+                        </a:rPr>
+                        <a:t>Bộ 120 học sinh</a:t>
+                      </a:r>
+                    </a:p>
+                  </a:txBody>
+                  <a:tcPr marL="73152" marR="73152"/>
+                </a:tc>
+                <a:tc>
+                  <a:txBody>
+                    <a:bodyPr/>
+                    <a:lstStyle/>
+                    <a:p>
+                      <a:pPr algn="r"/>
+                      <a:r>
+                        <a:rPr sz="1400" b="0" lang="vi-VN">
+                          <a:solidFill>
+                            <a:srgbClr val="1F1F1F"/>
+                          </a:solidFill>
+                        </a:rPr>
+                        <a:t>120</a:t>
+                      </a:r>
+                    </a:p>
+                  </a:txBody>
+                  <a:tcPr marL="73152" marR="73152"/>
+                </a:tc>
+                <a:tc>
+                  <a:txBody>
+                    <a:bodyPr/>
+                    <a:lstStyle/>
+                    <a:p>
+                      <a:pPr algn="r"/>
+                      <a:r>
+                        <a:rPr sz="1400" b="0" lang="vi-VN">
+                          <a:solidFill>
+                            <a:srgbClr val="1F1F1F"/>
+                          </a:solidFill>
+                        </a:rPr>
+                        <a:t>0</a:t>
+                      </a:r>
+                    </a:p>
+                  </a:txBody>
+                  <a:tcPr marL="73152" marR="73152"/>
+                </a:tc>
+                <a:tc>
+                  <a:txBody>
+                    <a:bodyPr/>
+                    <a:lstStyle/>
+                    <a:p>
+                      <a:pPr algn="r"/>
+                      <a:r>
+                        <a:rPr sz="1400" b="0" lang="vi-VN">
+                          <a:solidFill>
+                            <a:srgbClr val="1F1F1F"/>
+                          </a:solidFill>
+                        </a:rPr>
+                        <a:t>2</a:t>
+                      </a:r>
+                    </a:p>
+                  </a:txBody>
+                  <a:tcPr marL="73152" marR="73152"/>
+                </a:tc>
+              </a:tr>
+              <a:tr h="402336">
+                <a:tc>
+                  <a:txBody>
+                    <a:bodyPr/>
+                    <a:lstStyle/>
+                    <a:p>
+                      <a:pPr algn="l"/>
+                      <a:r>
+                        <a:rPr sz="1400" b="1" lang="vi-VN">
+                          <a:solidFill>
+                            <a:srgbClr val="1F1F1F"/>
+                          </a:solidFill>
+                        </a:rPr>
+                        <a:t>Tổng</a:t>
+                      </a:r>
+                    </a:p>
+                  </a:txBody>
+                  <a:tcPr marL="73152" marR="73152"/>
+                </a:tc>
+                <a:tc>
+                  <a:txBody>
+                    <a:bodyPr/>
+                    <a:lstStyle/>
+                    <a:p>
+                      <a:pPr algn="r"/>
+                      <a:r>
+                        <a:rPr sz="1400" b="1" lang="vi-VN">
+                          <a:solidFill>
+                            <a:srgbClr val="1F1F1F"/>
+                          </a:solidFill>
+                        </a:rPr>
+                        <a:t>270</a:t>
+                      </a:r>
+                    </a:p>
+                  </a:txBody>
+                  <a:tcPr marL="73152" marR="73152"/>
+                </a:tc>
+                <a:tc>
+                  <a:txBody>
+                    <a:bodyPr/>
+                    <a:lstStyle/>
+                    <a:p>
+                      <a:pPr algn="r"/>
+                      <a:r>
+                        <a:rPr sz="1400" b="1" lang="vi-VN">
+                          <a:solidFill>
+                            <a:srgbClr val="1F1F1F"/>
+                          </a:solidFill>
+                        </a:rPr>
+                        <a:t>0</a:t>
+                      </a:r>
+                    </a:p>
+                  </a:txBody>
+                  <a:tcPr marL="73152" marR="73152"/>
+                </a:tc>
+                <a:tc>
+                  <a:txBody>
+                    <a:bodyPr/>
+                    <a:lstStyle/>
+                    <a:p>
+                      <a:pPr algn="r"/>
+                      <a:r>
+                        <a:rPr sz="1400" b="1" lang="vi-VN">
+                          <a:solidFill>
+                            <a:srgbClr val="1F1F1F"/>
+                          </a:solidFill>
+                        </a:rPr>
+                        <a:t>3 (1,1%)</a:t>
+                      </a:r>
+                    </a:p>
+                  </a:txBody>
+                  <a:tcPr marL="73152" marR="73152"/>
+                </a:tc>
+              </a:tr>
+            </a:tbl>
+          </a:graphicData>
+        </a:graphic>
+      </p:graphicFrame>
+      <p:sp>
+        <p:nvSpPr>
+          <p:cNvPr id="6" name="TextBox 5"/>
+          <p:cNvSpPr txBox="1"/>
+          <p:nvPr/>
+        </p:nvSpPr>
+        <p:spPr>
+          <a:xfrm>
+            <a:off x="5989320" y="4526280"/>
+            <a:ext cx="5367528" cy="365760"/>
+          </a:xfrm>
+          <a:prstGeom prst="rect">
+            <a:avLst/>
+          </a:prstGeom>
+          <a:noFill/>
+        </p:spPr>
+        <p:txBody>
+          <a:bodyPr wrap="square" lIns="0" rIns="0" tIns="0" bIns="0">
+            <a:spAutoFit/>
+          </a:bodyPr>
+          <a:lstStyle/>
+          <a:p>
+            <a:r>
+              <a:rPr sz="1500" b="0" i="0" lang="vi-VN">
+                <a:solidFill>
+                  <a:srgbClr val="1F1F1F"/>
+                </a:solidFill>
+                <a:latin typeface="Arial"/>
+              </a:rPr>
+              <a:t>Thử tải 5 000 học sinh, 100 CLB: 0 cặp phá vỡ.</a:t>
+            </a:r>
+          </a:p>
+        </p:txBody>
+      </p:sp>
+      <p:sp>
+        <p:nvSpPr>
+          <p:cNvPr id="7" name="TextBox 6"/>
+          <p:cNvSpPr txBox="1"/>
+          <p:nvPr/>
+        </p:nvSpPr>
+        <p:spPr>
+          <a:xfrm>
+            <a:off x="5989320" y="4937760"/>
+            <a:ext cx="5367528" cy="365760"/>
+          </a:xfrm>
+          <a:prstGeom prst="rect">
+            <a:avLst/>
+          </a:prstGeom>
+          <a:noFill/>
+        </p:spPr>
+        <p:txBody>
+          <a:bodyPr wrap="square" lIns="0" rIns="0" tIns="0" bIns="0">
+            <a:spAutoFit/>
+          </a:bodyPr>
+          <a:lstStyle/>
+          <a:p>
+            <a:r>
+              <a:rPr sz="1500" b="0" i="0" lang="vi-VN">
+                <a:solidFill>
+                  <a:srgbClr val="1F1F1F"/>
+                </a:solidFill>
+                <a:latin typeface="Arial"/>
+              </a:rPr>
+              <a:t>Bộ kiểm thử: 757/757 bài đạt.</a:t>
+            </a:r>
+          </a:p>
+        </p:txBody>
+      </p:sp>
+      <p:sp>
+        <p:nvSpPr>
+          <p:cNvPr id="8" name="TextBox 7"/>
+          <p:cNvSpPr txBox="1"/>
+          <p:nvPr/>
+        </p:nvSpPr>
+        <p:spPr>
+          <a:xfrm>
+            <a:off x="5989320" y="5669280"/>
+            <a:ext cx="5367528" cy="548640"/>
+          </a:xfrm>
+          <a:prstGeom prst="rect">
+            <a:avLst/>
+          </a:prstGeom>
+          <a:noFill/>
+        </p:spPr>
+        <p:txBody>
+          <a:bodyPr wrap="square" lIns="0" rIns="0" tIns="0" bIns="0">
+            <a:spAutoFit/>
+          </a:bodyPr>
+          <a:lstStyle/>
+          <a:p>
+            <a:r>
+              <a:rPr sz="1200" b="0" i="1" lang="vi-VN">
+                <a:solidFill>
+                  <a:srgbClr val="595959"/>
+                </a:solidFill>
+                <a:latin typeface="Arial"/>
+              </a:rPr>
+              <a:t>Cặp phá vỡ: một học sinh và một CLB cùng muốn bỏ kết quả để chọn nhau. Số đo trên dữ liệu mô phỏng.</a:t>
+            </a:r>
           </a:p>
         </p:txBody>
       </p:sp>

</xml_diff>

<commit_message>
Add a glossary slide after the contents slide of the deck
New slide 3 explains the twelve technical terms the deck uses, in two
plain two-column tables: deferred acceptance, preference, tentative
holding, the two tiers, lottery number, reserved places, blocking pair,
stable result, competition ratio, fill rate, simulated data and
automated tests. Definitions match how the software behaves. Later
slides shift down by one.

Co-Authored-By: Claude Opus 5.5 <noreply@anthropic.com>
Claude-Session: https://claude.ai/code/session_01W1TN5sV8nD2mQymMCwHHSg
</commit_message>
<xml_diff>
--- a/THUYET_TRINH_KHKT_DA_SUA_FONT.pptx
+++ b/THUYET_TRINH_KHKT_DA_SUA_FONT.pptx
@@ -10,6 +10,7 @@
   <p:sldIdLst>
     <p:sldId id="256" r:id="rId2"/>
     <p:sldId id="257" r:id="rId3"/>
+    <p:sldId id="269" r:id="rId20"/>
     <p:sldId id="258" r:id="rId4"/>
     <p:sldId id="259" r:id="rId5"/>
     <p:sldId id="261" r:id="rId6"/>
@@ -998,6 +999,76 @@
           <a:p>
             <a:r>
               <a:t>Bảng bên phải là bằng chứng cho hai con số bên trái. Mỗi bộ dữ liệu được chạy lại với 200 hạt giống bốc thăm khác nhau. Không lần nào có cặp phá vỡ. Trên tổng 270 học sinh, chỉ 3 học sinh có lúc có chỗ, có lúc không, tùy lần bốc thăm, tức 1,1%. Lưu ý: số học sinh có thể đổi sang CLB khác khi đổi bốc thăm thì nhiều hơn, nhưng các học sinh đó vẫn luôn có chỗ. Nguồn: du_lieu_test/SO_LIEU_DA_KIEM_CHUNG.md mục 3c, thử tải trong du_lieu_test/thu_tai, và bộ kiểm thử chạy ngày 25/09: 757 bài đều đạt.</a:t>
+            </a:r>
+          </a:p>
+        </p:txBody>
+      </p:sp>
+      <p:sp>
+        <p:nvSpPr>
+          <p:cNvPr id="4" name="Slide Number Placeholder 3"/>
+          <p:cNvSpPr>
+            <a:spLocks noGrp="1"/>
+          </p:cNvSpPr>
+          <p:nvPr>
+            <p:ph type="sldNum" idx="5" sz="quarter"/>
+          </p:nvPr>
+        </p:nvSpPr>
+        <p:spPr/>
+      </p:sp>
+    </p:spTree>
+  </p:cSld>
+  <p:clrMapOvr>
+    <a:masterClrMapping/>
+  </p:clrMapOvr>
+</p:notes>
+</file>
+
+<file path=ppt/notesSlides/notesSlide5.xml><?xml version="1.0" encoding="utf-8"?>
+<p:notes xmlns:a="http://schemas.openxmlformats.org/drawingml/2006/main" xmlns:p="http://schemas.openxmlformats.org/presentationml/2006/main" xmlns:r="http://schemas.openxmlformats.org/officeDocument/2006/relationships">
+  <p:cSld>
+    <p:spTree>
+      <p:nvGrpSpPr>
+        <p:cNvPr id="1" name=""/>
+        <p:cNvGrpSpPr/>
+        <p:nvPr/>
+      </p:nvGrpSpPr>
+      <p:grpSpPr>
+        <a:xfrm>
+          <a:off x="0" y="0"/>
+          <a:ext cx="0" cy="0"/>
+          <a:chOff x="0" y="0"/>
+          <a:chExt cx="0" cy="0"/>
+        </a:xfrm>
+      </p:grpSpPr>
+      <p:sp>
+        <p:nvSpPr>
+          <p:cNvPr id="2" name="Slide Image Placeholder 1"/>
+          <p:cNvSpPr>
+            <a:spLocks noGrp="1"/>
+          </p:cNvSpPr>
+          <p:nvPr>
+            <p:ph type="sldImg" idx="2"/>
+          </p:nvPr>
+        </p:nvSpPr>
+        <p:spPr/>
+      </p:sp>
+      <p:sp>
+        <p:nvSpPr>
+          <p:cNvPr id="3" name="Notes Placeholder 2"/>
+          <p:cNvSpPr>
+            <a:spLocks noGrp="1"/>
+          </p:cNvSpPr>
+          <p:nvPr>
+            <p:ph type="body" idx="3" sz="quarter"/>
+          </p:nvPr>
+        </p:nvSpPr>
+        <p:spPr/>
+        <p:txBody>
+          <a:bodyPr/>
+          <a:lstStyle/>
+          <a:p>
+            <a:r>
+              <a:t>Slide này để người nghe tra lại khi gặp từ lạ ở các slide sau. Không cần đọc hết; chỉ nhấn vào cặp phá vỡ, kết quả ổn định và số bốc thăm.</a:t>
             </a:r>
           </a:p>
         </p:txBody>
@@ -6525,6 +6596,602 @@
       <p:bldP spid="2" grpId="0"/>
     </p:bldLst>
   </p:timing>
+</p:sld>
+</file>
+
+<file path=ppt/slides/slide14.xml><?xml version="1.0" encoding="utf-8"?>
+<p:sld xmlns:a="http://schemas.openxmlformats.org/drawingml/2006/main" xmlns:p="http://schemas.openxmlformats.org/presentationml/2006/main" xmlns:r="http://schemas.openxmlformats.org/officeDocument/2006/relationships">
+  <p:cSld>
+    <p:spTree>
+      <p:nvGrpSpPr>
+        <p:cNvPr id="1" name=""/>
+        <p:cNvGrpSpPr/>
+        <p:nvPr/>
+      </p:nvGrpSpPr>
+      <p:grpSpPr/>
+      <p:sp>
+        <p:nvSpPr>
+          <p:cNvPr id="2" name="Title 1"/>
+          <p:cNvSpPr>
+            <a:spLocks noGrp="1"/>
+          </p:cNvSpPr>
+          <p:nvPr>
+            <p:ph type="title"/>
+          </p:nvPr>
+        </p:nvSpPr>
+        <p:spPr/>
+        <p:txBody>
+          <a:bodyPr/>
+          <a:lstStyle/>
+          <a:p>
+            <a:r>
+              <a:rPr lang="vi-VN"/>
+              <a:t>Giải nghĩa thuật ngữ</a:t>
+            </a:r>
+          </a:p>
+        </p:txBody>
+      </p:sp>
+      <p:graphicFrame>
+        <p:nvGraphicFramePr>
+          <p:cNvPr id="3" name="Table 2"/>
+          <p:cNvGraphicFramePr>
+            <a:graphicFrameLocks noGrp="1"/>
+          </p:cNvGraphicFramePr>
+          <p:nvPr/>
+        </p:nvGraphicFramePr>
+        <p:xfrm>
+          <a:off x="841248" y="1783080"/>
+          <a:ext cx="5166360" cy="2194560"/>
+        </p:xfrm>
+        <a:graphic>
+          <a:graphicData uri="http://schemas.openxmlformats.org/drawingml/2006/table">
+            <a:tbl>
+              <a:tblPr firstRow="0" bandRow="0">
+                <a:tableStyleId>{5940675A-B579-460E-94D1-54222C63F5DA}</a:tableStyleId>
+              </a:tblPr>
+              <a:tblGrid>
+                <a:gridCol w="1600200"/>
+                <a:gridCol w="3566160"/>
+              </a:tblGrid>
+              <a:tr h="365760">
+                <a:tc>
+                  <a:txBody>
+                    <a:bodyPr/>
+                    <a:lstStyle/>
+                    <a:p>
+                      <a:r>
+                        <a:rPr sz="1500" b="1" lang="vi-VN">
+                          <a:solidFill>
+                            <a:srgbClr val="1F1F1F"/>
+                          </a:solidFill>
+                        </a:rPr>
+                        <a:t>Thuật ngữ</a:t>
+                      </a:r>
+                    </a:p>
+                  </a:txBody>
+                  <a:tcPr marL="73152" marR="73152" marT="36576" marB="36576"/>
+                </a:tc>
+                <a:tc>
+                  <a:txBody>
+                    <a:bodyPr/>
+                    <a:lstStyle/>
+                    <a:p>
+                      <a:r>
+                        <a:rPr sz="1500" b="1" lang="vi-VN">
+                          <a:solidFill>
+                            <a:srgbClr val="1F1F1F"/>
+                          </a:solidFill>
+                        </a:rPr>
+                        <a:t>Nghĩa</a:t>
+                      </a:r>
+                    </a:p>
+                  </a:txBody>
+                  <a:tcPr marL="73152" marR="73152" marT="36576" marB="36576"/>
+                </a:tc>
+              </a:tr>
+              <a:tr h="365760">
+                <a:tc>
+                  <a:txBody>
+                    <a:bodyPr/>
+                    <a:lstStyle/>
+                    <a:p>
+                      <a:r>
+                        <a:rPr sz="1500" b="1" lang="vi-VN">
+                          <a:solidFill>
+                            <a:srgbClr val="1F1F1F"/>
+                          </a:solidFill>
+                        </a:rPr>
+                        <a:t>Thuật toán chấp nhận trì hoãn</a:t>
+                      </a:r>
+                    </a:p>
+                  </a:txBody>
+                  <a:tcPr marL="73152" marR="73152" marT="36576" marB="36576"/>
+                </a:tc>
+                <a:tc>
+                  <a:txBody>
+                    <a:bodyPr/>
+                    <a:lstStyle/>
+                    <a:p>
+                      <a:r>
+                        <a:rPr sz="1500" b="0" lang="vi-VN">
+                          <a:solidFill>
+                            <a:srgbClr val="1F1F1F"/>
+                          </a:solidFill>
+                        </a:rPr>
+                        <a:t>Học sinh lần lượt nộp đơn theo nguyện vọng; CLB chỉ giữ tạm, tới cuối mới chốt. Còn gọi là thuật toán Gale-Shapley.</a:t>
+                      </a:r>
+                    </a:p>
+                  </a:txBody>
+                  <a:tcPr marL="73152" marR="73152" marT="36576" marB="36576"/>
+                </a:tc>
+              </a:tr>
+              <a:tr h="365760">
+                <a:tc>
+                  <a:txBody>
+                    <a:bodyPr/>
+                    <a:lstStyle/>
+                    <a:p>
+                      <a:r>
+                        <a:rPr sz="1500" b="1" lang="vi-VN">
+                          <a:solidFill>
+                            <a:srgbClr val="1F1F1F"/>
+                          </a:solidFill>
+                        </a:rPr>
+                        <a:t>Nguyện vọng (NV)</a:t>
+                      </a:r>
+                    </a:p>
+                  </a:txBody>
+                  <a:tcPr marL="73152" marR="73152" marT="36576" marB="36576"/>
+                </a:tc>
+                <a:tc>
+                  <a:txBody>
+                    <a:bodyPr/>
+                    <a:lstStyle/>
+                    <a:p>
+                      <a:r>
+                        <a:rPr sz="1500" b="0" lang="vi-VN">
+                          <a:solidFill>
+                            <a:srgbClr val="1F1F1F"/>
+                          </a:solidFill>
+                        </a:rPr>
+                        <a:t>Thứ tự các CLB học sinh muốn vào. NV1 là CLB học sinh thích nhất.</a:t>
+                      </a:r>
+                    </a:p>
+                  </a:txBody>
+                  <a:tcPr marL="73152" marR="73152" marT="36576" marB="36576"/>
+                </a:tc>
+              </a:tr>
+              <a:tr h="365760">
+                <a:tc>
+                  <a:txBody>
+                    <a:bodyPr/>
+                    <a:lstStyle/>
+                    <a:p>
+                      <a:r>
+                        <a:rPr sz="1500" b="1" lang="vi-VN">
+                          <a:solidFill>
+                            <a:srgbClr val="1F1F1F"/>
+                          </a:solidFill>
+                        </a:rPr>
+                        <a:t>Giữ tạm</a:t>
+                      </a:r>
+                    </a:p>
+                  </a:txBody>
+                  <a:tcPr marL="73152" marR="73152" marT="36576" marB="36576"/>
+                </a:tc>
+                <a:tc>
+                  <a:txBody>
+                    <a:bodyPr/>
+                    <a:lstStyle/>
+                    <a:p>
+                      <a:r>
+                        <a:rPr sz="1500" b="0" lang="vi-VN">
+                          <a:solidFill>
+                            <a:srgbClr val="1F1F1F"/>
+                          </a:solidFill>
+                        </a:rPr>
+                        <a:t>CLB tạm nhận những học sinh phù hợp nhất đang có, và có thể đổi sang người phù hợp hơn đến sau.</a:t>
+                      </a:r>
+                    </a:p>
+                  </a:txBody>
+                  <a:tcPr marL="73152" marR="73152" marT="36576" marB="36576"/>
+                </a:tc>
+              </a:tr>
+              <a:tr h="365760">
+                <a:tc>
+                  <a:txBody>
+                    <a:bodyPr/>
+                    <a:lstStyle/>
+                    <a:p>
+                      <a:r>
+                        <a:rPr sz="1500" b="1" lang="vi-VN">
+                          <a:solidFill>
+                            <a:srgbClr val="1F1F1F"/>
+                          </a:solidFill>
+                        </a:rPr>
+                        <a:t>Tầng 1, Tầng 2</a:t>
+                      </a:r>
+                    </a:p>
+                  </a:txBody>
+                  <a:tcPr marL="73152" marR="73152" marT="36576" marB="36576"/>
+                </a:tc>
+                <a:tc>
+                  <a:txBody>
+                    <a:bodyPr/>
+                    <a:lstStyle/>
+                    <a:p>
+                      <a:r>
+                        <a:rPr sz="1500" b="0" lang="vi-VN">
+                          <a:solidFill>
+                            <a:srgbClr val="1F1F1F"/>
+                          </a:solidFill>
+                        </a:rPr>
+                        <a:t>Tầng 1: học sinh đã thi CLB đó, xếp theo điểm. Tầng 2: học sinh không thi, xếp theo số bốc thăm, luôn đứng sau Tầng 1.</a:t>
+                      </a:r>
+                    </a:p>
+                  </a:txBody>
+                  <a:tcPr marL="73152" marR="73152" marT="36576" marB="36576"/>
+                </a:tc>
+              </a:tr>
+              <a:tr h="365760">
+                <a:tc>
+                  <a:txBody>
+                    <a:bodyPr/>
+                    <a:lstStyle/>
+                    <a:p>
+                      <a:r>
+                        <a:rPr sz="1500" b="1" lang="vi-VN">
+                          <a:solidFill>
+                            <a:srgbClr val="1F1F1F"/>
+                          </a:solidFill>
+                        </a:rPr>
+                        <a:t>Số bốc thăm</a:t>
+                      </a:r>
+                    </a:p>
+                  </a:txBody>
+                  <a:tcPr marL="73152" marR="73152" marT="36576" marB="36576"/>
+                </a:tc>
+                <a:tc>
+                  <a:txBody>
+                    <a:bodyPr/>
+                    <a:lstStyle/>
+                    <a:p>
+                      <a:r>
+                        <a:rPr sz="1500" b="0" lang="vi-VN">
+                          <a:solidFill>
+                            <a:srgbClr val="1F1F1F"/>
+                          </a:solidFill>
+                        </a:rPr>
+                        <a:t>Số ngẫu nhiên mỗi học sinh nhận, chỉ dùng khi hai học sinh ngang nhau. Bốc xong là khóa lại.</a:t>
+                      </a:r>
+                    </a:p>
+                  </a:txBody>
+                  <a:tcPr marL="73152" marR="73152" marT="36576" marB="36576"/>
+                </a:tc>
+              </a:tr>
+            </a:tbl>
+          </a:graphicData>
+        </a:graphic>
+      </p:graphicFrame>
+      <p:graphicFrame>
+        <p:nvGraphicFramePr>
+          <p:cNvPr id="4" name="Table 3"/>
+          <p:cNvGraphicFramePr>
+            <a:graphicFrameLocks noGrp="1"/>
+          </p:cNvGraphicFramePr>
+          <p:nvPr/>
+        </p:nvGraphicFramePr>
+        <p:xfrm>
+          <a:off x="6190488" y="1783080"/>
+          <a:ext cx="5166360" cy="2926080"/>
+        </p:xfrm>
+        <a:graphic>
+          <a:graphicData uri="http://schemas.openxmlformats.org/drawingml/2006/table">
+            <a:tbl>
+              <a:tblPr firstRow="0" bandRow="0">
+                <a:tableStyleId>{5940675A-B579-460E-94D1-54222C63F5DA}</a:tableStyleId>
+              </a:tblPr>
+              <a:tblGrid>
+                <a:gridCol w="1600200"/>
+                <a:gridCol w="3566160"/>
+              </a:tblGrid>
+              <a:tr h="365760">
+                <a:tc>
+                  <a:txBody>
+                    <a:bodyPr/>
+                    <a:lstStyle/>
+                    <a:p>
+                      <a:r>
+                        <a:rPr sz="1500" b="1" lang="vi-VN">
+                          <a:solidFill>
+                            <a:srgbClr val="1F1F1F"/>
+                          </a:solidFill>
+                        </a:rPr>
+                        <a:t>Thuật ngữ</a:t>
+                      </a:r>
+                    </a:p>
+                  </a:txBody>
+                  <a:tcPr marL="73152" marR="73152" marT="36576" marB="36576"/>
+                </a:tc>
+                <a:tc>
+                  <a:txBody>
+                    <a:bodyPr/>
+                    <a:lstStyle/>
+                    <a:p>
+                      <a:r>
+                        <a:rPr sz="1500" b="1" lang="vi-VN">
+                          <a:solidFill>
+                            <a:srgbClr val="1F1F1F"/>
+                          </a:solidFill>
+                        </a:rPr>
+                        <a:t>Nghĩa</a:t>
+                      </a:r>
+                    </a:p>
+                  </a:txBody>
+                  <a:tcPr marL="73152" marR="73152" marT="36576" marB="36576"/>
+                </a:tc>
+              </a:tr>
+              <a:tr h="365760">
+                <a:tc>
+                  <a:txBody>
+                    <a:bodyPr/>
+                    <a:lstStyle/>
+                    <a:p>
+                      <a:r>
+                        <a:rPr sz="1500" b="1" lang="vi-VN">
+                          <a:solidFill>
+                            <a:srgbClr val="1F1F1F"/>
+                          </a:solidFill>
+                        </a:rPr>
+                        <a:t>Suất dự trữ</a:t>
+                      </a:r>
+                    </a:p>
+                  </a:txBody>
+                  <a:tcPr marL="73152" marR="73152" marT="36576" marB="36576"/>
+                </a:tc>
+                <a:tc>
+                  <a:txBody>
+                    <a:bodyPr/>
+                    <a:lstStyle/>
+                    <a:p>
+                      <a:r>
+                        <a:rPr sz="1500" b="0" lang="vi-VN">
+                          <a:solidFill>
+                            <a:srgbClr val="1F1F1F"/>
+                          </a:solidFill>
+                        </a:rPr>
+                        <a:t>Chỗ CLB dành trước cho một nhóm ưu tiên. Không dùng hết thì trả lại cho xét chung.</a:t>
+                      </a:r>
+                    </a:p>
+                  </a:txBody>
+                  <a:tcPr marL="73152" marR="73152" marT="36576" marB="36576"/>
+                </a:tc>
+              </a:tr>
+              <a:tr h="365760">
+                <a:tc>
+                  <a:txBody>
+                    <a:bodyPr/>
+                    <a:lstStyle/>
+                    <a:p>
+                      <a:r>
+                        <a:rPr sz="1500" b="1" lang="vi-VN">
+                          <a:solidFill>
+                            <a:srgbClr val="1F1F1F"/>
+                          </a:solidFill>
+                        </a:rPr>
+                        <a:t>Cặp phá vỡ</a:t>
+                      </a:r>
+                    </a:p>
+                  </a:txBody>
+                  <a:tcPr marL="73152" marR="73152" marT="36576" marB="36576"/>
+                </a:tc>
+                <a:tc>
+                  <a:txBody>
+                    <a:bodyPr/>
+                    <a:lstStyle/>
+                    <a:p>
+                      <a:r>
+                        <a:rPr sz="1500" b="0" lang="vi-VN">
+                          <a:solidFill>
+                            <a:srgbClr val="1F1F1F"/>
+                          </a:solidFill>
+                        </a:rPr>
+                        <a:t>Một học sinh và một CLB cùng muốn bỏ kết quả hiện tại để chọn nhau.</a:t>
+                      </a:r>
+                    </a:p>
+                  </a:txBody>
+                  <a:tcPr marL="73152" marR="73152" marT="36576" marB="36576"/>
+                </a:tc>
+              </a:tr>
+              <a:tr h="365760">
+                <a:tc>
+                  <a:txBody>
+                    <a:bodyPr/>
+                    <a:lstStyle/>
+                    <a:p>
+                      <a:r>
+                        <a:rPr sz="1500" b="1" lang="vi-VN">
+                          <a:solidFill>
+                            <a:srgbClr val="1F1F1F"/>
+                          </a:solidFill>
+                        </a:rPr>
+                        <a:t>Kết quả ổn định</a:t>
+                      </a:r>
+                    </a:p>
+                  </a:txBody>
+                  <a:tcPr marL="73152" marR="73152" marT="36576" marB="36576"/>
+                </a:tc>
+                <a:tc>
+                  <a:txBody>
+                    <a:bodyPr/>
+                    <a:lstStyle/>
+                    <a:p>
+                      <a:r>
+                        <a:rPr sz="1500" b="0" lang="vi-VN">
+                          <a:solidFill>
+                            <a:srgbClr val="1F1F1F"/>
+                          </a:solidFill>
+                        </a:rPr>
+                        <a:t>Kết quả không có cặp phá vỡ nào.</a:t>
+                      </a:r>
+                    </a:p>
+                  </a:txBody>
+                  <a:tcPr marL="73152" marR="73152" marT="36576" marB="36576"/>
+                </a:tc>
+              </a:tr>
+              <a:tr h="365760">
+                <a:tc>
+                  <a:txBody>
+                    <a:bodyPr/>
+                    <a:lstStyle/>
+                    <a:p>
+                      <a:r>
+                        <a:rPr sz="1500" b="1" lang="vi-VN">
+                          <a:solidFill>
+                            <a:srgbClr val="1F1F1F"/>
+                          </a:solidFill>
+                        </a:rPr>
+                        <a:t>Tỉ lệ chọi</a:t>
+                      </a:r>
+                    </a:p>
+                  </a:txBody>
+                  <a:tcPr marL="73152" marR="73152" marT="36576" marB="36576"/>
+                </a:tc>
+                <a:tc>
+                  <a:txBody>
+                    <a:bodyPr/>
+                    <a:lstStyle/>
+                    <a:p>
+                      <a:r>
+                        <a:rPr sz="1500" b="0" lang="vi-VN">
+                          <a:solidFill>
+                            <a:srgbClr val="1F1F1F"/>
+                          </a:solidFill>
+                        </a:rPr>
+                        <a:t>Số học sinh đăng ký một CLB chia cho số chỗ của CLB đó.</a:t>
+                      </a:r>
+                    </a:p>
+                  </a:txBody>
+                  <a:tcPr marL="73152" marR="73152" marT="36576" marB="36576"/>
+                </a:tc>
+              </a:tr>
+              <a:tr h="365760">
+                <a:tc>
+                  <a:txBody>
+                    <a:bodyPr/>
+                    <a:lstStyle/>
+                    <a:p>
+                      <a:r>
+                        <a:rPr sz="1500" b="1" lang="vi-VN">
+                          <a:solidFill>
+                            <a:srgbClr val="1F1F1F"/>
+                          </a:solidFill>
+                        </a:rPr>
+                        <a:t>Mức lấp đầy</a:t>
+                      </a:r>
+                    </a:p>
+                  </a:txBody>
+                  <a:tcPr marL="73152" marR="73152" marT="36576" marB="36576"/>
+                </a:tc>
+                <a:tc>
+                  <a:txBody>
+                    <a:bodyPr/>
+                    <a:lstStyle/>
+                    <a:p>
+                      <a:r>
+                        <a:rPr sz="1500" b="0" lang="vi-VN">
+                          <a:solidFill>
+                            <a:srgbClr val="1F1F1F"/>
+                          </a:solidFill>
+                        </a:rPr>
+                        <a:t>Số chỗ đã xếp so với tổng số chỗ của CLB.</a:t>
+                      </a:r>
+                    </a:p>
+                  </a:txBody>
+                  <a:tcPr marL="73152" marR="73152" marT="36576" marB="36576"/>
+                </a:tc>
+              </a:tr>
+              <a:tr h="365760">
+                <a:tc>
+                  <a:txBody>
+                    <a:bodyPr/>
+                    <a:lstStyle/>
+                    <a:p>
+                      <a:r>
+                        <a:rPr sz="1500" b="1" lang="vi-VN">
+                          <a:solidFill>
+                            <a:srgbClr val="1F1F1F"/>
+                          </a:solidFill>
+                        </a:rPr>
+                        <a:t>Dữ liệu mô phỏng</a:t>
+                      </a:r>
+                    </a:p>
+                  </a:txBody>
+                  <a:tcPr marL="73152" marR="73152" marT="36576" marB="36576"/>
+                </a:tc>
+                <a:tc>
+                  <a:txBody>
+                    <a:bodyPr/>
+                    <a:lstStyle/>
+                    <a:p>
+                      <a:r>
+                        <a:rPr sz="1500" b="0" lang="vi-VN">
+                          <a:solidFill>
+                            <a:srgbClr val="1F1F1F"/>
+                          </a:solidFill>
+                        </a:rPr>
+                        <a:t>Dữ liệu do máy tạo ra để thử phần mềm, không phải học sinh thật.</a:t>
+                      </a:r>
+                    </a:p>
+                  </a:txBody>
+                  <a:tcPr marL="73152" marR="73152" marT="36576" marB="36576"/>
+                </a:tc>
+              </a:tr>
+              <a:tr h="365760">
+                <a:tc>
+                  <a:txBody>
+                    <a:bodyPr/>
+                    <a:lstStyle/>
+                    <a:p>
+                      <a:r>
+                        <a:rPr sz="1500" b="1" lang="vi-VN">
+                          <a:solidFill>
+                            <a:srgbClr val="1F1F1F"/>
+                          </a:solidFill>
+                        </a:rPr>
+                        <a:t>Bài kiểm thử tự động</a:t>
+                      </a:r>
+                    </a:p>
+                  </a:txBody>
+                  <a:tcPr marL="73152" marR="73152" marT="36576" marB="36576"/>
+                </a:tc>
+                <a:tc>
+                  <a:txBody>
+                    <a:bodyPr/>
+                    <a:lstStyle/>
+                    <a:p>
+                      <a:r>
+                        <a:rPr sz="1500" b="0" lang="vi-VN">
+                          <a:solidFill>
+                            <a:srgbClr val="1F1F1F"/>
+                          </a:solidFill>
+                        </a:rPr>
+                        <a:t>Chương trình nhỏ tự kiểm tra xem phần mềm có cho ra đúng kết quả mong đợi không.</a:t>
+                      </a:r>
+                    </a:p>
+                  </a:txBody>
+                  <a:tcPr marL="73152" marR="73152" marT="36576" marB="36576"/>
+                </a:tc>
+              </a:tr>
+            </a:tbl>
+          </a:graphicData>
+        </a:graphic>
+      </p:graphicFrame>
+    </p:spTree>
+  </p:cSld>
+  <p:clrMapOvr>
+    <a:masterClrMapping/>
+  </p:clrMapOvr>
 </p:sld>
 </file>
 

</xml_diff>

<commit_message>
Lay out the future-directions slide of the deck in two columns
The student's two future directions keep their exact wording and move
from a small bullet list into two numbered columns with a thin divider,
in the deck's plain black-and-white style. The student's added slides
had been typed in decomposed Unicode again; the whole deck is
normalised to precomposed text so tone marks cannot drift.

Co-Authored-By: Claude Opus 5.5 <noreply@anthropic.com>
Claude-Session: https://claude.ai/code/session_01W1TN5sV8nD2mQymMCwHHSg
</commit_message>
<xml_diff>
--- a/THUYET_TRINH_KHKT_DA_SUA_FONT.pptx
+++ b/THUYET_TRINH_KHKT_DA_SUA_FONT.pptx
@@ -6212,210 +6212,253 @@
           <a:lstStyle/>
           <a:p>
             <a:r>
-              <a:rPr lang="en-US" dirty="0" err="1"/>
-              <a:t>Định</a:t>
-            </a:r>
-            <a:r>
-              <a:rPr lang="en-US" dirty="0"/>
-              <a:t> </a:t>
-            </a:r>
-            <a:r>
-              <a:rPr lang="en-US" dirty="0" err="1"/>
-              <a:t>hướng</a:t>
-            </a:r>
-            <a:r>
-              <a:rPr lang="en-US" dirty="0"/>
-              <a:t> </a:t>
-            </a:r>
-            <a:r>
-              <a:rPr lang="en-US" dirty="0" err="1"/>
-              <a:t>tương</a:t>
-            </a:r>
-            <a:r>
-              <a:rPr lang="en-US" dirty="0"/>
-              <a:t> lai </a:t>
-            </a:r>
-          </a:p>
-        </p:txBody>
-      </p:sp>
-      <p:sp>
-        <p:nvSpPr>
-          <p:cNvPr id="3" name="Content Placeholder 2">
-            <a:extLst>
-              <a:ext uri="{FF2B5EF4-FFF2-40B4-BE49-F238E27FC236}">
-                <a16:creationId xmlns:a16="http://schemas.microsoft.com/office/drawing/2014/main" id="{C0ACB314-224B-9617-34CA-CA0897CAC418}"/>
-              </a:ext>
-            </a:extLst>
-          </p:cNvPr>
-          <p:cNvSpPr>
-            <a:spLocks noGrp="1"/>
-          </p:cNvSpPr>
-          <p:nvPr>
-            <p:ph idx="1"/>
-          </p:nvPr>
-        </p:nvSpPr>
-        <p:spPr/>
-        <p:txBody>
-          <a:bodyPr/>
+              <a:rPr lang="vi-VN"/>
+              <a:t>Định hướng tương lai </a:t>
+            </a:r>
+          </a:p>
+        </p:txBody>
+      </p:sp>
+      <p:sp>
+        <p:nvSpPr>
+          <p:cNvPr id="3" name="TextBox 2"/>
+          <p:cNvSpPr txBox="1"/>
+          <p:nvPr/>
+        </p:nvSpPr>
+        <p:spPr>
+          <a:xfrm>
+            <a:off x="841248" y="2148840"/>
+            <a:ext cx="4937760" cy="914400"/>
+          </a:xfrm>
+          <a:prstGeom prst="rect">
+            <a:avLst/>
+          </a:prstGeom>
+          <a:noFill/>
+        </p:spPr>
+        <p:txBody>
+          <a:bodyPr wrap="square" anchor="t" lIns="0" rIns="0" tIns="0" bIns="0">
+            <a:spAutoFit/>
+          </a:bodyPr>
           <a:lstStyle/>
           <a:p>
             <a:r>
-              <a:rPr lang="en-US" dirty="0" err="1"/>
-              <a:t>Cải</a:t>
-            </a:r>
-            <a:r>
-              <a:rPr lang="en-US" dirty="0"/>
-              <a:t> </a:t>
-            </a:r>
-            <a:r>
-              <a:rPr lang="en-US" dirty="0" err="1"/>
-              <a:t>thiện</a:t>
-            </a:r>
-            <a:r>
-              <a:rPr lang="en-US" dirty="0"/>
-              <a:t> </a:t>
-            </a:r>
-            <a:r>
-              <a:rPr lang="en-US" dirty="0" err="1"/>
-              <a:t>tương</a:t>
-            </a:r>
-            <a:r>
-              <a:rPr lang="en-US" dirty="0"/>
-              <a:t> </a:t>
-            </a:r>
-            <a:r>
-              <a:rPr lang="en-US" dirty="0" err="1"/>
-              <a:t>tác</a:t>
-            </a:r>
-            <a:r>
-              <a:rPr lang="en-US" dirty="0"/>
-              <a:t> </a:t>
-            </a:r>
-            <a:r>
-              <a:rPr lang="en-US" dirty="0" err="1"/>
-              <a:t>với</a:t>
-            </a:r>
-            <a:r>
-              <a:rPr lang="en-US" dirty="0"/>
-              <a:t> </a:t>
-            </a:r>
-            <a:r>
-              <a:rPr lang="en-US" dirty="0" err="1"/>
-              <a:t>người</a:t>
-            </a:r>
-            <a:r>
-              <a:rPr lang="en-US" dirty="0"/>
-              <a:t> </a:t>
-            </a:r>
-            <a:r>
-              <a:rPr lang="en-US" dirty="0" err="1"/>
-              <a:t>dùng</a:t>
-            </a:r>
-            <a:endParaRPr lang="en-US" dirty="0"/>
-          </a:p>
-          <a:p>
-            <a:r>
-              <a:rPr lang="en-US" dirty="0" err="1"/>
-              <a:t>Nghiên</a:t>
-            </a:r>
-            <a:r>
-              <a:rPr lang="en-US" dirty="0"/>
-              <a:t> </a:t>
-            </a:r>
-            <a:r>
-              <a:rPr lang="en-US" dirty="0" err="1"/>
-              <a:t>cứu</a:t>
-            </a:r>
-            <a:r>
-              <a:rPr lang="en-US" dirty="0"/>
-              <a:t> </a:t>
-            </a:r>
-            <a:r>
-              <a:rPr lang="en-US" dirty="0" err="1"/>
-              <a:t>thay</a:t>
-            </a:r>
-            <a:r>
-              <a:rPr lang="en-US" dirty="0"/>
-              <a:t> </a:t>
-            </a:r>
-            <a:r>
-              <a:rPr lang="en-US" dirty="0" err="1"/>
-              <a:t>đổi</a:t>
-            </a:r>
-            <a:r>
-              <a:rPr lang="en-US" dirty="0"/>
-              <a:t> </a:t>
-            </a:r>
-            <a:r>
-              <a:rPr lang="en-US" dirty="0" err="1"/>
-              <a:t>xét</a:t>
-            </a:r>
-            <a:r>
-              <a:rPr lang="en-US" dirty="0"/>
-              <a:t> </a:t>
-            </a:r>
-            <a:r>
-              <a:rPr lang="en-US" dirty="0" err="1"/>
-              <a:t>bằng</a:t>
-            </a:r>
-            <a:r>
-              <a:rPr lang="en-US" dirty="0"/>
-              <a:t> </a:t>
-            </a:r>
-            <a:r>
-              <a:rPr lang="en-US" dirty="0" err="1"/>
-              <a:t>sô</a:t>
-            </a:r>
-            <a:r>
-              <a:rPr lang="en-US" dirty="0"/>
-              <a:t>́ </a:t>
-            </a:r>
-            <a:r>
-              <a:rPr lang="en-US" dirty="0" err="1"/>
-              <a:t>bốc</a:t>
-            </a:r>
-            <a:r>
-              <a:rPr lang="en-US" dirty="0"/>
-              <a:t> </a:t>
-            </a:r>
-            <a:r>
-              <a:rPr lang="en-US" dirty="0" err="1"/>
-              <a:t>thăm</a:t>
-            </a:r>
-            <a:r>
-              <a:rPr lang="en-US" dirty="0"/>
-              <a:t> </a:t>
-            </a:r>
-            <a:r>
-              <a:rPr lang="en-US" dirty="0" err="1"/>
-              <a:t>bằng</a:t>
-            </a:r>
-            <a:r>
-              <a:rPr lang="en-US" dirty="0"/>
-              <a:t> </a:t>
-            </a:r>
-            <a:r>
-              <a:rPr lang="en-US" dirty="0" err="1"/>
-              <a:t>cách</a:t>
-            </a:r>
-            <a:r>
-              <a:rPr lang="en-US" dirty="0"/>
-              <a:t> </a:t>
-            </a:r>
-            <a:r>
-              <a:rPr lang="en-US" dirty="0" err="1"/>
-              <a:t>khác</a:t>
-            </a:r>
-            <a:r>
-              <a:rPr lang="en-US" dirty="0"/>
-              <a:t> </a:t>
-            </a:r>
-          </a:p>
-          <a:p>
-            <a:endParaRPr lang="en-US" dirty="0"/>
-          </a:p>
-        </p:txBody>
-      </p:sp>
+              <a:rPr sz="6000" b="1" lang="vi-VN">
+                <a:solidFill>
+                  <a:srgbClr val="1F1F1F"/>
+                </a:solidFill>
+                <a:latin typeface="Arial"/>
+              </a:rPr>
+              <a:t>01</a:t>
+            </a:r>
+          </a:p>
+        </p:txBody>
+      </p:sp>
+      <p:cxnSp>
+        <p:nvCxnSpPr>
+          <p:cNvPr id="4" name="Connector 3"/>
+          <p:cNvCxnSpPr/>
+          <p:nvPr/>
+        </p:nvCxnSpPr>
+        <p:spPr>
+          <a:xfrm>
+            <a:off x="841248" y="3154680"/>
+            <a:ext cx="1097280" cy="0"/>
+          </a:xfrm>
+          <a:prstGeom prst="line">
+            <a:avLst/>
+          </a:prstGeom>
+          <a:ln w="25400">
+            <a:solidFill>
+              <a:srgbClr val="1F1F1F"/>
+            </a:solidFill>
+          </a:ln>
+        </p:spPr>
+        <p:style>
+          <a:lnRef idx="2">
+            <a:schemeClr val="accent1"/>
+          </a:lnRef>
+          <a:fillRef idx="0">
+            <a:schemeClr val="accent1"/>
+          </a:fillRef>
+          <a:effectRef idx="1">
+            <a:schemeClr val="accent1"/>
+          </a:effectRef>
+          <a:fontRef idx="minor">
+            <a:schemeClr val="tx1"/>
+          </a:fontRef>
+        </p:style>
+      </p:cxnSp>
+      <p:sp>
+        <p:nvSpPr>
+          <p:cNvPr id="5" name="TextBox 4"/>
+          <p:cNvSpPr txBox="1"/>
+          <p:nvPr/>
+        </p:nvSpPr>
+        <p:spPr>
+          <a:xfrm>
+            <a:off x="841248" y="3429000"/>
+            <a:ext cx="4937760" cy="2011680"/>
+          </a:xfrm>
+          <a:prstGeom prst="rect">
+            <a:avLst/>
+          </a:prstGeom>
+          <a:noFill/>
+        </p:spPr>
+        <p:txBody>
+          <a:bodyPr wrap="square" anchor="t" lIns="0" rIns="0" tIns="0" bIns="0">
+            <a:spAutoFit/>
+          </a:bodyPr>
+          <a:lstStyle/>
+          <a:p>
+            <a:r>
+              <a:rPr sz="3000" b="0" lang="vi-VN">
+                <a:solidFill>
+                  <a:srgbClr val="1F1F1F"/>
+                </a:solidFill>
+                <a:latin typeface="Arial"/>
+              </a:rPr>
+              <a:t>Cải thiện tương tác với người dùng</a:t>
+            </a:r>
+          </a:p>
+        </p:txBody>
+      </p:sp>
+      <p:sp>
+        <p:nvSpPr>
+          <p:cNvPr id="6" name="TextBox 5"/>
+          <p:cNvSpPr txBox="1"/>
+          <p:nvPr/>
+        </p:nvSpPr>
+        <p:spPr>
+          <a:xfrm>
+            <a:off x="6419088" y="2148840"/>
+            <a:ext cx="4937760" cy="914400"/>
+          </a:xfrm>
+          <a:prstGeom prst="rect">
+            <a:avLst/>
+          </a:prstGeom>
+          <a:noFill/>
+        </p:spPr>
+        <p:txBody>
+          <a:bodyPr wrap="square" anchor="t" lIns="0" rIns="0" tIns="0" bIns="0">
+            <a:spAutoFit/>
+          </a:bodyPr>
+          <a:lstStyle/>
+          <a:p>
+            <a:r>
+              <a:rPr sz="6000" b="1" lang="vi-VN">
+                <a:solidFill>
+                  <a:srgbClr val="1F1F1F"/>
+                </a:solidFill>
+                <a:latin typeface="Arial"/>
+              </a:rPr>
+              <a:t>02</a:t>
+            </a:r>
+          </a:p>
+        </p:txBody>
+      </p:sp>
+      <p:cxnSp>
+        <p:nvCxnSpPr>
+          <p:cNvPr id="7" name="Connector 6"/>
+          <p:cNvCxnSpPr/>
+          <p:nvPr/>
+        </p:nvCxnSpPr>
+        <p:spPr>
+          <a:xfrm>
+            <a:off x="6419088" y="3154680"/>
+            <a:ext cx="1097279" cy="0"/>
+          </a:xfrm>
+          <a:prstGeom prst="line">
+            <a:avLst/>
+          </a:prstGeom>
+          <a:ln w="25400">
+            <a:solidFill>
+              <a:srgbClr val="1F1F1F"/>
+            </a:solidFill>
+          </a:ln>
+        </p:spPr>
+        <p:style>
+          <a:lnRef idx="2">
+            <a:schemeClr val="accent1"/>
+          </a:lnRef>
+          <a:fillRef idx="0">
+            <a:schemeClr val="accent1"/>
+          </a:fillRef>
+          <a:effectRef idx="1">
+            <a:schemeClr val="accent1"/>
+          </a:effectRef>
+          <a:fontRef idx="minor">
+            <a:schemeClr val="tx1"/>
+          </a:fontRef>
+        </p:style>
+      </p:cxnSp>
+      <p:sp>
+        <p:nvSpPr>
+          <p:cNvPr id="8" name="TextBox 7"/>
+          <p:cNvSpPr txBox="1"/>
+          <p:nvPr/>
+        </p:nvSpPr>
+        <p:spPr>
+          <a:xfrm>
+            <a:off x="6419088" y="3429000"/>
+            <a:ext cx="4937760" cy="2011680"/>
+          </a:xfrm>
+          <a:prstGeom prst="rect">
+            <a:avLst/>
+          </a:prstGeom>
+          <a:noFill/>
+        </p:spPr>
+        <p:txBody>
+          <a:bodyPr wrap="square" anchor="t" lIns="0" rIns="0" tIns="0" bIns="0">
+            <a:spAutoFit/>
+          </a:bodyPr>
+          <a:lstStyle/>
+          <a:p>
+            <a:r>
+              <a:rPr sz="3000" b="0" lang="vi-VN">
+                <a:solidFill>
+                  <a:srgbClr val="1F1F1F"/>
+                </a:solidFill>
+                <a:latin typeface="Arial"/>
+              </a:rPr>
+              <a:t>Nghiên cứu thay đổi xét bằng số bốc thăm bằng cách khác</a:t>
+            </a:r>
+          </a:p>
+        </p:txBody>
+      </p:sp>
+      <p:cxnSp>
+        <p:nvCxnSpPr>
+          <p:cNvPr id="9" name="Connector 8"/>
+          <p:cNvCxnSpPr/>
+          <p:nvPr/>
+        </p:nvCxnSpPr>
+        <p:spPr>
+          <a:xfrm>
+            <a:off x="6099048" y="2194560"/>
+            <a:ext cx="0" cy="3200400"/>
+          </a:xfrm>
+          <a:prstGeom prst="line">
+            <a:avLst/>
+          </a:prstGeom>
+          <a:ln w="12700">
+            <a:solidFill>
+              <a:srgbClr val="BFBFBF"/>
+            </a:solidFill>
+          </a:ln>
+        </p:spPr>
+        <p:style>
+          <a:lnRef idx="2">
+            <a:schemeClr val="accent1"/>
+          </a:lnRef>
+          <a:fillRef idx="0">
+            <a:schemeClr val="accent1"/>
+          </a:fillRef>
+          <a:effectRef idx="1">
+            <a:schemeClr val="accent1"/>
+          </a:effectRef>
+          <a:fontRef idx="minor">
+            <a:schemeClr val="tx1"/>
+          </a:fontRef>
+        </p:style>
+      </p:cxnSp>
     </p:spTree>
     <p:extLst>
       <p:ext uri="{BB962C8B-B14F-4D97-AF65-F5344CB8AC3E}">
@@ -6510,7 +6553,7 @@
           <a:lstStyle/>
           <a:p>
             <a:pPr algn="ctr"/>
-            <a:endParaRPr lang="en-US"/>
+            <a:endParaRPr lang="vi-VN"/>
           </a:p>
         </p:txBody>
       </p:sp>
@@ -6543,8 +6586,8 @@
           <a:lstStyle/>
           <a:p>
             <a:r>
-              <a:rPr lang="en-US" sz="4200"/>
-              <a:t>Cảm ơn mọi người đã lắng nghe </a:t>
+              <a:rPr lang="vi-VN" sz="4200"/>
+              <a:t>Cảm ơn mọi người đã lắng nghe </a:t>
             </a:r>
           </a:p>
         </p:txBody>
@@ -6828,7 +6871,7 @@
           <a:lstStyle/>
           <a:p>
             <a:pPr algn="ctr"/>
-            <a:endParaRPr lang="en-US"/>
+            <a:endParaRPr lang="vi-VN"/>
           </a:p>
         </p:txBody>
       </p:sp>
@@ -6861,8 +6904,8 @@
           <a:lstStyle/>
           <a:p>
             <a:r>
-              <a:rPr lang="en-US" sz="2200"/>
-              <a:t>Cảm ơn mọi người đã dành thời gian </a:t>
+              <a:rPr lang="vi-VN" sz="2200"/>
+              <a:t>Cảm ơn mọi người đã dành thời gian </a:t>
             </a:r>
           </a:p>
         </p:txBody>
@@ -11772,7 +11815,7 @@
               </a:spcAft>
             </a:pPr>
             <a:r>
-              <a:rPr lang="vi-VN" sz="2000" b="1" dirty="0">
+              <a:rPr lang="vi-VN" sz="2000" b="1">
                 <a:solidFill>
                   <a:srgbClr val="1F1F1F"/>
                 </a:solidFill>
@@ -11787,7 +11830,7 @@
               </a:spcAft>
             </a:pPr>
             <a:r>
-              <a:rPr lang="vi-VN" sz="1500" b="1" dirty="0">
+              <a:rPr lang="vi-VN" sz="1500" b="1">
                 <a:solidFill>
                   <a:srgbClr val="1F1F1F"/>
                 </a:solidFill>
@@ -11795,7 +11838,7 @@
               <a:t>Nộp đơn: </a:t>
             </a:r>
             <a:r>
-              <a:rPr lang="vi-VN" sz="1500" b="0" dirty="0">
+              <a:rPr lang="vi-VN" sz="1500" b="0">
                 <a:solidFill>
                   <a:srgbClr val="1F1F1F"/>
                 </a:solidFill>
@@ -11810,7 +11853,7 @@
               </a:spcAft>
             </a:pPr>
             <a:r>
-              <a:rPr lang="vi-VN" sz="1500" b="1" dirty="0">
+              <a:rPr lang="vi-VN" sz="1500" b="1">
                 <a:solidFill>
                   <a:srgbClr val="1F1F1F"/>
                 </a:solidFill>
@@ -11818,7 +11861,7 @@
               <a:t>Xếp hạng hai tầng: </a:t>
             </a:r>
             <a:r>
-              <a:rPr lang="vi-VN" sz="1500" b="0" dirty="0">
+              <a:rPr lang="vi-VN" sz="1500" b="0">
                 <a:solidFill>
                   <a:srgbClr val="1F1F1F"/>
                 </a:solidFill>
@@ -11833,7 +11876,7 @@
               </a:spcAft>
             </a:pPr>
             <a:r>
-              <a:rPr lang="vi-VN" sz="1500" b="1" dirty="0">
+              <a:rPr lang="vi-VN" sz="1500" b="1">
                 <a:solidFill>
                   <a:srgbClr val="1F1F1F"/>
                 </a:solidFill>
@@ -11841,7 +11884,7 @@
               <a:t>Suất dự trữ: </a:t>
             </a:r>
             <a:r>
-              <a:rPr lang="vi-VN" sz="1500" b="0" dirty="0">
+              <a:rPr lang="vi-VN" sz="1500" b="0">
                 <a:solidFill>
                   <a:srgbClr val="1F1F1F"/>
                 </a:solidFill>
@@ -11856,7 +11899,7 @@
               </a:spcAft>
             </a:pPr>
             <a:r>
-              <a:rPr lang="vi-VN" sz="1500" b="1" dirty="0">
+              <a:rPr lang="vi-VN" sz="1500" b="1">
                 <a:solidFill>
                   <a:srgbClr val="1F1F1F"/>
                 </a:solidFill>
@@ -11864,7 +11907,7 @@
               <a:t>Giữ tạm: </a:t>
             </a:r>
             <a:r>
-              <a:rPr lang="vi-VN" sz="1500" b="0" dirty="0">
+              <a:rPr lang="vi-VN" sz="1500" b="0">
                 <a:solidFill>
                   <a:srgbClr val="1F1F1F"/>
                 </a:solidFill>
@@ -11879,7 +11922,7 @@
               </a:spcAft>
             </a:pPr>
             <a:r>
-              <a:rPr lang="vi-VN" sz="1500" b="1" dirty="0">
+              <a:rPr lang="vi-VN" sz="1500" b="1">
                 <a:solidFill>
                   <a:srgbClr val="1F1F1F"/>
                 </a:solidFill>
@@ -11887,7 +11930,7 @@
               <a:t>Lặp lại: </a:t>
             </a:r>
             <a:r>
-              <a:rPr lang="vi-VN" sz="1500" b="0" dirty="0">
+              <a:rPr lang="vi-VN" sz="1500" b="0">
                 <a:solidFill>
                   <a:srgbClr val="1F1F1F"/>
                 </a:solidFill>

</xml_diff>

<commit_message>
Add a 'why us' slide before future directions in the deck
Slide 13 lists the student's three reasons (a working product, a real
school problem, ready to use now) in the same three-column style as the
future-directions slide. Under each is one line of evidence taken from
the project: the passing test suite, the report's description of
first-come registration, and the offline, no-install, Excel import set-up.

Co-Authored-By: Claude Opus 5.5 <noreply@anthropic.com>
Claude-Session: https://claude.ai/code/session_01W1TN5sV8nD2mQymMCwHHSg
</commit_message>
<xml_diff>
--- a/THUYET_TRINH_KHKT_DA_SUA_FONT.pptx
+++ b/THUYET_TRINH_KHKT_DA_SUA_FONT.pptx
@@ -20,6 +20,7 @@
     <p:sldId id="263" r:id="rId10"/>
     <p:sldId id="264" r:id="rId11"/>
     <p:sldId id="265" r:id="rId12"/>
+    <p:sldId id="270" r:id="rId21"/>
     <p:sldId id="267" r:id="rId13"/>
     <p:sldId id="268" r:id="rId14"/>
   </p:sldIdLst>
@@ -1139,6 +1140,76 @@
           <a:p>
             <a:r>
               <a:t>Mỗi CLB xếp các học sinh đăng ký thành hai tầng. Tầng 1 là học sinh đã thi, xếp theo điểm; nếu bằng điểm thì ai có số bốc thăm nhỏ hơn đứng trước, như An và Hòa cùng 8 điểm. Tầng 2 là học sinh không thi, xếp theo số bốc thăm, và luôn đứng sau cả Tầng 1: Bình có số bốc thăm 3, nhỏ nhất, nhưng vẫn xếp cuối vì không thi. CLB không được biết học sinh xếp mình là nguyện vọng thứ mấy, nên học sinh không cần khai chiến thuật. Ví dụ này minh họa quy tắc, không phải dữ liệu thật.</a:t>
+            </a:r>
+          </a:p>
+        </p:txBody>
+      </p:sp>
+      <p:sp>
+        <p:nvSpPr>
+          <p:cNvPr id="4" name="Slide Number Placeholder 3"/>
+          <p:cNvSpPr>
+            <a:spLocks noGrp="1"/>
+          </p:cNvSpPr>
+          <p:nvPr>
+            <p:ph type="sldNum" idx="5" sz="quarter"/>
+          </p:nvPr>
+        </p:nvSpPr>
+        <p:spPr/>
+      </p:sp>
+    </p:spTree>
+  </p:cSld>
+  <p:clrMapOvr>
+    <a:masterClrMapping/>
+  </p:clrMapOvr>
+</p:notes>
+</file>
+
+<file path=ppt/notesSlides/notesSlide7.xml><?xml version="1.0" encoding="utf-8"?>
+<p:notes xmlns:a="http://schemas.openxmlformats.org/drawingml/2006/main" xmlns:p="http://schemas.openxmlformats.org/presentationml/2006/main" xmlns:r="http://schemas.openxmlformats.org/officeDocument/2006/relationships">
+  <p:cSld>
+    <p:spTree>
+      <p:nvGrpSpPr>
+        <p:cNvPr id="1" name=""/>
+        <p:cNvGrpSpPr/>
+        <p:nvPr/>
+      </p:nvGrpSpPr>
+      <p:grpSpPr>
+        <a:xfrm>
+          <a:off x="0" y="0"/>
+          <a:ext cx="0" cy="0"/>
+          <a:chOff x="0" y="0"/>
+          <a:chExt cx="0" cy="0"/>
+        </a:xfrm>
+      </p:grpSpPr>
+      <p:sp>
+        <p:nvSpPr>
+          <p:cNvPr id="2" name="Slide Image Placeholder 1"/>
+          <p:cNvSpPr>
+            <a:spLocks noGrp="1"/>
+          </p:cNvSpPr>
+          <p:nvPr>
+            <p:ph type="sldImg" idx="2"/>
+          </p:nvPr>
+        </p:nvSpPr>
+        <p:spPr/>
+      </p:sp>
+      <p:sp>
+        <p:nvSpPr>
+          <p:cNvPr id="3" name="Notes Placeholder 2"/>
+          <p:cNvSpPr>
+            <a:spLocks noGrp="1"/>
+          </p:cNvSpPr>
+          <p:nvPr>
+            <p:ph type="body" idx="3" sz="quarter"/>
+          </p:nvPr>
+        </p:nvSpPr>
+        <p:spPr/>
+        <p:txBody>
+          <a:bodyPr/>
+          <a:lstStyle/>
+          <a:p>
+            <a:r>
+              <a:t>Ba lý do do nhóm nêu. Dòng nhỏ dưới mỗi ý là bằng chứng lấy từ chính dự án: bộ kiểm thử chạy ngày 25/09 đạt 757/757; báo cáo mục 2.2.1 mô tả cách xếp theo thứ tự đăng ký tại trường; hướng dẫn sử dụng ghi phần mềm chạy ngoại tuyến trên Windows 10 và 11, không cần cài đặt.</a:t>
             </a:r>
           </a:p>
         </p:txBody>
@@ -7155,6 +7226,527 @@
       <p:bldP spid="2" grpId="0"/>
     </p:bldLst>
   </p:timing>
+</p:sld>
+</file>
+
+<file path=ppt/slides/slide15.xml><?xml version="1.0" encoding="utf-8"?>
+<p:sld xmlns:a="http://schemas.openxmlformats.org/drawingml/2006/main" xmlns:p="http://schemas.openxmlformats.org/presentationml/2006/main" xmlns:r="http://schemas.openxmlformats.org/officeDocument/2006/relationships">
+  <p:cSld>
+    <p:spTree>
+      <p:nvGrpSpPr>
+        <p:cNvPr id="1" name=""/>
+        <p:cNvGrpSpPr/>
+        <p:nvPr/>
+      </p:nvGrpSpPr>
+      <p:grpSpPr/>
+      <p:sp>
+        <p:nvSpPr>
+          <p:cNvPr id="2" name="Title 1"/>
+          <p:cNvSpPr>
+            <a:spLocks noGrp="1"/>
+          </p:cNvSpPr>
+          <p:nvPr>
+            <p:ph type="title"/>
+          </p:nvPr>
+        </p:nvSpPr>
+        <p:spPr/>
+        <p:txBody>
+          <a:bodyPr/>
+          <a:lstStyle/>
+          <a:p>
+            <a:r>
+              <a:rPr lang="vi-VN"/>
+              <a:t>Vì sao chọn dự án của chúng tôi</a:t>
+            </a:r>
+          </a:p>
+        </p:txBody>
+      </p:sp>
+      <p:sp>
+        <p:nvSpPr>
+          <p:cNvPr id="3" name="TextBox 2"/>
+          <p:cNvSpPr txBox="1"/>
+          <p:nvPr/>
+        </p:nvSpPr>
+        <p:spPr>
+          <a:xfrm>
+            <a:off x="841248" y="2103120"/>
+            <a:ext cx="3200400" cy="914400"/>
+          </a:xfrm>
+          <a:prstGeom prst="rect">
+            <a:avLst/>
+          </a:prstGeom>
+          <a:noFill/>
+        </p:spPr>
+        <p:txBody>
+          <a:bodyPr wrap="square" lIns="0" rIns="0" tIns="0" bIns="0">
+            <a:spAutoFit/>
+          </a:bodyPr>
+          <a:lstStyle/>
+          <a:p>
+            <a:r>
+              <a:rPr sz="6000" b="1" lang="vi-VN">
+                <a:solidFill>
+                  <a:srgbClr val="1F1F1F"/>
+                </a:solidFill>
+                <a:latin typeface="Arial"/>
+              </a:rPr>
+              <a:t>01</a:t>
+            </a:r>
+          </a:p>
+        </p:txBody>
+      </p:sp>
+      <p:cxnSp>
+        <p:nvCxnSpPr>
+          <p:cNvPr id="4" name="Connector 3"/>
+          <p:cNvCxnSpPr/>
+          <p:nvPr/>
+        </p:nvCxnSpPr>
+        <p:spPr>
+          <a:xfrm>
+            <a:off x="841248" y="3108960"/>
+            <a:ext cx="1097280" cy="0"/>
+          </a:xfrm>
+          <a:prstGeom prst="line">
+            <a:avLst/>
+          </a:prstGeom>
+          <a:ln w="25400">
+            <a:solidFill>
+              <a:srgbClr val="1F1F1F"/>
+            </a:solidFill>
+          </a:ln>
+        </p:spPr>
+        <p:style>
+          <a:lnRef idx="2">
+            <a:schemeClr val="accent1"/>
+          </a:lnRef>
+          <a:fillRef idx="0">
+            <a:schemeClr val="accent1"/>
+          </a:fillRef>
+          <a:effectRef idx="1">
+            <a:schemeClr val="accent1"/>
+          </a:effectRef>
+          <a:fontRef idx="minor">
+            <a:schemeClr val="tx1"/>
+          </a:fontRef>
+        </p:style>
+      </p:cxnSp>
+      <p:sp>
+        <p:nvSpPr>
+          <p:cNvPr id="5" name="TextBox 4"/>
+          <p:cNvSpPr txBox="1"/>
+          <p:nvPr/>
+        </p:nvSpPr>
+        <p:spPr>
+          <a:xfrm>
+            <a:off x="841248" y="3383280"/>
+            <a:ext cx="3200400" cy="1005840"/>
+          </a:xfrm>
+          <a:prstGeom prst="rect">
+            <a:avLst/>
+          </a:prstGeom>
+          <a:noFill/>
+        </p:spPr>
+        <p:txBody>
+          <a:bodyPr wrap="square" lIns="0" rIns="0" tIns="0" bIns="0">
+            <a:spAutoFit/>
+          </a:bodyPr>
+          <a:lstStyle/>
+          <a:p>
+            <a:r>
+              <a:rPr sz="2600" b="1" lang="vi-VN">
+                <a:solidFill>
+                  <a:srgbClr val="1F1F1F"/>
+                </a:solidFill>
+                <a:latin typeface="Arial"/>
+              </a:rPr>
+              <a:t>Có sản phẩm</a:t>
+            </a:r>
+          </a:p>
+        </p:txBody>
+      </p:sp>
+      <p:sp>
+        <p:nvSpPr>
+          <p:cNvPr id="6" name="TextBox 5"/>
+          <p:cNvSpPr txBox="1"/>
+          <p:nvPr/>
+        </p:nvSpPr>
+        <p:spPr>
+          <a:xfrm>
+            <a:off x="841248" y="4434840"/>
+            <a:ext cx="3200400" cy="1371600"/>
+          </a:xfrm>
+          <a:prstGeom prst="rect">
+            <a:avLst/>
+          </a:prstGeom>
+          <a:noFill/>
+        </p:spPr>
+        <p:txBody>
+          <a:bodyPr wrap="square" lIns="0" rIns="0" tIns="0" bIns="0">
+            <a:spAutoFit/>
+          </a:bodyPr>
+          <a:lstStyle/>
+          <a:p>
+            <a:r>
+              <a:rPr sz="1600" b="0" lang="vi-VN">
+                <a:solidFill>
+                  <a:srgbClr val="555555"/>
+                </a:solidFill>
+                <a:latin typeface="Arial"/>
+              </a:rPr>
+              <a:t>Phần mềm chạy được trên máy Windows; 757 bài kiểm thử tự động đều đạt.</a:t>
+            </a:r>
+          </a:p>
+        </p:txBody>
+      </p:sp>
+      <p:cxnSp>
+        <p:nvCxnSpPr>
+          <p:cNvPr id="7" name="Connector 6"/>
+          <p:cNvCxnSpPr/>
+          <p:nvPr/>
+        </p:nvCxnSpPr>
+        <p:spPr>
+          <a:xfrm>
+            <a:off x="4270248" y="2194560"/>
+            <a:ext cx="0" cy="3474720"/>
+          </a:xfrm>
+          <a:prstGeom prst="line">
+            <a:avLst/>
+          </a:prstGeom>
+          <a:ln w="12700">
+            <a:solidFill>
+              <a:srgbClr val="BFBFBF"/>
+            </a:solidFill>
+          </a:ln>
+        </p:spPr>
+        <p:style>
+          <a:lnRef idx="2">
+            <a:schemeClr val="accent1"/>
+          </a:lnRef>
+          <a:fillRef idx="0">
+            <a:schemeClr val="accent1"/>
+          </a:fillRef>
+          <a:effectRef idx="1">
+            <a:schemeClr val="accent1"/>
+          </a:effectRef>
+          <a:fontRef idx="minor">
+            <a:schemeClr val="tx1"/>
+          </a:fontRef>
+        </p:style>
+      </p:cxnSp>
+      <p:sp>
+        <p:nvSpPr>
+          <p:cNvPr id="8" name="TextBox 7"/>
+          <p:cNvSpPr txBox="1"/>
+          <p:nvPr/>
+        </p:nvSpPr>
+        <p:spPr>
+          <a:xfrm>
+            <a:off x="4498848" y="2103120"/>
+            <a:ext cx="3200400" cy="914400"/>
+          </a:xfrm>
+          <a:prstGeom prst="rect">
+            <a:avLst/>
+          </a:prstGeom>
+          <a:noFill/>
+        </p:spPr>
+        <p:txBody>
+          <a:bodyPr wrap="square" lIns="0" rIns="0" tIns="0" bIns="0">
+            <a:spAutoFit/>
+          </a:bodyPr>
+          <a:lstStyle/>
+          <a:p>
+            <a:r>
+              <a:rPr sz="6000" b="1" lang="vi-VN">
+                <a:solidFill>
+                  <a:srgbClr val="1F1F1F"/>
+                </a:solidFill>
+                <a:latin typeface="Arial"/>
+              </a:rPr>
+              <a:t>02</a:t>
+            </a:r>
+          </a:p>
+        </p:txBody>
+      </p:sp>
+      <p:cxnSp>
+        <p:nvCxnSpPr>
+          <p:cNvPr id="9" name="Connector 8"/>
+          <p:cNvCxnSpPr/>
+          <p:nvPr/>
+        </p:nvCxnSpPr>
+        <p:spPr>
+          <a:xfrm>
+            <a:off x="4498848" y="3108960"/>
+            <a:ext cx="1097280" cy="0"/>
+          </a:xfrm>
+          <a:prstGeom prst="line">
+            <a:avLst/>
+          </a:prstGeom>
+          <a:ln w="25400">
+            <a:solidFill>
+              <a:srgbClr val="1F1F1F"/>
+            </a:solidFill>
+          </a:ln>
+        </p:spPr>
+        <p:style>
+          <a:lnRef idx="2">
+            <a:schemeClr val="accent1"/>
+          </a:lnRef>
+          <a:fillRef idx="0">
+            <a:schemeClr val="accent1"/>
+          </a:fillRef>
+          <a:effectRef idx="1">
+            <a:schemeClr val="accent1"/>
+          </a:effectRef>
+          <a:fontRef idx="minor">
+            <a:schemeClr val="tx1"/>
+          </a:fontRef>
+        </p:style>
+      </p:cxnSp>
+      <p:sp>
+        <p:nvSpPr>
+          <p:cNvPr id="10" name="TextBox 9"/>
+          <p:cNvSpPr txBox="1"/>
+          <p:nvPr/>
+        </p:nvSpPr>
+        <p:spPr>
+          <a:xfrm>
+            <a:off x="4498848" y="3383280"/>
+            <a:ext cx="3200400" cy="1005840"/>
+          </a:xfrm>
+          <a:prstGeom prst="rect">
+            <a:avLst/>
+          </a:prstGeom>
+          <a:noFill/>
+        </p:spPr>
+        <p:txBody>
+          <a:bodyPr wrap="square" lIns="0" rIns="0" tIns="0" bIns="0">
+            <a:spAutoFit/>
+          </a:bodyPr>
+          <a:lstStyle/>
+          <a:p>
+            <a:r>
+              <a:rPr sz="2600" b="1" lang="vi-VN">
+                <a:solidFill>
+                  <a:srgbClr val="1F1F1F"/>
+                </a:solidFill>
+                <a:latin typeface="Arial"/>
+              </a:rPr>
+              <a:t>Giải quyết vấn đề thực tiễn</a:t>
+            </a:r>
+          </a:p>
+        </p:txBody>
+      </p:sp>
+      <p:sp>
+        <p:nvSpPr>
+          <p:cNvPr id="11" name="TextBox 10"/>
+          <p:cNvSpPr txBox="1"/>
+          <p:nvPr/>
+        </p:nvSpPr>
+        <p:spPr>
+          <a:xfrm>
+            <a:off x="4498848" y="4434840"/>
+            <a:ext cx="3200400" cy="1371600"/>
+          </a:xfrm>
+          <a:prstGeom prst="rect">
+            <a:avLst/>
+          </a:prstGeom>
+          <a:noFill/>
+        </p:spPr>
+        <p:txBody>
+          <a:bodyPr wrap="square" lIns="0" rIns="0" tIns="0" bIns="0">
+            <a:spAutoFit/>
+          </a:bodyPr>
+          <a:lstStyle/>
+          <a:p>
+            <a:r>
+              <a:rPr sz="1600" b="0" lang="vi-VN">
+                <a:solidFill>
+                  <a:srgbClr val="555555"/>
+                </a:solidFill>
+                <a:latin typeface="Arial"/>
+              </a:rPr>
+              <a:t>Thay cách xếp CLB theo thứ tự đăng ký đang dùng tại trường.</a:t>
+            </a:r>
+          </a:p>
+        </p:txBody>
+      </p:sp>
+      <p:cxnSp>
+        <p:nvCxnSpPr>
+          <p:cNvPr id="12" name="Connector 11"/>
+          <p:cNvCxnSpPr/>
+          <p:nvPr/>
+        </p:nvCxnSpPr>
+        <p:spPr>
+          <a:xfrm>
+            <a:off x="7927848" y="2194560"/>
+            <a:ext cx="0" cy="3474720"/>
+          </a:xfrm>
+          <a:prstGeom prst="line">
+            <a:avLst/>
+          </a:prstGeom>
+          <a:ln w="12700">
+            <a:solidFill>
+              <a:srgbClr val="BFBFBF"/>
+            </a:solidFill>
+          </a:ln>
+        </p:spPr>
+        <p:style>
+          <a:lnRef idx="2">
+            <a:schemeClr val="accent1"/>
+          </a:lnRef>
+          <a:fillRef idx="0">
+            <a:schemeClr val="accent1"/>
+          </a:fillRef>
+          <a:effectRef idx="1">
+            <a:schemeClr val="accent1"/>
+          </a:effectRef>
+          <a:fontRef idx="minor">
+            <a:schemeClr val="tx1"/>
+          </a:fontRef>
+        </p:style>
+      </p:cxnSp>
+      <p:sp>
+        <p:nvSpPr>
+          <p:cNvPr id="13" name="TextBox 12"/>
+          <p:cNvSpPr txBox="1"/>
+          <p:nvPr/>
+        </p:nvSpPr>
+        <p:spPr>
+          <a:xfrm>
+            <a:off x="8156448" y="2103120"/>
+            <a:ext cx="3200400" cy="914400"/>
+          </a:xfrm>
+          <a:prstGeom prst="rect">
+            <a:avLst/>
+          </a:prstGeom>
+          <a:noFill/>
+        </p:spPr>
+        <p:txBody>
+          <a:bodyPr wrap="square" lIns="0" rIns="0" tIns="0" bIns="0">
+            <a:spAutoFit/>
+          </a:bodyPr>
+          <a:lstStyle/>
+          <a:p>
+            <a:r>
+              <a:rPr sz="6000" b="1" lang="vi-VN">
+                <a:solidFill>
+                  <a:srgbClr val="1F1F1F"/>
+                </a:solidFill>
+                <a:latin typeface="Arial"/>
+              </a:rPr>
+              <a:t>03</a:t>
+            </a:r>
+          </a:p>
+        </p:txBody>
+      </p:sp>
+      <p:cxnSp>
+        <p:nvCxnSpPr>
+          <p:cNvPr id="14" name="Connector 13"/>
+          <p:cNvCxnSpPr/>
+          <p:nvPr/>
+        </p:nvCxnSpPr>
+        <p:spPr>
+          <a:xfrm>
+            <a:off x="8156448" y="3108960"/>
+            <a:ext cx="1097280" cy="0"/>
+          </a:xfrm>
+          <a:prstGeom prst="line">
+            <a:avLst/>
+          </a:prstGeom>
+          <a:ln w="25400">
+            <a:solidFill>
+              <a:srgbClr val="1F1F1F"/>
+            </a:solidFill>
+          </a:ln>
+        </p:spPr>
+        <p:style>
+          <a:lnRef idx="2">
+            <a:schemeClr val="accent1"/>
+          </a:lnRef>
+          <a:fillRef idx="0">
+            <a:schemeClr val="accent1"/>
+          </a:fillRef>
+          <a:effectRef idx="1">
+            <a:schemeClr val="accent1"/>
+          </a:effectRef>
+          <a:fontRef idx="minor">
+            <a:schemeClr val="tx1"/>
+          </a:fontRef>
+        </p:style>
+      </p:cxnSp>
+      <p:sp>
+        <p:nvSpPr>
+          <p:cNvPr id="15" name="TextBox 14"/>
+          <p:cNvSpPr txBox="1"/>
+          <p:nvPr/>
+        </p:nvSpPr>
+        <p:spPr>
+          <a:xfrm>
+            <a:off x="8156448" y="3383280"/>
+            <a:ext cx="3200400" cy="1005840"/>
+          </a:xfrm>
+          <a:prstGeom prst="rect">
+            <a:avLst/>
+          </a:prstGeom>
+          <a:noFill/>
+        </p:spPr>
+        <p:txBody>
+          <a:bodyPr wrap="square" lIns="0" rIns="0" tIns="0" bIns="0">
+            <a:spAutoFit/>
+          </a:bodyPr>
+          <a:lstStyle/>
+          <a:p>
+            <a:r>
+              <a:rPr sz="2600" b="1" lang="vi-VN">
+                <a:solidFill>
+                  <a:srgbClr val="1F1F1F"/>
+                </a:solidFill>
+                <a:latin typeface="Arial"/>
+              </a:rPr>
+              <a:t>Có thể triển khai ngay lập tức</a:t>
+            </a:r>
+          </a:p>
+        </p:txBody>
+      </p:sp>
+      <p:sp>
+        <p:nvSpPr>
+          <p:cNvPr id="16" name="TextBox 15"/>
+          <p:cNvSpPr txBox="1"/>
+          <p:nvPr/>
+        </p:nvSpPr>
+        <p:spPr>
+          <a:xfrm>
+            <a:off x="8156448" y="4434840"/>
+            <a:ext cx="3200400" cy="1371600"/>
+          </a:xfrm>
+          <a:prstGeom prst="rect">
+            <a:avLst/>
+          </a:prstGeom>
+          <a:noFill/>
+        </p:spPr>
+        <p:txBody>
+          <a:bodyPr wrap="square" lIns="0" rIns="0" tIns="0" bIns="0">
+            <a:spAutoFit/>
+          </a:bodyPr>
+          <a:lstStyle/>
+          <a:p>
+            <a:r>
+              <a:rPr sz="1600" b="0" lang="vi-VN">
+                <a:solidFill>
+                  <a:srgbClr val="555555"/>
+                </a:solidFill>
+                <a:latin typeface="Arial"/>
+              </a:rPr>
+              <a:t>Chạy ngoại tuyến, không cần cài đặt, nhập thẳng tệp Excel từ Microsoft Forms.</a:t>
+            </a:r>
+          </a:p>
+        </p:txBody>
+      </p:sp>
+    </p:spTree>
+  </p:cSld>
+  <p:clrMapOvr>
+    <a:masterClrMapping/>
+  </p:clrMapOvr>
 </p:sld>
 </file>
 

</xml_diff>

<commit_message>
Give the deck a light warm background instead of white
Slides 2 to 15 now use #F8F3ED, the cream already behind the picture on
the student's thank-you slide, so the closing slide no longer has a
white panel against a cream image. The cool grey card fills and arrows
on slides 2 to 6 are shifted to matching warm tones. The black title
slide is kept as the one dark slide.

Co-Authored-By: Claude Opus 5.5 <noreply@anthropic.com>
Claude-Session: https://claude.ai/code/session_01W1TN5sV8nD2mQymMCwHHSg
</commit_message>
<xml_diff>
--- a/THUYET_TRINH_KHKT_DA_SUA_FONT.pptx
+++ b/THUYET_TRINH_KHKT_DA_SUA_FONT.pptx
@@ -4910,6 +4910,14 @@
 <file path=ppt/slides/slide10.xml><?xml version="1.0" encoding="utf-8"?>
 <p:sld xmlns:a="http://schemas.openxmlformats.org/drawingml/2006/main" xmlns:r="http://schemas.openxmlformats.org/officeDocument/2006/relationships" xmlns:p="http://schemas.openxmlformats.org/presentationml/2006/main">
   <p:cSld>
+    <p:bg>
+      <p:bgPr>
+        <a:solidFill>
+          <a:srgbClr val="F8F3ED"/>
+        </a:solidFill>
+        <a:effectLst/>
+      </p:bgPr>
+    </p:bg>
     <p:spTree>
       <p:nvGrpSpPr>
         <p:cNvPr id="1" name=""/>
@@ -5356,6 +5364,14 @@
 <file path=ppt/slides/slide11.xml><?xml version="1.0" encoding="utf-8"?>
 <p:sld xmlns:a="http://schemas.openxmlformats.org/drawingml/2006/main" xmlns:r="http://schemas.openxmlformats.org/officeDocument/2006/relationships" xmlns:p="http://schemas.openxmlformats.org/presentationml/2006/main">
   <p:cSld>
+    <p:bg>
+      <p:bgPr>
+        <a:solidFill>
+          <a:srgbClr val="F8F3ED"/>
+        </a:solidFill>
+        <a:effectLst/>
+      </p:bgPr>
+    </p:bg>
     <p:spTree>
       <p:nvGrpSpPr>
         <p:cNvPr id="1" name=""/>
@@ -6036,6 +6052,14 @@
 <file path=ppt/slides/slide12.xml><?xml version="1.0" encoding="utf-8"?>
 <p:sld xmlns:a="http://schemas.openxmlformats.org/drawingml/2006/main" xmlns:r="http://schemas.openxmlformats.org/officeDocument/2006/relationships" xmlns:p="http://schemas.openxmlformats.org/presentationml/2006/main">
   <p:cSld>
+    <p:bg>
+      <p:bgPr>
+        <a:solidFill>
+          <a:srgbClr val="F8F3ED"/>
+        </a:solidFill>
+        <a:effectLst/>
+      </p:bgPr>
+    </p:bg>
     <p:spTree>
       <p:nvGrpSpPr>
         <p:cNvPr id="1" name=""/>
@@ -6245,8 +6269,545 @@
 </file>
 
 <file path=ppt/slides/slide13.xml><?xml version="1.0" encoding="utf-8"?>
+<p:sld xmlns:a="http://schemas.openxmlformats.org/drawingml/2006/main" xmlns:p="http://schemas.openxmlformats.org/presentationml/2006/main" xmlns:r="http://schemas.openxmlformats.org/officeDocument/2006/relationships">
+  <p:cSld>
+    <p:bg>
+      <p:bgPr>
+        <a:solidFill>
+          <a:srgbClr val="F8F3ED"/>
+        </a:solidFill>
+        <a:effectLst/>
+      </p:bgPr>
+    </p:bg>
+    <p:spTree>
+      <p:nvGrpSpPr>
+        <p:cNvPr id="1" name=""/>
+        <p:cNvGrpSpPr/>
+        <p:nvPr/>
+      </p:nvGrpSpPr>
+      <p:grpSpPr/>
+      <p:sp>
+        <p:nvSpPr>
+          <p:cNvPr id="2" name="Title 1"/>
+          <p:cNvSpPr>
+            <a:spLocks noGrp="1"/>
+          </p:cNvSpPr>
+          <p:nvPr>
+            <p:ph type="title"/>
+          </p:nvPr>
+        </p:nvSpPr>
+        <p:spPr/>
+        <p:txBody>
+          <a:bodyPr/>
+          <a:lstStyle/>
+          <a:p>
+            <a:r>
+              <a:rPr lang="vi-VN"/>
+              <a:t>Vì sao chọn dự án của chúng tôi</a:t>
+            </a:r>
+          </a:p>
+        </p:txBody>
+      </p:sp>
+      <p:sp>
+        <p:nvSpPr>
+          <p:cNvPr id="3" name="TextBox 2"/>
+          <p:cNvSpPr txBox="1"/>
+          <p:nvPr/>
+        </p:nvSpPr>
+        <p:spPr>
+          <a:xfrm>
+            <a:off x="841248" y="2103120"/>
+            <a:ext cx="3200400" cy="914400"/>
+          </a:xfrm>
+          <a:prstGeom prst="rect">
+            <a:avLst/>
+          </a:prstGeom>
+          <a:noFill/>
+        </p:spPr>
+        <p:txBody>
+          <a:bodyPr wrap="square" lIns="0" rIns="0" tIns="0" bIns="0">
+            <a:spAutoFit/>
+          </a:bodyPr>
+          <a:lstStyle/>
+          <a:p>
+            <a:r>
+              <a:rPr sz="6000" b="1" lang="vi-VN">
+                <a:solidFill>
+                  <a:srgbClr val="1F1F1F"/>
+                </a:solidFill>
+                <a:latin typeface="Arial"/>
+              </a:rPr>
+              <a:t>01</a:t>
+            </a:r>
+          </a:p>
+        </p:txBody>
+      </p:sp>
+      <p:cxnSp>
+        <p:nvCxnSpPr>
+          <p:cNvPr id="4" name="Connector 3"/>
+          <p:cNvCxnSpPr/>
+          <p:nvPr/>
+        </p:nvCxnSpPr>
+        <p:spPr>
+          <a:xfrm>
+            <a:off x="841248" y="3108960"/>
+            <a:ext cx="1097280" cy="0"/>
+          </a:xfrm>
+          <a:prstGeom prst="line">
+            <a:avLst/>
+          </a:prstGeom>
+          <a:ln w="25400">
+            <a:solidFill>
+              <a:srgbClr val="1F1F1F"/>
+            </a:solidFill>
+          </a:ln>
+        </p:spPr>
+        <p:style>
+          <a:lnRef idx="2">
+            <a:schemeClr val="accent1"/>
+          </a:lnRef>
+          <a:fillRef idx="0">
+            <a:schemeClr val="accent1"/>
+          </a:fillRef>
+          <a:effectRef idx="1">
+            <a:schemeClr val="accent1"/>
+          </a:effectRef>
+          <a:fontRef idx="minor">
+            <a:schemeClr val="tx1"/>
+          </a:fontRef>
+        </p:style>
+      </p:cxnSp>
+      <p:sp>
+        <p:nvSpPr>
+          <p:cNvPr id="5" name="TextBox 4"/>
+          <p:cNvSpPr txBox="1"/>
+          <p:nvPr/>
+        </p:nvSpPr>
+        <p:spPr>
+          <a:xfrm>
+            <a:off x="841248" y="3383280"/>
+            <a:ext cx="3200400" cy="1005840"/>
+          </a:xfrm>
+          <a:prstGeom prst="rect">
+            <a:avLst/>
+          </a:prstGeom>
+          <a:noFill/>
+        </p:spPr>
+        <p:txBody>
+          <a:bodyPr wrap="square" lIns="0" rIns="0" tIns="0" bIns="0">
+            <a:spAutoFit/>
+          </a:bodyPr>
+          <a:lstStyle/>
+          <a:p>
+            <a:r>
+              <a:rPr sz="2600" b="1" lang="vi-VN">
+                <a:solidFill>
+                  <a:srgbClr val="1F1F1F"/>
+                </a:solidFill>
+                <a:latin typeface="Arial"/>
+              </a:rPr>
+              <a:t>Có sản phẩm</a:t>
+            </a:r>
+          </a:p>
+        </p:txBody>
+      </p:sp>
+      <p:sp>
+        <p:nvSpPr>
+          <p:cNvPr id="6" name="TextBox 5"/>
+          <p:cNvSpPr txBox="1"/>
+          <p:nvPr/>
+        </p:nvSpPr>
+        <p:spPr>
+          <a:xfrm>
+            <a:off x="841248" y="4434840"/>
+            <a:ext cx="3200400" cy="1371600"/>
+          </a:xfrm>
+          <a:prstGeom prst="rect">
+            <a:avLst/>
+          </a:prstGeom>
+          <a:noFill/>
+        </p:spPr>
+        <p:txBody>
+          <a:bodyPr wrap="square" lIns="0" rIns="0" tIns="0" bIns="0">
+            <a:spAutoFit/>
+          </a:bodyPr>
+          <a:lstStyle/>
+          <a:p>
+            <a:r>
+              <a:rPr sz="1600" b="0" lang="vi-VN">
+                <a:solidFill>
+                  <a:srgbClr val="555555"/>
+                </a:solidFill>
+                <a:latin typeface="Arial"/>
+              </a:rPr>
+              <a:t>Phần mềm chạy được trên máy Windows; 757 bài kiểm thử tự động đều đạt.</a:t>
+            </a:r>
+          </a:p>
+        </p:txBody>
+      </p:sp>
+      <p:cxnSp>
+        <p:nvCxnSpPr>
+          <p:cNvPr id="7" name="Connector 6"/>
+          <p:cNvCxnSpPr/>
+          <p:nvPr/>
+        </p:nvCxnSpPr>
+        <p:spPr>
+          <a:xfrm>
+            <a:off x="4270248" y="2194560"/>
+            <a:ext cx="0" cy="3474720"/>
+          </a:xfrm>
+          <a:prstGeom prst="line">
+            <a:avLst/>
+          </a:prstGeom>
+          <a:ln w="12700">
+            <a:solidFill>
+              <a:srgbClr val="BFBFBF"/>
+            </a:solidFill>
+          </a:ln>
+        </p:spPr>
+        <p:style>
+          <a:lnRef idx="2">
+            <a:schemeClr val="accent1"/>
+          </a:lnRef>
+          <a:fillRef idx="0">
+            <a:schemeClr val="accent1"/>
+          </a:fillRef>
+          <a:effectRef idx="1">
+            <a:schemeClr val="accent1"/>
+          </a:effectRef>
+          <a:fontRef idx="minor">
+            <a:schemeClr val="tx1"/>
+          </a:fontRef>
+        </p:style>
+      </p:cxnSp>
+      <p:sp>
+        <p:nvSpPr>
+          <p:cNvPr id="8" name="TextBox 7"/>
+          <p:cNvSpPr txBox="1"/>
+          <p:nvPr/>
+        </p:nvSpPr>
+        <p:spPr>
+          <a:xfrm>
+            <a:off x="4498848" y="2103120"/>
+            <a:ext cx="3200400" cy="914400"/>
+          </a:xfrm>
+          <a:prstGeom prst="rect">
+            <a:avLst/>
+          </a:prstGeom>
+          <a:noFill/>
+        </p:spPr>
+        <p:txBody>
+          <a:bodyPr wrap="square" lIns="0" rIns="0" tIns="0" bIns="0">
+            <a:spAutoFit/>
+          </a:bodyPr>
+          <a:lstStyle/>
+          <a:p>
+            <a:r>
+              <a:rPr sz="6000" b="1" lang="vi-VN">
+                <a:solidFill>
+                  <a:srgbClr val="1F1F1F"/>
+                </a:solidFill>
+                <a:latin typeface="Arial"/>
+              </a:rPr>
+              <a:t>02</a:t>
+            </a:r>
+          </a:p>
+        </p:txBody>
+      </p:sp>
+      <p:cxnSp>
+        <p:nvCxnSpPr>
+          <p:cNvPr id="9" name="Connector 8"/>
+          <p:cNvCxnSpPr/>
+          <p:nvPr/>
+        </p:nvCxnSpPr>
+        <p:spPr>
+          <a:xfrm>
+            <a:off x="4498848" y="3108960"/>
+            <a:ext cx="1097280" cy="0"/>
+          </a:xfrm>
+          <a:prstGeom prst="line">
+            <a:avLst/>
+          </a:prstGeom>
+          <a:ln w="25400">
+            <a:solidFill>
+              <a:srgbClr val="1F1F1F"/>
+            </a:solidFill>
+          </a:ln>
+        </p:spPr>
+        <p:style>
+          <a:lnRef idx="2">
+            <a:schemeClr val="accent1"/>
+          </a:lnRef>
+          <a:fillRef idx="0">
+            <a:schemeClr val="accent1"/>
+          </a:fillRef>
+          <a:effectRef idx="1">
+            <a:schemeClr val="accent1"/>
+          </a:effectRef>
+          <a:fontRef idx="minor">
+            <a:schemeClr val="tx1"/>
+          </a:fontRef>
+        </p:style>
+      </p:cxnSp>
+      <p:sp>
+        <p:nvSpPr>
+          <p:cNvPr id="10" name="TextBox 9"/>
+          <p:cNvSpPr txBox="1"/>
+          <p:nvPr/>
+        </p:nvSpPr>
+        <p:spPr>
+          <a:xfrm>
+            <a:off x="4498848" y="3383280"/>
+            <a:ext cx="3200400" cy="1005840"/>
+          </a:xfrm>
+          <a:prstGeom prst="rect">
+            <a:avLst/>
+          </a:prstGeom>
+          <a:noFill/>
+        </p:spPr>
+        <p:txBody>
+          <a:bodyPr wrap="square" lIns="0" rIns="0" tIns="0" bIns="0">
+            <a:spAutoFit/>
+          </a:bodyPr>
+          <a:lstStyle/>
+          <a:p>
+            <a:r>
+              <a:rPr sz="2600" b="1" lang="vi-VN">
+                <a:solidFill>
+                  <a:srgbClr val="1F1F1F"/>
+                </a:solidFill>
+                <a:latin typeface="Arial"/>
+              </a:rPr>
+              <a:t>Giải quyết vấn đề thực tiễn</a:t>
+            </a:r>
+          </a:p>
+        </p:txBody>
+      </p:sp>
+      <p:sp>
+        <p:nvSpPr>
+          <p:cNvPr id="11" name="TextBox 10"/>
+          <p:cNvSpPr txBox="1"/>
+          <p:nvPr/>
+        </p:nvSpPr>
+        <p:spPr>
+          <a:xfrm>
+            <a:off x="4498848" y="4434840"/>
+            <a:ext cx="3200400" cy="1371600"/>
+          </a:xfrm>
+          <a:prstGeom prst="rect">
+            <a:avLst/>
+          </a:prstGeom>
+          <a:noFill/>
+        </p:spPr>
+        <p:txBody>
+          <a:bodyPr wrap="square" lIns="0" rIns="0" tIns="0" bIns="0">
+            <a:spAutoFit/>
+          </a:bodyPr>
+          <a:lstStyle/>
+          <a:p>
+            <a:r>
+              <a:rPr sz="1600" b="0" lang="vi-VN">
+                <a:solidFill>
+                  <a:srgbClr val="555555"/>
+                </a:solidFill>
+                <a:latin typeface="Arial"/>
+              </a:rPr>
+              <a:t>Thay cách xếp CLB theo thứ tự đăng ký đang dùng tại trường.</a:t>
+            </a:r>
+          </a:p>
+        </p:txBody>
+      </p:sp>
+      <p:cxnSp>
+        <p:nvCxnSpPr>
+          <p:cNvPr id="12" name="Connector 11"/>
+          <p:cNvCxnSpPr/>
+          <p:nvPr/>
+        </p:nvCxnSpPr>
+        <p:spPr>
+          <a:xfrm>
+            <a:off x="7927848" y="2194560"/>
+            <a:ext cx="0" cy="3474720"/>
+          </a:xfrm>
+          <a:prstGeom prst="line">
+            <a:avLst/>
+          </a:prstGeom>
+          <a:ln w="12700">
+            <a:solidFill>
+              <a:srgbClr val="BFBFBF"/>
+            </a:solidFill>
+          </a:ln>
+        </p:spPr>
+        <p:style>
+          <a:lnRef idx="2">
+            <a:schemeClr val="accent1"/>
+          </a:lnRef>
+          <a:fillRef idx="0">
+            <a:schemeClr val="accent1"/>
+          </a:fillRef>
+          <a:effectRef idx="1">
+            <a:schemeClr val="accent1"/>
+          </a:effectRef>
+          <a:fontRef idx="minor">
+            <a:schemeClr val="tx1"/>
+          </a:fontRef>
+        </p:style>
+      </p:cxnSp>
+      <p:sp>
+        <p:nvSpPr>
+          <p:cNvPr id="13" name="TextBox 12"/>
+          <p:cNvSpPr txBox="1"/>
+          <p:nvPr/>
+        </p:nvSpPr>
+        <p:spPr>
+          <a:xfrm>
+            <a:off x="8156448" y="2103120"/>
+            <a:ext cx="3200400" cy="914400"/>
+          </a:xfrm>
+          <a:prstGeom prst="rect">
+            <a:avLst/>
+          </a:prstGeom>
+          <a:noFill/>
+        </p:spPr>
+        <p:txBody>
+          <a:bodyPr wrap="square" lIns="0" rIns="0" tIns="0" bIns="0">
+            <a:spAutoFit/>
+          </a:bodyPr>
+          <a:lstStyle/>
+          <a:p>
+            <a:r>
+              <a:rPr sz="6000" b="1" lang="vi-VN">
+                <a:solidFill>
+                  <a:srgbClr val="1F1F1F"/>
+                </a:solidFill>
+                <a:latin typeface="Arial"/>
+              </a:rPr>
+              <a:t>03</a:t>
+            </a:r>
+          </a:p>
+        </p:txBody>
+      </p:sp>
+      <p:cxnSp>
+        <p:nvCxnSpPr>
+          <p:cNvPr id="14" name="Connector 13"/>
+          <p:cNvCxnSpPr/>
+          <p:nvPr/>
+        </p:nvCxnSpPr>
+        <p:spPr>
+          <a:xfrm>
+            <a:off x="8156448" y="3108960"/>
+            <a:ext cx="1097280" cy="0"/>
+          </a:xfrm>
+          <a:prstGeom prst="line">
+            <a:avLst/>
+          </a:prstGeom>
+          <a:ln w="25400">
+            <a:solidFill>
+              <a:srgbClr val="1F1F1F"/>
+            </a:solidFill>
+          </a:ln>
+        </p:spPr>
+        <p:style>
+          <a:lnRef idx="2">
+            <a:schemeClr val="accent1"/>
+          </a:lnRef>
+          <a:fillRef idx="0">
+            <a:schemeClr val="accent1"/>
+          </a:fillRef>
+          <a:effectRef idx="1">
+            <a:schemeClr val="accent1"/>
+          </a:effectRef>
+          <a:fontRef idx="minor">
+            <a:schemeClr val="tx1"/>
+          </a:fontRef>
+        </p:style>
+      </p:cxnSp>
+      <p:sp>
+        <p:nvSpPr>
+          <p:cNvPr id="15" name="TextBox 14"/>
+          <p:cNvSpPr txBox="1"/>
+          <p:nvPr/>
+        </p:nvSpPr>
+        <p:spPr>
+          <a:xfrm>
+            <a:off x="8156448" y="3383280"/>
+            <a:ext cx="3200400" cy="1005840"/>
+          </a:xfrm>
+          <a:prstGeom prst="rect">
+            <a:avLst/>
+          </a:prstGeom>
+          <a:noFill/>
+        </p:spPr>
+        <p:txBody>
+          <a:bodyPr wrap="square" lIns="0" rIns="0" tIns="0" bIns="0">
+            <a:spAutoFit/>
+          </a:bodyPr>
+          <a:lstStyle/>
+          <a:p>
+            <a:r>
+              <a:rPr sz="2600" b="1" lang="vi-VN">
+                <a:solidFill>
+                  <a:srgbClr val="1F1F1F"/>
+                </a:solidFill>
+                <a:latin typeface="Arial"/>
+              </a:rPr>
+              <a:t>Có thể triển khai ngay lập tức</a:t>
+            </a:r>
+          </a:p>
+        </p:txBody>
+      </p:sp>
+      <p:sp>
+        <p:nvSpPr>
+          <p:cNvPr id="16" name="TextBox 15"/>
+          <p:cNvSpPr txBox="1"/>
+          <p:nvPr/>
+        </p:nvSpPr>
+        <p:spPr>
+          <a:xfrm>
+            <a:off x="8156448" y="4434840"/>
+            <a:ext cx="3200400" cy="1371600"/>
+          </a:xfrm>
+          <a:prstGeom prst="rect">
+            <a:avLst/>
+          </a:prstGeom>
+          <a:noFill/>
+        </p:spPr>
+        <p:txBody>
+          <a:bodyPr wrap="square" lIns="0" rIns="0" tIns="0" bIns="0">
+            <a:spAutoFit/>
+          </a:bodyPr>
+          <a:lstStyle/>
+          <a:p>
+            <a:r>
+              <a:rPr sz="1600" b="0" lang="vi-VN">
+                <a:solidFill>
+                  <a:srgbClr val="555555"/>
+                </a:solidFill>
+                <a:latin typeface="Arial"/>
+              </a:rPr>
+              <a:t>Chạy ngoại tuyến, không cần cài đặt, nhập thẳng tệp Excel từ Microsoft Forms.</a:t>
+            </a:r>
+          </a:p>
+        </p:txBody>
+      </p:sp>
+    </p:spTree>
+  </p:cSld>
+  <p:clrMapOvr>
+    <a:masterClrMapping/>
+  </p:clrMapOvr>
+</p:sld>
+</file>
+
+<file path=ppt/slides/slide14.xml><?xml version="1.0" encoding="utf-8"?>
 <p:sld xmlns:a="http://schemas.openxmlformats.org/drawingml/2006/main" xmlns:r="http://schemas.openxmlformats.org/officeDocument/2006/relationships" xmlns:p="http://schemas.openxmlformats.org/presentationml/2006/main">
   <p:cSld>
+    <p:bg>
+      <p:bgPr>
+        <a:solidFill>
+          <a:srgbClr val="F8F3ED"/>
+        </a:solidFill>
+        <a:effectLst/>
+      </p:bgPr>
+    </p:bg>
     <p:spTree>
       <p:nvGrpSpPr>
         <p:cNvPr id="1" name=""/>
@@ -6543,13 +7104,13 @@
 </p:sld>
 </file>
 
-<file path=ppt/slides/slide14.xml><?xml version="1.0" encoding="utf-8"?>
+<file path=ppt/slides/slide15.xml><?xml version="1.0" encoding="utf-8"?>
 <p:sld xmlns:a="http://schemas.openxmlformats.org/drawingml/2006/main" xmlns:r="http://schemas.openxmlformats.org/officeDocument/2006/relationships" xmlns:p="http://schemas.openxmlformats.org/presentationml/2006/main">
   <p:cSld>
     <p:bg>
       <p:bgPr>
         <a:solidFill>
-          <a:schemeClr val="bg1"/>
+          <a:srgbClr val="F8F3ED"/>
         </a:solidFill>
         <a:effectLst/>
       </p:bgPr>
@@ -6599,6 +7160,9 @@
           <a:prstGeom prst="rect">
             <a:avLst/>
           </a:prstGeom>
+          <a:solidFill>
+            <a:srgbClr val="F8F3ED"/>
+          </a:solidFill>
           <a:ln>
             <a:noFill/>
           </a:ln>
@@ -7229,530 +7793,17 @@
 </p:sld>
 </file>
 
-<file path=ppt/slides/slide15.xml><?xml version="1.0" encoding="utf-8"?>
-<p:sld xmlns:a="http://schemas.openxmlformats.org/drawingml/2006/main" xmlns:p="http://schemas.openxmlformats.org/presentationml/2006/main" xmlns:r="http://schemas.openxmlformats.org/officeDocument/2006/relationships">
-  <p:cSld>
-    <p:spTree>
-      <p:nvGrpSpPr>
-        <p:cNvPr id="1" name=""/>
-        <p:cNvGrpSpPr/>
-        <p:nvPr/>
-      </p:nvGrpSpPr>
-      <p:grpSpPr/>
-      <p:sp>
-        <p:nvSpPr>
-          <p:cNvPr id="2" name="Title 1"/>
-          <p:cNvSpPr>
-            <a:spLocks noGrp="1"/>
-          </p:cNvSpPr>
-          <p:nvPr>
-            <p:ph type="title"/>
-          </p:nvPr>
-        </p:nvSpPr>
-        <p:spPr/>
-        <p:txBody>
-          <a:bodyPr/>
-          <a:lstStyle/>
-          <a:p>
-            <a:r>
-              <a:rPr lang="vi-VN"/>
-              <a:t>Vì sao chọn dự án của chúng tôi</a:t>
-            </a:r>
-          </a:p>
-        </p:txBody>
-      </p:sp>
-      <p:sp>
-        <p:nvSpPr>
-          <p:cNvPr id="3" name="TextBox 2"/>
-          <p:cNvSpPr txBox="1"/>
-          <p:nvPr/>
-        </p:nvSpPr>
-        <p:spPr>
-          <a:xfrm>
-            <a:off x="841248" y="2103120"/>
-            <a:ext cx="3200400" cy="914400"/>
-          </a:xfrm>
-          <a:prstGeom prst="rect">
-            <a:avLst/>
-          </a:prstGeom>
-          <a:noFill/>
-        </p:spPr>
-        <p:txBody>
-          <a:bodyPr wrap="square" lIns="0" rIns="0" tIns="0" bIns="0">
-            <a:spAutoFit/>
-          </a:bodyPr>
-          <a:lstStyle/>
-          <a:p>
-            <a:r>
-              <a:rPr sz="6000" b="1" lang="vi-VN">
-                <a:solidFill>
-                  <a:srgbClr val="1F1F1F"/>
-                </a:solidFill>
-                <a:latin typeface="Arial"/>
-              </a:rPr>
-              <a:t>01</a:t>
-            </a:r>
-          </a:p>
-        </p:txBody>
-      </p:sp>
-      <p:cxnSp>
-        <p:nvCxnSpPr>
-          <p:cNvPr id="4" name="Connector 3"/>
-          <p:cNvCxnSpPr/>
-          <p:nvPr/>
-        </p:nvCxnSpPr>
-        <p:spPr>
-          <a:xfrm>
-            <a:off x="841248" y="3108960"/>
-            <a:ext cx="1097280" cy="0"/>
-          </a:xfrm>
-          <a:prstGeom prst="line">
-            <a:avLst/>
-          </a:prstGeom>
-          <a:ln w="25400">
-            <a:solidFill>
-              <a:srgbClr val="1F1F1F"/>
-            </a:solidFill>
-          </a:ln>
-        </p:spPr>
-        <p:style>
-          <a:lnRef idx="2">
-            <a:schemeClr val="accent1"/>
-          </a:lnRef>
-          <a:fillRef idx="0">
-            <a:schemeClr val="accent1"/>
-          </a:fillRef>
-          <a:effectRef idx="1">
-            <a:schemeClr val="accent1"/>
-          </a:effectRef>
-          <a:fontRef idx="minor">
-            <a:schemeClr val="tx1"/>
-          </a:fontRef>
-        </p:style>
-      </p:cxnSp>
-      <p:sp>
-        <p:nvSpPr>
-          <p:cNvPr id="5" name="TextBox 4"/>
-          <p:cNvSpPr txBox="1"/>
-          <p:nvPr/>
-        </p:nvSpPr>
-        <p:spPr>
-          <a:xfrm>
-            <a:off x="841248" y="3383280"/>
-            <a:ext cx="3200400" cy="1005840"/>
-          </a:xfrm>
-          <a:prstGeom prst="rect">
-            <a:avLst/>
-          </a:prstGeom>
-          <a:noFill/>
-        </p:spPr>
-        <p:txBody>
-          <a:bodyPr wrap="square" lIns="0" rIns="0" tIns="0" bIns="0">
-            <a:spAutoFit/>
-          </a:bodyPr>
-          <a:lstStyle/>
-          <a:p>
-            <a:r>
-              <a:rPr sz="2600" b="1" lang="vi-VN">
-                <a:solidFill>
-                  <a:srgbClr val="1F1F1F"/>
-                </a:solidFill>
-                <a:latin typeface="Arial"/>
-              </a:rPr>
-              <a:t>Có sản phẩm</a:t>
-            </a:r>
-          </a:p>
-        </p:txBody>
-      </p:sp>
-      <p:sp>
-        <p:nvSpPr>
-          <p:cNvPr id="6" name="TextBox 5"/>
-          <p:cNvSpPr txBox="1"/>
-          <p:nvPr/>
-        </p:nvSpPr>
-        <p:spPr>
-          <a:xfrm>
-            <a:off x="841248" y="4434840"/>
-            <a:ext cx="3200400" cy="1371600"/>
-          </a:xfrm>
-          <a:prstGeom prst="rect">
-            <a:avLst/>
-          </a:prstGeom>
-          <a:noFill/>
-        </p:spPr>
-        <p:txBody>
-          <a:bodyPr wrap="square" lIns="0" rIns="0" tIns="0" bIns="0">
-            <a:spAutoFit/>
-          </a:bodyPr>
-          <a:lstStyle/>
-          <a:p>
-            <a:r>
-              <a:rPr sz="1600" b="0" lang="vi-VN">
-                <a:solidFill>
-                  <a:srgbClr val="555555"/>
-                </a:solidFill>
-                <a:latin typeface="Arial"/>
-              </a:rPr>
-              <a:t>Phần mềm chạy được trên máy Windows; 757 bài kiểm thử tự động đều đạt.</a:t>
-            </a:r>
-          </a:p>
-        </p:txBody>
-      </p:sp>
-      <p:cxnSp>
-        <p:nvCxnSpPr>
-          <p:cNvPr id="7" name="Connector 6"/>
-          <p:cNvCxnSpPr/>
-          <p:nvPr/>
-        </p:nvCxnSpPr>
-        <p:spPr>
-          <a:xfrm>
-            <a:off x="4270248" y="2194560"/>
-            <a:ext cx="0" cy="3474720"/>
-          </a:xfrm>
-          <a:prstGeom prst="line">
-            <a:avLst/>
-          </a:prstGeom>
-          <a:ln w="12700">
-            <a:solidFill>
-              <a:srgbClr val="BFBFBF"/>
-            </a:solidFill>
-          </a:ln>
-        </p:spPr>
-        <p:style>
-          <a:lnRef idx="2">
-            <a:schemeClr val="accent1"/>
-          </a:lnRef>
-          <a:fillRef idx="0">
-            <a:schemeClr val="accent1"/>
-          </a:fillRef>
-          <a:effectRef idx="1">
-            <a:schemeClr val="accent1"/>
-          </a:effectRef>
-          <a:fontRef idx="minor">
-            <a:schemeClr val="tx1"/>
-          </a:fontRef>
-        </p:style>
-      </p:cxnSp>
-      <p:sp>
-        <p:nvSpPr>
-          <p:cNvPr id="8" name="TextBox 7"/>
-          <p:cNvSpPr txBox="1"/>
-          <p:nvPr/>
-        </p:nvSpPr>
-        <p:spPr>
-          <a:xfrm>
-            <a:off x="4498848" y="2103120"/>
-            <a:ext cx="3200400" cy="914400"/>
-          </a:xfrm>
-          <a:prstGeom prst="rect">
-            <a:avLst/>
-          </a:prstGeom>
-          <a:noFill/>
-        </p:spPr>
-        <p:txBody>
-          <a:bodyPr wrap="square" lIns="0" rIns="0" tIns="0" bIns="0">
-            <a:spAutoFit/>
-          </a:bodyPr>
-          <a:lstStyle/>
-          <a:p>
-            <a:r>
-              <a:rPr sz="6000" b="1" lang="vi-VN">
-                <a:solidFill>
-                  <a:srgbClr val="1F1F1F"/>
-                </a:solidFill>
-                <a:latin typeface="Arial"/>
-              </a:rPr>
-              <a:t>02</a:t>
-            </a:r>
-          </a:p>
-        </p:txBody>
-      </p:sp>
-      <p:cxnSp>
-        <p:nvCxnSpPr>
-          <p:cNvPr id="9" name="Connector 8"/>
-          <p:cNvCxnSpPr/>
-          <p:nvPr/>
-        </p:nvCxnSpPr>
-        <p:spPr>
-          <a:xfrm>
-            <a:off x="4498848" y="3108960"/>
-            <a:ext cx="1097280" cy="0"/>
-          </a:xfrm>
-          <a:prstGeom prst="line">
-            <a:avLst/>
-          </a:prstGeom>
-          <a:ln w="25400">
-            <a:solidFill>
-              <a:srgbClr val="1F1F1F"/>
-            </a:solidFill>
-          </a:ln>
-        </p:spPr>
-        <p:style>
-          <a:lnRef idx="2">
-            <a:schemeClr val="accent1"/>
-          </a:lnRef>
-          <a:fillRef idx="0">
-            <a:schemeClr val="accent1"/>
-          </a:fillRef>
-          <a:effectRef idx="1">
-            <a:schemeClr val="accent1"/>
-          </a:effectRef>
-          <a:fontRef idx="minor">
-            <a:schemeClr val="tx1"/>
-          </a:fontRef>
-        </p:style>
-      </p:cxnSp>
-      <p:sp>
-        <p:nvSpPr>
-          <p:cNvPr id="10" name="TextBox 9"/>
-          <p:cNvSpPr txBox="1"/>
-          <p:nvPr/>
-        </p:nvSpPr>
-        <p:spPr>
-          <a:xfrm>
-            <a:off x="4498848" y="3383280"/>
-            <a:ext cx="3200400" cy="1005840"/>
-          </a:xfrm>
-          <a:prstGeom prst="rect">
-            <a:avLst/>
-          </a:prstGeom>
-          <a:noFill/>
-        </p:spPr>
-        <p:txBody>
-          <a:bodyPr wrap="square" lIns="0" rIns="0" tIns="0" bIns="0">
-            <a:spAutoFit/>
-          </a:bodyPr>
-          <a:lstStyle/>
-          <a:p>
-            <a:r>
-              <a:rPr sz="2600" b="1" lang="vi-VN">
-                <a:solidFill>
-                  <a:srgbClr val="1F1F1F"/>
-                </a:solidFill>
-                <a:latin typeface="Arial"/>
-              </a:rPr>
-              <a:t>Giải quyết vấn đề thực tiễn</a:t>
-            </a:r>
-          </a:p>
-        </p:txBody>
-      </p:sp>
-      <p:sp>
-        <p:nvSpPr>
-          <p:cNvPr id="11" name="TextBox 10"/>
-          <p:cNvSpPr txBox="1"/>
-          <p:nvPr/>
-        </p:nvSpPr>
-        <p:spPr>
-          <a:xfrm>
-            <a:off x="4498848" y="4434840"/>
-            <a:ext cx="3200400" cy="1371600"/>
-          </a:xfrm>
-          <a:prstGeom prst="rect">
-            <a:avLst/>
-          </a:prstGeom>
-          <a:noFill/>
-        </p:spPr>
-        <p:txBody>
-          <a:bodyPr wrap="square" lIns="0" rIns="0" tIns="0" bIns="0">
-            <a:spAutoFit/>
-          </a:bodyPr>
-          <a:lstStyle/>
-          <a:p>
-            <a:r>
-              <a:rPr sz="1600" b="0" lang="vi-VN">
-                <a:solidFill>
-                  <a:srgbClr val="555555"/>
-                </a:solidFill>
-                <a:latin typeface="Arial"/>
-              </a:rPr>
-              <a:t>Thay cách xếp CLB theo thứ tự đăng ký đang dùng tại trường.</a:t>
-            </a:r>
-          </a:p>
-        </p:txBody>
-      </p:sp>
-      <p:cxnSp>
-        <p:nvCxnSpPr>
-          <p:cNvPr id="12" name="Connector 11"/>
-          <p:cNvCxnSpPr/>
-          <p:nvPr/>
-        </p:nvCxnSpPr>
-        <p:spPr>
-          <a:xfrm>
-            <a:off x="7927848" y="2194560"/>
-            <a:ext cx="0" cy="3474720"/>
-          </a:xfrm>
-          <a:prstGeom prst="line">
-            <a:avLst/>
-          </a:prstGeom>
-          <a:ln w="12700">
-            <a:solidFill>
-              <a:srgbClr val="BFBFBF"/>
-            </a:solidFill>
-          </a:ln>
-        </p:spPr>
-        <p:style>
-          <a:lnRef idx="2">
-            <a:schemeClr val="accent1"/>
-          </a:lnRef>
-          <a:fillRef idx="0">
-            <a:schemeClr val="accent1"/>
-          </a:fillRef>
-          <a:effectRef idx="1">
-            <a:schemeClr val="accent1"/>
-          </a:effectRef>
-          <a:fontRef idx="minor">
-            <a:schemeClr val="tx1"/>
-          </a:fontRef>
-        </p:style>
-      </p:cxnSp>
-      <p:sp>
-        <p:nvSpPr>
-          <p:cNvPr id="13" name="TextBox 12"/>
-          <p:cNvSpPr txBox="1"/>
-          <p:nvPr/>
-        </p:nvSpPr>
-        <p:spPr>
-          <a:xfrm>
-            <a:off x="8156448" y="2103120"/>
-            <a:ext cx="3200400" cy="914400"/>
-          </a:xfrm>
-          <a:prstGeom prst="rect">
-            <a:avLst/>
-          </a:prstGeom>
-          <a:noFill/>
-        </p:spPr>
-        <p:txBody>
-          <a:bodyPr wrap="square" lIns="0" rIns="0" tIns="0" bIns="0">
-            <a:spAutoFit/>
-          </a:bodyPr>
-          <a:lstStyle/>
-          <a:p>
-            <a:r>
-              <a:rPr sz="6000" b="1" lang="vi-VN">
-                <a:solidFill>
-                  <a:srgbClr val="1F1F1F"/>
-                </a:solidFill>
-                <a:latin typeface="Arial"/>
-              </a:rPr>
-              <a:t>03</a:t>
-            </a:r>
-          </a:p>
-        </p:txBody>
-      </p:sp>
-      <p:cxnSp>
-        <p:nvCxnSpPr>
-          <p:cNvPr id="14" name="Connector 13"/>
-          <p:cNvCxnSpPr/>
-          <p:nvPr/>
-        </p:nvCxnSpPr>
-        <p:spPr>
-          <a:xfrm>
-            <a:off x="8156448" y="3108960"/>
-            <a:ext cx="1097280" cy="0"/>
-          </a:xfrm>
-          <a:prstGeom prst="line">
-            <a:avLst/>
-          </a:prstGeom>
-          <a:ln w="25400">
-            <a:solidFill>
-              <a:srgbClr val="1F1F1F"/>
-            </a:solidFill>
-          </a:ln>
-        </p:spPr>
-        <p:style>
-          <a:lnRef idx="2">
-            <a:schemeClr val="accent1"/>
-          </a:lnRef>
-          <a:fillRef idx="0">
-            <a:schemeClr val="accent1"/>
-          </a:fillRef>
-          <a:effectRef idx="1">
-            <a:schemeClr val="accent1"/>
-          </a:effectRef>
-          <a:fontRef idx="minor">
-            <a:schemeClr val="tx1"/>
-          </a:fontRef>
-        </p:style>
-      </p:cxnSp>
-      <p:sp>
-        <p:nvSpPr>
-          <p:cNvPr id="15" name="TextBox 14"/>
-          <p:cNvSpPr txBox="1"/>
-          <p:nvPr/>
-        </p:nvSpPr>
-        <p:spPr>
-          <a:xfrm>
-            <a:off x="8156448" y="3383280"/>
-            <a:ext cx="3200400" cy="1005840"/>
-          </a:xfrm>
-          <a:prstGeom prst="rect">
-            <a:avLst/>
-          </a:prstGeom>
-          <a:noFill/>
-        </p:spPr>
-        <p:txBody>
-          <a:bodyPr wrap="square" lIns="0" rIns="0" tIns="0" bIns="0">
-            <a:spAutoFit/>
-          </a:bodyPr>
-          <a:lstStyle/>
-          <a:p>
-            <a:r>
-              <a:rPr sz="2600" b="1" lang="vi-VN">
-                <a:solidFill>
-                  <a:srgbClr val="1F1F1F"/>
-                </a:solidFill>
-                <a:latin typeface="Arial"/>
-              </a:rPr>
-              <a:t>Có thể triển khai ngay lập tức</a:t>
-            </a:r>
-          </a:p>
-        </p:txBody>
-      </p:sp>
-      <p:sp>
-        <p:nvSpPr>
-          <p:cNvPr id="16" name="TextBox 15"/>
-          <p:cNvSpPr txBox="1"/>
-          <p:nvPr/>
-        </p:nvSpPr>
-        <p:spPr>
-          <a:xfrm>
-            <a:off x="8156448" y="4434840"/>
-            <a:ext cx="3200400" cy="1371600"/>
-          </a:xfrm>
-          <a:prstGeom prst="rect">
-            <a:avLst/>
-          </a:prstGeom>
-          <a:noFill/>
-        </p:spPr>
-        <p:txBody>
-          <a:bodyPr wrap="square" lIns="0" rIns="0" tIns="0" bIns="0">
-            <a:spAutoFit/>
-          </a:bodyPr>
-          <a:lstStyle/>
-          <a:p>
-            <a:r>
-              <a:rPr sz="1600" b="0" lang="vi-VN">
-                <a:solidFill>
-                  <a:srgbClr val="555555"/>
-                </a:solidFill>
-                <a:latin typeface="Arial"/>
-              </a:rPr>
-              <a:t>Chạy ngoại tuyến, không cần cài đặt, nhập thẳng tệp Excel từ Microsoft Forms.</a:t>
-            </a:r>
-          </a:p>
-        </p:txBody>
-      </p:sp>
-    </p:spTree>
-  </p:cSld>
-  <p:clrMapOvr>
-    <a:masterClrMapping/>
-  </p:clrMapOvr>
-</p:sld>
-</file>
-
 <file path=ppt/slides/slide2.xml><?xml version="1.0" encoding="utf-8"?>
 <p:sld xmlns:a="http://schemas.openxmlformats.org/drawingml/2006/main" xmlns:r="http://schemas.openxmlformats.org/officeDocument/2006/relationships" xmlns:p="http://schemas.openxmlformats.org/presentationml/2006/main">
   <p:cSld name="Slide2">
+    <p:bg>
+      <p:bgPr>
+        <a:solidFill>
+          <a:srgbClr val="F8F3ED"/>
+        </a:solidFill>
+        <a:effectLst/>
+      </p:bgPr>
+    </p:bg>
     <p:spTree>
       <p:nvGrpSpPr>
         <p:cNvPr id="1" name=""/>
@@ -7812,7 +7863,7 @@
             </a:avLst>
           </a:prstGeom>
           <a:solidFill>
-            <a:srgbClr val="F3F4F1"/>
+            <a:srgbClr val="EFE8DE"/>
           </a:solidFill>
           <a:ln>
             <a:noFill/>
@@ -7928,7 +7979,7 @@
             </a:avLst>
           </a:prstGeom>
           <a:solidFill>
-            <a:srgbClr val="F3F4F1"/>
+            <a:srgbClr val="EFE8DE"/>
           </a:solidFill>
           <a:ln>
             <a:noFill/>
@@ -8044,7 +8095,7 @@
             </a:avLst>
           </a:prstGeom>
           <a:solidFill>
-            <a:srgbClr val="F3F4F1"/>
+            <a:srgbClr val="EFE8DE"/>
           </a:solidFill>
           <a:ln>
             <a:noFill/>
@@ -8160,7 +8211,7 @@
             </a:avLst>
           </a:prstGeom>
           <a:solidFill>
-            <a:srgbClr val="F3F4F1"/>
+            <a:srgbClr val="EFE8DE"/>
           </a:solidFill>
           <a:ln>
             <a:noFill/>
@@ -8276,7 +8327,7 @@
             </a:avLst>
           </a:prstGeom>
           <a:solidFill>
-            <a:srgbClr val="F3F4F1"/>
+            <a:srgbClr val="EFE8DE"/>
           </a:solidFill>
           <a:ln>
             <a:noFill/>
@@ -8392,7 +8443,7 @@
             </a:avLst>
           </a:prstGeom>
           <a:solidFill>
-            <a:srgbClr val="F3F4F1"/>
+            <a:srgbClr val="EFE8DE"/>
           </a:solidFill>
           <a:ln>
             <a:noFill/>
@@ -8502,6 +8553,14 @@
 <file path=ppt/slides/slide3.xml><?xml version="1.0" encoding="utf-8"?>
 <p:sld xmlns:a="http://schemas.openxmlformats.org/drawingml/2006/main" xmlns:p="http://schemas.openxmlformats.org/presentationml/2006/main" xmlns:r="http://schemas.openxmlformats.org/officeDocument/2006/relationships">
   <p:cSld>
+    <p:bg>
+      <p:bgPr>
+        <a:solidFill>
+          <a:srgbClr val="F8F3ED"/>
+        </a:solidFill>
+        <a:effectLst/>
+      </p:bgPr>
+    </p:bg>
     <p:spTree>
       <p:nvGrpSpPr>
         <p:cNvPr id="1" name=""/>
@@ -9098,6 +9157,14 @@
 <file path=ppt/slides/slide4.xml><?xml version="1.0" encoding="utf-8"?>
 <p:sld xmlns:a="http://schemas.openxmlformats.org/drawingml/2006/main" xmlns:r="http://schemas.openxmlformats.org/officeDocument/2006/relationships" xmlns:p="http://schemas.openxmlformats.org/presentationml/2006/main">
   <p:cSld>
+    <p:bg>
+      <p:bgPr>
+        <a:solidFill>
+          <a:srgbClr val="F8F3ED"/>
+        </a:solidFill>
+        <a:effectLst/>
+      </p:bgPr>
+    </p:bg>
     <p:spTree>
       <p:nvGrpSpPr>
         <p:cNvPr id="1" name=""/>
@@ -9157,7 +9224,7 @@
             </a:avLst>
           </a:prstGeom>
           <a:solidFill>
-            <a:srgbClr val="F3F4F1"/>
+            <a:srgbClr val="EFE8DE"/>
           </a:solidFill>
           <a:ln>
             <a:noFill/>
@@ -9323,7 +9390,7 @@
             </a:avLst>
           </a:prstGeom>
           <a:solidFill>
-            <a:srgbClr val="F3F4F1"/>
+            <a:srgbClr val="EFE8DE"/>
           </a:solidFill>
           <a:ln>
             <a:noFill/>
@@ -9489,7 +9556,7 @@
             </a:avLst>
           </a:prstGeom>
           <a:solidFill>
-            <a:srgbClr val="F3F4F1"/>
+            <a:srgbClr val="EFE8DE"/>
           </a:solidFill>
           <a:ln>
             <a:noFill/>
@@ -9655,7 +9722,7 @@
             </a:avLst>
           </a:prstGeom>
           <a:solidFill>
-            <a:srgbClr val="F3F4F1"/>
+            <a:srgbClr val="EFE8DE"/>
           </a:solidFill>
           <a:ln>
             <a:noFill/>
@@ -9820,6 +9887,14 @@
 <file path=ppt/slides/slide5.xml><?xml version="1.0" encoding="utf-8"?>
 <p:sld xmlns:a="http://schemas.openxmlformats.org/drawingml/2006/main" xmlns:r="http://schemas.openxmlformats.org/officeDocument/2006/relationships" xmlns:p="http://schemas.openxmlformats.org/presentationml/2006/main">
   <p:cSld>
+    <p:bg>
+      <p:bgPr>
+        <a:solidFill>
+          <a:srgbClr val="F8F3ED"/>
+        </a:solidFill>
+        <a:effectLst/>
+      </p:bgPr>
+    </p:bg>
     <p:spTree>
       <p:nvGrpSpPr>
         <p:cNvPr id="1" name=""/>
@@ -9880,7 +9955,7 @@
             </a:avLst>
           </a:prstGeom>
           <a:solidFill>
-            <a:srgbClr val="F3F4F1"/>
+            <a:srgbClr val="EFE8DE"/>
           </a:solidFill>
           <a:ln>
             <a:noFill/>
@@ -10063,7 +10138,7 @@
             <a:avLst/>
           </a:prstGeom>
           <a:solidFill>
-            <a:srgbClr val="D5D8D2"/>
+            <a:srgbClr val="D9D0C3"/>
           </a:solidFill>
           <a:ln>
             <a:noFill/>
@@ -10293,7 +10368,7 @@
             <a:avLst/>
           </a:prstGeom>
           <a:solidFill>
-            <a:srgbClr val="D5D8D2"/>
+            <a:srgbClr val="D9D0C3"/>
           </a:solidFill>
           <a:ln>
             <a:noFill/>
@@ -10340,7 +10415,7 @@
             </a:avLst>
           </a:prstGeom>
           <a:solidFill>
-            <a:srgbClr val="F3F4F1"/>
+            <a:srgbClr val="EFE8DE"/>
           </a:solidFill>
           <a:ln>
             <a:noFill/>
@@ -10524,6 +10599,14 @@
 <file path=ppt/slides/slide6.xml><?xml version="1.0" encoding="utf-8"?>
 <p:sld xmlns:a="http://schemas.openxmlformats.org/drawingml/2006/main" xmlns:r="http://schemas.openxmlformats.org/officeDocument/2006/relationships" xmlns:p="http://schemas.openxmlformats.org/presentationml/2006/main">
   <p:cSld>
+    <p:bg>
+      <p:bgPr>
+        <a:solidFill>
+          <a:srgbClr val="F8F3ED"/>
+        </a:solidFill>
+        <a:effectLst/>
+      </p:bgPr>
+    </p:bg>
     <p:spTree>
       <p:nvGrpSpPr>
         <p:cNvPr id="1" name=""/>
@@ -10672,7 +10755,7 @@
             </a:avLst>
           </a:prstGeom>
           <a:solidFill>
-            <a:srgbClr val="F3F4F1"/>
+            <a:srgbClr val="EFE8DE"/>
           </a:solidFill>
           <a:ln>
             <a:noFill/>
@@ -10875,7 +10958,7 @@
             </a:avLst>
           </a:prstGeom>
           <a:solidFill>
-            <a:srgbClr val="F3F4F1"/>
+            <a:srgbClr val="EFE8DE"/>
           </a:solidFill>
           <a:ln>
             <a:noFill/>
@@ -11078,7 +11161,7 @@
             </a:avLst>
           </a:prstGeom>
           <a:solidFill>
-            <a:srgbClr val="F3F4F1"/>
+            <a:srgbClr val="EFE8DE"/>
           </a:solidFill>
           <a:ln>
             <a:noFill/>
@@ -11281,7 +11364,7 @@
             </a:avLst>
           </a:prstGeom>
           <a:solidFill>
-            <a:srgbClr val="F3F4F1"/>
+            <a:srgbClr val="EFE8DE"/>
           </a:solidFill>
           <a:ln>
             <a:noFill/>
@@ -11430,6 +11513,14 @@
 <file path=ppt/slides/slide7.xml><?xml version="1.0" encoding="utf-8"?>
 <p:sld xmlns:a="http://schemas.openxmlformats.org/drawingml/2006/main" xmlns:r="http://schemas.openxmlformats.org/officeDocument/2006/relationships" xmlns:p="http://schemas.openxmlformats.org/presentationml/2006/main">
   <p:cSld>
+    <p:bg>
+      <p:bgPr>
+        <a:solidFill>
+          <a:srgbClr val="F8F3ED"/>
+        </a:solidFill>
+        <a:effectLst/>
+      </p:bgPr>
+    </p:bg>
     <p:spTree>
       <p:nvGrpSpPr>
         <p:cNvPr id="1" name=""/>
@@ -12206,6 +12297,14 @@
 <file path=ppt/slides/slide8.xml><?xml version="1.0" encoding="utf-8"?>
 <p:sld xmlns:a="http://schemas.openxmlformats.org/drawingml/2006/main" xmlns:r="http://schemas.openxmlformats.org/officeDocument/2006/relationships" xmlns:p="http://schemas.openxmlformats.org/presentationml/2006/main">
   <p:cSld>
+    <p:bg>
+      <p:bgPr>
+        <a:solidFill>
+          <a:srgbClr val="F8F3ED"/>
+        </a:solidFill>
+        <a:effectLst/>
+      </p:bgPr>
+    </p:bg>
     <p:spTree>
       <p:nvGrpSpPr>
         <p:cNvPr id="1" name=""/>
@@ -12855,6 +12954,14 @@
 <file path=ppt/slides/slide9.xml><?xml version="1.0" encoding="utf-8"?>
 <p:sld xmlns:a="http://schemas.openxmlformats.org/drawingml/2006/main" xmlns:r="http://schemas.openxmlformats.org/officeDocument/2006/relationships" xmlns:p="http://schemas.openxmlformats.org/presentationml/2006/main">
   <p:cSld>
+    <p:bg>
+      <p:bgPr>
+        <a:solidFill>
+          <a:srgbClr val="F8F3ED"/>
+        </a:solidFill>
+        <a:effectLst/>
+      </p:bgPr>
+    </p:bg>
     <p:spTree>
       <p:nvGrpSpPr>
         <p:cNvPr id="1" name=""/>

</xml_diff>

<commit_message>
Make the deck's contents slide match its actual slides
The contents slide still listed the original six sections in an order
the deck no longer follows, and omitted the sections added since. It
now lists eight sections in slide order, from the problem to future
directions, each with the slide numbers it covers, plus a pointer to
the glossary on slide 3. Same card style and warm background.

Co-Authored-By: Claude Opus 5.5 <noreply@anthropic.com>
Claude-Session: https://claude.ai/code/session_01W1TN5sV8nD2mQymMCwHHSg
</commit_message>
<xml_diff>
--- a/THUYET_TRINH_KHKT_DA_SUA_FONT.pptx
+++ b/THUYET_TRINH_KHKT_DA_SUA_FONT.pptx
@@ -7854,8 +7854,8 @@
         </p:nvSpPr>
         <p:spPr>
           <a:xfrm>
-            <a:off x="841248" y="1828800"/>
-            <a:ext cx="3322320" cy="2057400"/>
+            <a:off x="841248" y="1783080"/>
+            <a:ext cx="2423160" cy="2011680"/>
           </a:xfrm>
           <a:prstGeom prst="roundRect">
             <a:avLst>
@@ -7888,7 +7888,7 @@
           <a:bodyPr rtlCol="0" anchor="ctr"/>
           <a:lstStyle/>
           <a:p>
-            <a:endParaRPr/>
+            <a:pPr algn="ctr"/>
           </a:p>
         </p:txBody>
       </p:sp>
@@ -7900,8 +7900,8 @@
         </p:nvSpPr>
         <p:spPr>
           <a:xfrm>
-            <a:off x="1161288" y="2148840"/>
-            <a:ext cx="1371600" cy="640080"/>
+            <a:off x="1115568" y="2011680"/>
+            <a:ext cx="1280160" cy="548640"/>
           </a:xfrm>
           <a:prstGeom prst="rect">
             <a:avLst/>
@@ -7909,14 +7909,13 @@
           <a:noFill/>
         </p:spPr>
         <p:txBody>
-          <a:bodyPr wrap="square" lIns="0" tIns="0" rIns="0" bIns="0" anchor="t">
+          <a:bodyPr wrap="square" lIns="0" rIns="0" tIns="0" bIns="0">
             <a:spAutoFit/>
           </a:bodyPr>
           <a:lstStyle/>
           <a:p>
-            <a:pPr algn="l"/>
-            <a:r>
-              <a:rPr lang="vi-VN" sz="4000" b="1">
+            <a:r>
+              <a:rPr sz="3200" b="1" i="0" lang="vi-VN">
                 <a:solidFill>
                   <a:srgbClr val="3F6B52"/>
                 </a:solidFill>
@@ -7935,8 +7934,8 @@
         </p:nvSpPr>
         <p:spPr>
           <a:xfrm>
-            <a:off x="1161288" y="2971800"/>
-            <a:ext cx="2682240" cy="731520"/>
+            <a:off x="1115568" y="2606040"/>
+            <a:ext cx="1874519" cy="731520"/>
           </a:xfrm>
           <a:prstGeom prst="rect">
             <a:avLst/>
@@ -7944,14 +7943,13 @@
           <a:noFill/>
         </p:spPr>
         <p:txBody>
-          <a:bodyPr wrap="square" lIns="0" tIns="0" rIns="0" bIns="0" anchor="t">
+          <a:bodyPr wrap="square" lIns="0" rIns="0" tIns="0" bIns="0">
             <a:spAutoFit/>
           </a:bodyPr>
           <a:lstStyle/>
           <a:p>
-            <a:pPr algn="l"/>
-            <a:r>
-              <a:rPr lang="vi-VN" sz="2000" b="1">
+            <a:r>
+              <a:rPr sz="1700" b="1" i="0" lang="vi-VN">
                 <a:solidFill>
                   <a:srgbClr val="1F1F1F"/>
                 </a:solidFill>
@@ -7964,14 +7962,48 @@
       </p:sp>
       <p:sp>
         <p:nvSpPr>
-          <p:cNvPr id="6" name="Rounded Rectangle 5"/>
+          <p:cNvPr id="6" name="TextBox 5"/>
+          <p:cNvSpPr txBox="1"/>
+          <p:nvPr/>
+        </p:nvSpPr>
+        <p:spPr>
+          <a:xfrm>
+            <a:off x="1115568" y="3410712"/>
+            <a:ext cx="1874519" cy="274320"/>
+          </a:xfrm>
+          <a:prstGeom prst="rect">
+            <a:avLst/>
+          </a:prstGeom>
+          <a:noFill/>
+        </p:spPr>
+        <p:txBody>
+          <a:bodyPr wrap="square" lIns="0" rIns="0" tIns="0" bIns="0">
+            <a:spAutoFit/>
+          </a:bodyPr>
+          <a:lstStyle/>
+          <a:p>
+            <a:r>
+              <a:rPr sz="1200" b="0" i="0" lang="vi-VN">
+                <a:solidFill>
+                  <a:srgbClr val="595959"/>
+                </a:solidFill>
+                <a:latin typeface="Arial"/>
+              </a:rPr>
+              <a:t>Trang 4</a:t>
+            </a:r>
+          </a:p>
+        </p:txBody>
+      </p:sp>
+      <p:sp>
+        <p:nvSpPr>
+          <p:cNvPr id="7" name="Rounded Rectangle 6"/>
           <p:cNvSpPr/>
           <p:nvPr/>
         </p:nvSpPr>
         <p:spPr>
           <a:xfrm>
-            <a:off x="4437888" y="1828800"/>
-            <a:ext cx="3322320" cy="2057400"/>
+            <a:off x="3538727" y="1783080"/>
+            <a:ext cx="2423160" cy="2011680"/>
           </a:xfrm>
           <a:prstGeom prst="roundRect">
             <a:avLst>
@@ -8004,20 +8036,20 @@
           <a:bodyPr rtlCol="0" anchor="ctr"/>
           <a:lstStyle/>
           <a:p>
-            <a:endParaRPr/>
-          </a:p>
-        </p:txBody>
-      </p:sp>
-      <p:sp>
-        <p:nvSpPr>
-          <p:cNvPr id="7" name="TextBox 6"/>
+            <a:pPr algn="ctr"/>
+          </a:p>
+        </p:txBody>
+      </p:sp>
+      <p:sp>
+        <p:nvSpPr>
+          <p:cNvPr id="8" name="TextBox 7"/>
           <p:cNvSpPr txBox="1"/>
           <p:nvPr/>
         </p:nvSpPr>
         <p:spPr>
           <a:xfrm>
-            <a:off x="4757928" y="2148840"/>
-            <a:ext cx="1371600" cy="640080"/>
+            <a:off x="3813048" y="2011680"/>
+            <a:ext cx="1280160" cy="548640"/>
           </a:xfrm>
           <a:prstGeom prst="rect">
             <a:avLst/>
@@ -8025,14 +8057,13 @@
           <a:noFill/>
         </p:spPr>
         <p:txBody>
-          <a:bodyPr wrap="square" lIns="0" tIns="0" rIns="0" bIns="0" anchor="t">
+          <a:bodyPr wrap="square" lIns="0" rIns="0" tIns="0" bIns="0">
             <a:spAutoFit/>
           </a:bodyPr>
           <a:lstStyle/>
           <a:p>
-            <a:pPr algn="l"/>
-            <a:r>
-              <a:rPr lang="vi-VN" sz="4000" b="1">
+            <a:r>
+              <a:rPr sz="3200" b="1" i="0" lang="vi-VN">
                 <a:solidFill>
                   <a:srgbClr val="3F6B52"/>
                 </a:solidFill>
@@ -8045,14 +8076,14 @@
       </p:sp>
       <p:sp>
         <p:nvSpPr>
-          <p:cNvPr id="8" name="TextBox 7"/>
+          <p:cNvPr id="9" name="TextBox 8"/>
           <p:cNvSpPr txBox="1"/>
           <p:nvPr/>
         </p:nvSpPr>
         <p:spPr>
           <a:xfrm>
-            <a:off x="4757928" y="2971800"/>
-            <a:ext cx="2682240" cy="731520"/>
+            <a:off x="3813048" y="2606040"/>
+            <a:ext cx="1874519" cy="731520"/>
           </a:xfrm>
           <a:prstGeom prst="rect">
             <a:avLst/>
@@ -8060,14 +8091,13 @@
           <a:noFill/>
         </p:spPr>
         <p:txBody>
-          <a:bodyPr wrap="square" lIns="0" tIns="0" rIns="0" bIns="0" anchor="t">
+          <a:bodyPr wrap="square" lIns="0" rIns="0" tIns="0" bIns="0">
             <a:spAutoFit/>
           </a:bodyPr>
           <a:lstStyle/>
           <a:p>
-            <a:pPr algn="l"/>
-            <a:r>
-              <a:rPr lang="vi-VN" sz="2000" b="1">
+            <a:r>
+              <a:rPr sz="1700" b="1" i="0" lang="vi-VN">
                 <a:solidFill>
                   <a:srgbClr val="1F1F1F"/>
                 </a:solidFill>
@@ -8080,14 +8110,48 @@
       </p:sp>
       <p:sp>
         <p:nvSpPr>
-          <p:cNvPr id="9" name="Rounded Rectangle 8"/>
+          <p:cNvPr id="10" name="TextBox 9"/>
+          <p:cNvSpPr txBox="1"/>
+          <p:nvPr/>
+        </p:nvSpPr>
+        <p:spPr>
+          <a:xfrm>
+            <a:off x="3813048" y="3410712"/>
+            <a:ext cx="1874519" cy="274320"/>
+          </a:xfrm>
+          <a:prstGeom prst="rect">
+            <a:avLst/>
+          </a:prstGeom>
+          <a:noFill/>
+        </p:spPr>
+        <p:txBody>
+          <a:bodyPr wrap="square" lIns="0" rIns="0" tIns="0" bIns="0">
+            <a:spAutoFit/>
+          </a:bodyPr>
+          <a:lstStyle/>
+          <a:p>
+            <a:r>
+              <a:rPr sz="1200" b="0" i="0" lang="vi-VN">
+                <a:solidFill>
+                  <a:srgbClr val="595959"/>
+                </a:solidFill>
+                <a:latin typeface="Arial"/>
+              </a:rPr>
+              <a:t>Trang 5</a:t>
+            </a:r>
+          </a:p>
+        </p:txBody>
+      </p:sp>
+      <p:sp>
+        <p:nvSpPr>
+          <p:cNvPr id="11" name="Rounded Rectangle 10"/>
           <p:cNvSpPr/>
           <p:nvPr/>
         </p:nvSpPr>
         <p:spPr>
           <a:xfrm>
-            <a:off x="8034528" y="1828800"/>
-            <a:ext cx="3322320" cy="2057400"/>
+            <a:off x="6236207" y="1783080"/>
+            <a:ext cx="2423160" cy="2011680"/>
           </a:xfrm>
           <a:prstGeom prst="roundRect">
             <a:avLst>
@@ -8120,20 +8184,20 @@
           <a:bodyPr rtlCol="0" anchor="ctr"/>
           <a:lstStyle/>
           <a:p>
-            <a:endParaRPr/>
-          </a:p>
-        </p:txBody>
-      </p:sp>
-      <p:sp>
-        <p:nvSpPr>
-          <p:cNvPr id="10" name="TextBox 9"/>
+            <a:pPr algn="ctr"/>
+          </a:p>
+        </p:txBody>
+      </p:sp>
+      <p:sp>
+        <p:nvSpPr>
+          <p:cNvPr id="12" name="TextBox 11"/>
           <p:cNvSpPr txBox="1"/>
           <p:nvPr/>
         </p:nvSpPr>
         <p:spPr>
           <a:xfrm>
-            <a:off x="8354568" y="2148840"/>
-            <a:ext cx="1371600" cy="640080"/>
+            <a:off x="6510527" y="2011680"/>
+            <a:ext cx="1280160" cy="548640"/>
           </a:xfrm>
           <a:prstGeom prst="rect">
             <a:avLst/>
@@ -8141,14 +8205,13 @@
           <a:noFill/>
         </p:spPr>
         <p:txBody>
-          <a:bodyPr wrap="square" lIns="0" tIns="0" rIns="0" bIns="0" anchor="t">
+          <a:bodyPr wrap="square" lIns="0" rIns="0" tIns="0" bIns="0">
             <a:spAutoFit/>
           </a:bodyPr>
           <a:lstStyle/>
           <a:p>
-            <a:pPr algn="l"/>
-            <a:r>
-              <a:rPr lang="vi-VN" sz="4000" b="1">
+            <a:r>
+              <a:rPr sz="3200" b="1" i="0" lang="vi-VN">
                 <a:solidFill>
                   <a:srgbClr val="3F6B52"/>
                 </a:solidFill>
@@ -8161,14 +8224,14 @@
       </p:sp>
       <p:sp>
         <p:nvSpPr>
-          <p:cNvPr id="11" name="TextBox 10"/>
+          <p:cNvPr id="13" name="TextBox 12"/>
           <p:cNvSpPr txBox="1"/>
           <p:nvPr/>
         </p:nvSpPr>
         <p:spPr>
           <a:xfrm>
-            <a:off x="8354568" y="2971800"/>
-            <a:ext cx="2682240" cy="731520"/>
+            <a:off x="6510527" y="2606040"/>
+            <a:ext cx="1874519" cy="731520"/>
           </a:xfrm>
           <a:prstGeom prst="rect">
             <a:avLst/>
@@ -8176,34 +8239,67 @@
           <a:noFill/>
         </p:spPr>
         <p:txBody>
-          <a:bodyPr wrap="square" lIns="0" tIns="0" rIns="0" bIns="0" anchor="t">
+          <a:bodyPr wrap="square" lIns="0" rIns="0" tIns="0" bIns="0">
             <a:spAutoFit/>
           </a:bodyPr>
           <a:lstStyle/>
           <a:p>
-            <a:pPr algn="l"/>
-            <a:r>
-              <a:rPr lang="vi-VN" sz="2000" b="1">
+            <a:r>
+              <a:rPr sz="1700" b="1" i="0" lang="vi-VN">
                 <a:solidFill>
                   <a:srgbClr val="1F1F1F"/>
                 </a:solidFill>
                 <a:latin typeface="Arial"/>
               </a:rPr>
-              <a:t>Cách phần mềm hoạt động</a:t>
-            </a:r>
-          </a:p>
-        </p:txBody>
-      </p:sp>
-      <p:sp>
-        <p:nvSpPr>
-          <p:cNvPr id="12" name="Rounded Rectangle 11"/>
+              <a:t>Vận hành phần mềm</a:t>
+            </a:r>
+          </a:p>
+        </p:txBody>
+      </p:sp>
+      <p:sp>
+        <p:nvSpPr>
+          <p:cNvPr id="14" name="TextBox 13"/>
+          <p:cNvSpPr txBox="1"/>
+          <p:nvPr/>
+        </p:nvSpPr>
+        <p:spPr>
+          <a:xfrm>
+            <a:off x="6510527" y="3410712"/>
+            <a:ext cx="1874519" cy="274320"/>
+          </a:xfrm>
+          <a:prstGeom prst="rect">
+            <a:avLst/>
+          </a:prstGeom>
+          <a:noFill/>
+        </p:spPr>
+        <p:txBody>
+          <a:bodyPr wrap="square" lIns="0" rIns="0" tIns="0" bIns="0">
+            <a:spAutoFit/>
+          </a:bodyPr>
+          <a:lstStyle/>
+          <a:p>
+            <a:r>
+              <a:rPr sz="1200" b="0" i="0" lang="vi-VN">
+                <a:solidFill>
+                  <a:srgbClr val="595959"/>
+                </a:solidFill>
+                <a:latin typeface="Arial"/>
+              </a:rPr>
+              <a:t>Trang 6</a:t>
+            </a:r>
+          </a:p>
+        </p:txBody>
+      </p:sp>
+      <p:sp>
+        <p:nvSpPr>
+          <p:cNvPr id="15" name="Rounded Rectangle 14"/>
           <p:cNvSpPr/>
           <p:nvPr/>
         </p:nvSpPr>
         <p:spPr>
           <a:xfrm>
-            <a:off x="841248" y="4160520"/>
-            <a:ext cx="3322320" cy="2057400"/>
+            <a:off x="8933688" y="1783080"/>
+            <a:ext cx="2423160" cy="2011680"/>
           </a:xfrm>
           <a:prstGeom prst="roundRect">
             <a:avLst>
@@ -8236,20 +8332,20 @@
           <a:bodyPr rtlCol="0" anchor="ctr"/>
           <a:lstStyle/>
           <a:p>
-            <a:endParaRPr/>
-          </a:p>
-        </p:txBody>
-      </p:sp>
-      <p:sp>
-        <p:nvSpPr>
-          <p:cNvPr id="13" name="TextBox 12"/>
+            <a:pPr algn="ctr"/>
+          </a:p>
+        </p:txBody>
+      </p:sp>
+      <p:sp>
+        <p:nvSpPr>
+          <p:cNvPr id="16" name="TextBox 15"/>
           <p:cNvSpPr txBox="1"/>
           <p:nvPr/>
         </p:nvSpPr>
         <p:spPr>
           <a:xfrm>
-            <a:off x="1161288" y="4480559"/>
-            <a:ext cx="1371600" cy="640080"/>
+            <a:off x="9208008" y="2011680"/>
+            <a:ext cx="1280160" cy="548640"/>
           </a:xfrm>
           <a:prstGeom prst="rect">
             <a:avLst/>
@@ -8257,14 +8353,13 @@
           <a:noFill/>
         </p:spPr>
         <p:txBody>
-          <a:bodyPr wrap="square" lIns="0" tIns="0" rIns="0" bIns="0" anchor="t">
+          <a:bodyPr wrap="square" lIns="0" rIns="0" tIns="0" bIns="0">
             <a:spAutoFit/>
           </a:bodyPr>
           <a:lstStyle/>
           <a:p>
-            <a:pPr algn="l"/>
-            <a:r>
-              <a:rPr lang="vi-VN" sz="4000" b="1">
+            <a:r>
+              <a:rPr sz="3200" b="1" i="0" lang="vi-VN">
                 <a:solidFill>
                   <a:srgbClr val="3F6B52"/>
                 </a:solidFill>
@@ -8277,14 +8372,14 @@
       </p:sp>
       <p:sp>
         <p:nvSpPr>
-          <p:cNvPr id="14" name="TextBox 13"/>
+          <p:cNvPr id="17" name="TextBox 16"/>
           <p:cNvSpPr txBox="1"/>
           <p:nvPr/>
         </p:nvSpPr>
         <p:spPr>
           <a:xfrm>
-            <a:off x="1161288" y="5303520"/>
-            <a:ext cx="2682240" cy="731520"/>
+            <a:off x="9208008" y="2606040"/>
+            <a:ext cx="1874519" cy="731520"/>
           </a:xfrm>
           <a:prstGeom prst="rect">
             <a:avLst/>
@@ -8292,34 +8387,67 @@
           <a:noFill/>
         </p:spPr>
         <p:txBody>
-          <a:bodyPr wrap="square" lIns="0" tIns="0" rIns="0" bIns="0" anchor="t">
+          <a:bodyPr wrap="square" lIns="0" rIns="0" tIns="0" bIns="0">
             <a:spAutoFit/>
           </a:bodyPr>
           <a:lstStyle/>
           <a:p>
-            <a:pPr algn="l"/>
-            <a:r>
-              <a:rPr lang="vi-VN" sz="2000" b="1">
+            <a:r>
+              <a:rPr sz="1700" b="1" i="0" lang="vi-VN">
                 <a:solidFill>
                   <a:srgbClr val="1F1F1F"/>
                 </a:solidFill>
                 <a:latin typeface="Arial"/>
               </a:rPr>
-              <a:t>Vận hành phần mềm</a:t>
-            </a:r>
-          </a:p>
-        </p:txBody>
-      </p:sp>
-      <p:sp>
-        <p:nvSpPr>
-          <p:cNvPr id="15" name="Rounded Rectangle 14"/>
+              <a:t>Cách phần mềm hoạt động</a:t>
+            </a:r>
+          </a:p>
+        </p:txBody>
+      </p:sp>
+      <p:sp>
+        <p:nvSpPr>
+          <p:cNvPr id="18" name="TextBox 17"/>
+          <p:cNvSpPr txBox="1"/>
+          <p:nvPr/>
+        </p:nvSpPr>
+        <p:spPr>
+          <a:xfrm>
+            <a:off x="9208008" y="3410712"/>
+            <a:ext cx="1874519" cy="274320"/>
+          </a:xfrm>
+          <a:prstGeom prst="rect">
+            <a:avLst/>
+          </a:prstGeom>
+          <a:noFill/>
+        </p:spPr>
+        <p:txBody>
+          <a:bodyPr wrap="square" lIns="0" rIns="0" tIns="0" bIns="0">
+            <a:spAutoFit/>
+          </a:bodyPr>
+          <a:lstStyle/>
+          <a:p>
+            <a:r>
+              <a:rPr sz="1200" b="0" i="0" lang="vi-VN">
+                <a:solidFill>
+                  <a:srgbClr val="595959"/>
+                </a:solidFill>
+                <a:latin typeface="Arial"/>
+              </a:rPr>
+              <a:t>Trang 7 và 8</a:t>
+            </a:r>
+          </a:p>
+        </p:txBody>
+      </p:sp>
+      <p:sp>
+        <p:nvSpPr>
+          <p:cNvPr id="19" name="Rounded Rectangle 18"/>
           <p:cNvSpPr/>
           <p:nvPr/>
         </p:nvSpPr>
         <p:spPr>
           <a:xfrm>
-            <a:off x="4437888" y="4160520"/>
-            <a:ext cx="3322320" cy="2057400"/>
+            <a:off x="841248" y="4069080"/>
+            <a:ext cx="2423160" cy="2011680"/>
           </a:xfrm>
           <a:prstGeom prst="roundRect">
             <a:avLst>
@@ -8352,20 +8480,20 @@
           <a:bodyPr rtlCol="0" anchor="ctr"/>
           <a:lstStyle/>
           <a:p>
-            <a:endParaRPr/>
-          </a:p>
-        </p:txBody>
-      </p:sp>
-      <p:sp>
-        <p:nvSpPr>
-          <p:cNvPr id="16" name="TextBox 15"/>
+            <a:pPr algn="ctr"/>
+          </a:p>
+        </p:txBody>
+      </p:sp>
+      <p:sp>
+        <p:nvSpPr>
+          <p:cNvPr id="20" name="TextBox 19"/>
           <p:cNvSpPr txBox="1"/>
           <p:nvPr/>
         </p:nvSpPr>
         <p:spPr>
           <a:xfrm>
-            <a:off x="4757928" y="4480559"/>
-            <a:ext cx="1371600" cy="640080"/>
+            <a:off x="1115568" y="4297680"/>
+            <a:ext cx="1280160" cy="548640"/>
           </a:xfrm>
           <a:prstGeom prst="rect">
             <a:avLst/>
@@ -8373,14 +8501,13 @@
           <a:noFill/>
         </p:spPr>
         <p:txBody>
-          <a:bodyPr wrap="square" lIns="0" tIns="0" rIns="0" bIns="0" anchor="t">
+          <a:bodyPr wrap="square" lIns="0" rIns="0" tIns="0" bIns="0">
             <a:spAutoFit/>
           </a:bodyPr>
           <a:lstStyle/>
           <a:p>
-            <a:pPr algn="l"/>
-            <a:r>
-              <a:rPr lang="vi-VN" sz="4000" b="1">
+            <a:r>
+              <a:rPr sz="3200" b="1" i="0" lang="vi-VN">
                 <a:solidFill>
                   <a:srgbClr val="3F6B52"/>
                 </a:solidFill>
@@ -8393,14 +8520,14 @@
       </p:sp>
       <p:sp>
         <p:nvSpPr>
-          <p:cNvPr id="17" name="TextBox 16"/>
+          <p:cNvPr id="21" name="TextBox 20"/>
           <p:cNvSpPr txBox="1"/>
           <p:nvPr/>
         </p:nvSpPr>
         <p:spPr>
           <a:xfrm>
-            <a:off x="4757928" y="5303520"/>
-            <a:ext cx="2682240" cy="731520"/>
+            <a:off x="1115568" y="4892040"/>
+            <a:ext cx="1874519" cy="731520"/>
           </a:xfrm>
           <a:prstGeom prst="rect">
             <a:avLst/>
@@ -8408,34 +8535,67 @@
           <a:noFill/>
         </p:spPr>
         <p:txBody>
-          <a:bodyPr wrap="square" lIns="0" tIns="0" rIns="0" bIns="0" anchor="t">
+          <a:bodyPr wrap="square" lIns="0" rIns="0" tIns="0" bIns="0">
             <a:spAutoFit/>
           </a:bodyPr>
           <a:lstStyle/>
           <a:p>
-            <a:pPr algn="l"/>
-            <a:r>
-              <a:rPr lang="vi-VN" sz="2000" b="1">
+            <a:r>
+              <a:rPr sz="1700" b="1" i="0" lang="vi-VN">
                 <a:solidFill>
                   <a:srgbClr val="1F1F1F"/>
                 </a:solidFill>
                 <a:latin typeface="Arial"/>
               </a:rPr>
-              <a:t>Các số liệu khác</a:t>
-            </a:r>
-          </a:p>
-        </p:txBody>
-      </p:sp>
-      <p:sp>
-        <p:nvSpPr>
-          <p:cNvPr id="18" name="Rounded Rectangle 17"/>
+              <a:t>Các số liệu</a:t>
+            </a:r>
+          </a:p>
+        </p:txBody>
+      </p:sp>
+      <p:sp>
+        <p:nvSpPr>
+          <p:cNvPr id="22" name="TextBox 21"/>
+          <p:cNvSpPr txBox="1"/>
+          <p:nvPr/>
+        </p:nvSpPr>
+        <p:spPr>
+          <a:xfrm>
+            <a:off x="1115568" y="5696712"/>
+            <a:ext cx="1874519" cy="274320"/>
+          </a:xfrm>
+          <a:prstGeom prst="rect">
+            <a:avLst/>
+          </a:prstGeom>
+          <a:noFill/>
+        </p:spPr>
+        <p:txBody>
+          <a:bodyPr wrap="square" lIns="0" rIns="0" tIns="0" bIns="0">
+            <a:spAutoFit/>
+          </a:bodyPr>
+          <a:lstStyle/>
+          <a:p>
+            <a:r>
+              <a:rPr sz="1200" b="0" i="0" lang="vi-VN">
+                <a:solidFill>
+                  <a:srgbClr val="595959"/>
+                </a:solidFill>
+                <a:latin typeface="Arial"/>
+              </a:rPr>
+              <a:t>Trang 9 đến 11</a:t>
+            </a:r>
+          </a:p>
+        </p:txBody>
+      </p:sp>
+      <p:sp>
+        <p:nvSpPr>
+          <p:cNvPr id="23" name="Rounded Rectangle 22"/>
           <p:cNvSpPr/>
           <p:nvPr/>
         </p:nvSpPr>
         <p:spPr>
           <a:xfrm>
-            <a:off x="8034528" y="4160520"/>
-            <a:ext cx="3322320" cy="2057400"/>
+            <a:off x="3538727" y="4069080"/>
+            <a:ext cx="2423160" cy="2011680"/>
           </a:xfrm>
           <a:prstGeom prst="roundRect">
             <a:avLst>
@@ -8468,20 +8628,20 @@
           <a:bodyPr rtlCol="0" anchor="ctr"/>
           <a:lstStyle/>
           <a:p>
-            <a:endParaRPr/>
-          </a:p>
-        </p:txBody>
-      </p:sp>
-      <p:sp>
-        <p:nvSpPr>
-          <p:cNvPr id="19" name="TextBox 18"/>
+            <a:pPr algn="ctr"/>
+          </a:p>
+        </p:txBody>
+      </p:sp>
+      <p:sp>
+        <p:nvSpPr>
+          <p:cNvPr id="24" name="TextBox 23"/>
           <p:cNvSpPr txBox="1"/>
           <p:nvPr/>
         </p:nvSpPr>
         <p:spPr>
           <a:xfrm>
-            <a:off x="8354568" y="4480559"/>
-            <a:ext cx="1371600" cy="640080"/>
+            <a:off x="3813048" y="4297680"/>
+            <a:ext cx="1280160" cy="548640"/>
           </a:xfrm>
           <a:prstGeom prst="rect">
             <a:avLst/>
@@ -8489,14 +8649,13 @@
           <a:noFill/>
         </p:spPr>
         <p:txBody>
-          <a:bodyPr wrap="square" lIns="0" tIns="0" rIns="0" bIns="0" anchor="t">
+          <a:bodyPr wrap="square" lIns="0" rIns="0" tIns="0" bIns="0">
             <a:spAutoFit/>
           </a:bodyPr>
           <a:lstStyle/>
           <a:p>
-            <a:pPr algn="l"/>
-            <a:r>
-              <a:rPr lang="vi-VN" sz="4000" b="1">
+            <a:r>
+              <a:rPr sz="3200" b="1" i="0" lang="vi-VN">
                 <a:solidFill>
                   <a:srgbClr val="3F6B52"/>
                 </a:solidFill>
@@ -8509,14 +8668,14 @@
       </p:sp>
       <p:sp>
         <p:nvSpPr>
-          <p:cNvPr id="20" name="TextBox 19"/>
+          <p:cNvPr id="25" name="TextBox 24"/>
           <p:cNvSpPr txBox="1"/>
           <p:nvPr/>
         </p:nvSpPr>
         <p:spPr>
           <a:xfrm>
-            <a:off x="8354568" y="5303520"/>
-            <a:ext cx="2682240" cy="731520"/>
+            <a:off x="3813048" y="4892040"/>
+            <a:ext cx="1874519" cy="731520"/>
           </a:xfrm>
           <a:prstGeom prst="rect">
             <a:avLst/>
@@ -8524,20 +8683,383 @@
           <a:noFill/>
         </p:spPr>
         <p:txBody>
-          <a:bodyPr wrap="square" lIns="0" tIns="0" rIns="0" bIns="0" anchor="t">
+          <a:bodyPr wrap="square" lIns="0" rIns="0" tIns="0" bIns="0">
             <a:spAutoFit/>
           </a:bodyPr>
           <a:lstStyle/>
           <a:p>
-            <a:pPr algn="l"/>
-            <a:r>
-              <a:rPr lang="vi-VN" sz="2000" b="1">
+            <a:r>
+              <a:rPr sz="1700" b="1" i="0" lang="vi-VN">
                 <a:solidFill>
                   <a:srgbClr val="1F1F1F"/>
                 </a:solidFill>
                 <a:latin typeface="Arial"/>
               </a:rPr>
               <a:t>Tính năng khác</a:t>
+            </a:r>
+          </a:p>
+        </p:txBody>
+      </p:sp>
+      <p:sp>
+        <p:nvSpPr>
+          <p:cNvPr id="26" name="TextBox 25"/>
+          <p:cNvSpPr txBox="1"/>
+          <p:nvPr/>
+        </p:nvSpPr>
+        <p:spPr>
+          <a:xfrm>
+            <a:off x="3813048" y="5696712"/>
+            <a:ext cx="1874519" cy="274320"/>
+          </a:xfrm>
+          <a:prstGeom prst="rect">
+            <a:avLst/>
+          </a:prstGeom>
+          <a:noFill/>
+        </p:spPr>
+        <p:txBody>
+          <a:bodyPr wrap="square" lIns="0" rIns="0" tIns="0" bIns="0">
+            <a:spAutoFit/>
+          </a:bodyPr>
+          <a:lstStyle/>
+          <a:p>
+            <a:r>
+              <a:rPr sz="1200" b="0" i="0" lang="vi-VN">
+                <a:solidFill>
+                  <a:srgbClr val="595959"/>
+                </a:solidFill>
+                <a:latin typeface="Arial"/>
+              </a:rPr>
+              <a:t>Trang 12</a:t>
+            </a:r>
+          </a:p>
+        </p:txBody>
+      </p:sp>
+      <p:sp>
+        <p:nvSpPr>
+          <p:cNvPr id="27" name="Rounded Rectangle 26"/>
+          <p:cNvSpPr/>
+          <p:nvPr/>
+        </p:nvSpPr>
+        <p:spPr>
+          <a:xfrm>
+            <a:off x="6236207" y="4069080"/>
+            <a:ext cx="2423160" cy="2011680"/>
+          </a:xfrm>
+          <a:prstGeom prst="roundRect">
+            <a:avLst>
+              <a:gd name="adj" fmla="val 6000"/>
+            </a:avLst>
+          </a:prstGeom>
+          <a:solidFill>
+            <a:srgbClr val="EFE8DE"/>
+          </a:solidFill>
+          <a:ln>
+            <a:noFill/>
+          </a:ln>
+          <a:effectLst/>
+        </p:spPr>
+        <p:style>
+          <a:lnRef idx="1">
+            <a:schemeClr val="accent1"/>
+          </a:lnRef>
+          <a:fillRef idx="3">
+            <a:schemeClr val="accent1"/>
+          </a:fillRef>
+          <a:effectRef idx="2">
+            <a:schemeClr val="accent1"/>
+          </a:effectRef>
+          <a:fontRef idx="minor">
+            <a:schemeClr val="lt1"/>
+          </a:fontRef>
+        </p:style>
+        <p:txBody>
+          <a:bodyPr rtlCol="0" anchor="ctr"/>
+          <a:lstStyle/>
+          <a:p>
+            <a:pPr algn="ctr"/>
+          </a:p>
+        </p:txBody>
+      </p:sp>
+      <p:sp>
+        <p:nvSpPr>
+          <p:cNvPr id="28" name="TextBox 27"/>
+          <p:cNvSpPr txBox="1"/>
+          <p:nvPr/>
+        </p:nvSpPr>
+        <p:spPr>
+          <a:xfrm>
+            <a:off x="6510527" y="4297680"/>
+            <a:ext cx="1280160" cy="548640"/>
+          </a:xfrm>
+          <a:prstGeom prst="rect">
+            <a:avLst/>
+          </a:prstGeom>
+          <a:noFill/>
+        </p:spPr>
+        <p:txBody>
+          <a:bodyPr wrap="square" lIns="0" rIns="0" tIns="0" bIns="0">
+            <a:spAutoFit/>
+          </a:bodyPr>
+          <a:lstStyle/>
+          <a:p>
+            <a:r>
+              <a:rPr sz="3200" b="1" i="0" lang="vi-VN">
+                <a:solidFill>
+                  <a:srgbClr val="3F6B52"/>
+                </a:solidFill>
+                <a:latin typeface="Arial"/>
+              </a:rPr>
+              <a:t>07</a:t>
+            </a:r>
+          </a:p>
+        </p:txBody>
+      </p:sp>
+      <p:sp>
+        <p:nvSpPr>
+          <p:cNvPr id="29" name="TextBox 28"/>
+          <p:cNvSpPr txBox="1"/>
+          <p:nvPr/>
+        </p:nvSpPr>
+        <p:spPr>
+          <a:xfrm>
+            <a:off x="6510527" y="4892040"/>
+            <a:ext cx="1874519" cy="731520"/>
+          </a:xfrm>
+          <a:prstGeom prst="rect">
+            <a:avLst/>
+          </a:prstGeom>
+          <a:noFill/>
+        </p:spPr>
+        <p:txBody>
+          <a:bodyPr wrap="square" lIns="0" rIns="0" tIns="0" bIns="0">
+            <a:spAutoFit/>
+          </a:bodyPr>
+          <a:lstStyle/>
+          <a:p>
+            <a:r>
+              <a:rPr sz="1700" b="1" i="0" lang="vi-VN">
+                <a:solidFill>
+                  <a:srgbClr val="1F1F1F"/>
+                </a:solidFill>
+                <a:latin typeface="Arial"/>
+              </a:rPr>
+              <a:t>Vì sao chọn dự án</a:t>
+            </a:r>
+          </a:p>
+        </p:txBody>
+      </p:sp>
+      <p:sp>
+        <p:nvSpPr>
+          <p:cNvPr id="30" name="TextBox 29"/>
+          <p:cNvSpPr txBox="1"/>
+          <p:nvPr/>
+        </p:nvSpPr>
+        <p:spPr>
+          <a:xfrm>
+            <a:off x="6510527" y="5696712"/>
+            <a:ext cx="1874519" cy="274320"/>
+          </a:xfrm>
+          <a:prstGeom prst="rect">
+            <a:avLst/>
+          </a:prstGeom>
+          <a:noFill/>
+        </p:spPr>
+        <p:txBody>
+          <a:bodyPr wrap="square" lIns="0" rIns="0" tIns="0" bIns="0">
+            <a:spAutoFit/>
+          </a:bodyPr>
+          <a:lstStyle/>
+          <a:p>
+            <a:r>
+              <a:rPr sz="1200" b="0" i="0" lang="vi-VN">
+                <a:solidFill>
+                  <a:srgbClr val="595959"/>
+                </a:solidFill>
+                <a:latin typeface="Arial"/>
+              </a:rPr>
+              <a:t>Trang 13</a:t>
+            </a:r>
+          </a:p>
+        </p:txBody>
+      </p:sp>
+      <p:sp>
+        <p:nvSpPr>
+          <p:cNvPr id="31" name="Rounded Rectangle 30"/>
+          <p:cNvSpPr/>
+          <p:nvPr/>
+        </p:nvSpPr>
+        <p:spPr>
+          <a:xfrm>
+            <a:off x="8933688" y="4069080"/>
+            <a:ext cx="2423160" cy="2011680"/>
+          </a:xfrm>
+          <a:prstGeom prst="roundRect">
+            <a:avLst>
+              <a:gd name="adj" fmla="val 6000"/>
+            </a:avLst>
+          </a:prstGeom>
+          <a:solidFill>
+            <a:srgbClr val="EFE8DE"/>
+          </a:solidFill>
+          <a:ln>
+            <a:noFill/>
+          </a:ln>
+          <a:effectLst/>
+        </p:spPr>
+        <p:style>
+          <a:lnRef idx="1">
+            <a:schemeClr val="accent1"/>
+          </a:lnRef>
+          <a:fillRef idx="3">
+            <a:schemeClr val="accent1"/>
+          </a:fillRef>
+          <a:effectRef idx="2">
+            <a:schemeClr val="accent1"/>
+          </a:effectRef>
+          <a:fontRef idx="minor">
+            <a:schemeClr val="lt1"/>
+          </a:fontRef>
+        </p:style>
+        <p:txBody>
+          <a:bodyPr rtlCol="0" anchor="ctr"/>
+          <a:lstStyle/>
+          <a:p>
+            <a:pPr algn="ctr"/>
+          </a:p>
+        </p:txBody>
+      </p:sp>
+      <p:sp>
+        <p:nvSpPr>
+          <p:cNvPr id="32" name="TextBox 31"/>
+          <p:cNvSpPr txBox="1"/>
+          <p:nvPr/>
+        </p:nvSpPr>
+        <p:spPr>
+          <a:xfrm>
+            <a:off x="9208008" y="4297680"/>
+            <a:ext cx="1280160" cy="548640"/>
+          </a:xfrm>
+          <a:prstGeom prst="rect">
+            <a:avLst/>
+          </a:prstGeom>
+          <a:noFill/>
+        </p:spPr>
+        <p:txBody>
+          <a:bodyPr wrap="square" lIns="0" rIns="0" tIns="0" bIns="0">
+            <a:spAutoFit/>
+          </a:bodyPr>
+          <a:lstStyle/>
+          <a:p>
+            <a:r>
+              <a:rPr sz="3200" b="1" i="0" lang="vi-VN">
+                <a:solidFill>
+                  <a:srgbClr val="3F6B52"/>
+                </a:solidFill>
+                <a:latin typeface="Arial"/>
+              </a:rPr>
+              <a:t>08</a:t>
+            </a:r>
+          </a:p>
+        </p:txBody>
+      </p:sp>
+      <p:sp>
+        <p:nvSpPr>
+          <p:cNvPr id="33" name="TextBox 32"/>
+          <p:cNvSpPr txBox="1"/>
+          <p:nvPr/>
+        </p:nvSpPr>
+        <p:spPr>
+          <a:xfrm>
+            <a:off x="9208008" y="4892040"/>
+            <a:ext cx="1874519" cy="731520"/>
+          </a:xfrm>
+          <a:prstGeom prst="rect">
+            <a:avLst/>
+          </a:prstGeom>
+          <a:noFill/>
+        </p:spPr>
+        <p:txBody>
+          <a:bodyPr wrap="square" lIns="0" rIns="0" tIns="0" bIns="0">
+            <a:spAutoFit/>
+          </a:bodyPr>
+          <a:lstStyle/>
+          <a:p>
+            <a:r>
+              <a:rPr sz="1700" b="1" i="0" lang="vi-VN">
+                <a:solidFill>
+                  <a:srgbClr val="1F1F1F"/>
+                </a:solidFill>
+                <a:latin typeface="Arial"/>
+              </a:rPr>
+              <a:t>Định hướng tương lai</a:t>
+            </a:r>
+          </a:p>
+        </p:txBody>
+      </p:sp>
+      <p:sp>
+        <p:nvSpPr>
+          <p:cNvPr id="34" name="TextBox 33"/>
+          <p:cNvSpPr txBox="1"/>
+          <p:nvPr/>
+        </p:nvSpPr>
+        <p:spPr>
+          <a:xfrm>
+            <a:off x="9208008" y="5696712"/>
+            <a:ext cx="1874519" cy="274320"/>
+          </a:xfrm>
+          <a:prstGeom prst="rect">
+            <a:avLst/>
+          </a:prstGeom>
+          <a:noFill/>
+        </p:spPr>
+        <p:txBody>
+          <a:bodyPr wrap="square" lIns="0" rIns="0" tIns="0" bIns="0">
+            <a:spAutoFit/>
+          </a:bodyPr>
+          <a:lstStyle/>
+          <a:p>
+            <a:r>
+              <a:rPr sz="1200" b="0" i="0" lang="vi-VN">
+                <a:solidFill>
+                  <a:srgbClr val="595959"/>
+                </a:solidFill>
+                <a:latin typeface="Arial"/>
+              </a:rPr>
+              <a:t>Trang 14</a:t>
+            </a:r>
+          </a:p>
+        </p:txBody>
+      </p:sp>
+      <p:sp>
+        <p:nvSpPr>
+          <p:cNvPr id="35" name="TextBox 34"/>
+          <p:cNvSpPr txBox="1"/>
+          <p:nvPr/>
+        </p:nvSpPr>
+        <p:spPr>
+          <a:xfrm>
+            <a:off x="841248" y="6263640"/>
+            <a:ext cx="10515600" cy="274320"/>
+          </a:xfrm>
+          <a:prstGeom prst="rect">
+            <a:avLst/>
+          </a:prstGeom>
+          <a:noFill/>
+        </p:spPr>
+        <p:txBody>
+          <a:bodyPr wrap="square" lIns="0" rIns="0" tIns="0" bIns="0">
+            <a:spAutoFit/>
+          </a:bodyPr>
+          <a:lstStyle/>
+          <a:p>
+            <a:r>
+              <a:rPr sz="1200" b="0" i="1" lang="vi-VN">
+                <a:solidFill>
+                  <a:srgbClr val="595959"/>
+                </a:solidFill>
+                <a:latin typeface="Arial"/>
+              </a:rPr>
+              <a:t>Giải nghĩa thuật ngữ: trang 3</a:t>
             </a:r>
           </a:p>
         </p:txBody>

</xml_diff>